<commit_message>
Auto-build: 2026-03-11 16:50 UTC
</commit_message>
<xml_diff>
--- a/reports/2026-01.pptx
+++ b/reports/2026-01.pptx
@@ -268,10 +268,10 @@
                   <c:v>1</c:v>
                 </c:pt>
                 <c:pt idx="2">
-                  <c:v>1</c:v>
+                  <c:v>26</c:v>
                 </c:pt>
                 <c:pt idx="3">
-                  <c:v>1</c:v>
+                  <c:v>25</c:v>
                 </c:pt>
                 <c:pt idx="4">
                   <c:v>1</c:v>
@@ -890,10 +890,10 @@
                   <c:v>1080878.933</c:v>
                 </c:pt>
                 <c:pt idx="2">
-                  <c:v>210518.4175</c:v>
+                  <c:v>227864.7372</c:v>
                 </c:pt>
                 <c:pt idx="3">
-                  <c:v>493834.2037</c:v>
+                  <c:v>372652.1739</c:v>
                 </c:pt>
                 <c:pt idx="4">
                   <c:v>83007.24638</c:v>
@@ -1201,10 +1201,10 @@
                   <c:v>218.315276</c:v>
                 </c:pt>
                 <c:pt idx="2">
-                  <c:v>233.132245</c:v>
+                  <c:v>252.341902</c:v>
                 </c:pt>
                 <c:pt idx="3">
-                  <c:v>423.165556</c:v>
+                  <c:v>425.402025</c:v>
                 </c:pt>
                 <c:pt idx="4">
                   <c:v>226.795755</c:v>
@@ -1515,7 +1515,7 @@
                   <c:v>41</c:v>
                 </c:pt>
                 <c:pt idx="3">
-                  <c:v>39</c:v>
+                  <c:v>29</c:v>
                 </c:pt>
                 <c:pt idx="4">
                   <c:v>23</c:v>
@@ -1823,10 +1823,10 @@
                   <c:v>4786073.167</c:v>
                 </c:pt>
                 <c:pt idx="2">
-                  <c:v>1421675.472</c:v>
+                  <c:v>1538818.844</c:v>
                 </c:pt>
                 <c:pt idx="3">
-                  <c:v>1440365.185</c:v>
+                  <c:v>1427026.151</c:v>
                 </c:pt>
                 <c:pt idx="4">
                   <c:v>577267.6961</c:v>
@@ -2134,10 +2134,10 @@
                   <c:v>0</c:v>
                 </c:pt>
                 <c:pt idx="2">
-                  <c:v>-27</c:v>
+                  <c:v>-5264</c:v>
                 </c:pt>
                 <c:pt idx="3">
-                  <c:v>-16</c:v>
+                  <c:v>-2042</c:v>
                 </c:pt>
                 <c:pt idx="4">
                   <c:v>-17</c:v>
@@ -2445,10 +2445,10 @@
                   <c:v>0</c:v>
                 </c:pt>
                 <c:pt idx="2">
-                  <c:v>-2</c:v>
+                  <c:v>-716</c:v>
                 </c:pt>
                 <c:pt idx="3">
-                  <c:v>-3</c:v>
+                  <c:v>-388</c:v>
                 </c:pt>
                 <c:pt idx="4">
                   <c:v>-3</c:v>
@@ -2756,10 +2756,10 @@
                   <c:v>0</c:v>
                 </c:pt>
                 <c:pt idx="2">
-                  <c:v>-1</c:v>
+                  <c:v>-19</c:v>
                 </c:pt>
                 <c:pt idx="3">
-                  <c:v>0</c:v>
+                  <c:v>-62</c:v>
                 </c:pt>
                 <c:pt idx="4">
                   <c:v>-3</c:v>
@@ -5507,13 +5507,13 @@
             <a:r>
               <a:rPr lang="en-US" sz="1000" b="1" dirty="0">
                 <a:solidFill>
-                  <a:srgbClr val="1A7A6E"/>
+                  <a:srgbClr val="718096"/>
                 </a:solidFill>
                 <a:latin typeface="Calibri" pitchFamily="34" charset="0"/>
                 <a:ea typeface="Calibri" pitchFamily="34" charset="-122"/>
                 <a:cs typeface="Calibri" pitchFamily="34" charset="-120"/>
               </a:rPr>
-              <a:t>-59.1%</a:t>
+              <a:t>—</a:t>
             </a:r>
             <a:endParaRPr lang="en-US" sz="1000" dirty="0"/>
           </a:p>
@@ -5546,13 +5546,13 @@
             <a:r>
               <a:rPr lang="en-US" sz="1000" b="1" dirty="0">
                 <a:solidFill>
-                  <a:srgbClr val="1A7A6E"/>
+                  <a:srgbClr val="718096"/>
                 </a:solidFill>
                 <a:latin typeface="Calibri" pitchFamily="34" charset="0"/>
                 <a:ea typeface="Calibri" pitchFamily="34" charset="-122"/>
                 <a:cs typeface="Calibri" pitchFamily="34" charset="-120"/>
               </a:rPr>
-              <a:t>-23.8%</a:t>
+              <a:t>—</a:t>
             </a:r>
             <a:endParaRPr lang="en-US" sz="1000" dirty="0"/>
           </a:p>
@@ -6113,13 +6113,13 @@
             <a:r>
               <a:rPr lang="en-US" sz="1000" b="1" dirty="0">
                 <a:solidFill>
-                  <a:srgbClr val="1A7A6E"/>
+                  <a:srgbClr val="718096"/>
                 </a:solidFill>
                 <a:latin typeface="Calibri" pitchFamily="34" charset="0"/>
                 <a:ea typeface="Calibri" pitchFamily="34" charset="-122"/>
                 <a:cs typeface="Calibri" pitchFamily="34" charset="-120"/>
               </a:rPr>
-              <a:t>-77.8%</a:t>
+              <a:t>—</a:t>
             </a:r>
             <a:endParaRPr lang="en-US" sz="1000" dirty="0"/>
           </a:p>
@@ -6152,13 +6152,13 @@
             <a:r>
               <a:rPr lang="en-US" sz="1000" b="1" dirty="0">
                 <a:solidFill>
-                  <a:srgbClr val="1A7A6E"/>
+                  <a:srgbClr val="718096"/>
                 </a:solidFill>
                 <a:latin typeface="Calibri" pitchFamily="34" charset="0"/>
                 <a:ea typeface="Calibri" pitchFamily="34" charset="-122"/>
                 <a:cs typeface="Calibri" pitchFamily="34" charset="-120"/>
               </a:rPr>
-              <a:t>-25.0%</a:t>
+              <a:t>—</a:t>
             </a:r>
             <a:endParaRPr lang="en-US" sz="1000" dirty="0"/>
           </a:p>
@@ -7505,7 +7505,7 @@
                 <a:ea typeface="Century Gothic" pitchFamily="34" charset="-122"/>
                 <a:cs typeface="Century Gothic" pitchFamily="34" charset="-120"/>
               </a:rPr>
-              <a:t>28,118</a:t>
+              <a:t>26,845</a:t>
             </a:r>
             <a:endParaRPr lang="en-US" sz="2000" dirty="0"/>
           </a:p>
@@ -7775,7 +7775,7 @@
                 <a:ea typeface="Century Gothic" pitchFamily="34" charset="-122"/>
                 <a:cs typeface="Century Gothic" pitchFamily="34" charset="-120"/>
               </a:rPr>
-              <a:t>13,887</a:t>
+              <a:t>10,834</a:t>
             </a:r>
             <a:endParaRPr lang="en-US" sz="2000" dirty="0"/>
           </a:p>
@@ -9783,7 +9783,7 @@
                 <a:ea typeface="Century Gothic" pitchFamily="34" charset="-122"/>
                 <a:cs typeface="Century Gothic" pitchFamily="34" charset="-120"/>
               </a:rPr>
-              <a:t>$3,937,968</a:t>
+              <a:t>$3,834,132</a:t>
             </a:r>
             <a:endParaRPr lang="en-US" sz="2000" dirty="0"/>
           </a:p>
@@ -10355,7 +10355,7 @@
                 <a:ea typeface="Century Gothic" pitchFamily="34" charset="-122"/>
                 <a:cs typeface="Century Gothic" pitchFamily="34" charset="-120"/>
               </a:rPr>
-              <a:t>1,557</a:t>
+              <a:t>39</a:t>
             </a:r>
             <a:endParaRPr lang="en-US" sz="1200" dirty="0"/>
           </a:p>
@@ -10458,7 +10458,7 @@
                 <a:ea typeface="Century Gothic" pitchFamily="34" charset="-122"/>
                 <a:cs typeface="Century Gothic" pitchFamily="34" charset="-120"/>
               </a:rPr>
-              <a:t>1,568</a:t>
+              <a:t>33</a:t>
             </a:r>
             <a:endParaRPr lang="en-US" sz="1200" dirty="0"/>
           </a:p>
@@ -12386,7 +12386,7 @@
                 <a:ea typeface="Century Gothic" pitchFamily="34" charset="-122"/>
                 <a:cs typeface="Century Gothic" pitchFamily="34" charset="-120"/>
               </a:rPr>
-              <a:t>$15,321,293</a:t>
+              <a:t>$15,425,098</a:t>
             </a:r>
             <a:endParaRPr lang="en-US" sz="2000" dirty="0"/>
           </a:p>
@@ -15986,7 +15986,7 @@
                           <a:ea typeface="Calibri" pitchFamily="34" charset="-122"/>
                           <a:cs typeface="Calibri" pitchFamily="34" charset="-120"/>
                         </a:rPr>
-                        <a:t>23.6%</a:t>
+                        <a:t>20.0%</a:t>
                       </a:r>
                       <a:endParaRPr lang="en-US" sz="950" dirty="0">
                         <a:latin typeface="Calibri" charset="0"/>
@@ -16054,7 +16054,7 @@
                           <a:ea typeface="Calibri" pitchFamily="34" charset="-122"/>
                           <a:cs typeface="Calibri" pitchFamily="34" charset="-120"/>
                         </a:rPr>
-                        <a:t>+2361 bps</a:t>
+                        <a:t>+1995 bps</a:t>
                       </a:r>
                       <a:endParaRPr lang="en-US" sz="950" dirty="0">
                         <a:latin typeface="Calibri" charset="0"/>
@@ -16260,7 +16260,7 @@
                           <a:ea typeface="Calibri" pitchFamily="34" charset="-122"/>
                           <a:cs typeface="Calibri" pitchFamily="34" charset="-120"/>
                         </a:rPr>
-                        <a:t>2.6%</a:t>
+                        <a:t>2.3%</a:t>
                       </a:r>
                       <a:endParaRPr lang="en-US" sz="950" dirty="0">
                         <a:latin typeface="Calibri" charset="0"/>
@@ -16328,7 +16328,7 @@
                           <a:ea typeface="Calibri" pitchFamily="34" charset="-122"/>
                           <a:cs typeface="Calibri" pitchFamily="34" charset="-120"/>
                         </a:rPr>
-                        <a:t>+261 bps</a:t>
+                        <a:t>+234 bps</a:t>
                       </a:r>
                       <a:endParaRPr lang="en-US" sz="950" dirty="0">
                         <a:latin typeface="Calibri" charset="0"/>
@@ -18515,7 +18515,7 @@
                           <a:ea typeface="Calibri" pitchFamily="34" charset="-122"/>
                           <a:cs typeface="Calibri" pitchFamily="34" charset="-120"/>
                         </a:rPr>
-                        <a:t>$148,399</a:t>
+                        <a:t>$186,729</a:t>
                       </a:r>
                       <a:endParaRPr lang="en-US" sz="900" dirty="0">
                         <a:latin typeface="Calibri" charset="0"/>
@@ -18583,7 +18583,7 @@
                           <a:ea typeface="Calibri" pitchFamily="34" charset="-122"/>
                           <a:cs typeface="Calibri" pitchFamily="34" charset="-120"/>
                         </a:rPr>
-                        <a:t>$-70,540</a:t>
+                        <a:t>$-65,799</a:t>
                       </a:r>
                       <a:endParaRPr lang="en-US" sz="900" dirty="0">
                         <a:latin typeface="Calibri" charset="0"/>
@@ -18651,7 +18651,7 @@
                           <a:ea typeface="Calibri" pitchFamily="34" charset="-122"/>
                           <a:cs typeface="Calibri" pitchFamily="34" charset="-120"/>
                         </a:rPr>
-                        <a:t>$-140,209</a:t>
+                        <a:t>$-234,258</a:t>
                       </a:r>
                       <a:endParaRPr lang="en-US" sz="900" dirty="0">
                         <a:latin typeface="Calibri" charset="0"/>
@@ -18719,7 +18719,7 @@
                           <a:ea typeface="Calibri" pitchFamily="34" charset="-122"/>
                           <a:cs typeface="Calibri" pitchFamily="34" charset="-120"/>
                         </a:rPr>
-                        <a:t>$-62,350</a:t>
+                        <a:t>$-113,329</a:t>
                       </a:r>
                       <a:endParaRPr lang="en-US" sz="900" dirty="0">
                         <a:latin typeface="Calibri" charset="0"/>
@@ -18787,7 +18787,7 @@
                           <a:ea typeface="Calibri" pitchFamily="34" charset="-122"/>
                           <a:cs typeface="Calibri" pitchFamily="34" charset="-120"/>
                         </a:rPr>
-                        <a:t>-42.0%</a:t>
+                        <a:t>-60.7%</a:t>
                       </a:r>
                       <a:endParaRPr lang="en-US" sz="900" dirty="0">
                         <a:latin typeface="Calibri" charset="0"/>
@@ -18855,7 +18855,7 @@
                           <a:ea typeface="Calibri" pitchFamily="34" charset="-122"/>
                           <a:cs typeface="Calibri" pitchFamily="34" charset="-120"/>
                         </a:rPr>
-                        <a:t>$-113,329</a:t>
+                        <a:t>$0</a:t>
                       </a:r>
                       <a:endParaRPr lang="en-US" sz="900" dirty="0">
                         <a:latin typeface="Calibri" charset="0"/>
@@ -18993,7 +18993,7 @@
                           <a:ea typeface="Calibri" pitchFamily="34" charset="-122"/>
                           <a:cs typeface="Calibri" pitchFamily="34" charset="-120"/>
                         </a:rPr>
-                        <a:t>$183,186</a:t>
+                        <a:t>$172,432</a:t>
                       </a:r>
                       <a:endParaRPr lang="en-US" sz="900" dirty="0">
                         <a:latin typeface="Calibri" charset="0"/>
@@ -19061,7 +19061,7 @@
                           <a:ea typeface="Calibri" pitchFamily="34" charset="-122"/>
                           <a:cs typeface="Calibri" pitchFamily="34" charset="-120"/>
                         </a:rPr>
-                        <a:t>$-7,306</a:t>
+                        <a:t>$-6,675</a:t>
                       </a:r>
                       <a:endParaRPr lang="en-US" sz="900" dirty="0">
                         <a:latin typeface="Calibri" charset="0"/>
@@ -19129,7 +19129,75 @@
                           <a:ea typeface="Calibri" pitchFamily="34" charset="-122"/>
                           <a:cs typeface="Calibri" pitchFamily="34" charset="-120"/>
                         </a:rPr>
-                        <a:t>$-120,605</a:t>
+                        <a:t>$-225,558</a:t>
+                      </a:r>
+                      <a:endParaRPr lang="en-US" sz="900" dirty="0">
+                        <a:latin typeface="Calibri" charset="0"/>
+                        <a:ea typeface="Calibri" charset="0"/>
+                        <a:cs typeface="Calibri" charset="0"/>
+                      </a:endParaRPr>
+                    </a:p>
+                  </a:txBody>
+                  <a:tcPr marL="91440" marR="91440" marT="45720" marB="45720" anchor="ctr">
+                    <a:lnL w="6350" cap="flat" cmpd="sng" algn="ctr">
+                      <a:solidFill>
+                        <a:srgbClr val="D6CFC4"/>
+                      </a:solidFill>
+                      <a:prstDash val="solid"/>
+                      <a:round/>
+                      <a:headEnd type="none" w="med" len="med"/>
+                      <a:tailEnd type="none" w="med" len="med"/>
+                    </a:lnL>
+                    <a:lnR w="6350" cap="flat" cmpd="sng" algn="ctr">
+                      <a:solidFill>
+                        <a:srgbClr val="D6CFC4"/>
+                      </a:solidFill>
+                      <a:prstDash val="solid"/>
+                      <a:round/>
+                      <a:headEnd type="none" w="med" len="med"/>
+                      <a:tailEnd type="none" w="med" len="med"/>
+                    </a:lnR>
+                    <a:lnT w="6350" cap="flat" cmpd="sng" algn="ctr">
+                      <a:solidFill>
+                        <a:srgbClr val="D6CFC4"/>
+                      </a:solidFill>
+                      <a:prstDash val="solid"/>
+                      <a:round/>
+                      <a:headEnd type="none" w="med" len="med"/>
+                      <a:tailEnd type="none" w="med" len="med"/>
+                    </a:lnT>
+                    <a:lnB w="6350" cap="flat" cmpd="sng" algn="ctr">
+                      <a:solidFill>
+                        <a:srgbClr val="D6CFC4"/>
+                      </a:solidFill>
+                      <a:prstDash val="solid"/>
+                      <a:round/>
+                      <a:headEnd type="none" w="med" len="med"/>
+                      <a:tailEnd type="none" w="med" len="med"/>
+                    </a:lnB>
+                    <a:solidFill>
+                      <a:srgbClr val="FAF7F2"/>
+                    </a:solidFill>
+                  </a:tcPr>
+                </a:tc>
+                <a:tc>
+                  <a:txBody>
+                    <a:bodyPr/>
+                    <a:lstStyle/>
+                    <a:p>
+                      <a:pPr algn="ctr" indent="0" marL="0">
+                        <a:buNone/>
+                      </a:pPr>
+                      <a:r>
+                        <a:rPr lang="en-US" sz="900" dirty="0">
+                          <a:solidFill>
+                            <a:srgbClr val="C0392B"/>
+                          </a:solidFill>
+                          <a:latin typeface="Calibri" pitchFamily="34" charset="0"/>
+                          <a:ea typeface="Calibri" pitchFamily="34" charset="-122"/>
+                          <a:cs typeface="Calibri" pitchFamily="34" charset="-120"/>
+                        </a:rPr>
+                        <a:t>$-59,801</a:t>
                       </a:r>
                       <a:endParaRPr lang="en-US" sz="900" dirty="0">
                         <a:latin typeface="Calibri" charset="0"/>
@@ -19197,7 +19265,7 @@
                           <a:ea typeface="Calibri" pitchFamily="34" charset="-122"/>
                           <a:cs typeface="Calibri" pitchFamily="34" charset="-120"/>
                         </a:rPr>
-                        <a:t>$55,275</a:t>
+                        <a:t>-34.7%</a:t>
                       </a:r>
                       <a:endParaRPr lang="en-US" sz="900" dirty="0">
                         <a:latin typeface="Calibri" charset="0"/>
@@ -19265,75 +19333,7 @@
                           <a:ea typeface="Calibri" pitchFamily="34" charset="-122"/>
                           <a:cs typeface="Calibri" pitchFamily="34" charset="-120"/>
                         </a:rPr>
-                        <a:t>30.2%</a:t>
-                      </a:r>
-                      <a:endParaRPr lang="en-US" sz="900" dirty="0">
-                        <a:latin typeface="Calibri" charset="0"/>
-                        <a:ea typeface="Calibri" charset="0"/>
-                        <a:cs typeface="Calibri" charset="0"/>
-                      </a:endParaRPr>
-                    </a:p>
-                  </a:txBody>
-                  <a:tcPr marL="91440" marR="91440" marT="45720" marB="45720" anchor="ctr">
-                    <a:lnL w="6350" cap="flat" cmpd="sng" algn="ctr">
-                      <a:solidFill>
-                        <a:srgbClr val="D6CFC4"/>
-                      </a:solidFill>
-                      <a:prstDash val="solid"/>
-                      <a:round/>
-                      <a:headEnd type="none" w="med" len="med"/>
-                      <a:tailEnd type="none" w="med" len="med"/>
-                    </a:lnL>
-                    <a:lnR w="6350" cap="flat" cmpd="sng" algn="ctr">
-                      <a:solidFill>
-                        <a:srgbClr val="D6CFC4"/>
-                      </a:solidFill>
-                      <a:prstDash val="solid"/>
-                      <a:round/>
-                      <a:headEnd type="none" w="med" len="med"/>
-                      <a:tailEnd type="none" w="med" len="med"/>
-                    </a:lnR>
-                    <a:lnT w="6350" cap="flat" cmpd="sng" algn="ctr">
-                      <a:solidFill>
-                        <a:srgbClr val="D6CFC4"/>
-                      </a:solidFill>
-                      <a:prstDash val="solid"/>
-                      <a:round/>
-                      <a:headEnd type="none" w="med" len="med"/>
-                      <a:tailEnd type="none" w="med" len="med"/>
-                    </a:lnT>
-                    <a:lnB w="6350" cap="flat" cmpd="sng" algn="ctr">
-                      <a:solidFill>
-                        <a:srgbClr val="D6CFC4"/>
-                      </a:solidFill>
-                      <a:prstDash val="solid"/>
-                      <a:round/>
-                      <a:headEnd type="none" w="med" len="med"/>
-                      <a:tailEnd type="none" w="med" len="med"/>
-                    </a:lnB>
-                    <a:solidFill>
-                      <a:srgbClr val="FAF7F2"/>
-                    </a:solidFill>
-                  </a:tcPr>
-                </a:tc>
-                <a:tc>
-                  <a:txBody>
-                    <a:bodyPr/>
-                    <a:lstStyle/>
-                    <a:p>
-                      <a:pPr algn="ctr" indent="0" marL="0">
-                        <a:buNone/>
-                      </a:pPr>
-                      <a:r>
-                        <a:rPr lang="en-US" sz="900" dirty="0">
-                          <a:solidFill>
-                            <a:srgbClr val="2D2A26"/>
-                          </a:solidFill>
-                          <a:latin typeface="Calibri" pitchFamily="34" charset="0"/>
-                          <a:ea typeface="Calibri" pitchFamily="34" charset="-122"/>
-                          <a:cs typeface="Calibri" pitchFamily="34" charset="-120"/>
-                        </a:rPr>
-                        <a:t>$-59,801</a:t>
+                        <a:t>$0</a:t>
                       </a:r>
                       <a:endParaRPr lang="en-US" sz="900" dirty="0">
                         <a:latin typeface="Calibri" charset="0"/>
@@ -19949,7 +19949,7 @@
                           <a:ea typeface="Calibri" pitchFamily="34" charset="-122"/>
                           <a:cs typeface="Calibri" pitchFamily="34" charset="-120"/>
                         </a:rPr>
-                        <a:t>$1,885,356</a:t>
+                        <a:t>$1,912,932</a:t>
                       </a:r>
                       <a:endParaRPr lang="en-US" sz="950" dirty="0">
                         <a:latin typeface="Calibri" charset="0"/>
@@ -20017,7 +20017,7 @@
                           <a:ea typeface="Calibri" pitchFamily="34" charset="-122"/>
                           <a:cs typeface="Calibri" pitchFamily="34" charset="-120"/>
                         </a:rPr>
-                        <a:t>$-330,066</a:t>
+                        <a:t>$-324,695</a:t>
                       </a:r>
                       <a:endParaRPr lang="en-US" sz="950" dirty="0">
                         <a:latin typeface="Calibri" charset="0"/>
@@ -20085,7 +20085,7 @@
                           <a:ea typeface="Calibri" pitchFamily="34" charset="-122"/>
                           <a:cs typeface="Calibri" pitchFamily="34" charset="-120"/>
                         </a:rPr>
-                        <a:t>$-1,033,683</a:t>
+                        <a:t>$-1,232,685</a:t>
                       </a:r>
                       <a:endParaRPr lang="en-US" sz="950" dirty="0">
                         <a:latin typeface="Calibri" charset="0"/>
@@ -20153,7 +20153,7 @@
                           <a:ea typeface="Calibri" pitchFamily="34" charset="-122"/>
                           <a:cs typeface="Calibri" pitchFamily="34" charset="-120"/>
                         </a:rPr>
-                        <a:t>$521,608</a:t>
+                        <a:t>$355,552</a:t>
                       </a:r>
                       <a:endParaRPr lang="en-US" sz="950" dirty="0">
                         <a:latin typeface="Calibri" charset="0"/>
@@ -20221,7 +20221,7 @@
                           <a:ea typeface="Calibri" pitchFamily="34" charset="-122"/>
                           <a:cs typeface="Calibri" pitchFamily="34" charset="-120"/>
                         </a:rPr>
-                        <a:t>27.7%</a:t>
+                        <a:t>18.6%</a:t>
                       </a:r>
                       <a:endParaRPr lang="en-US" sz="950" dirty="0">
                         <a:latin typeface="Calibri" charset="0"/>
@@ -20289,7 +20289,7 @@
                           <a:ea typeface="Calibri" pitchFamily="34" charset="-122"/>
                           <a:cs typeface="Calibri" pitchFamily="34" charset="-120"/>
                         </a:rPr>
-                        <a:t>$-507,344</a:t>
+                        <a:t>$-334,214</a:t>
                       </a:r>
                       <a:endParaRPr lang="en-US" sz="950" dirty="0">
                         <a:latin typeface="Calibri" charset="0"/>
@@ -20474,7 +20474,7 @@
                 <a:ea typeface="Century Gothic" pitchFamily="34" charset="-122"/>
                 <a:cs typeface="Century Gothic" pitchFamily="34" charset="-120"/>
               </a:rPr>
-              <a:t>$1,885,356</a:t>
+              <a:t>$1,912,932</a:t>
             </a:r>
             <a:endParaRPr lang="en-US" sz="2000" dirty="0"/>
           </a:p>
@@ -20609,7 +20609,7 @@
                 <a:ea typeface="Century Gothic" pitchFamily="34" charset="-122"/>
                 <a:cs typeface="Century Gothic" pitchFamily="34" charset="-120"/>
               </a:rPr>
-              <a:t>$521,608</a:t>
+              <a:t>$355,552</a:t>
             </a:r>
             <a:endParaRPr lang="en-US" sz="2000" dirty="0"/>
           </a:p>
@@ -20744,7 +20744,7 @@
                 <a:ea typeface="Century Gothic" pitchFamily="34" charset="-122"/>
                 <a:cs typeface="Century Gothic" pitchFamily="34" charset="-120"/>
               </a:rPr>
-              <a:t>27.7%</a:t>
+              <a:t>18.6%</a:t>
             </a:r>
             <a:endParaRPr lang="en-US" sz="2000" dirty="0"/>
           </a:p>

</xml_diff>

<commit_message>
Auto-build: 2026-03-11 17:22 UTC
</commit_message>
<xml_diff>
--- a/reports/2026-01.pptx
+++ b/reports/2026-01.pptx
@@ -262,10 +262,10 @@
                 <c:formatCode>General</c:formatCode>
                 <c:ptCount val="5"/>
                 <c:pt idx="0">
-                  <c:v>103</c:v>
+                  <c:v>70</c:v>
                 </c:pt>
                 <c:pt idx="1">
-                  <c:v>1</c:v>
+                  <c:v>65</c:v>
                 </c:pt>
                 <c:pt idx="2">
                   <c:v>26</c:v>
@@ -274,7 +274,7 @@
                   <c:v>25</c:v>
                 </c:pt>
                 <c:pt idx="4">
-                  <c:v>1</c:v>
+                  <c:v>27</c:v>
                 </c:pt>
               </c:numCache>
             </c:numRef>
@@ -884,7 +884,7 @@
                 <c:formatCode>General</c:formatCode>
                 <c:ptCount val="5"/>
                 <c:pt idx="0">
-                  <c:v>2069728.877</c:v>
+                  <c:v>2103650.315</c:v>
                 </c:pt>
                 <c:pt idx="1">
                   <c:v>1080878.933</c:v>
@@ -896,7 +896,7 @@
                   <c:v>372652.1739</c:v>
                 </c:pt>
                 <c:pt idx="4">
-                  <c:v>83007.24638</c:v>
+                  <c:v>79825.78397</c:v>
                 </c:pt>
               </c:numCache>
             </c:numRef>
@@ -1195,7 +1195,7 @@
                 <c:formatCode>General</c:formatCode>
                 <c:ptCount val="5"/>
                 <c:pt idx="0">
-                  <c:v>209.932942</c:v>
+                  <c:v>214.789699</c:v>
                 </c:pt>
                 <c:pt idx="1">
                   <c:v>218.315276</c:v>
@@ -1207,7 +1207,7 @@
                   <c:v>425.402025</c:v>
                 </c:pt>
                 <c:pt idx="4">
-                  <c:v>226.795755</c:v>
+                  <c:v>218.103235</c:v>
                 </c:pt>
               </c:numCache>
             </c:numRef>
@@ -1506,7 +1506,7 @@
                 <c:formatCode>General</c:formatCode>
                 <c:ptCount val="5"/>
                 <c:pt idx="0">
-                  <c:v>219</c:v>
+                  <c:v>218</c:v>
                 </c:pt>
                 <c:pt idx="1">
                   <c:v>134</c:v>
@@ -1817,7 +1817,7 @@
                 <c:formatCode>General</c:formatCode>
                 <c:ptCount val="5"/>
                 <c:pt idx="0">
-                  <c:v>7095911.809</c:v>
+                  <c:v>7255634.044</c:v>
                 </c:pt>
                 <c:pt idx="1">
                   <c:v>4786073.167</c:v>
@@ -1829,7 +1829,7 @@
                   <c:v>1427026.151</c:v>
                 </c:pt>
                 <c:pt idx="4">
-                  <c:v>577267.6961</c:v>
+                  <c:v>555142.4534</c:v>
                 </c:pt>
               </c:numCache>
             </c:numRef>
@@ -2128,10 +2128,10 @@
                 <c:formatCode>General</c:formatCode>
                 <c:ptCount val="5"/>
                 <c:pt idx="0">
-                  <c:v>-1249</c:v>
+                  <c:v>-7518</c:v>
                 </c:pt>
                 <c:pt idx="1">
-                  <c:v>0</c:v>
+                  <c:v>-2895</c:v>
                 </c:pt>
                 <c:pt idx="2">
                   <c:v>-5264</c:v>
@@ -2140,7 +2140,7 @@
                   <c:v>-2042</c:v>
                 </c:pt>
                 <c:pt idx="4">
-                  <c:v>-17</c:v>
+                  <c:v>0</c:v>
                 </c:pt>
               </c:numCache>
             </c:numRef>
@@ -2439,10 +2439,10 @@
                 <c:formatCode>General</c:formatCode>
                 <c:ptCount val="5"/>
                 <c:pt idx="0">
-                  <c:v>-288</c:v>
+                  <c:v>-841</c:v>
                 </c:pt>
                 <c:pt idx="1">
-                  <c:v>0</c:v>
+                  <c:v>-346</c:v>
                 </c:pt>
                 <c:pt idx="2">
                   <c:v>-716</c:v>
@@ -2451,7 +2451,7 @@
                   <c:v>-388</c:v>
                 </c:pt>
                 <c:pt idx="4">
-                  <c:v>-3</c:v>
+                  <c:v>0</c:v>
                 </c:pt>
               </c:numCache>
             </c:numRef>
@@ -2750,10 +2750,10 @@
                 <c:formatCode>General</c:formatCode>
                 <c:ptCount val="5"/>
                 <c:pt idx="0">
-                  <c:v>-60</c:v>
+                  <c:v>-156</c:v>
                 </c:pt>
                 <c:pt idx="1">
-                  <c:v>0</c:v>
+                  <c:v>-23</c:v>
                 </c:pt>
                 <c:pt idx="2">
                   <c:v>-19</c:v>
@@ -2762,7 +2762,7 @@
                   <c:v>-62</c:v>
                 </c:pt>
                 <c:pt idx="4">
-                  <c:v>-3</c:v>
+                  <c:v>0</c:v>
                 </c:pt>
               </c:numCache>
             </c:numRef>
@@ -5429,13 +5429,13 @@
             <a:r>
               <a:rPr lang="en-US" sz="1000" b="1" dirty="0">
                 <a:solidFill>
-                  <a:srgbClr val="1A7A6E"/>
+                  <a:srgbClr val="718096"/>
                 </a:solidFill>
                 <a:latin typeface="Calibri" pitchFamily="34" charset="0"/>
                 <a:ea typeface="Calibri" pitchFamily="34" charset="-122"/>
                 <a:cs typeface="Calibri" pitchFamily="34" charset="-120"/>
               </a:rPr>
-              <a:t>-66.8%</a:t>
+              <a:t>—</a:t>
             </a:r>
             <a:endParaRPr lang="en-US" sz="1000" dirty="0"/>
           </a:p>
@@ -6035,13 +6035,13 @@
             <a:r>
               <a:rPr lang="en-US" sz="1000" b="1" dirty="0">
                 <a:solidFill>
-                  <a:srgbClr val="1A7A6E"/>
+                  <a:srgbClr val="718096"/>
                 </a:solidFill>
                 <a:latin typeface="Calibri" pitchFamily="34" charset="0"/>
                 <a:ea typeface="Calibri" pitchFamily="34" charset="-122"/>
                 <a:cs typeface="Calibri" pitchFamily="34" charset="-120"/>
               </a:rPr>
-              <a:t>-31.6%</a:t>
+              <a:t>—</a:t>
             </a:r>
             <a:endParaRPr lang="en-US" sz="1000" dirty="0"/>
           </a:p>
@@ -6641,13 +6641,13 @@
             <a:r>
               <a:rPr lang="en-US" sz="1000" b="1" dirty="0">
                 <a:solidFill>
-                  <a:srgbClr val="1A7A6E"/>
+                  <a:srgbClr val="718096"/>
                 </a:solidFill>
                 <a:latin typeface="Calibri" pitchFamily="34" charset="0"/>
                 <a:ea typeface="Calibri" pitchFamily="34" charset="-122"/>
                 <a:cs typeface="Calibri" pitchFamily="34" charset="-120"/>
               </a:rPr>
-              <a:t>-61.5%</a:t>
+              <a:t>—</a:t>
             </a:r>
             <a:endParaRPr lang="en-US" sz="1000" dirty="0"/>
           </a:p>
@@ -7505,7 +7505,7 @@
                 <a:ea typeface="Century Gothic" pitchFamily="34" charset="-122"/>
                 <a:cs typeface="Century Gothic" pitchFamily="34" charset="-120"/>
               </a:rPr>
-              <a:t>26,845</a:t>
+              <a:t>18,579</a:t>
             </a:r>
             <a:endParaRPr lang="en-US" sz="2000" dirty="0"/>
           </a:p>
@@ -7640,7 +7640,7 @@
                 <a:ea typeface="Century Gothic" pitchFamily="34" charset="-122"/>
                 <a:cs typeface="Century Gothic" pitchFamily="34" charset="-120"/>
               </a:rPr>
-              <a:t>2</a:t>
+              <a:t>56</a:t>
             </a:r>
             <a:endParaRPr lang="en-US" sz="2000" dirty="0"/>
           </a:p>
@@ -7775,7 +7775,7 @@
                 <a:ea typeface="Century Gothic" pitchFamily="34" charset="-122"/>
                 <a:cs typeface="Century Gothic" pitchFamily="34" charset="-120"/>
               </a:rPr>
-              <a:t>10,834</a:t>
+              <a:t>330</a:t>
             </a:r>
             <a:endParaRPr lang="en-US" sz="2000" dirty="0"/>
           </a:p>
@@ -9783,7 +9783,7 @@
                 <a:ea typeface="Century Gothic" pitchFamily="34" charset="-122"/>
                 <a:cs typeface="Century Gothic" pitchFamily="34" charset="-120"/>
               </a:rPr>
-              <a:t>$3,834,132</a:t>
+              <a:t>$3,864,872</a:t>
             </a:r>
             <a:endParaRPr lang="en-US" sz="2000" dirty="0"/>
           </a:p>
@@ -10252,7 +10252,7 @@
                 <a:ea typeface="Century Gothic" pitchFamily="34" charset="-122"/>
                 <a:cs typeface="Century Gothic" pitchFamily="34" charset="-120"/>
               </a:rPr>
-              <a:t>9,890</a:t>
+              <a:t>100</a:t>
             </a:r>
             <a:endParaRPr lang="en-US" sz="1200" dirty="0"/>
           </a:p>
@@ -10561,7 +10561,7 @@
                 <a:ea typeface="Century Gothic" pitchFamily="34" charset="-122"/>
                 <a:cs typeface="Century Gothic" pitchFamily="34" charset="-120"/>
               </a:rPr>
-              <a:t>733</a:t>
+              <a:t>19</a:t>
             </a:r>
             <a:endParaRPr lang="en-US" sz="1200" dirty="0"/>
           </a:p>
@@ -12386,7 +12386,7 @@
                 <a:ea typeface="Century Gothic" pitchFamily="34" charset="-122"/>
                 <a:cs typeface="Century Gothic" pitchFamily="34" charset="-120"/>
               </a:rPr>
-              <a:t>$15,425,098</a:t>
+              <a:t>$15,562,695</a:t>
             </a:r>
             <a:endParaRPr lang="en-US" sz="2000" dirty="0"/>
           </a:p>
@@ -15438,7 +15438,7 @@
                           <a:ea typeface="Calibri" pitchFamily="34" charset="-122"/>
                           <a:cs typeface="Calibri" pitchFamily="34" charset="-120"/>
                         </a:rPr>
-                        <a:t>11.1%</a:t>
+                        <a:t>9.4%</a:t>
                       </a:r>
                       <a:endParaRPr lang="en-US" sz="950" dirty="0">
                         <a:latin typeface="Calibri" charset="0"/>
@@ -15506,7 +15506,7 @@
                           <a:ea typeface="Calibri" pitchFamily="34" charset="-122"/>
                           <a:cs typeface="Calibri" pitchFamily="34" charset="-120"/>
                         </a:rPr>
-                        <a:t>+1109 bps</a:t>
+                        <a:t>+944 bps</a:t>
                       </a:r>
                       <a:endParaRPr lang="en-US" sz="950" dirty="0">
                         <a:latin typeface="Calibri" charset="0"/>
@@ -15712,7 +15712,7 @@
                           <a:ea typeface="Calibri" pitchFamily="34" charset="-122"/>
                           <a:cs typeface="Calibri" pitchFamily="34" charset="-120"/>
                         </a:rPr>
-                        <a:t>8.4%</a:t>
+                        <a:t>6.5%</a:t>
                       </a:r>
                       <a:endParaRPr lang="en-US" sz="950" dirty="0">
                         <a:latin typeface="Calibri" charset="0"/>
@@ -15780,7 +15780,7 @@
                           <a:ea typeface="Calibri" pitchFamily="34" charset="-122"/>
                           <a:cs typeface="Calibri" pitchFamily="34" charset="-120"/>
                         </a:rPr>
-                        <a:t>+842 bps</a:t>
+                        <a:t>+649 bps</a:t>
                       </a:r>
                       <a:endParaRPr lang="en-US" sz="950" dirty="0">
                         <a:latin typeface="Calibri" charset="0"/>
@@ -16534,7 +16534,7 @@
                           <a:ea typeface="Calibri" pitchFamily="34" charset="-122"/>
                           <a:cs typeface="Calibri" pitchFamily="34" charset="-120"/>
                         </a:rPr>
-                        <a:t>22.1%</a:t>
+                        <a:t>18.6%</a:t>
                       </a:r>
                       <a:endParaRPr lang="en-US" sz="950" dirty="0">
                         <a:latin typeface="Calibri" charset="0"/>
@@ -16602,7 +16602,7 @@
                           <a:ea typeface="Calibri" pitchFamily="34" charset="-122"/>
                           <a:cs typeface="Calibri" pitchFamily="34" charset="-120"/>
                         </a:rPr>
-                        <a:t>+2211 bps</a:t>
+                        <a:t>+1857 bps</a:t>
                       </a:r>
                       <a:endParaRPr lang="en-US" sz="950" dirty="0">
                         <a:latin typeface="Calibri" charset="0"/>
@@ -17559,7 +17559,7 @@
                           <a:ea typeface="Calibri" pitchFamily="34" charset="-122"/>
                           <a:cs typeface="Calibri" pitchFamily="34" charset="-120"/>
                         </a:rPr>
-                        <a:t>$871,059</a:t>
+                        <a:t>$716,856</a:t>
                       </a:r>
                       <a:endParaRPr lang="en-US" sz="900" dirty="0">
                         <a:latin typeface="Calibri" charset="0"/>
@@ -17627,7 +17627,7 @@
                           <a:ea typeface="Calibri" pitchFamily="34" charset="-122"/>
                           <a:cs typeface="Calibri" pitchFamily="34" charset="-120"/>
                         </a:rPr>
-                        <a:t>$-147,088</a:t>
+                        <a:t>$-153,200</a:t>
                       </a:r>
                       <a:endParaRPr lang="en-US" sz="900" dirty="0">
                         <a:latin typeface="Calibri" charset="0"/>
@@ -17695,7 +17695,75 @@
                           <a:ea typeface="Calibri" pitchFamily="34" charset="-122"/>
                           <a:cs typeface="Calibri" pitchFamily="34" charset="-120"/>
                         </a:rPr>
-                        <a:t>$-495,207</a:t>
+                        <a:t>$-897,871</a:t>
+                      </a:r>
+                      <a:endParaRPr lang="en-US" sz="900" dirty="0">
+                        <a:latin typeface="Calibri" charset="0"/>
+                        <a:ea typeface="Calibri" charset="0"/>
+                        <a:cs typeface="Calibri" charset="0"/>
+                      </a:endParaRPr>
+                    </a:p>
+                  </a:txBody>
+                  <a:tcPr marL="91440" marR="91440" marT="45720" marB="45720" anchor="ctr">
+                    <a:lnL w="6350" cap="flat" cmpd="sng" algn="ctr">
+                      <a:solidFill>
+                        <a:srgbClr val="D6CFC4"/>
+                      </a:solidFill>
+                      <a:prstDash val="solid"/>
+                      <a:round/>
+                      <a:headEnd type="none" w="med" len="med"/>
+                      <a:tailEnd type="none" w="med" len="med"/>
+                    </a:lnL>
+                    <a:lnR w="6350" cap="flat" cmpd="sng" algn="ctr">
+                      <a:solidFill>
+                        <a:srgbClr val="D6CFC4"/>
+                      </a:solidFill>
+                      <a:prstDash val="solid"/>
+                      <a:round/>
+                      <a:headEnd type="none" w="med" len="med"/>
+                      <a:tailEnd type="none" w="med" len="med"/>
+                    </a:lnR>
+                    <a:lnT w="6350" cap="flat" cmpd="sng" algn="ctr">
+                      <a:solidFill>
+                        <a:srgbClr val="D6CFC4"/>
+                      </a:solidFill>
+                      <a:prstDash val="solid"/>
+                      <a:round/>
+                      <a:headEnd type="none" w="med" len="med"/>
+                      <a:tailEnd type="none" w="med" len="med"/>
+                    </a:lnT>
+                    <a:lnB w="6350" cap="flat" cmpd="sng" algn="ctr">
+                      <a:solidFill>
+                        <a:srgbClr val="D6CFC4"/>
+                      </a:solidFill>
+                      <a:prstDash val="solid"/>
+                      <a:round/>
+                      <a:headEnd type="none" w="med" len="med"/>
+                      <a:tailEnd type="none" w="med" len="med"/>
+                    </a:lnB>
+                    <a:solidFill>
+                      <a:srgbClr val="FFFFFF"/>
+                    </a:solidFill>
+                  </a:tcPr>
+                </a:tc>
+                <a:tc>
+                  <a:txBody>
+                    <a:bodyPr/>
+                    <a:lstStyle/>
+                    <a:p>
+                      <a:pPr algn="ctr" indent="0" marL="0">
+                        <a:buNone/>
+                      </a:pPr>
+                      <a:r>
+                        <a:rPr lang="en-US" sz="900" dirty="0">
+                          <a:solidFill>
+                            <a:srgbClr val="C0392B"/>
+                          </a:solidFill>
+                          <a:latin typeface="Calibri" pitchFamily="34" charset="0"/>
+                          <a:ea typeface="Calibri" pitchFamily="34" charset="-122"/>
+                          <a:cs typeface="Calibri" pitchFamily="34" charset="-120"/>
+                        </a:rPr>
+                        <a:t>$-334,214</a:t>
                       </a:r>
                       <a:endParaRPr lang="en-US" sz="900" dirty="0">
                         <a:latin typeface="Calibri" charset="0"/>
@@ -17763,7 +17831,7 @@
                           <a:ea typeface="Calibri" pitchFamily="34" charset="-122"/>
                           <a:cs typeface="Calibri" pitchFamily="34" charset="-120"/>
                         </a:rPr>
-                        <a:t>$228,764</a:t>
+                        <a:t>-46.6%</a:t>
                       </a:r>
                       <a:endParaRPr lang="en-US" sz="900" dirty="0">
                         <a:latin typeface="Calibri" charset="0"/>
@@ -17831,75 +17899,7 @@
                           <a:ea typeface="Calibri" pitchFamily="34" charset="-122"/>
                           <a:cs typeface="Calibri" pitchFamily="34" charset="-120"/>
                         </a:rPr>
-                        <a:t>26.3%</a:t>
-                      </a:r>
-                      <a:endParaRPr lang="en-US" sz="900" dirty="0">
-                        <a:latin typeface="Calibri" charset="0"/>
-                        <a:ea typeface="Calibri" charset="0"/>
-                        <a:cs typeface="Calibri" charset="0"/>
-                      </a:endParaRPr>
-                    </a:p>
-                  </a:txBody>
-                  <a:tcPr marL="91440" marR="91440" marT="45720" marB="45720" anchor="ctr">
-                    <a:lnL w="6350" cap="flat" cmpd="sng" algn="ctr">
-                      <a:solidFill>
-                        <a:srgbClr val="D6CFC4"/>
-                      </a:solidFill>
-                      <a:prstDash val="solid"/>
-                      <a:round/>
-                      <a:headEnd type="none" w="med" len="med"/>
-                      <a:tailEnd type="none" w="med" len="med"/>
-                    </a:lnL>
-                    <a:lnR w="6350" cap="flat" cmpd="sng" algn="ctr">
-                      <a:solidFill>
-                        <a:srgbClr val="D6CFC4"/>
-                      </a:solidFill>
-                      <a:prstDash val="solid"/>
-                      <a:round/>
-                      <a:headEnd type="none" w="med" len="med"/>
-                      <a:tailEnd type="none" w="med" len="med"/>
-                    </a:lnR>
-                    <a:lnT w="6350" cap="flat" cmpd="sng" algn="ctr">
-                      <a:solidFill>
-                        <a:srgbClr val="D6CFC4"/>
-                      </a:solidFill>
-                      <a:prstDash val="solid"/>
-                      <a:round/>
-                      <a:headEnd type="none" w="med" len="med"/>
-                      <a:tailEnd type="none" w="med" len="med"/>
-                    </a:lnT>
-                    <a:lnB w="6350" cap="flat" cmpd="sng" algn="ctr">
-                      <a:solidFill>
-                        <a:srgbClr val="D6CFC4"/>
-                      </a:solidFill>
-                      <a:prstDash val="solid"/>
-                      <a:round/>
-                      <a:headEnd type="none" w="med" len="med"/>
-                      <a:tailEnd type="none" w="med" len="med"/>
-                    </a:lnB>
-                    <a:solidFill>
-                      <a:srgbClr val="FFFFFF"/>
-                    </a:solidFill>
-                  </a:tcPr>
-                </a:tc>
-                <a:tc>
-                  <a:txBody>
-                    <a:bodyPr/>
-                    <a:lstStyle/>
-                    <a:p>
-                      <a:pPr algn="ctr" indent="0" marL="0">
-                        <a:buNone/>
-                      </a:pPr>
-                      <a:r>
-                        <a:rPr lang="en-US" sz="900" dirty="0">
-                          <a:solidFill>
-                            <a:srgbClr val="2D2A26"/>
-                          </a:solidFill>
-                          <a:latin typeface="Calibri" pitchFamily="34" charset="0"/>
-                          <a:ea typeface="Calibri" pitchFamily="34" charset="-122"/>
-                          <a:cs typeface="Calibri" pitchFamily="34" charset="-120"/>
-                        </a:rPr>
-                        <a:t>$-334,214</a:t>
+                        <a:t>$0</a:t>
                       </a:r>
                       <a:endParaRPr lang="en-US" sz="900" dirty="0">
                         <a:latin typeface="Calibri" charset="0"/>
@@ -18173,7 +18173,7 @@
                           <a:ea typeface="Calibri" pitchFamily="34" charset="-122"/>
                           <a:cs typeface="Calibri" pitchFamily="34" charset="-120"/>
                         </a:rPr>
-                        <a:t>$-175,503</a:t>
+                        <a:t>$-382,270</a:t>
                       </a:r>
                       <a:endParaRPr lang="en-US" sz="900" dirty="0">
                         <a:latin typeface="Calibri" charset="0"/>
@@ -18241,7 +18241,7 @@
                           <a:ea typeface="Calibri" pitchFamily="34" charset="-122"/>
                           <a:cs typeface="Calibri" pitchFamily="34" charset="-120"/>
                         </a:rPr>
-                        <a:t>$369,337</a:t>
+                        <a:t>$162,571</a:t>
                       </a:r>
                       <a:endParaRPr lang="en-US" sz="900" dirty="0">
                         <a:latin typeface="Calibri" charset="0"/>
@@ -18309,7 +18309,7 @@
                           <a:ea typeface="Calibri" pitchFamily="34" charset="-122"/>
                           <a:cs typeface="Calibri" pitchFamily="34" charset="-120"/>
                         </a:rPr>
-                        <a:t>60.0%</a:t>
+                        <a:t>26.4%</a:t>
                       </a:r>
                       <a:endParaRPr lang="en-US" sz="900" dirty="0">
                         <a:latin typeface="Calibri" charset="0"/>
@@ -19471,7 +19471,7 @@
                           <a:ea typeface="Calibri" pitchFamily="34" charset="-122"/>
                           <a:cs typeface="Calibri" pitchFamily="34" charset="-120"/>
                         </a:rPr>
-                        <a:t>$67,009</a:t>
+                        <a:t>$0</a:t>
                       </a:r>
                       <a:endParaRPr lang="en-US" sz="900" dirty="0">
                         <a:latin typeface="Calibri" charset="0"/>
@@ -19539,7 +19539,7 @@
                           <a:ea typeface="Calibri" pitchFamily="34" charset="-122"/>
                           <a:cs typeface="Calibri" pitchFamily="34" charset="-120"/>
                         </a:rPr>
-                        <a:t>$-34,270</a:t>
+                        <a:t>$0</a:t>
                       </a:r>
                       <a:endParaRPr lang="en-US" sz="900" dirty="0">
                         <a:latin typeface="Calibri" charset="0"/>
@@ -19607,75 +19607,7 @@
                           <a:ea typeface="Calibri" pitchFamily="34" charset="-122"/>
                           <a:cs typeface="Calibri" pitchFamily="34" charset="-120"/>
                         </a:rPr>
-                        <a:t>$-102,159</a:t>
-                      </a:r>
-                      <a:endParaRPr lang="en-US" sz="900" dirty="0">
-                        <a:latin typeface="Calibri" charset="0"/>
-                        <a:ea typeface="Calibri" charset="0"/>
-                        <a:cs typeface="Calibri" charset="0"/>
-                      </a:endParaRPr>
-                    </a:p>
-                  </a:txBody>
-                  <a:tcPr marL="91440" marR="91440" marT="45720" marB="45720" anchor="ctr">
-                    <a:lnL w="6350" cap="flat" cmpd="sng" algn="ctr">
-                      <a:solidFill>
-                        <a:srgbClr val="D6CFC4"/>
-                      </a:solidFill>
-                      <a:prstDash val="solid"/>
-                      <a:round/>
-                      <a:headEnd type="none" w="med" len="med"/>
-                      <a:tailEnd type="none" w="med" len="med"/>
-                    </a:lnL>
-                    <a:lnR w="6350" cap="flat" cmpd="sng" algn="ctr">
-                      <a:solidFill>
-                        <a:srgbClr val="D6CFC4"/>
-                      </a:solidFill>
-                      <a:prstDash val="solid"/>
-                      <a:round/>
-                      <a:headEnd type="none" w="med" len="med"/>
-                      <a:tailEnd type="none" w="med" len="med"/>
-                    </a:lnR>
-                    <a:lnT w="6350" cap="flat" cmpd="sng" algn="ctr">
-                      <a:solidFill>
-                        <a:srgbClr val="D6CFC4"/>
-                      </a:solidFill>
-                      <a:prstDash val="solid"/>
-                      <a:round/>
-                      <a:headEnd type="none" w="med" len="med"/>
-                      <a:tailEnd type="none" w="med" len="med"/>
-                    </a:lnT>
-                    <a:lnB w="6350" cap="flat" cmpd="sng" algn="ctr">
-                      <a:solidFill>
-                        <a:srgbClr val="D6CFC4"/>
-                      </a:solidFill>
-                      <a:prstDash val="solid"/>
-                      <a:round/>
-                      <a:headEnd type="none" w="med" len="med"/>
-                      <a:tailEnd type="none" w="med" len="med"/>
-                    </a:lnB>
-                    <a:solidFill>
-                      <a:srgbClr val="FFFFFF"/>
-                    </a:solidFill>
-                  </a:tcPr>
-                </a:tc>
-                <a:tc>
-                  <a:txBody>
-                    <a:bodyPr/>
-                    <a:lstStyle/>
-                    <a:p>
-                      <a:pPr algn="ctr" indent="0" marL="0">
-                        <a:buNone/>
-                      </a:pPr>
-                      <a:r>
-                        <a:rPr lang="en-US" sz="900" dirty="0">
-                          <a:solidFill>
-                            <a:srgbClr val="C0392B"/>
-                          </a:solidFill>
-                          <a:latin typeface="Calibri" pitchFamily="34" charset="0"/>
-                          <a:ea typeface="Calibri" pitchFamily="34" charset="-122"/>
-                          <a:cs typeface="Calibri" pitchFamily="34" charset="-120"/>
-                        </a:rPr>
-                        <a:t>$-69,419</a:t>
+                        <a:t>$0</a:t>
                       </a:r>
                       <a:endParaRPr lang="en-US" sz="900" dirty="0">
                         <a:latin typeface="Calibri" charset="0"/>
@@ -19743,7 +19675,75 @@
                           <a:ea typeface="Calibri" pitchFamily="34" charset="-122"/>
                           <a:cs typeface="Calibri" pitchFamily="34" charset="-120"/>
                         </a:rPr>
-                        <a:t>-103.6%</a:t>
+                        <a:t>$0</a:t>
+                      </a:r>
+                      <a:endParaRPr lang="en-US" sz="900" dirty="0">
+                        <a:latin typeface="Calibri" charset="0"/>
+                        <a:ea typeface="Calibri" charset="0"/>
+                        <a:cs typeface="Calibri" charset="0"/>
+                      </a:endParaRPr>
+                    </a:p>
+                  </a:txBody>
+                  <a:tcPr marL="91440" marR="91440" marT="45720" marB="45720" anchor="ctr">
+                    <a:lnL w="6350" cap="flat" cmpd="sng" algn="ctr">
+                      <a:solidFill>
+                        <a:srgbClr val="D6CFC4"/>
+                      </a:solidFill>
+                      <a:prstDash val="solid"/>
+                      <a:round/>
+                      <a:headEnd type="none" w="med" len="med"/>
+                      <a:tailEnd type="none" w="med" len="med"/>
+                    </a:lnL>
+                    <a:lnR w="6350" cap="flat" cmpd="sng" algn="ctr">
+                      <a:solidFill>
+                        <a:srgbClr val="D6CFC4"/>
+                      </a:solidFill>
+                      <a:prstDash val="solid"/>
+                      <a:round/>
+                      <a:headEnd type="none" w="med" len="med"/>
+                      <a:tailEnd type="none" w="med" len="med"/>
+                    </a:lnR>
+                    <a:lnT w="6350" cap="flat" cmpd="sng" algn="ctr">
+                      <a:solidFill>
+                        <a:srgbClr val="D6CFC4"/>
+                      </a:solidFill>
+                      <a:prstDash val="solid"/>
+                      <a:round/>
+                      <a:headEnd type="none" w="med" len="med"/>
+                      <a:tailEnd type="none" w="med" len="med"/>
+                    </a:lnT>
+                    <a:lnB w="6350" cap="flat" cmpd="sng" algn="ctr">
+                      <a:solidFill>
+                        <a:srgbClr val="D6CFC4"/>
+                      </a:solidFill>
+                      <a:prstDash val="solid"/>
+                      <a:round/>
+                      <a:headEnd type="none" w="med" len="med"/>
+                      <a:tailEnd type="none" w="med" len="med"/>
+                    </a:lnB>
+                    <a:solidFill>
+                      <a:srgbClr val="FFFFFF"/>
+                    </a:solidFill>
+                  </a:tcPr>
+                </a:tc>
+                <a:tc>
+                  <a:txBody>
+                    <a:bodyPr/>
+                    <a:lstStyle/>
+                    <a:p>
+                      <a:pPr algn="ctr" indent="0" marL="0">
+                        <a:buNone/>
+                      </a:pPr>
+                      <a:r>
+                        <a:rPr lang="en-US" sz="900" dirty="0">
+                          <a:solidFill>
+                            <a:srgbClr val="2D2A26"/>
+                          </a:solidFill>
+                          <a:latin typeface="Calibri" pitchFamily="34" charset="0"/>
+                          <a:ea typeface="Calibri" pitchFamily="34" charset="-122"/>
+                          <a:cs typeface="Calibri" pitchFamily="34" charset="-120"/>
+                        </a:rPr>
+                        <a:t>N/M</a:t>
                       </a:r>
                       <a:endParaRPr lang="en-US" sz="900" dirty="0">
                         <a:latin typeface="Calibri" charset="0"/>
@@ -19949,7 +19949,7 @@
                           <a:ea typeface="Calibri" pitchFamily="34" charset="-122"/>
                           <a:cs typeface="Calibri" pitchFamily="34" charset="-120"/>
                         </a:rPr>
-                        <a:t>$1,912,932</a:t>
+                        <a:t>$1,691,720</a:t>
                       </a:r>
                       <a:endParaRPr lang="en-US" sz="950" dirty="0">
                         <a:latin typeface="Calibri" charset="0"/>
@@ -20017,7 +20017,7 @@
                           <a:ea typeface="Calibri" pitchFamily="34" charset="-122"/>
                           <a:cs typeface="Calibri" pitchFamily="34" charset="-120"/>
                         </a:rPr>
-                        <a:t>$-324,695</a:t>
+                        <a:t>$-296,537</a:t>
                       </a:r>
                       <a:endParaRPr lang="en-US" sz="950" dirty="0">
                         <a:latin typeface="Calibri" charset="0"/>
@@ -20085,7 +20085,7 @@
                           <a:ea typeface="Calibri" pitchFamily="34" charset="-122"/>
                           <a:cs typeface="Calibri" pitchFamily="34" charset="-120"/>
                         </a:rPr>
-                        <a:t>$-1,232,685</a:t>
+                        <a:t>$-1,739,957</a:t>
                       </a:r>
                       <a:endParaRPr lang="en-US" sz="950" dirty="0">
                         <a:latin typeface="Calibri" charset="0"/>
@@ -20147,13 +20147,13 @@
                       <a:r>
                         <a:rPr lang="en-US" sz="950" b="1" dirty="0">
                           <a:solidFill>
-                            <a:srgbClr val="2D2A26"/>
+                            <a:srgbClr val="C0392B"/>
                           </a:solidFill>
                           <a:latin typeface="Calibri" pitchFamily="34" charset="0"/>
                           <a:ea typeface="Calibri" pitchFamily="34" charset="-122"/>
                           <a:cs typeface="Calibri" pitchFamily="34" charset="-120"/>
                         </a:rPr>
-                        <a:t>$355,552</a:t>
+                        <a:t>$-344,774</a:t>
                       </a:r>
                       <a:endParaRPr lang="en-US" sz="950" dirty="0">
                         <a:latin typeface="Calibri" charset="0"/>
@@ -20221,7 +20221,7 @@
                           <a:ea typeface="Calibri" pitchFamily="34" charset="-122"/>
                           <a:cs typeface="Calibri" pitchFamily="34" charset="-120"/>
                         </a:rPr>
-                        <a:t>18.6%</a:t>
+                        <a:t>-20.4%</a:t>
                       </a:r>
                       <a:endParaRPr lang="en-US" sz="950" dirty="0">
                         <a:latin typeface="Calibri" charset="0"/>
@@ -20289,7 +20289,7 @@
                           <a:ea typeface="Calibri" pitchFamily="34" charset="-122"/>
                           <a:cs typeface="Calibri" pitchFamily="34" charset="-120"/>
                         </a:rPr>
-                        <a:t>$-334,214</a:t>
+                        <a:t>$0</a:t>
                       </a:r>
                       <a:endParaRPr lang="en-US" sz="950" dirty="0">
                         <a:latin typeface="Calibri" charset="0"/>
@@ -20474,7 +20474,7 @@
                 <a:ea typeface="Century Gothic" pitchFamily="34" charset="-122"/>
                 <a:cs typeface="Century Gothic" pitchFamily="34" charset="-120"/>
               </a:rPr>
-              <a:t>$1,912,932</a:t>
+              <a:t>$1,691,720</a:t>
             </a:r>
             <a:endParaRPr lang="en-US" sz="2000" dirty="0"/>
           </a:p>
@@ -20609,7 +20609,7 @@
                 <a:ea typeface="Century Gothic" pitchFamily="34" charset="-122"/>
                 <a:cs typeface="Century Gothic" pitchFamily="34" charset="-120"/>
               </a:rPr>
-              <a:t>$355,552</a:t>
+              <a:t>$-344,774</a:t>
             </a:r>
             <a:endParaRPr lang="en-US" sz="2000" dirty="0"/>
           </a:p>
@@ -20744,7 +20744,7 @@
                 <a:ea typeface="Century Gothic" pitchFamily="34" charset="-122"/>
                 <a:cs typeface="Century Gothic" pitchFamily="34" charset="-120"/>
               </a:rPr>
-              <a:t>18.6%</a:t>
+              <a:t>-20.4%</a:t>
             </a:r>
             <a:endParaRPr lang="en-US" sz="2000" dirty="0"/>
           </a:p>

</xml_diff>

<commit_message>
Auto-build: 2026-03-11 19:45 UTC
</commit_message>
<xml_diff>
--- a/reports/2026-01.pptx
+++ b/reports/2026-01.pptx
@@ -262,19 +262,19 @@
                 <c:formatCode>General</c:formatCode>
                 <c:ptCount val="5"/>
                 <c:pt idx="0">
-                  <c:v>70</c:v>
+                  <c:v>103</c:v>
                 </c:pt>
                 <c:pt idx="1">
-                  <c:v>65</c:v>
+                  <c:v>111</c:v>
                 </c:pt>
                 <c:pt idx="2">
-                  <c:v>26</c:v>
+                  <c:v>45</c:v>
                 </c:pt>
                 <c:pt idx="3">
-                  <c:v>25</c:v>
+                  <c:v>57</c:v>
                 </c:pt>
                 <c:pt idx="4">
-                  <c:v>27</c:v>
+                  <c:v>33</c:v>
                 </c:pt>
               </c:numCache>
             </c:numRef>
@@ -576,16 +576,16 @@
                   <c:v>0</c:v>
                 </c:pt>
                 <c:pt idx="1">
-                  <c:v>0</c:v>
+                  <c:v>0.891081</c:v>
                 </c:pt>
                 <c:pt idx="2">
-                  <c:v>0</c:v>
+                  <c:v>0.885795</c:v>
                 </c:pt>
                 <c:pt idx="3">
-                  <c:v>0</c:v>
+                  <c:v>0.831038</c:v>
                 </c:pt>
                 <c:pt idx="4">
-                  <c:v>0</c:v>
+                  <c:v>0.618565</c:v>
                 </c:pt>
               </c:numCache>
             </c:numRef>
@@ -884,19 +884,19 @@
                 <c:formatCode>General</c:formatCode>
                 <c:ptCount val="5"/>
                 <c:pt idx="0">
-                  <c:v>2103650.315</c:v>
+                  <c:v>2069728.877</c:v>
                 </c:pt>
                 <c:pt idx="1">
                   <c:v>1080878.933</c:v>
                 </c:pt>
                 <c:pt idx="2">
-                  <c:v>227864.7372</c:v>
+                  <c:v>210518.4175</c:v>
                 </c:pt>
                 <c:pt idx="3">
-                  <c:v>372652.1739</c:v>
+                  <c:v>493834.2037</c:v>
                 </c:pt>
                 <c:pt idx="4">
-                  <c:v>79825.78397</c:v>
+                  <c:v>83007.24638</c:v>
                 </c:pt>
               </c:numCache>
             </c:numRef>
@@ -1195,19 +1195,19 @@
                 <c:formatCode>General</c:formatCode>
                 <c:ptCount val="5"/>
                 <c:pt idx="0">
-                  <c:v>214.789699</c:v>
+                  <c:v>209.932942</c:v>
                 </c:pt>
                 <c:pt idx="1">
                   <c:v>218.315276</c:v>
                 </c:pt>
                 <c:pt idx="2">
-                  <c:v>252.341902</c:v>
+                  <c:v>233.132245</c:v>
                 </c:pt>
                 <c:pt idx="3">
-                  <c:v>425.402025</c:v>
+                  <c:v>423.165556</c:v>
                 </c:pt>
                 <c:pt idx="4">
-                  <c:v>218.103235</c:v>
+                  <c:v>226.795755</c:v>
                 </c:pt>
               </c:numCache>
             </c:numRef>
@@ -1506,7 +1506,7 @@
                 <c:formatCode>General</c:formatCode>
                 <c:ptCount val="5"/>
                 <c:pt idx="0">
-                  <c:v>218</c:v>
+                  <c:v>219</c:v>
                 </c:pt>
                 <c:pt idx="1">
                   <c:v>134</c:v>
@@ -1515,7 +1515,7 @@
                   <c:v>41</c:v>
                 </c:pt>
                 <c:pt idx="3">
-                  <c:v>29</c:v>
+                  <c:v>39</c:v>
                 </c:pt>
                 <c:pt idx="4">
                   <c:v>23</c:v>
@@ -1817,19 +1817,19 @@
                 <c:formatCode>General</c:formatCode>
                 <c:ptCount val="5"/>
                 <c:pt idx="0">
-                  <c:v>7255634.044</c:v>
+                  <c:v>5610175.933</c:v>
                 </c:pt>
                 <c:pt idx="1">
-                  <c:v>4786073.167</c:v>
+                  <c:v>3784306.511</c:v>
                 </c:pt>
                 <c:pt idx="2">
-                  <c:v>1538818.844</c:v>
+                  <c:v>1124088.812</c:v>
                 </c:pt>
                 <c:pt idx="3">
-                  <c:v>1427026.151</c:v>
+                  <c:v>1169213.148</c:v>
                 </c:pt>
                 <c:pt idx="4">
-                  <c:v>555142.4534</c:v>
+                  <c:v>469005.4218</c:v>
                 </c:pt>
               </c:numCache>
             </c:numRef>
@@ -2128,19 +2128,19 @@
                 <c:formatCode>General</c:formatCode>
                 <c:ptCount val="5"/>
                 <c:pt idx="0">
-                  <c:v>-7518</c:v>
+                  <c:v>-2498</c:v>
                 </c:pt>
                 <c:pt idx="1">
                   <c:v>-2895</c:v>
                 </c:pt>
                 <c:pt idx="2">
-                  <c:v>-5264</c:v>
+                  <c:v>-2145</c:v>
                 </c:pt>
                 <c:pt idx="3">
-                  <c:v>-2042</c:v>
+                  <c:v>-1517</c:v>
                 </c:pt>
                 <c:pt idx="4">
-                  <c:v>0</c:v>
+                  <c:v>-676</c:v>
                 </c:pt>
               </c:numCache>
             </c:numRef>
@@ -2439,19 +2439,19 @@
                 <c:formatCode>General</c:formatCode>
                 <c:ptCount val="5"/>
                 <c:pt idx="0">
-                  <c:v>-841</c:v>
+                  <c:v>-576</c:v>
                 </c:pt>
                 <c:pt idx="1">
                   <c:v>-346</c:v>
                 </c:pt>
                 <c:pt idx="2">
-                  <c:v>-716</c:v>
+                  <c:v>-175</c:v>
                 </c:pt>
                 <c:pt idx="3">
-                  <c:v>-388</c:v>
+                  <c:v>-282</c:v>
                 </c:pt>
                 <c:pt idx="4">
-                  <c:v>0</c:v>
+                  <c:v>-106</c:v>
                 </c:pt>
               </c:numCache>
             </c:numRef>
@@ -2750,19 +2750,19 @@
                 <c:formatCode>General</c:formatCode>
                 <c:ptCount val="5"/>
                 <c:pt idx="0">
-                  <c:v>-156</c:v>
+                  <c:v>-60</c:v>
                 </c:pt>
                 <c:pt idx="1">
                   <c:v>-23</c:v>
                 </c:pt>
                 <c:pt idx="2">
-                  <c:v>-19</c:v>
+                  <c:v>-23</c:v>
                 </c:pt>
                 <c:pt idx="3">
-                  <c:v>-62</c:v>
+                  <c:v>-21</c:v>
                 </c:pt>
                 <c:pt idx="4">
-                  <c:v>0</c:v>
+                  <c:v>-68</c:v>
                 </c:pt>
               </c:numCache>
             </c:numRef>
@@ -5429,13 +5429,13 @@
             <a:r>
               <a:rPr lang="en-US" sz="1000" b="1" dirty="0">
                 <a:solidFill>
-                  <a:srgbClr val="718096"/>
+                  <a:srgbClr val="1A7A6E"/>
                 </a:solidFill>
                 <a:latin typeface="Calibri" pitchFamily="34" charset="0"/>
                 <a:ea typeface="Calibri" pitchFamily="34" charset="-122"/>
                 <a:cs typeface="Calibri" pitchFamily="34" charset="-120"/>
               </a:rPr>
-              <a:t>—</a:t>
+              <a:t>-66.8%</a:t>
             </a:r>
             <a:endParaRPr lang="en-US" sz="1000" dirty="0"/>
           </a:p>
@@ -5507,13 +5507,13 @@
             <a:r>
               <a:rPr lang="en-US" sz="1000" b="1" dirty="0">
                 <a:solidFill>
-                  <a:srgbClr val="718096"/>
+                  <a:srgbClr val="1A7A6E"/>
                 </a:solidFill>
                 <a:latin typeface="Calibri" pitchFamily="34" charset="0"/>
                 <a:ea typeface="Calibri" pitchFamily="34" charset="-122"/>
                 <a:cs typeface="Calibri" pitchFamily="34" charset="-120"/>
               </a:rPr>
-              <a:t>—</a:t>
+              <a:t>-59.3%</a:t>
             </a:r>
             <a:endParaRPr lang="en-US" sz="1000" dirty="0"/>
           </a:p>
@@ -5546,13 +5546,13 @@
             <a:r>
               <a:rPr lang="en-US" sz="1000" b="1" dirty="0">
                 <a:solidFill>
-                  <a:srgbClr val="718096"/>
+                  <a:srgbClr val="1A7A6E"/>
                 </a:solidFill>
                 <a:latin typeface="Calibri" pitchFamily="34" charset="0"/>
                 <a:ea typeface="Calibri" pitchFamily="34" charset="-122"/>
                 <a:cs typeface="Calibri" pitchFamily="34" charset="-120"/>
               </a:rPr>
-              <a:t>—</a:t>
+              <a:t>-25.7%</a:t>
             </a:r>
             <a:endParaRPr lang="en-US" sz="1000" dirty="0"/>
           </a:p>
@@ -6035,13 +6035,13 @@
             <a:r>
               <a:rPr lang="en-US" sz="1000" b="1" dirty="0">
                 <a:solidFill>
-                  <a:srgbClr val="718096"/>
+                  <a:srgbClr val="1A7A6E"/>
                 </a:solidFill>
                 <a:latin typeface="Calibri" pitchFamily="34" charset="0"/>
                 <a:ea typeface="Calibri" pitchFamily="34" charset="-122"/>
                 <a:cs typeface="Calibri" pitchFamily="34" charset="-120"/>
               </a:rPr>
-              <a:t>—</a:t>
+              <a:t>-31.5%</a:t>
             </a:r>
             <a:endParaRPr lang="en-US" sz="1000" dirty="0"/>
           </a:p>
@@ -6113,13 +6113,13 @@
             <a:r>
               <a:rPr lang="en-US" sz="1000" b="1" dirty="0">
                 <a:solidFill>
-                  <a:srgbClr val="718096"/>
+                  <a:srgbClr val="1A7A6E"/>
                 </a:solidFill>
                 <a:latin typeface="Calibri" pitchFamily="34" charset="0"/>
                 <a:ea typeface="Calibri" pitchFamily="34" charset="-122"/>
                 <a:cs typeface="Calibri" pitchFamily="34" charset="-120"/>
               </a:rPr>
-              <a:t>—</a:t>
+              <a:t>-75.6%</a:t>
             </a:r>
             <a:endParaRPr lang="en-US" sz="1000" dirty="0"/>
           </a:p>
@@ -6152,13 +6152,13 @@
             <a:r>
               <a:rPr lang="en-US" sz="1000" b="1" dirty="0">
                 <a:solidFill>
-                  <a:srgbClr val="718096"/>
+                  <a:srgbClr val="1A7A6E"/>
                 </a:solidFill>
                 <a:latin typeface="Calibri" pitchFamily="34" charset="0"/>
                 <a:ea typeface="Calibri" pitchFamily="34" charset="-122"/>
                 <a:cs typeface="Calibri" pitchFamily="34" charset="-120"/>
               </a:rPr>
-              <a:t>—</a:t>
+              <a:t>-27.3%</a:t>
             </a:r>
             <a:endParaRPr lang="en-US" sz="1000" dirty="0"/>
           </a:p>
@@ -6641,13 +6641,13 @@
             <a:r>
               <a:rPr lang="en-US" sz="1000" b="1" dirty="0">
                 <a:solidFill>
-                  <a:srgbClr val="718096"/>
+                  <a:srgbClr val="1A7A6E"/>
                 </a:solidFill>
                 <a:latin typeface="Calibri" pitchFamily="34" charset="0"/>
                 <a:ea typeface="Calibri" pitchFamily="34" charset="-122"/>
                 <a:cs typeface="Calibri" pitchFamily="34" charset="-120"/>
               </a:rPr>
-              <a:t>—</a:t>
+              <a:t>-61.5%</a:t>
             </a:r>
             <a:endParaRPr lang="en-US" sz="1000" dirty="0"/>
           </a:p>
@@ -6719,13 +6719,13 @@
             <a:r>
               <a:rPr lang="en-US" sz="1000" b="1" dirty="0">
                 <a:solidFill>
-                  <a:srgbClr val="718096"/>
+                  <a:srgbClr val="C0392B"/>
                 </a:solidFill>
                 <a:latin typeface="Calibri" pitchFamily="34" charset="0"/>
                 <a:ea typeface="Calibri" pitchFamily="34" charset="-122"/>
                 <a:cs typeface="Calibri" pitchFamily="34" charset="-120"/>
               </a:rPr>
-              <a:t>—</a:t>
+              <a:t>+21.1%</a:t>
             </a:r>
             <a:endParaRPr lang="en-US" sz="1000" dirty="0"/>
           </a:p>
@@ -6758,13 +6758,13 @@
             <a:r>
               <a:rPr lang="en-US" sz="1000" b="1" dirty="0">
                 <a:solidFill>
-                  <a:srgbClr val="718096"/>
+                  <a:srgbClr val="1A7A6E"/>
                 </a:solidFill>
                 <a:latin typeface="Calibri" pitchFamily="34" charset="0"/>
                 <a:ea typeface="Calibri" pitchFamily="34" charset="-122"/>
                 <a:cs typeface="Calibri" pitchFamily="34" charset="-120"/>
               </a:rPr>
-              <a:t>—</a:t>
+              <a:t>-66.1%</a:t>
             </a:r>
             <a:endParaRPr lang="en-US" sz="1000" dirty="0"/>
           </a:p>
@@ -7505,7 +7505,7 @@
                 <a:ea typeface="Century Gothic" pitchFamily="34" charset="-122"/>
                 <a:cs typeface="Century Gothic" pitchFamily="34" charset="-120"/>
               </a:rPr>
-              <a:t>18,579</a:t>
+              <a:t>30,291</a:t>
             </a:r>
             <a:endParaRPr lang="en-US" sz="2000" dirty="0"/>
           </a:p>
@@ -7640,7 +7640,7 @@
                 <a:ea typeface="Century Gothic" pitchFamily="34" charset="-122"/>
                 <a:cs typeface="Century Gothic" pitchFamily="34" charset="-120"/>
               </a:rPr>
-              <a:t>56</a:t>
+              <a:t>87</a:t>
             </a:r>
             <a:endParaRPr lang="en-US" sz="2000" dirty="0"/>
           </a:p>
@@ -7775,7 +7775,7 @@
                 <a:ea typeface="Century Gothic" pitchFamily="34" charset="-122"/>
                 <a:cs typeface="Century Gothic" pitchFamily="34" charset="-120"/>
               </a:rPr>
-              <a:t>330</a:t>
+              <a:t>347</a:t>
             </a:r>
             <a:endParaRPr lang="en-US" sz="2000" dirty="0"/>
           </a:p>
@@ -8431,7 +8431,7 @@
                 <a:ea typeface="Calibri" pitchFamily="34" charset="-122"/>
                 <a:cs typeface="Calibri" pitchFamily="34" charset="-120"/>
               </a:rPr>
-              <a:t>+0 bps</a:t>
+              <a:t>+8911 bps</a:t>
             </a:r>
             <a:endParaRPr lang="en-US" sz="1000" dirty="0"/>
           </a:p>
@@ -8470,7 +8470,7 @@
                 <a:ea typeface="Calibri" pitchFamily="34" charset="-122"/>
                 <a:cs typeface="Calibri" pitchFamily="34" charset="-120"/>
               </a:rPr>
-              <a:t>+0 bps</a:t>
+              <a:t>+8858 bps</a:t>
             </a:r>
             <a:endParaRPr lang="en-US" sz="1000" dirty="0"/>
           </a:p>
@@ -8509,7 +8509,7 @@
                 <a:ea typeface="Calibri" pitchFamily="34" charset="-122"/>
                 <a:cs typeface="Calibri" pitchFamily="34" charset="-120"/>
               </a:rPr>
-              <a:t>+0 bps</a:t>
+              <a:t>+8310 bps</a:t>
             </a:r>
             <a:endParaRPr lang="en-US" sz="1000" dirty="0"/>
           </a:p>
@@ -8548,7 +8548,7 @@
                 <a:ea typeface="Calibri" pitchFamily="34" charset="-122"/>
                 <a:cs typeface="Calibri" pitchFamily="34" charset="-120"/>
               </a:rPr>
-              <a:t>+0 bps</a:t>
+              <a:t>+6186 bps</a:t>
             </a:r>
             <a:endParaRPr lang="en-US" sz="1000" dirty="0"/>
           </a:p>
@@ -8644,7 +8644,7 @@
                 <a:ea typeface="Century Gothic" pitchFamily="34" charset="-122"/>
                 <a:cs typeface="Century Gothic" pitchFamily="34" charset="-120"/>
               </a:rPr>
-              <a:t>0</a:t>
+              <a:t>13,752</a:t>
             </a:r>
             <a:endParaRPr lang="en-US" sz="2000" dirty="0"/>
           </a:p>
@@ -8779,7 +8779,7 @@
                 <a:ea typeface="Century Gothic" pitchFamily="34" charset="-122"/>
                 <a:cs typeface="Century Gothic" pitchFamily="34" charset="-120"/>
               </a:rPr>
-              <a:t>0.0%</a:t>
+              <a:t>45.4%</a:t>
             </a:r>
             <a:endParaRPr lang="en-US" sz="2000" dirty="0"/>
           </a:p>
@@ -8914,7 +8914,7 @@
                 <a:ea typeface="Century Gothic" pitchFamily="34" charset="-122"/>
                 <a:cs typeface="Century Gothic" pitchFamily="34" charset="-120"/>
               </a:rPr>
-              <a:t>+0 bps</a:t>
+              <a:t>+4540 bps</a:t>
             </a:r>
             <a:endParaRPr lang="en-US" sz="2000" dirty="0"/>
           </a:p>
@@ -9783,7 +9783,7 @@
                 <a:ea typeface="Century Gothic" pitchFamily="34" charset="-122"/>
                 <a:cs typeface="Century Gothic" pitchFamily="34" charset="-120"/>
               </a:rPr>
-              <a:t>$3,864,872</a:t>
+              <a:t>$3,937,968</a:t>
             </a:r>
             <a:endParaRPr lang="en-US" sz="2000" dirty="0"/>
           </a:p>
@@ -10561,7 +10561,7 @@
                 <a:ea typeface="Century Gothic" pitchFamily="34" charset="-122"/>
                 <a:cs typeface="Century Gothic" pitchFamily="34" charset="-120"/>
               </a:rPr>
-              <a:t>19</a:t>
+              <a:t>36</a:t>
             </a:r>
             <a:endParaRPr lang="en-US" sz="1200" dirty="0"/>
           </a:p>
@@ -12386,7 +12386,7 @@
                 <a:ea typeface="Century Gothic" pitchFamily="34" charset="-122"/>
                 <a:cs typeface="Century Gothic" pitchFamily="34" charset="-120"/>
               </a:rPr>
-              <a:t>$15,562,695</a:t>
+              <a:t>$12,156,790</a:t>
             </a:r>
             <a:endParaRPr lang="en-US" sz="2000" dirty="0"/>
           </a:p>
@@ -13456,7 +13456,7 @@
                           <a:ea typeface="Calibri" pitchFamily="34" charset="-122"/>
                           <a:cs typeface="Calibri" pitchFamily="34" charset="-120"/>
                         </a:rPr>
-                        <a:t>5.7%</a:t>
+                        <a:t>0.0%</a:t>
                       </a:r>
                       <a:endParaRPr lang="en-US" sz="950" dirty="0">
                         <a:latin typeface="Calibri" charset="0"/>
@@ -13518,13 +13518,13 @@
                       <a:r>
                         <a:rPr lang="en-US" sz="950" dirty="0">
                           <a:solidFill>
-                            <a:srgbClr val="C0392B"/>
+                            <a:srgbClr val="1A7A6E"/>
                           </a:solidFill>
                           <a:latin typeface="Calibri" pitchFamily="34" charset="0"/>
                           <a:ea typeface="Calibri" pitchFamily="34" charset="-122"/>
                           <a:cs typeface="Calibri" pitchFamily="34" charset="-120"/>
                         </a:rPr>
-                        <a:t>+571 bps</a:t>
+                        <a:t>+0 bps</a:t>
                       </a:r>
                       <a:endParaRPr lang="en-US" sz="950" dirty="0">
                         <a:latin typeface="Calibri" charset="0"/>
@@ -13730,7 +13730,7 @@
                           <a:ea typeface="Calibri" pitchFamily="34" charset="-122"/>
                           <a:cs typeface="Calibri" pitchFamily="34" charset="-120"/>
                         </a:rPr>
-                        <a:t>17.1%</a:t>
+                        <a:t>0.0%</a:t>
                       </a:r>
                       <a:endParaRPr lang="en-US" sz="950" dirty="0">
                         <a:latin typeface="Calibri" charset="0"/>
@@ -13792,13 +13792,13 @@
                       <a:r>
                         <a:rPr lang="en-US" sz="950" dirty="0">
                           <a:solidFill>
-                            <a:srgbClr val="C0392B"/>
+                            <a:srgbClr val="1A7A6E"/>
                           </a:solidFill>
                           <a:latin typeface="Calibri" pitchFamily="34" charset="0"/>
                           <a:ea typeface="Calibri" pitchFamily="34" charset="-122"/>
                           <a:cs typeface="Calibri" pitchFamily="34" charset="-120"/>
                         </a:rPr>
-                        <a:t>+1714 bps</a:t>
+                        <a:t>+0 bps</a:t>
                       </a:r>
                       <a:endParaRPr lang="en-US" sz="950" dirty="0">
                         <a:latin typeface="Calibri" charset="0"/>
@@ -14004,7 +14004,7 @@
                           <a:ea typeface="Calibri" pitchFamily="34" charset="-122"/>
                           <a:cs typeface="Calibri" pitchFamily="34" charset="-120"/>
                         </a:rPr>
-                        <a:t>14.0%</a:t>
+                        <a:t>0.0%</a:t>
                       </a:r>
                       <a:endParaRPr lang="en-US" sz="950" dirty="0">
                         <a:latin typeface="Calibri" charset="0"/>
@@ -14066,13 +14066,13 @@
                       <a:r>
                         <a:rPr lang="en-US" sz="950" dirty="0">
                           <a:solidFill>
-                            <a:srgbClr val="C0392B"/>
+                            <a:srgbClr val="1A7A6E"/>
                           </a:solidFill>
                           <a:latin typeface="Calibri" pitchFamily="34" charset="0"/>
                           <a:ea typeface="Calibri" pitchFamily="34" charset="-122"/>
                           <a:cs typeface="Calibri" pitchFamily="34" charset="-120"/>
                         </a:rPr>
-                        <a:t>+1401 bps</a:t>
+                        <a:t>+0 bps</a:t>
                       </a:r>
                       <a:endParaRPr lang="en-US" sz="950" dirty="0">
                         <a:latin typeface="Calibri" charset="0"/>
@@ -14278,7 +14278,7 @@
                           <a:ea typeface="Calibri" pitchFamily="34" charset="-122"/>
                           <a:cs typeface="Calibri" pitchFamily="34" charset="-120"/>
                         </a:rPr>
-                        <a:t>3.3%</a:t>
+                        <a:t>0.0%</a:t>
                       </a:r>
                       <a:endParaRPr lang="en-US" sz="950" dirty="0">
                         <a:latin typeface="Calibri" charset="0"/>
@@ -14340,13 +14340,13 @@
                       <a:r>
                         <a:rPr lang="en-US" sz="950" dirty="0">
                           <a:solidFill>
-                            <a:srgbClr val="C0392B"/>
+                            <a:srgbClr val="1A7A6E"/>
                           </a:solidFill>
                           <a:latin typeface="Calibri" pitchFamily="34" charset="0"/>
                           <a:ea typeface="Calibri" pitchFamily="34" charset="-122"/>
                           <a:cs typeface="Calibri" pitchFamily="34" charset="-120"/>
                         </a:rPr>
-                        <a:t>+330 bps</a:t>
+                        <a:t>+0 bps</a:t>
                       </a:r>
                       <a:endParaRPr lang="en-US" sz="950" dirty="0">
                         <a:latin typeface="Calibri" charset="0"/>
@@ -14552,7 +14552,7 @@
                           <a:ea typeface="Calibri" pitchFamily="34" charset="-122"/>
                           <a:cs typeface="Calibri" pitchFamily="34" charset="-120"/>
                         </a:rPr>
-                        <a:t>19.3%</a:t>
+                        <a:t>0.0%</a:t>
                       </a:r>
                       <a:endParaRPr lang="en-US" sz="950" dirty="0">
                         <a:latin typeface="Calibri" charset="0"/>
@@ -14614,13 +14614,13 @@
                       <a:r>
                         <a:rPr lang="en-US" sz="950" dirty="0">
                           <a:solidFill>
-                            <a:srgbClr val="C0392B"/>
+                            <a:srgbClr val="1A7A6E"/>
                           </a:solidFill>
                           <a:latin typeface="Calibri" pitchFamily="34" charset="0"/>
                           <a:ea typeface="Calibri" pitchFamily="34" charset="-122"/>
                           <a:cs typeface="Calibri" pitchFamily="34" charset="-120"/>
                         </a:rPr>
-                        <a:t>+1934 bps</a:t>
+                        <a:t>+0 bps</a:t>
                       </a:r>
                       <a:endParaRPr lang="en-US" sz="950" dirty="0">
                         <a:latin typeface="Calibri" charset="0"/>
@@ -15438,7 +15438,7 @@
                           <a:ea typeface="Calibri" pitchFamily="34" charset="-122"/>
                           <a:cs typeface="Calibri" pitchFamily="34" charset="-120"/>
                         </a:rPr>
-                        <a:t>9.4%</a:t>
+                        <a:t>11.1%</a:t>
                       </a:r>
                       <a:endParaRPr lang="en-US" sz="950" dirty="0">
                         <a:latin typeface="Calibri" charset="0"/>
@@ -15506,7 +15506,7 @@
                           <a:ea typeface="Calibri" pitchFamily="34" charset="-122"/>
                           <a:cs typeface="Calibri" pitchFamily="34" charset="-120"/>
                         </a:rPr>
-                        <a:t>+944 bps</a:t>
+                        <a:t>+1109 bps</a:t>
                       </a:r>
                       <a:endParaRPr lang="en-US" sz="950" dirty="0">
                         <a:latin typeface="Calibri" charset="0"/>
@@ -15712,7 +15712,7 @@
                           <a:ea typeface="Calibri" pitchFamily="34" charset="-122"/>
                           <a:cs typeface="Calibri" pitchFamily="34" charset="-120"/>
                         </a:rPr>
-                        <a:t>6.5%</a:t>
+                        <a:t>8.4%</a:t>
                       </a:r>
                       <a:endParaRPr lang="en-US" sz="950" dirty="0">
                         <a:latin typeface="Calibri" charset="0"/>
@@ -15780,7 +15780,7 @@
                           <a:ea typeface="Calibri" pitchFamily="34" charset="-122"/>
                           <a:cs typeface="Calibri" pitchFamily="34" charset="-120"/>
                         </a:rPr>
-                        <a:t>+649 bps</a:t>
+                        <a:t>+842 bps</a:t>
                       </a:r>
                       <a:endParaRPr lang="en-US" sz="950" dirty="0">
                         <a:latin typeface="Calibri" charset="0"/>
@@ -15986,7 +15986,7 @@
                           <a:ea typeface="Calibri" pitchFamily="34" charset="-122"/>
                           <a:cs typeface="Calibri" pitchFamily="34" charset="-120"/>
                         </a:rPr>
-                        <a:t>20.0%</a:t>
+                        <a:t>23.6%</a:t>
                       </a:r>
                       <a:endParaRPr lang="en-US" sz="950" dirty="0">
                         <a:latin typeface="Calibri" charset="0"/>
@@ -16054,7 +16054,7 @@
                           <a:ea typeface="Calibri" pitchFamily="34" charset="-122"/>
                           <a:cs typeface="Calibri" pitchFamily="34" charset="-120"/>
                         </a:rPr>
-                        <a:t>+1995 bps</a:t>
+                        <a:t>+2361 bps</a:t>
                       </a:r>
                       <a:endParaRPr lang="en-US" sz="950" dirty="0">
                         <a:latin typeface="Calibri" charset="0"/>
@@ -16260,7 +16260,7 @@
                           <a:ea typeface="Calibri" pitchFamily="34" charset="-122"/>
                           <a:cs typeface="Calibri" pitchFamily="34" charset="-120"/>
                         </a:rPr>
-                        <a:t>2.3%</a:t>
+                        <a:t>2.6%</a:t>
                       </a:r>
                       <a:endParaRPr lang="en-US" sz="950" dirty="0">
                         <a:latin typeface="Calibri" charset="0"/>
@@ -16328,7 +16328,7 @@
                           <a:ea typeface="Calibri" pitchFamily="34" charset="-122"/>
                           <a:cs typeface="Calibri" pitchFamily="34" charset="-120"/>
                         </a:rPr>
-                        <a:t>+234 bps</a:t>
+                        <a:t>+261 bps</a:t>
                       </a:r>
                       <a:endParaRPr lang="en-US" sz="950" dirty="0">
                         <a:latin typeface="Calibri" charset="0"/>
@@ -16534,7 +16534,7 @@
                           <a:ea typeface="Calibri" pitchFamily="34" charset="-122"/>
                           <a:cs typeface="Calibri" pitchFamily="34" charset="-120"/>
                         </a:rPr>
-                        <a:t>18.6%</a:t>
+                        <a:t>22.1%</a:t>
                       </a:r>
                       <a:endParaRPr lang="en-US" sz="950" dirty="0">
                         <a:latin typeface="Calibri" charset="0"/>
@@ -16602,7 +16602,7 @@
                           <a:ea typeface="Calibri" pitchFamily="34" charset="-122"/>
                           <a:cs typeface="Calibri" pitchFamily="34" charset="-120"/>
                         </a:rPr>
-                        <a:t>+1857 bps</a:t>
+                        <a:t>+2211 bps</a:t>
                       </a:r>
                       <a:endParaRPr lang="en-US" sz="950" dirty="0">
                         <a:latin typeface="Calibri" charset="0"/>
@@ -17559,7 +17559,7 @@
                           <a:ea typeface="Calibri" pitchFamily="34" charset="-122"/>
                           <a:cs typeface="Calibri" pitchFamily="34" charset="-120"/>
                         </a:rPr>
-                        <a:t>$716,856</a:t>
+                        <a:t>$871,059</a:t>
                       </a:r>
                       <a:endParaRPr lang="en-US" sz="900" dirty="0">
                         <a:latin typeface="Calibri" charset="0"/>
@@ -17627,7 +17627,7 @@
                           <a:ea typeface="Calibri" pitchFamily="34" charset="-122"/>
                           <a:cs typeface="Calibri" pitchFamily="34" charset="-120"/>
                         </a:rPr>
-                        <a:t>$-153,200</a:t>
+                        <a:t>$-147,088</a:t>
                       </a:r>
                       <a:endParaRPr lang="en-US" sz="900" dirty="0">
                         <a:latin typeface="Calibri" charset="0"/>
@@ -17695,75 +17695,7 @@
                           <a:ea typeface="Calibri" pitchFamily="34" charset="-122"/>
                           <a:cs typeface="Calibri" pitchFamily="34" charset="-120"/>
                         </a:rPr>
-                        <a:t>$-897,871</a:t>
-                      </a:r>
-                      <a:endParaRPr lang="en-US" sz="900" dirty="0">
-                        <a:latin typeface="Calibri" charset="0"/>
-                        <a:ea typeface="Calibri" charset="0"/>
-                        <a:cs typeface="Calibri" charset="0"/>
-                      </a:endParaRPr>
-                    </a:p>
-                  </a:txBody>
-                  <a:tcPr marL="91440" marR="91440" marT="45720" marB="45720" anchor="ctr">
-                    <a:lnL w="6350" cap="flat" cmpd="sng" algn="ctr">
-                      <a:solidFill>
-                        <a:srgbClr val="D6CFC4"/>
-                      </a:solidFill>
-                      <a:prstDash val="solid"/>
-                      <a:round/>
-                      <a:headEnd type="none" w="med" len="med"/>
-                      <a:tailEnd type="none" w="med" len="med"/>
-                    </a:lnL>
-                    <a:lnR w="6350" cap="flat" cmpd="sng" algn="ctr">
-                      <a:solidFill>
-                        <a:srgbClr val="D6CFC4"/>
-                      </a:solidFill>
-                      <a:prstDash val="solid"/>
-                      <a:round/>
-                      <a:headEnd type="none" w="med" len="med"/>
-                      <a:tailEnd type="none" w="med" len="med"/>
-                    </a:lnR>
-                    <a:lnT w="6350" cap="flat" cmpd="sng" algn="ctr">
-                      <a:solidFill>
-                        <a:srgbClr val="D6CFC4"/>
-                      </a:solidFill>
-                      <a:prstDash val="solid"/>
-                      <a:round/>
-                      <a:headEnd type="none" w="med" len="med"/>
-                      <a:tailEnd type="none" w="med" len="med"/>
-                    </a:lnT>
-                    <a:lnB w="6350" cap="flat" cmpd="sng" algn="ctr">
-                      <a:solidFill>
-                        <a:srgbClr val="D6CFC4"/>
-                      </a:solidFill>
-                      <a:prstDash val="solid"/>
-                      <a:round/>
-                      <a:headEnd type="none" w="med" len="med"/>
-                      <a:tailEnd type="none" w="med" len="med"/>
-                    </a:lnB>
-                    <a:solidFill>
-                      <a:srgbClr val="FFFFFF"/>
-                    </a:solidFill>
-                  </a:tcPr>
-                </a:tc>
-                <a:tc>
-                  <a:txBody>
-                    <a:bodyPr/>
-                    <a:lstStyle/>
-                    <a:p>
-                      <a:pPr algn="ctr" indent="0" marL="0">
-                        <a:buNone/>
-                      </a:pPr>
-                      <a:r>
-                        <a:rPr lang="en-US" sz="900" dirty="0">
-                          <a:solidFill>
-                            <a:srgbClr val="C0392B"/>
-                          </a:solidFill>
-                          <a:latin typeface="Calibri" pitchFamily="34" charset="0"/>
-                          <a:ea typeface="Calibri" pitchFamily="34" charset="-122"/>
-                          <a:cs typeface="Calibri" pitchFamily="34" charset="-120"/>
-                        </a:rPr>
-                        <a:t>$-334,214</a:t>
+                        <a:t>$-495,207</a:t>
                       </a:r>
                       <a:endParaRPr lang="en-US" sz="900" dirty="0">
                         <a:latin typeface="Calibri" charset="0"/>
@@ -17831,7 +17763,7 @@
                           <a:ea typeface="Calibri" pitchFamily="34" charset="-122"/>
                           <a:cs typeface="Calibri" pitchFamily="34" charset="-120"/>
                         </a:rPr>
-                        <a:t>-46.6%</a:t>
+                        <a:t>$228,764</a:t>
                       </a:r>
                       <a:endParaRPr lang="en-US" sz="900" dirty="0">
                         <a:latin typeface="Calibri" charset="0"/>
@@ -17899,7 +17831,75 @@
                           <a:ea typeface="Calibri" pitchFamily="34" charset="-122"/>
                           <a:cs typeface="Calibri" pitchFamily="34" charset="-120"/>
                         </a:rPr>
-                        <a:t>$0</a:t>
+                        <a:t>26.3%</a:t>
+                      </a:r>
+                      <a:endParaRPr lang="en-US" sz="900" dirty="0">
+                        <a:latin typeface="Calibri" charset="0"/>
+                        <a:ea typeface="Calibri" charset="0"/>
+                        <a:cs typeface="Calibri" charset="0"/>
+                      </a:endParaRPr>
+                    </a:p>
+                  </a:txBody>
+                  <a:tcPr marL="91440" marR="91440" marT="45720" marB="45720" anchor="ctr">
+                    <a:lnL w="6350" cap="flat" cmpd="sng" algn="ctr">
+                      <a:solidFill>
+                        <a:srgbClr val="D6CFC4"/>
+                      </a:solidFill>
+                      <a:prstDash val="solid"/>
+                      <a:round/>
+                      <a:headEnd type="none" w="med" len="med"/>
+                      <a:tailEnd type="none" w="med" len="med"/>
+                    </a:lnL>
+                    <a:lnR w="6350" cap="flat" cmpd="sng" algn="ctr">
+                      <a:solidFill>
+                        <a:srgbClr val="D6CFC4"/>
+                      </a:solidFill>
+                      <a:prstDash val="solid"/>
+                      <a:round/>
+                      <a:headEnd type="none" w="med" len="med"/>
+                      <a:tailEnd type="none" w="med" len="med"/>
+                    </a:lnR>
+                    <a:lnT w="6350" cap="flat" cmpd="sng" algn="ctr">
+                      <a:solidFill>
+                        <a:srgbClr val="D6CFC4"/>
+                      </a:solidFill>
+                      <a:prstDash val="solid"/>
+                      <a:round/>
+                      <a:headEnd type="none" w="med" len="med"/>
+                      <a:tailEnd type="none" w="med" len="med"/>
+                    </a:lnT>
+                    <a:lnB w="6350" cap="flat" cmpd="sng" algn="ctr">
+                      <a:solidFill>
+                        <a:srgbClr val="D6CFC4"/>
+                      </a:solidFill>
+                      <a:prstDash val="solid"/>
+                      <a:round/>
+                      <a:headEnd type="none" w="med" len="med"/>
+                      <a:tailEnd type="none" w="med" len="med"/>
+                    </a:lnB>
+                    <a:solidFill>
+                      <a:srgbClr val="FFFFFF"/>
+                    </a:solidFill>
+                  </a:tcPr>
+                </a:tc>
+                <a:tc>
+                  <a:txBody>
+                    <a:bodyPr/>
+                    <a:lstStyle/>
+                    <a:p>
+                      <a:pPr algn="ctr" indent="0" marL="0">
+                        <a:buNone/>
+                      </a:pPr>
+                      <a:r>
+                        <a:rPr lang="en-US" sz="900" dirty="0">
+                          <a:solidFill>
+                            <a:srgbClr val="2D2A26"/>
+                          </a:solidFill>
+                          <a:latin typeface="Calibri" pitchFamily="34" charset="0"/>
+                          <a:ea typeface="Calibri" pitchFamily="34" charset="-122"/>
+                          <a:cs typeface="Calibri" pitchFamily="34" charset="-120"/>
+                        </a:rPr>
+                        <a:t>$-334,214</a:t>
                       </a:r>
                       <a:endParaRPr lang="en-US" sz="900" dirty="0">
                         <a:latin typeface="Calibri" charset="0"/>
@@ -18515,7 +18515,7 @@
                           <a:ea typeface="Calibri" pitchFamily="34" charset="-122"/>
                           <a:cs typeface="Calibri" pitchFamily="34" charset="-120"/>
                         </a:rPr>
-                        <a:t>$186,729</a:t>
+                        <a:t>$148,399</a:t>
                       </a:r>
                       <a:endParaRPr lang="en-US" sz="900" dirty="0">
                         <a:latin typeface="Calibri" charset="0"/>
@@ -18583,7 +18583,7 @@
                           <a:ea typeface="Calibri" pitchFamily="34" charset="-122"/>
                           <a:cs typeface="Calibri" pitchFamily="34" charset="-120"/>
                         </a:rPr>
-                        <a:t>$-65,799</a:t>
+                        <a:t>$-70,540</a:t>
                       </a:r>
                       <a:endParaRPr lang="en-US" sz="900" dirty="0">
                         <a:latin typeface="Calibri" charset="0"/>
@@ -18651,7 +18651,7 @@
                           <a:ea typeface="Calibri" pitchFamily="34" charset="-122"/>
                           <a:cs typeface="Calibri" pitchFamily="34" charset="-120"/>
                         </a:rPr>
-                        <a:t>$-234,258</a:t>
+                        <a:t>$-140,209</a:t>
                       </a:r>
                       <a:endParaRPr lang="en-US" sz="900" dirty="0">
                         <a:latin typeface="Calibri" charset="0"/>
@@ -18719,7 +18719,7 @@
                           <a:ea typeface="Calibri" pitchFamily="34" charset="-122"/>
                           <a:cs typeface="Calibri" pitchFamily="34" charset="-120"/>
                         </a:rPr>
-                        <a:t>$-113,329</a:t>
+                        <a:t>$-62,350</a:t>
                       </a:r>
                       <a:endParaRPr lang="en-US" sz="900" dirty="0">
                         <a:latin typeface="Calibri" charset="0"/>
@@ -18787,7 +18787,7 @@
                           <a:ea typeface="Calibri" pitchFamily="34" charset="-122"/>
                           <a:cs typeface="Calibri" pitchFamily="34" charset="-120"/>
                         </a:rPr>
-                        <a:t>-60.7%</a:t>
+                        <a:t>-42.0%</a:t>
                       </a:r>
                       <a:endParaRPr lang="en-US" sz="900" dirty="0">
                         <a:latin typeface="Calibri" charset="0"/>
@@ -18855,7 +18855,7 @@
                           <a:ea typeface="Calibri" pitchFamily="34" charset="-122"/>
                           <a:cs typeface="Calibri" pitchFamily="34" charset="-120"/>
                         </a:rPr>
-                        <a:t>$0</a:t>
+                        <a:t>$-113,329</a:t>
                       </a:r>
                       <a:endParaRPr lang="en-US" sz="900" dirty="0">
                         <a:latin typeface="Calibri" charset="0"/>
@@ -18993,7 +18993,7 @@
                           <a:ea typeface="Calibri" pitchFamily="34" charset="-122"/>
                           <a:cs typeface="Calibri" pitchFamily="34" charset="-120"/>
                         </a:rPr>
-                        <a:t>$172,432</a:t>
+                        <a:t>$183,186</a:t>
                       </a:r>
                       <a:endParaRPr lang="en-US" sz="900" dirty="0">
                         <a:latin typeface="Calibri" charset="0"/>
@@ -19061,7 +19061,7 @@
                           <a:ea typeface="Calibri" pitchFamily="34" charset="-122"/>
                           <a:cs typeface="Calibri" pitchFamily="34" charset="-120"/>
                         </a:rPr>
-                        <a:t>$-6,675</a:t>
+                        <a:t>$-7,306</a:t>
                       </a:r>
                       <a:endParaRPr lang="en-US" sz="900" dirty="0">
                         <a:latin typeface="Calibri" charset="0"/>
@@ -19129,75 +19129,7 @@
                           <a:ea typeface="Calibri" pitchFamily="34" charset="-122"/>
                           <a:cs typeface="Calibri" pitchFamily="34" charset="-120"/>
                         </a:rPr>
-                        <a:t>$-225,558</a:t>
-                      </a:r>
-                      <a:endParaRPr lang="en-US" sz="900" dirty="0">
-                        <a:latin typeface="Calibri" charset="0"/>
-                        <a:ea typeface="Calibri" charset="0"/>
-                        <a:cs typeface="Calibri" charset="0"/>
-                      </a:endParaRPr>
-                    </a:p>
-                  </a:txBody>
-                  <a:tcPr marL="91440" marR="91440" marT="45720" marB="45720" anchor="ctr">
-                    <a:lnL w="6350" cap="flat" cmpd="sng" algn="ctr">
-                      <a:solidFill>
-                        <a:srgbClr val="D6CFC4"/>
-                      </a:solidFill>
-                      <a:prstDash val="solid"/>
-                      <a:round/>
-                      <a:headEnd type="none" w="med" len="med"/>
-                      <a:tailEnd type="none" w="med" len="med"/>
-                    </a:lnL>
-                    <a:lnR w="6350" cap="flat" cmpd="sng" algn="ctr">
-                      <a:solidFill>
-                        <a:srgbClr val="D6CFC4"/>
-                      </a:solidFill>
-                      <a:prstDash val="solid"/>
-                      <a:round/>
-                      <a:headEnd type="none" w="med" len="med"/>
-                      <a:tailEnd type="none" w="med" len="med"/>
-                    </a:lnR>
-                    <a:lnT w="6350" cap="flat" cmpd="sng" algn="ctr">
-                      <a:solidFill>
-                        <a:srgbClr val="D6CFC4"/>
-                      </a:solidFill>
-                      <a:prstDash val="solid"/>
-                      <a:round/>
-                      <a:headEnd type="none" w="med" len="med"/>
-                      <a:tailEnd type="none" w="med" len="med"/>
-                    </a:lnT>
-                    <a:lnB w="6350" cap="flat" cmpd="sng" algn="ctr">
-                      <a:solidFill>
-                        <a:srgbClr val="D6CFC4"/>
-                      </a:solidFill>
-                      <a:prstDash val="solid"/>
-                      <a:round/>
-                      <a:headEnd type="none" w="med" len="med"/>
-                      <a:tailEnd type="none" w="med" len="med"/>
-                    </a:lnB>
-                    <a:solidFill>
-                      <a:srgbClr val="FAF7F2"/>
-                    </a:solidFill>
-                  </a:tcPr>
-                </a:tc>
-                <a:tc>
-                  <a:txBody>
-                    <a:bodyPr/>
-                    <a:lstStyle/>
-                    <a:p>
-                      <a:pPr algn="ctr" indent="0" marL="0">
-                        <a:buNone/>
-                      </a:pPr>
-                      <a:r>
-                        <a:rPr lang="en-US" sz="900" dirty="0">
-                          <a:solidFill>
-                            <a:srgbClr val="C0392B"/>
-                          </a:solidFill>
-                          <a:latin typeface="Calibri" pitchFamily="34" charset="0"/>
-                          <a:ea typeface="Calibri" pitchFamily="34" charset="-122"/>
-                          <a:cs typeface="Calibri" pitchFamily="34" charset="-120"/>
-                        </a:rPr>
-                        <a:t>$-59,801</a:t>
+                        <a:t>$-120,605</a:t>
                       </a:r>
                       <a:endParaRPr lang="en-US" sz="900" dirty="0">
                         <a:latin typeface="Calibri" charset="0"/>
@@ -19265,7 +19197,7 @@
                           <a:ea typeface="Calibri" pitchFamily="34" charset="-122"/>
                           <a:cs typeface="Calibri" pitchFamily="34" charset="-120"/>
                         </a:rPr>
-                        <a:t>-34.7%</a:t>
+                        <a:t>$55,275</a:t>
                       </a:r>
                       <a:endParaRPr lang="en-US" sz="900" dirty="0">
                         <a:latin typeface="Calibri" charset="0"/>
@@ -19333,7 +19265,75 @@
                           <a:ea typeface="Calibri" pitchFamily="34" charset="-122"/>
                           <a:cs typeface="Calibri" pitchFamily="34" charset="-120"/>
                         </a:rPr>
-                        <a:t>$0</a:t>
+                        <a:t>30.2%</a:t>
+                      </a:r>
+                      <a:endParaRPr lang="en-US" sz="900" dirty="0">
+                        <a:latin typeface="Calibri" charset="0"/>
+                        <a:ea typeface="Calibri" charset="0"/>
+                        <a:cs typeface="Calibri" charset="0"/>
+                      </a:endParaRPr>
+                    </a:p>
+                  </a:txBody>
+                  <a:tcPr marL="91440" marR="91440" marT="45720" marB="45720" anchor="ctr">
+                    <a:lnL w="6350" cap="flat" cmpd="sng" algn="ctr">
+                      <a:solidFill>
+                        <a:srgbClr val="D6CFC4"/>
+                      </a:solidFill>
+                      <a:prstDash val="solid"/>
+                      <a:round/>
+                      <a:headEnd type="none" w="med" len="med"/>
+                      <a:tailEnd type="none" w="med" len="med"/>
+                    </a:lnL>
+                    <a:lnR w="6350" cap="flat" cmpd="sng" algn="ctr">
+                      <a:solidFill>
+                        <a:srgbClr val="D6CFC4"/>
+                      </a:solidFill>
+                      <a:prstDash val="solid"/>
+                      <a:round/>
+                      <a:headEnd type="none" w="med" len="med"/>
+                      <a:tailEnd type="none" w="med" len="med"/>
+                    </a:lnR>
+                    <a:lnT w="6350" cap="flat" cmpd="sng" algn="ctr">
+                      <a:solidFill>
+                        <a:srgbClr val="D6CFC4"/>
+                      </a:solidFill>
+                      <a:prstDash val="solid"/>
+                      <a:round/>
+                      <a:headEnd type="none" w="med" len="med"/>
+                      <a:tailEnd type="none" w="med" len="med"/>
+                    </a:lnT>
+                    <a:lnB w="6350" cap="flat" cmpd="sng" algn="ctr">
+                      <a:solidFill>
+                        <a:srgbClr val="D6CFC4"/>
+                      </a:solidFill>
+                      <a:prstDash val="solid"/>
+                      <a:round/>
+                      <a:headEnd type="none" w="med" len="med"/>
+                      <a:tailEnd type="none" w="med" len="med"/>
+                    </a:lnB>
+                    <a:solidFill>
+                      <a:srgbClr val="FAF7F2"/>
+                    </a:solidFill>
+                  </a:tcPr>
+                </a:tc>
+                <a:tc>
+                  <a:txBody>
+                    <a:bodyPr/>
+                    <a:lstStyle/>
+                    <a:p>
+                      <a:pPr algn="ctr" indent="0" marL="0">
+                        <a:buNone/>
+                      </a:pPr>
+                      <a:r>
+                        <a:rPr lang="en-US" sz="900" dirty="0">
+                          <a:solidFill>
+                            <a:srgbClr val="2D2A26"/>
+                          </a:solidFill>
+                          <a:latin typeface="Calibri" pitchFamily="34" charset="0"/>
+                          <a:ea typeface="Calibri" pitchFamily="34" charset="-122"/>
+                          <a:cs typeface="Calibri" pitchFamily="34" charset="-120"/>
+                        </a:rPr>
+                        <a:t>$-59,801</a:t>
                       </a:r>
                       <a:endParaRPr lang="en-US" sz="900" dirty="0">
                         <a:latin typeface="Calibri" charset="0"/>
@@ -19471,7 +19471,7 @@
                           <a:ea typeface="Calibri" pitchFamily="34" charset="-122"/>
                           <a:cs typeface="Calibri" pitchFamily="34" charset="-120"/>
                         </a:rPr>
-                        <a:t>$0</a:t>
+                        <a:t>$67,009</a:t>
                       </a:r>
                       <a:endParaRPr lang="en-US" sz="900" dirty="0">
                         <a:latin typeface="Calibri" charset="0"/>
@@ -19539,7 +19539,7 @@
                           <a:ea typeface="Calibri" pitchFamily="34" charset="-122"/>
                           <a:cs typeface="Calibri" pitchFamily="34" charset="-120"/>
                         </a:rPr>
-                        <a:t>$0</a:t>
+                        <a:t>$-34,270</a:t>
                       </a:r>
                       <a:endParaRPr lang="en-US" sz="900" dirty="0">
                         <a:latin typeface="Calibri" charset="0"/>
@@ -19607,7 +19607,75 @@
                           <a:ea typeface="Calibri" pitchFamily="34" charset="-122"/>
                           <a:cs typeface="Calibri" pitchFamily="34" charset="-120"/>
                         </a:rPr>
-                        <a:t>$0</a:t>
+                        <a:t>$-102,159</a:t>
+                      </a:r>
+                      <a:endParaRPr lang="en-US" sz="900" dirty="0">
+                        <a:latin typeface="Calibri" charset="0"/>
+                        <a:ea typeface="Calibri" charset="0"/>
+                        <a:cs typeface="Calibri" charset="0"/>
+                      </a:endParaRPr>
+                    </a:p>
+                  </a:txBody>
+                  <a:tcPr marL="91440" marR="91440" marT="45720" marB="45720" anchor="ctr">
+                    <a:lnL w="6350" cap="flat" cmpd="sng" algn="ctr">
+                      <a:solidFill>
+                        <a:srgbClr val="D6CFC4"/>
+                      </a:solidFill>
+                      <a:prstDash val="solid"/>
+                      <a:round/>
+                      <a:headEnd type="none" w="med" len="med"/>
+                      <a:tailEnd type="none" w="med" len="med"/>
+                    </a:lnL>
+                    <a:lnR w="6350" cap="flat" cmpd="sng" algn="ctr">
+                      <a:solidFill>
+                        <a:srgbClr val="D6CFC4"/>
+                      </a:solidFill>
+                      <a:prstDash val="solid"/>
+                      <a:round/>
+                      <a:headEnd type="none" w="med" len="med"/>
+                      <a:tailEnd type="none" w="med" len="med"/>
+                    </a:lnR>
+                    <a:lnT w="6350" cap="flat" cmpd="sng" algn="ctr">
+                      <a:solidFill>
+                        <a:srgbClr val="D6CFC4"/>
+                      </a:solidFill>
+                      <a:prstDash val="solid"/>
+                      <a:round/>
+                      <a:headEnd type="none" w="med" len="med"/>
+                      <a:tailEnd type="none" w="med" len="med"/>
+                    </a:lnT>
+                    <a:lnB w="6350" cap="flat" cmpd="sng" algn="ctr">
+                      <a:solidFill>
+                        <a:srgbClr val="D6CFC4"/>
+                      </a:solidFill>
+                      <a:prstDash val="solid"/>
+                      <a:round/>
+                      <a:headEnd type="none" w="med" len="med"/>
+                      <a:tailEnd type="none" w="med" len="med"/>
+                    </a:lnB>
+                    <a:solidFill>
+                      <a:srgbClr val="FFFFFF"/>
+                    </a:solidFill>
+                  </a:tcPr>
+                </a:tc>
+                <a:tc>
+                  <a:txBody>
+                    <a:bodyPr/>
+                    <a:lstStyle/>
+                    <a:p>
+                      <a:pPr algn="ctr" indent="0" marL="0">
+                        <a:buNone/>
+                      </a:pPr>
+                      <a:r>
+                        <a:rPr lang="en-US" sz="900" dirty="0">
+                          <a:solidFill>
+                            <a:srgbClr val="C0392B"/>
+                          </a:solidFill>
+                          <a:latin typeface="Calibri" pitchFamily="34" charset="0"/>
+                          <a:ea typeface="Calibri" pitchFamily="34" charset="-122"/>
+                          <a:cs typeface="Calibri" pitchFamily="34" charset="-120"/>
+                        </a:rPr>
+                        <a:t>$-69,419</a:t>
                       </a:r>
                       <a:endParaRPr lang="en-US" sz="900" dirty="0">
                         <a:latin typeface="Calibri" charset="0"/>
@@ -19675,75 +19743,7 @@
                           <a:ea typeface="Calibri" pitchFamily="34" charset="-122"/>
                           <a:cs typeface="Calibri" pitchFamily="34" charset="-120"/>
                         </a:rPr>
-                        <a:t>$0</a:t>
-                      </a:r>
-                      <a:endParaRPr lang="en-US" sz="900" dirty="0">
-                        <a:latin typeface="Calibri" charset="0"/>
-                        <a:ea typeface="Calibri" charset="0"/>
-                        <a:cs typeface="Calibri" charset="0"/>
-                      </a:endParaRPr>
-                    </a:p>
-                  </a:txBody>
-                  <a:tcPr marL="91440" marR="91440" marT="45720" marB="45720" anchor="ctr">
-                    <a:lnL w="6350" cap="flat" cmpd="sng" algn="ctr">
-                      <a:solidFill>
-                        <a:srgbClr val="D6CFC4"/>
-                      </a:solidFill>
-                      <a:prstDash val="solid"/>
-                      <a:round/>
-                      <a:headEnd type="none" w="med" len="med"/>
-                      <a:tailEnd type="none" w="med" len="med"/>
-                    </a:lnL>
-                    <a:lnR w="6350" cap="flat" cmpd="sng" algn="ctr">
-                      <a:solidFill>
-                        <a:srgbClr val="D6CFC4"/>
-                      </a:solidFill>
-                      <a:prstDash val="solid"/>
-                      <a:round/>
-                      <a:headEnd type="none" w="med" len="med"/>
-                      <a:tailEnd type="none" w="med" len="med"/>
-                    </a:lnR>
-                    <a:lnT w="6350" cap="flat" cmpd="sng" algn="ctr">
-                      <a:solidFill>
-                        <a:srgbClr val="D6CFC4"/>
-                      </a:solidFill>
-                      <a:prstDash val="solid"/>
-                      <a:round/>
-                      <a:headEnd type="none" w="med" len="med"/>
-                      <a:tailEnd type="none" w="med" len="med"/>
-                    </a:lnT>
-                    <a:lnB w="6350" cap="flat" cmpd="sng" algn="ctr">
-                      <a:solidFill>
-                        <a:srgbClr val="D6CFC4"/>
-                      </a:solidFill>
-                      <a:prstDash val="solid"/>
-                      <a:round/>
-                      <a:headEnd type="none" w="med" len="med"/>
-                      <a:tailEnd type="none" w="med" len="med"/>
-                    </a:lnB>
-                    <a:solidFill>
-                      <a:srgbClr val="FFFFFF"/>
-                    </a:solidFill>
-                  </a:tcPr>
-                </a:tc>
-                <a:tc>
-                  <a:txBody>
-                    <a:bodyPr/>
-                    <a:lstStyle/>
-                    <a:p>
-                      <a:pPr algn="ctr" indent="0" marL="0">
-                        <a:buNone/>
-                      </a:pPr>
-                      <a:r>
-                        <a:rPr lang="en-US" sz="900" dirty="0">
-                          <a:solidFill>
-                            <a:srgbClr val="2D2A26"/>
-                          </a:solidFill>
-                          <a:latin typeface="Calibri" pitchFamily="34" charset="0"/>
-                          <a:ea typeface="Calibri" pitchFamily="34" charset="-122"/>
-                          <a:cs typeface="Calibri" pitchFamily="34" charset="-120"/>
-                        </a:rPr>
-                        <a:t>N/M</a:t>
+                        <a:t>-103.6%</a:t>
                       </a:r>
                       <a:endParaRPr lang="en-US" sz="900" dirty="0">
                         <a:latin typeface="Calibri" charset="0"/>
@@ -19949,7 +19949,7 @@
                           <a:ea typeface="Calibri" pitchFamily="34" charset="-122"/>
                           <a:cs typeface="Calibri" pitchFamily="34" charset="-120"/>
                         </a:rPr>
-                        <a:t>$1,691,720</a:t>
+                        <a:t>$1,885,356</a:t>
                       </a:r>
                       <a:endParaRPr lang="en-US" sz="950" dirty="0">
                         <a:latin typeface="Calibri" charset="0"/>
@@ -20017,7 +20017,7 @@
                           <a:ea typeface="Calibri" pitchFamily="34" charset="-122"/>
                           <a:cs typeface="Calibri" pitchFamily="34" charset="-120"/>
                         </a:rPr>
-                        <a:t>$-296,537</a:t>
+                        <a:t>$-330,066</a:t>
                       </a:r>
                       <a:endParaRPr lang="en-US" sz="950" dirty="0">
                         <a:latin typeface="Calibri" charset="0"/>
@@ -20085,7 +20085,7 @@
                           <a:ea typeface="Calibri" pitchFamily="34" charset="-122"/>
                           <a:cs typeface="Calibri" pitchFamily="34" charset="-120"/>
                         </a:rPr>
-                        <a:t>$-1,739,957</a:t>
+                        <a:t>$-1,240,449</a:t>
                       </a:r>
                       <a:endParaRPr lang="en-US" sz="950" dirty="0">
                         <a:latin typeface="Calibri" charset="0"/>
@@ -20147,13 +20147,13 @@
                       <a:r>
                         <a:rPr lang="en-US" sz="950" b="1" dirty="0">
                           <a:solidFill>
-                            <a:srgbClr val="C0392B"/>
+                            <a:srgbClr val="2D2A26"/>
                           </a:solidFill>
                           <a:latin typeface="Calibri" pitchFamily="34" charset="0"/>
                           <a:ea typeface="Calibri" pitchFamily="34" charset="-122"/>
                           <a:cs typeface="Calibri" pitchFamily="34" charset="-120"/>
                         </a:rPr>
-                        <a:t>$-344,774</a:t>
+                        <a:t>$314,841</a:t>
                       </a:r>
                       <a:endParaRPr lang="en-US" sz="950" dirty="0">
                         <a:latin typeface="Calibri" charset="0"/>
@@ -20221,7 +20221,7 @@
                           <a:ea typeface="Calibri" pitchFamily="34" charset="-122"/>
                           <a:cs typeface="Calibri" pitchFamily="34" charset="-120"/>
                         </a:rPr>
-                        <a:t>-20.4%</a:t>
+                        <a:t>16.7%</a:t>
                       </a:r>
                       <a:endParaRPr lang="en-US" sz="950" dirty="0">
                         <a:latin typeface="Calibri" charset="0"/>
@@ -20289,7 +20289,7 @@
                           <a:ea typeface="Calibri" pitchFamily="34" charset="-122"/>
                           <a:cs typeface="Calibri" pitchFamily="34" charset="-120"/>
                         </a:rPr>
-                        <a:t>$0</a:t>
+                        <a:t>$-507,344</a:t>
                       </a:r>
                       <a:endParaRPr lang="en-US" sz="950" dirty="0">
                         <a:latin typeface="Calibri" charset="0"/>
@@ -20474,7 +20474,7 @@
                 <a:ea typeface="Century Gothic" pitchFamily="34" charset="-122"/>
                 <a:cs typeface="Century Gothic" pitchFamily="34" charset="-120"/>
               </a:rPr>
-              <a:t>$1,691,720</a:t>
+              <a:t>$1,885,356</a:t>
             </a:r>
             <a:endParaRPr lang="en-US" sz="2000" dirty="0"/>
           </a:p>
@@ -20609,7 +20609,7 @@
                 <a:ea typeface="Century Gothic" pitchFamily="34" charset="-122"/>
                 <a:cs typeface="Century Gothic" pitchFamily="34" charset="-120"/>
               </a:rPr>
-              <a:t>$-344,774</a:t>
+              <a:t>$314,841</a:t>
             </a:r>
             <a:endParaRPr lang="en-US" sz="2000" dirty="0"/>
           </a:p>
@@ -20744,7 +20744,7 @@
                 <a:ea typeface="Century Gothic" pitchFamily="34" charset="-122"/>
                 <a:cs typeface="Century Gothic" pitchFamily="34" charset="-120"/>
               </a:rPr>
-              <a:t>-20.4%</a:t>
+              <a:t>16.7%</a:t>
             </a:r>
             <a:endParaRPr lang="en-US" sz="2000" dirty="0"/>
           </a:p>

</xml_diff>

<commit_message>
Auto-build: 2026-03-11 23:04 UTC
</commit_message>
<xml_diff>
--- a/reports/2026-01.pptx
+++ b/reports/2026-01.pptx
@@ -573,7 +573,7 @@
                 <c:formatCode>General</c:formatCode>
                 <c:ptCount val="5"/>
                 <c:pt idx="0">
-                  <c:v>0</c:v>
+                  <c:v>0.96448</c:v>
                 </c:pt>
                 <c:pt idx="1">
                   <c:v>0.891081</c:v>
@@ -8392,7 +8392,7 @@
                 <a:ea typeface="Calibri" pitchFamily="34" charset="-122"/>
                 <a:cs typeface="Calibri" pitchFamily="34" charset="-120"/>
               </a:rPr>
-              <a:t>+0 bps</a:t>
+              <a:t>+9645 bps</a:t>
             </a:r>
             <a:endParaRPr lang="en-US" sz="1000" dirty="0"/>
           </a:p>
@@ -8644,7 +8644,7 @@
                 <a:ea typeface="Century Gothic" pitchFamily="34" charset="-122"/>
                 <a:cs typeface="Century Gothic" pitchFamily="34" charset="-120"/>
               </a:rPr>
-              <a:t>13,752</a:t>
+              <a:t>27,600</a:t>
             </a:r>
             <a:endParaRPr lang="en-US" sz="2000" dirty="0"/>
           </a:p>
@@ -8779,7 +8779,7 @@
                 <a:ea typeface="Century Gothic" pitchFamily="34" charset="-122"/>
                 <a:cs typeface="Century Gothic" pitchFamily="34" charset="-120"/>
               </a:rPr>
-              <a:t>45.4%</a:t>
+              <a:t>91.1%</a:t>
             </a:r>
             <a:endParaRPr lang="en-US" sz="2000" dirty="0"/>
           </a:p>
@@ -8914,7 +8914,7 @@
                 <a:ea typeface="Century Gothic" pitchFamily="34" charset="-122"/>
                 <a:cs typeface="Century Gothic" pitchFamily="34" charset="-120"/>
               </a:rPr>
-              <a:t>+4540 bps</a:t>
+              <a:t>+9112 bps</a:t>
             </a:r>
             <a:endParaRPr lang="en-US" sz="2000" dirty="0"/>
           </a:p>
@@ -13456,7 +13456,7 @@
                           <a:ea typeface="Calibri" pitchFamily="34" charset="-122"/>
                           <a:cs typeface="Calibri" pitchFamily="34" charset="-120"/>
                         </a:rPr>
-                        <a:t>0.0%</a:t>
+                        <a:t>4.5%</a:t>
                       </a:r>
                       <a:endParaRPr lang="en-US" sz="950" dirty="0">
                         <a:latin typeface="Calibri" charset="0"/>
@@ -13518,13 +13518,13 @@
                       <a:r>
                         <a:rPr lang="en-US" sz="950" dirty="0">
                           <a:solidFill>
-                            <a:srgbClr val="1A7A6E"/>
+                            <a:srgbClr val="C0392B"/>
                           </a:solidFill>
                           <a:latin typeface="Calibri" pitchFamily="34" charset="0"/>
                           <a:ea typeface="Calibri" pitchFamily="34" charset="-122"/>
                           <a:cs typeface="Calibri" pitchFamily="34" charset="-120"/>
                         </a:rPr>
-                        <a:t>+0 bps</a:t>
+                        <a:t>+452 bps</a:t>
                       </a:r>
                       <a:endParaRPr lang="en-US" sz="950" dirty="0">
                         <a:latin typeface="Calibri" charset="0"/>
@@ -13730,7 +13730,7 @@
                           <a:ea typeface="Calibri" pitchFamily="34" charset="-122"/>
                           <a:cs typeface="Calibri" pitchFamily="34" charset="-120"/>
                         </a:rPr>
-                        <a:t>0.0%</a:t>
+                        <a:t>13.5%</a:t>
                       </a:r>
                       <a:endParaRPr lang="en-US" sz="950" dirty="0">
                         <a:latin typeface="Calibri" charset="0"/>
@@ -13792,13 +13792,13 @@
                       <a:r>
                         <a:rPr lang="en-US" sz="950" dirty="0">
                           <a:solidFill>
-                            <a:srgbClr val="1A7A6E"/>
+                            <a:srgbClr val="C0392B"/>
                           </a:solidFill>
                           <a:latin typeface="Calibri" pitchFamily="34" charset="0"/>
                           <a:ea typeface="Calibri" pitchFamily="34" charset="-122"/>
                           <a:cs typeface="Calibri" pitchFamily="34" charset="-120"/>
                         </a:rPr>
-                        <a:t>+0 bps</a:t>
+                        <a:t>+1355 bps</a:t>
                       </a:r>
                       <a:endParaRPr lang="en-US" sz="950" dirty="0">
                         <a:latin typeface="Calibri" charset="0"/>
@@ -14004,7 +14004,7 @@
                           <a:ea typeface="Calibri" pitchFamily="34" charset="-122"/>
                           <a:cs typeface="Calibri" pitchFamily="34" charset="-120"/>
                         </a:rPr>
-                        <a:t>0.0%</a:t>
+                        <a:t>11.1%</a:t>
                       </a:r>
                       <a:endParaRPr lang="en-US" sz="950" dirty="0">
                         <a:latin typeface="Calibri" charset="0"/>
@@ -14066,13 +14066,13 @@
                       <a:r>
                         <a:rPr lang="en-US" sz="950" dirty="0">
                           <a:solidFill>
-                            <a:srgbClr val="1A7A6E"/>
+                            <a:srgbClr val="C0392B"/>
                           </a:solidFill>
                           <a:latin typeface="Calibri" pitchFamily="34" charset="0"/>
                           <a:ea typeface="Calibri" pitchFamily="34" charset="-122"/>
                           <a:cs typeface="Calibri" pitchFamily="34" charset="-120"/>
                         </a:rPr>
-                        <a:t>+0 bps</a:t>
+                        <a:t>+1107 bps</a:t>
                       </a:r>
                       <a:endParaRPr lang="en-US" sz="950" dirty="0">
                         <a:latin typeface="Calibri" charset="0"/>
@@ -14278,7 +14278,7 @@
                           <a:ea typeface="Calibri" pitchFamily="34" charset="-122"/>
                           <a:cs typeface="Calibri" pitchFamily="34" charset="-120"/>
                         </a:rPr>
-                        <a:t>0.0%</a:t>
+                        <a:t>2.7%</a:t>
                       </a:r>
                       <a:endParaRPr lang="en-US" sz="950" dirty="0">
                         <a:latin typeface="Calibri" charset="0"/>
@@ -14340,13 +14340,13 @@
                       <a:r>
                         <a:rPr lang="en-US" sz="950" dirty="0">
                           <a:solidFill>
-                            <a:srgbClr val="1A7A6E"/>
+                            <a:srgbClr val="C0392B"/>
                           </a:solidFill>
                           <a:latin typeface="Calibri" pitchFamily="34" charset="0"/>
                           <a:ea typeface="Calibri" pitchFamily="34" charset="-122"/>
                           <a:cs typeface="Calibri" pitchFamily="34" charset="-120"/>
                         </a:rPr>
-                        <a:t>+0 bps</a:t>
+                        <a:t>+268 bps</a:t>
                       </a:r>
                       <a:endParaRPr lang="en-US" sz="950" dirty="0">
                         <a:latin typeface="Calibri" charset="0"/>
@@ -14552,7 +14552,7 @@
                           <a:ea typeface="Calibri" pitchFamily="34" charset="-122"/>
                           <a:cs typeface="Calibri" pitchFamily="34" charset="-120"/>
                         </a:rPr>
-                        <a:t>0.0%</a:t>
+                        <a:t>15.7%</a:t>
                       </a:r>
                       <a:endParaRPr lang="en-US" sz="950" dirty="0">
                         <a:latin typeface="Calibri" charset="0"/>
@@ -14614,13 +14614,13 @@
                       <a:r>
                         <a:rPr lang="en-US" sz="950" dirty="0">
                           <a:solidFill>
-                            <a:srgbClr val="1A7A6E"/>
+                            <a:srgbClr val="C0392B"/>
                           </a:solidFill>
                           <a:latin typeface="Calibri" pitchFamily="34" charset="0"/>
                           <a:ea typeface="Calibri" pitchFamily="34" charset="-122"/>
                           <a:cs typeface="Calibri" pitchFamily="34" charset="-120"/>
                         </a:rPr>
-                        <a:t>+0 bps</a:t>
+                        <a:t>+1572 bps</a:t>
                       </a:r>
                       <a:endParaRPr lang="en-US" sz="950" dirty="0">
                         <a:latin typeface="Calibri" charset="0"/>
@@ -15438,7 +15438,7 @@
                           <a:ea typeface="Calibri" pitchFamily="34" charset="-122"/>
                           <a:cs typeface="Calibri" pitchFamily="34" charset="-120"/>
                         </a:rPr>
-                        <a:t>11.1%</a:t>
+                        <a:t>8.2%</a:t>
                       </a:r>
                       <a:endParaRPr lang="en-US" sz="950" dirty="0">
                         <a:latin typeface="Calibri" charset="0"/>
@@ -15506,7 +15506,7 @@
                           <a:ea typeface="Calibri" pitchFamily="34" charset="-122"/>
                           <a:cs typeface="Calibri" pitchFamily="34" charset="-120"/>
                         </a:rPr>
-                        <a:t>+1109 bps</a:t>
+                        <a:t>+815 bps</a:t>
                       </a:r>
                       <a:endParaRPr lang="en-US" sz="950" dirty="0">
                         <a:latin typeface="Calibri" charset="0"/>
@@ -15712,7 +15712,7 @@
                           <a:ea typeface="Calibri" pitchFamily="34" charset="-122"/>
                           <a:cs typeface="Calibri" pitchFamily="34" charset="-120"/>
                         </a:rPr>
-                        <a:t>8.4%</a:t>
+                        <a:t>6.2%</a:t>
                       </a:r>
                       <a:endParaRPr lang="en-US" sz="950" dirty="0">
                         <a:latin typeface="Calibri" charset="0"/>
@@ -15780,7 +15780,7 @@
                           <a:ea typeface="Calibri" pitchFamily="34" charset="-122"/>
                           <a:cs typeface="Calibri" pitchFamily="34" charset="-120"/>
                         </a:rPr>
-                        <a:t>+842 bps</a:t>
+                        <a:t>+619 bps</a:t>
                       </a:r>
                       <a:endParaRPr lang="en-US" sz="950" dirty="0">
                         <a:latin typeface="Calibri" charset="0"/>
@@ -15986,7 +15986,7 @@
                           <a:ea typeface="Calibri" pitchFamily="34" charset="-122"/>
                           <a:cs typeface="Calibri" pitchFamily="34" charset="-120"/>
                         </a:rPr>
-                        <a:t>23.6%</a:t>
+                        <a:t>17.4%</a:t>
                       </a:r>
                       <a:endParaRPr lang="en-US" sz="950" dirty="0">
                         <a:latin typeface="Calibri" charset="0"/>
@@ -16054,7 +16054,7 @@
                           <a:ea typeface="Calibri" pitchFamily="34" charset="-122"/>
                           <a:cs typeface="Calibri" pitchFamily="34" charset="-120"/>
                         </a:rPr>
-                        <a:t>+2361 bps</a:t>
+                        <a:t>+1736 bps</a:t>
                       </a:r>
                       <a:endParaRPr lang="en-US" sz="950" dirty="0">
                         <a:latin typeface="Calibri" charset="0"/>
@@ -16260,7 +16260,7 @@
                           <a:ea typeface="Calibri" pitchFamily="34" charset="-122"/>
                           <a:cs typeface="Calibri" pitchFamily="34" charset="-120"/>
                         </a:rPr>
-                        <a:t>2.6%</a:t>
+                        <a:t>2.0%</a:t>
                       </a:r>
                       <a:endParaRPr lang="en-US" sz="950" dirty="0">
                         <a:latin typeface="Calibri" charset="0"/>
@@ -16328,7 +16328,7 @@
                           <a:ea typeface="Calibri" pitchFamily="34" charset="-122"/>
                           <a:cs typeface="Calibri" pitchFamily="34" charset="-120"/>
                         </a:rPr>
-                        <a:t>+261 bps</a:t>
+                        <a:t>+201 bps</a:t>
                       </a:r>
                       <a:endParaRPr lang="en-US" sz="950" dirty="0">
                         <a:latin typeface="Calibri" charset="0"/>
@@ -16534,7 +16534,7 @@
                           <a:ea typeface="Calibri" pitchFamily="34" charset="-122"/>
                           <a:cs typeface="Calibri" pitchFamily="34" charset="-120"/>
                         </a:rPr>
-                        <a:t>22.1%</a:t>
+                        <a:t>17.0%</a:t>
                       </a:r>
                       <a:endParaRPr lang="en-US" sz="950" dirty="0">
                         <a:latin typeface="Calibri" charset="0"/>
@@ -16602,7 +16602,7 @@
                           <a:ea typeface="Calibri" pitchFamily="34" charset="-122"/>
                           <a:cs typeface="Calibri" pitchFamily="34" charset="-120"/>
                         </a:rPr>
-                        <a:t>+2211 bps</a:t>
+                        <a:t>+1700 bps</a:t>
                       </a:r>
                       <a:endParaRPr lang="en-US" sz="950" dirty="0">
                         <a:latin typeface="Calibri" charset="0"/>

</xml_diff>

<commit_message>
Auto-build: 2026-03-12 00:23 UTC
</commit_message>
<xml_diff>
--- a/reports/2026-01.pptx
+++ b/reports/2026-01.pptx
@@ -4946,7 +4946,7 @@
                 <a:ea typeface="Calibri" pitchFamily="34" charset="-122"/>
                 <a:cs typeface="Calibri" pitchFamily="34" charset="-120"/>
               </a:rPr>
-              <a:t>Prepared: March 11, 2026</a:t>
+              <a:t>Prepared: March 12, 2026</a:t>
             </a:r>
             <a:endParaRPr lang="en-US" sz="1100" dirty="0"/>
           </a:p>
@@ -13730,7 +13730,7 @@
                           <a:ea typeface="Calibri" pitchFamily="34" charset="-122"/>
                           <a:cs typeface="Calibri" pitchFamily="34" charset="-120"/>
                         </a:rPr>
-                        <a:t>13.5%</a:t>
+                        <a:t>5.1%</a:t>
                       </a:r>
                       <a:endParaRPr lang="en-US" sz="950" dirty="0">
                         <a:latin typeface="Calibri" charset="0"/>
@@ -13798,7 +13798,7 @@
                           <a:ea typeface="Calibri" pitchFamily="34" charset="-122"/>
                           <a:cs typeface="Calibri" pitchFamily="34" charset="-120"/>
                         </a:rPr>
-                        <a:t>+1355 bps</a:t>
+                        <a:t>+514 bps</a:t>
                       </a:r>
                       <a:endParaRPr lang="en-US" sz="950" dirty="0">
                         <a:latin typeface="Calibri" charset="0"/>

</xml_diff>

<commit_message>
Auto-build: 2026-03-12 01:41 UTC
</commit_message>
<xml_diff>
--- a/reports/2026-01.pptx
+++ b/reports/2026-01.pptx
@@ -2128,19 +2128,19 @@
                 <c:formatCode>General</c:formatCode>
                 <c:ptCount val="5"/>
                 <c:pt idx="0">
-                  <c:v>-2498</c:v>
+                  <c:v>2498</c:v>
                 </c:pt>
                 <c:pt idx="1">
-                  <c:v>-2895</c:v>
+                  <c:v>2895</c:v>
                 </c:pt>
                 <c:pt idx="2">
-                  <c:v>-2145</c:v>
+                  <c:v>2145</c:v>
                 </c:pt>
                 <c:pt idx="3">
-                  <c:v>-1517</c:v>
+                  <c:v>1517</c:v>
                 </c:pt>
                 <c:pt idx="4">
-                  <c:v>-676</c:v>
+                  <c:v>676</c:v>
                 </c:pt>
               </c:numCache>
             </c:numRef>
@@ -2439,19 +2439,19 @@
                 <c:formatCode>General</c:formatCode>
                 <c:ptCount val="5"/>
                 <c:pt idx="0">
-                  <c:v>-576</c:v>
+                  <c:v>576</c:v>
                 </c:pt>
                 <c:pt idx="1">
-                  <c:v>-346</c:v>
+                  <c:v>346</c:v>
                 </c:pt>
                 <c:pt idx="2">
-                  <c:v>-175</c:v>
+                  <c:v>175</c:v>
                 </c:pt>
                 <c:pt idx="3">
-                  <c:v>-282</c:v>
+                  <c:v>282</c:v>
                 </c:pt>
                 <c:pt idx="4">
-                  <c:v>-106</c:v>
+                  <c:v>106</c:v>
                 </c:pt>
               </c:numCache>
             </c:numRef>
@@ -2750,19 +2750,19 @@
                 <c:formatCode>General</c:formatCode>
                 <c:ptCount val="5"/>
                 <c:pt idx="0">
-                  <c:v>-60</c:v>
+                  <c:v>60</c:v>
                 </c:pt>
                 <c:pt idx="1">
-                  <c:v>-23</c:v>
+                  <c:v>23</c:v>
                 </c:pt>
                 <c:pt idx="2">
-                  <c:v>-23</c:v>
+                  <c:v>23</c:v>
                 </c:pt>
                 <c:pt idx="3">
-                  <c:v>-21</c:v>
+                  <c:v>21</c:v>
                 </c:pt>
                 <c:pt idx="4">
-                  <c:v>-68</c:v>
+                  <c:v>68</c:v>
                 </c:pt>
               </c:numCache>
             </c:numRef>
@@ -5429,7 +5429,7 @@
             <a:r>
               <a:rPr lang="en-US" sz="1000" b="1" dirty="0">
                 <a:solidFill>
-                  <a:srgbClr val="1A7A6E"/>
+                  <a:srgbClr val="C0392B"/>
                 </a:solidFill>
                 <a:latin typeface="Calibri" pitchFamily="34" charset="0"/>
                 <a:ea typeface="Calibri" pitchFamily="34" charset="-122"/>
@@ -5507,7 +5507,7 @@
             <a:r>
               <a:rPr lang="en-US" sz="1000" b="1" dirty="0">
                 <a:solidFill>
-                  <a:srgbClr val="1A7A6E"/>
+                  <a:srgbClr val="C0392B"/>
                 </a:solidFill>
                 <a:latin typeface="Calibri" pitchFamily="34" charset="0"/>
                 <a:ea typeface="Calibri" pitchFamily="34" charset="-122"/>
@@ -5546,7 +5546,7 @@
             <a:r>
               <a:rPr lang="en-US" sz="1000" b="1" dirty="0">
                 <a:solidFill>
-                  <a:srgbClr val="1A7A6E"/>
+                  <a:srgbClr val="C0392B"/>
                 </a:solidFill>
                 <a:latin typeface="Calibri" pitchFamily="34" charset="0"/>
                 <a:ea typeface="Calibri" pitchFamily="34" charset="-122"/>
@@ -6035,7 +6035,7 @@
             <a:r>
               <a:rPr lang="en-US" sz="1000" b="1" dirty="0">
                 <a:solidFill>
-                  <a:srgbClr val="1A7A6E"/>
+                  <a:srgbClr val="C0392B"/>
                 </a:solidFill>
                 <a:latin typeface="Calibri" pitchFamily="34" charset="0"/>
                 <a:ea typeface="Calibri" pitchFamily="34" charset="-122"/>
@@ -6113,7 +6113,7 @@
             <a:r>
               <a:rPr lang="en-US" sz="1000" b="1" dirty="0">
                 <a:solidFill>
-                  <a:srgbClr val="1A7A6E"/>
+                  <a:srgbClr val="C0392B"/>
                 </a:solidFill>
                 <a:latin typeface="Calibri" pitchFamily="34" charset="0"/>
                 <a:ea typeface="Calibri" pitchFamily="34" charset="-122"/>
@@ -6152,7 +6152,7 @@
             <a:r>
               <a:rPr lang="en-US" sz="1000" b="1" dirty="0">
                 <a:solidFill>
-                  <a:srgbClr val="1A7A6E"/>
+                  <a:srgbClr val="C0392B"/>
                 </a:solidFill>
                 <a:latin typeface="Calibri" pitchFamily="34" charset="0"/>
                 <a:ea typeface="Calibri" pitchFamily="34" charset="-122"/>
@@ -6641,7 +6641,7 @@
             <a:r>
               <a:rPr lang="en-US" sz="1000" b="1" dirty="0">
                 <a:solidFill>
-                  <a:srgbClr val="1A7A6E"/>
+                  <a:srgbClr val="C0392B"/>
                 </a:solidFill>
                 <a:latin typeface="Calibri" pitchFamily="34" charset="0"/>
                 <a:ea typeface="Calibri" pitchFamily="34" charset="-122"/>
@@ -6719,7 +6719,7 @@
             <a:r>
               <a:rPr lang="en-US" sz="1000" b="1" dirty="0">
                 <a:solidFill>
-                  <a:srgbClr val="C0392B"/>
+                  <a:srgbClr val="1A7A6E"/>
                 </a:solidFill>
                 <a:latin typeface="Calibri" pitchFamily="34" charset="0"/>
                 <a:ea typeface="Calibri" pitchFamily="34" charset="-122"/>
@@ -6758,7 +6758,7 @@
             <a:r>
               <a:rPr lang="en-US" sz="1000" b="1" dirty="0">
                 <a:solidFill>
-                  <a:srgbClr val="1A7A6E"/>
+                  <a:srgbClr val="C0392B"/>
                 </a:solidFill>
                 <a:latin typeface="Calibri" pitchFamily="34" charset="0"/>
                 <a:ea typeface="Calibri" pitchFamily="34" charset="-122"/>
@@ -7123,7 +7123,7 @@
         </p:nvGraphicFramePr>
         <p:xfrm>
           <a:off x="137160" y="841248"/>
-          <a:ext cx="7589520" cy="3474720"/>
+          <a:ext cx="7589520" cy="2834640"/>
         </p:xfrm>
         <a:graphic xmlns:a="http://schemas.openxmlformats.org/drawingml/2006/main">
           <a:graphicData uri="http://schemas.openxmlformats.org/drawingml/2006/chart">
@@ -7139,7 +7139,7 @@
         </p:nvSpPr>
         <p:spPr>
           <a:xfrm>
-            <a:off x="0" y="4343400"/>
+            <a:off x="0" y="3730752"/>
             <a:ext cx="7772400" cy="274320"/>
           </a:xfrm>
           <a:prstGeom prst="rect">
@@ -7164,7 +7164,7 @@
         </p:nvSpPr>
         <p:spPr>
           <a:xfrm>
-            <a:off x="0" y="4343400"/>
+            <a:off x="0" y="3730752"/>
             <a:ext cx="54864" cy="274320"/>
           </a:xfrm>
           <a:prstGeom prst="rect">
@@ -7189,7 +7189,7 @@
         </p:nvSpPr>
         <p:spPr>
           <a:xfrm>
-            <a:off x="109728" y="4343400"/>
+            <a:off x="109728" y="3730752"/>
             <a:ext cx="7662672" cy="274320"/>
           </a:xfrm>
           <a:prstGeom prst="rect">
@@ -7228,7 +7228,7 @@
         </p:nvSpPr>
         <p:spPr>
           <a:xfrm>
-            <a:off x="137160" y="4645152"/>
+            <a:off x="137160" y="4041648"/>
             <a:ext cx="1517904" cy="347472"/>
           </a:xfrm>
           <a:prstGeom prst="rect">
@@ -7267,7 +7267,7 @@
         </p:nvSpPr>
         <p:spPr>
           <a:xfrm>
-            <a:off x="1655064" y="4645152"/>
+            <a:off x="1655064" y="4041648"/>
             <a:ext cx="1517904" cy="347472"/>
           </a:xfrm>
           <a:prstGeom prst="rect">
@@ -7306,7 +7306,7 @@
         </p:nvSpPr>
         <p:spPr>
           <a:xfrm>
-            <a:off x="3172968" y="4645152"/>
+            <a:off x="3172968" y="4041648"/>
             <a:ext cx="1517904" cy="347472"/>
           </a:xfrm>
           <a:prstGeom prst="rect">
@@ -7345,7 +7345,7 @@
         </p:nvSpPr>
         <p:spPr>
           <a:xfrm>
-            <a:off x="4690872" y="4645152"/>
+            <a:off x="4690872" y="4041648"/>
             <a:ext cx="1517904" cy="347472"/>
           </a:xfrm>
           <a:prstGeom prst="rect">
@@ -7384,7 +7384,7 @@
         </p:nvSpPr>
         <p:spPr>
           <a:xfrm>
-            <a:off x="6208776" y="4645152"/>
+            <a:off x="6208776" y="4041648"/>
             <a:ext cx="1517904" cy="347472"/>
           </a:xfrm>
           <a:prstGeom prst="rect">
@@ -8262,7 +8262,7 @@
         </p:nvGraphicFramePr>
         <p:xfrm>
           <a:off x="137160" y="841248"/>
-          <a:ext cx="7589520" cy="3474720"/>
+          <a:ext cx="7589520" cy="2834640"/>
         </p:xfrm>
         <a:graphic xmlns:a="http://schemas.openxmlformats.org/drawingml/2006/main">
           <a:graphicData uri="http://schemas.openxmlformats.org/drawingml/2006/chart">
@@ -8278,7 +8278,7 @@
         </p:nvSpPr>
         <p:spPr>
           <a:xfrm>
-            <a:off x="0" y="4343400"/>
+            <a:off x="0" y="3730752"/>
             <a:ext cx="7772400" cy="274320"/>
           </a:xfrm>
           <a:prstGeom prst="rect">
@@ -8303,7 +8303,7 @@
         </p:nvSpPr>
         <p:spPr>
           <a:xfrm>
-            <a:off x="0" y="4343400"/>
+            <a:off x="0" y="3730752"/>
             <a:ext cx="54864" cy="274320"/>
           </a:xfrm>
           <a:prstGeom prst="rect">
@@ -8328,7 +8328,7 @@
         </p:nvSpPr>
         <p:spPr>
           <a:xfrm>
-            <a:off x="109728" y="4343400"/>
+            <a:off x="109728" y="3730752"/>
             <a:ext cx="7662672" cy="274320"/>
           </a:xfrm>
           <a:prstGeom prst="rect">
@@ -8367,7 +8367,7 @@
         </p:nvSpPr>
         <p:spPr>
           <a:xfrm>
-            <a:off x="137160" y="4645152"/>
+            <a:off x="137160" y="4041648"/>
             <a:ext cx="1517904" cy="347472"/>
           </a:xfrm>
           <a:prstGeom prst="rect">
@@ -8406,7 +8406,7 @@
         </p:nvSpPr>
         <p:spPr>
           <a:xfrm>
-            <a:off x="1655064" y="4645152"/>
+            <a:off x="1655064" y="4041648"/>
             <a:ext cx="1517904" cy="347472"/>
           </a:xfrm>
           <a:prstGeom prst="rect">
@@ -8445,7 +8445,7 @@
         </p:nvSpPr>
         <p:spPr>
           <a:xfrm>
-            <a:off x="3172968" y="4645152"/>
+            <a:off x="3172968" y="4041648"/>
             <a:ext cx="1517904" cy="347472"/>
           </a:xfrm>
           <a:prstGeom prst="rect">
@@ -8484,7 +8484,7 @@
         </p:nvSpPr>
         <p:spPr>
           <a:xfrm>
-            <a:off x="4690872" y="4645152"/>
+            <a:off x="4690872" y="4041648"/>
             <a:ext cx="1517904" cy="347472"/>
           </a:xfrm>
           <a:prstGeom prst="rect">
@@ -8523,7 +8523,7 @@
         </p:nvSpPr>
         <p:spPr>
           <a:xfrm>
-            <a:off x="6208776" y="4645152"/>
+            <a:off x="6208776" y="4041648"/>
             <a:ext cx="1517904" cy="347472"/>
           </a:xfrm>
           <a:prstGeom prst="rect">
@@ -9401,7 +9401,7 @@
         </p:nvGraphicFramePr>
         <p:xfrm>
           <a:off x="137160" y="841248"/>
-          <a:ext cx="7589520" cy="3474720"/>
+          <a:ext cx="7589520" cy="2834640"/>
         </p:xfrm>
         <a:graphic xmlns:a="http://schemas.openxmlformats.org/drawingml/2006/main">
           <a:graphicData uri="http://schemas.openxmlformats.org/drawingml/2006/chart">
@@ -9417,7 +9417,7 @@
         </p:nvSpPr>
         <p:spPr>
           <a:xfrm>
-            <a:off x="0" y="4343400"/>
+            <a:off x="0" y="3730752"/>
             <a:ext cx="7772400" cy="274320"/>
           </a:xfrm>
           <a:prstGeom prst="rect">
@@ -9442,7 +9442,7 @@
         </p:nvSpPr>
         <p:spPr>
           <a:xfrm>
-            <a:off x="0" y="4343400"/>
+            <a:off x="0" y="3730752"/>
             <a:ext cx="54864" cy="274320"/>
           </a:xfrm>
           <a:prstGeom prst="rect">
@@ -9467,7 +9467,7 @@
         </p:nvSpPr>
         <p:spPr>
           <a:xfrm>
-            <a:off x="109728" y="4343400"/>
+            <a:off x="109728" y="3730752"/>
             <a:ext cx="7662672" cy="274320"/>
           </a:xfrm>
           <a:prstGeom prst="rect">
@@ -9506,7 +9506,7 @@
         </p:nvSpPr>
         <p:spPr>
           <a:xfrm>
-            <a:off x="137160" y="4645152"/>
+            <a:off x="137160" y="4041648"/>
             <a:ext cx="1517904" cy="347472"/>
           </a:xfrm>
           <a:prstGeom prst="rect">
@@ -9545,7 +9545,7 @@
         </p:nvSpPr>
         <p:spPr>
           <a:xfrm>
-            <a:off x="1655064" y="4645152"/>
+            <a:off x="1655064" y="4041648"/>
             <a:ext cx="1517904" cy="347472"/>
           </a:xfrm>
           <a:prstGeom prst="rect">
@@ -9584,7 +9584,7 @@
         </p:nvSpPr>
         <p:spPr>
           <a:xfrm>
-            <a:off x="3172968" y="4645152"/>
+            <a:off x="3172968" y="4041648"/>
             <a:ext cx="1517904" cy="347472"/>
           </a:xfrm>
           <a:prstGeom prst="rect">
@@ -9623,7 +9623,7 @@
         </p:nvSpPr>
         <p:spPr>
           <a:xfrm>
-            <a:off x="4690872" y="4645152"/>
+            <a:off x="4690872" y="4041648"/>
             <a:ext cx="1517904" cy="347472"/>
           </a:xfrm>
           <a:prstGeom prst="rect">
@@ -9662,7 +9662,7 @@
         </p:nvSpPr>
         <p:spPr>
           <a:xfrm>
-            <a:off x="6208776" y="4645152"/>
+            <a:off x="6208776" y="4041648"/>
             <a:ext cx="1517904" cy="347472"/>
           </a:xfrm>
           <a:prstGeom prst="rect">
@@ -11098,7 +11098,7 @@
         </p:nvGraphicFramePr>
         <p:xfrm>
           <a:off x="137160" y="841248"/>
-          <a:ext cx="5806440" cy="3474720"/>
+          <a:ext cx="5806440" cy="2834640"/>
         </p:xfrm>
         <a:graphic xmlns:a="http://schemas.openxmlformats.org/drawingml/2006/main">
           <a:graphicData uri="http://schemas.openxmlformats.org/drawingml/2006/chart">
@@ -11114,7 +11114,7 @@
         </p:nvGraphicFramePr>
         <p:xfrm>
           <a:off x="6172200" y="841248"/>
-          <a:ext cx="5806440" cy="3474720"/>
+          <a:ext cx="5806440" cy="2834640"/>
         </p:xfrm>
         <a:graphic xmlns:a="http://schemas.openxmlformats.org/drawingml/2006/main">
           <a:graphicData uri="http://schemas.openxmlformats.org/drawingml/2006/chart">
@@ -11130,7 +11130,7 @@
         </p:nvSpPr>
         <p:spPr>
           <a:xfrm>
-            <a:off x="0" y="4343400"/>
+            <a:off x="0" y="3730752"/>
             <a:ext cx="5989320" cy="274320"/>
           </a:xfrm>
           <a:prstGeom prst="rect">
@@ -11155,7 +11155,7 @@
         </p:nvSpPr>
         <p:spPr>
           <a:xfrm>
-            <a:off x="0" y="4343400"/>
+            <a:off x="0" y="3730752"/>
             <a:ext cx="54864" cy="274320"/>
           </a:xfrm>
           <a:prstGeom prst="rect">
@@ -11180,7 +11180,7 @@
         </p:nvSpPr>
         <p:spPr>
           <a:xfrm>
-            <a:off x="109728" y="4343400"/>
+            <a:off x="109728" y="3730752"/>
             <a:ext cx="5879592" cy="274320"/>
           </a:xfrm>
           <a:prstGeom prst="rect">
@@ -11219,7 +11219,7 @@
         </p:nvSpPr>
         <p:spPr>
           <a:xfrm>
-            <a:off x="137160" y="4645152"/>
+            <a:off x="137160" y="4041648"/>
             <a:ext cx="1161288" cy="347472"/>
           </a:xfrm>
           <a:prstGeom prst="rect">
@@ -11258,7 +11258,7 @@
         </p:nvSpPr>
         <p:spPr>
           <a:xfrm>
-            <a:off x="1298448" y="4645152"/>
+            <a:off x="1298448" y="4041648"/>
             <a:ext cx="1161288" cy="347472"/>
           </a:xfrm>
           <a:prstGeom prst="rect">
@@ -11297,7 +11297,7 @@
         </p:nvSpPr>
         <p:spPr>
           <a:xfrm>
-            <a:off x="2459736" y="4645152"/>
+            <a:off x="2459736" y="4041648"/>
             <a:ext cx="1161288" cy="347472"/>
           </a:xfrm>
           <a:prstGeom prst="rect">
@@ -11336,7 +11336,7 @@
         </p:nvSpPr>
         <p:spPr>
           <a:xfrm>
-            <a:off x="3621024" y="4645152"/>
+            <a:off x="3621024" y="4041648"/>
             <a:ext cx="1161288" cy="347472"/>
           </a:xfrm>
           <a:prstGeom prst="rect">
@@ -11375,7 +11375,7 @@
         </p:nvSpPr>
         <p:spPr>
           <a:xfrm>
-            <a:off x="4782312" y="4645152"/>
+            <a:off x="4782312" y="4041648"/>
             <a:ext cx="1161288" cy="347472"/>
           </a:xfrm>
           <a:prstGeom prst="rect">
@@ -11414,7 +11414,7 @@
         </p:nvSpPr>
         <p:spPr>
           <a:xfrm>
-            <a:off x="6172200" y="4343400"/>
+            <a:off x="6172200" y="3730752"/>
             <a:ext cx="5852160" cy="274320"/>
           </a:xfrm>
           <a:prstGeom prst="rect">
@@ -11439,7 +11439,7 @@
         </p:nvSpPr>
         <p:spPr>
           <a:xfrm>
-            <a:off x="6172200" y="4343400"/>
+            <a:off x="6172200" y="3730752"/>
             <a:ext cx="54864" cy="274320"/>
           </a:xfrm>
           <a:prstGeom prst="rect">
@@ -11464,7 +11464,7 @@
         </p:nvSpPr>
         <p:spPr>
           <a:xfrm>
-            <a:off x="6281928" y="4343400"/>
+            <a:off x="6281928" y="3730752"/>
             <a:ext cx="5742432" cy="274320"/>
           </a:xfrm>
           <a:prstGeom prst="rect">
@@ -11503,7 +11503,7 @@
         </p:nvSpPr>
         <p:spPr>
           <a:xfrm>
-            <a:off x="6172200" y="4645152"/>
+            <a:off x="6172200" y="4041648"/>
             <a:ext cx="1161288" cy="347472"/>
           </a:xfrm>
           <a:prstGeom prst="rect">
@@ -11542,7 +11542,7 @@
         </p:nvSpPr>
         <p:spPr>
           <a:xfrm>
-            <a:off x="7333488" y="4645152"/>
+            <a:off x="7333488" y="4041648"/>
             <a:ext cx="1161288" cy="347472"/>
           </a:xfrm>
           <a:prstGeom prst="rect">
@@ -11581,7 +11581,7 @@
         </p:nvSpPr>
         <p:spPr>
           <a:xfrm>
-            <a:off x="8494776" y="4645152"/>
+            <a:off x="8494776" y="4041648"/>
             <a:ext cx="1161288" cy="347472"/>
           </a:xfrm>
           <a:prstGeom prst="rect">
@@ -11620,7 +11620,7 @@
         </p:nvSpPr>
         <p:spPr>
           <a:xfrm>
-            <a:off x="9656064" y="4645152"/>
+            <a:off x="9656064" y="4041648"/>
             <a:ext cx="1161288" cy="347472"/>
           </a:xfrm>
           <a:prstGeom prst="rect">
@@ -11659,7 +11659,7 @@
         </p:nvSpPr>
         <p:spPr>
           <a:xfrm>
-            <a:off x="10817352" y="4645152"/>
+            <a:off x="10817352" y="4041648"/>
             <a:ext cx="1161288" cy="347472"/>
           </a:xfrm>
           <a:prstGeom prst="rect">
@@ -12004,7 +12004,7 @@
         </p:nvGraphicFramePr>
         <p:xfrm>
           <a:off x="137160" y="841248"/>
-          <a:ext cx="7589520" cy="3474720"/>
+          <a:ext cx="7589520" cy="2834640"/>
         </p:xfrm>
         <a:graphic xmlns:a="http://schemas.openxmlformats.org/drawingml/2006/main">
           <a:graphicData uri="http://schemas.openxmlformats.org/drawingml/2006/chart">
@@ -12020,7 +12020,7 @@
         </p:nvSpPr>
         <p:spPr>
           <a:xfrm>
-            <a:off x="0" y="4343400"/>
+            <a:off x="0" y="3730752"/>
             <a:ext cx="7772400" cy="274320"/>
           </a:xfrm>
           <a:prstGeom prst="rect">
@@ -12045,7 +12045,7 @@
         </p:nvSpPr>
         <p:spPr>
           <a:xfrm>
-            <a:off x="0" y="4343400"/>
+            <a:off x="0" y="3730752"/>
             <a:ext cx="54864" cy="274320"/>
           </a:xfrm>
           <a:prstGeom prst="rect">
@@ -12070,7 +12070,7 @@
         </p:nvSpPr>
         <p:spPr>
           <a:xfrm>
-            <a:off x="109728" y="4343400"/>
+            <a:off x="109728" y="3730752"/>
             <a:ext cx="7662672" cy="274320"/>
           </a:xfrm>
           <a:prstGeom prst="rect">
@@ -12109,7 +12109,7 @@
         </p:nvSpPr>
         <p:spPr>
           <a:xfrm>
-            <a:off x="137160" y="4645152"/>
+            <a:off x="137160" y="4041648"/>
             <a:ext cx="1517904" cy="347472"/>
           </a:xfrm>
           <a:prstGeom prst="rect">
@@ -12148,7 +12148,7 @@
         </p:nvSpPr>
         <p:spPr>
           <a:xfrm>
-            <a:off x="1655064" y="4645152"/>
+            <a:off x="1655064" y="4041648"/>
             <a:ext cx="1517904" cy="347472"/>
           </a:xfrm>
           <a:prstGeom prst="rect">
@@ -12187,7 +12187,7 @@
         </p:nvSpPr>
         <p:spPr>
           <a:xfrm>
-            <a:off x="3172968" y="4645152"/>
+            <a:off x="3172968" y="4041648"/>
             <a:ext cx="1517904" cy="347472"/>
           </a:xfrm>
           <a:prstGeom prst="rect">
@@ -12226,7 +12226,7 @@
         </p:nvSpPr>
         <p:spPr>
           <a:xfrm>
-            <a:off x="4690872" y="4645152"/>
+            <a:off x="4690872" y="4041648"/>
             <a:ext cx="1517904" cy="347472"/>
           </a:xfrm>
           <a:prstGeom prst="rect">
@@ -12265,7 +12265,7 @@
         </p:nvSpPr>
         <p:spPr>
           <a:xfrm>
-            <a:off x="6208776" y="4645152"/>
+            <a:off x="6208776" y="4041648"/>
             <a:ext cx="1517904" cy="347472"/>
           </a:xfrm>
           <a:prstGeom prst="rect">

</xml_diff>

<commit_message>
Auto-build: 2026-03-12 01:58 UTC
</commit_message>
<xml_diff>
--- a/reports/2026-01.pptx
+++ b/reports/2026-01.pptx
@@ -7123,7 +7123,7 @@
         </p:nvGraphicFramePr>
         <p:xfrm>
           <a:off x="137160" y="841248"/>
-          <a:ext cx="7589520" cy="2834640"/>
+          <a:ext cx="7589520" cy="3200400"/>
         </p:xfrm>
         <a:graphic xmlns:a="http://schemas.openxmlformats.org/drawingml/2006/main">
           <a:graphicData uri="http://schemas.openxmlformats.org/drawingml/2006/chart">
@@ -7139,7 +7139,7 @@
         </p:nvSpPr>
         <p:spPr>
           <a:xfrm>
-            <a:off x="0" y="3730752"/>
+            <a:off x="0" y="4114800"/>
             <a:ext cx="7772400" cy="274320"/>
           </a:xfrm>
           <a:prstGeom prst="rect">
@@ -7164,7 +7164,7 @@
         </p:nvSpPr>
         <p:spPr>
           <a:xfrm>
-            <a:off x="0" y="3730752"/>
+            <a:off x="0" y="4114800"/>
             <a:ext cx="54864" cy="274320"/>
           </a:xfrm>
           <a:prstGeom prst="rect">
@@ -7189,7 +7189,7 @@
         </p:nvSpPr>
         <p:spPr>
           <a:xfrm>
-            <a:off x="109728" y="3730752"/>
+            <a:off x="109728" y="4114800"/>
             <a:ext cx="7662672" cy="274320"/>
           </a:xfrm>
           <a:prstGeom prst="rect">
@@ -7228,7 +7228,7 @@
         </p:nvSpPr>
         <p:spPr>
           <a:xfrm>
-            <a:off x="137160" y="4041648"/>
+            <a:off x="137160" y="4425696"/>
             <a:ext cx="1517904" cy="347472"/>
           </a:xfrm>
           <a:prstGeom prst="rect">
@@ -7267,7 +7267,7 @@
         </p:nvSpPr>
         <p:spPr>
           <a:xfrm>
-            <a:off x="1655064" y="4041648"/>
+            <a:off x="1655064" y="4425696"/>
             <a:ext cx="1517904" cy="347472"/>
           </a:xfrm>
           <a:prstGeom prst="rect">
@@ -7306,7 +7306,7 @@
         </p:nvSpPr>
         <p:spPr>
           <a:xfrm>
-            <a:off x="3172968" y="4041648"/>
+            <a:off x="3172968" y="4425696"/>
             <a:ext cx="1517904" cy="347472"/>
           </a:xfrm>
           <a:prstGeom prst="rect">
@@ -7345,7 +7345,7 @@
         </p:nvSpPr>
         <p:spPr>
           <a:xfrm>
-            <a:off x="4690872" y="4041648"/>
+            <a:off x="4690872" y="4425696"/>
             <a:ext cx="1517904" cy="347472"/>
           </a:xfrm>
           <a:prstGeom prst="rect">
@@ -7384,7 +7384,7 @@
         </p:nvSpPr>
         <p:spPr>
           <a:xfrm>
-            <a:off x="6208776" y="4041648"/>
+            <a:off x="6208776" y="4425696"/>
             <a:ext cx="1517904" cy="347472"/>
           </a:xfrm>
           <a:prstGeom prst="rect">
@@ -7942,7 +7942,24 @@
                 <a:ea typeface="Calibri" pitchFamily="34" charset="-122"/>
                 <a:cs typeface="Calibri" pitchFamily="34" charset="-120"/>
               </a:rPr>
-              <a:t>—</a:t>
+              <a:t>Group total: 30,291 applications.</a:t>
+            </a:r>
+            <a:endParaRPr lang="en-US" sz="900" dirty="0"/>
+          </a:p>
+          <a:p>
+            <a:pPr indent="0" marL="0">
+              <a:buNone/>
+            </a:pPr>
+            <a:r>
+              <a:rPr lang="en-US" sz="900" dirty="0">
+                <a:solidFill>
+                  <a:srgbClr val="2D2A26"/>
+                </a:solidFill>
+                <a:latin typeface="Calibri" pitchFamily="34" charset="0"/>
+                <a:ea typeface="Calibri" pitchFamily="34" charset="-122"/>
+                <a:cs typeface="Calibri" pitchFamily="34" charset="-120"/>
+              </a:rPr>
+              <a:t>Kenya had the highest avg applications per team (111).</a:t>
             </a:r>
             <a:endParaRPr lang="en-US" sz="900" dirty="0"/>
           </a:p>
@@ -8262,7 +8279,7 @@
         </p:nvGraphicFramePr>
         <p:xfrm>
           <a:off x="137160" y="841248"/>
-          <a:ext cx="7589520" cy="2834640"/>
+          <a:ext cx="7589520" cy="3200400"/>
         </p:xfrm>
         <a:graphic xmlns:a="http://schemas.openxmlformats.org/drawingml/2006/main">
           <a:graphicData uri="http://schemas.openxmlformats.org/drawingml/2006/chart">
@@ -8278,7 +8295,7 @@
         </p:nvSpPr>
         <p:spPr>
           <a:xfrm>
-            <a:off x="0" y="3730752"/>
+            <a:off x="0" y="4114800"/>
             <a:ext cx="7772400" cy="274320"/>
           </a:xfrm>
           <a:prstGeom prst="rect">
@@ -8303,7 +8320,7 @@
         </p:nvSpPr>
         <p:spPr>
           <a:xfrm>
-            <a:off x="0" y="3730752"/>
+            <a:off x="0" y="4114800"/>
             <a:ext cx="54864" cy="274320"/>
           </a:xfrm>
           <a:prstGeom prst="rect">
@@ -8328,7 +8345,7 @@
         </p:nvSpPr>
         <p:spPr>
           <a:xfrm>
-            <a:off x="109728" y="3730752"/>
+            <a:off x="109728" y="4114800"/>
             <a:ext cx="7662672" cy="274320"/>
           </a:xfrm>
           <a:prstGeom prst="rect">
@@ -8367,7 +8384,7 @@
         </p:nvSpPr>
         <p:spPr>
           <a:xfrm>
-            <a:off x="137160" y="4041648"/>
+            <a:off x="137160" y="4425696"/>
             <a:ext cx="1517904" cy="347472"/>
           </a:xfrm>
           <a:prstGeom prst="rect">
@@ -8406,7 +8423,7 @@
         </p:nvSpPr>
         <p:spPr>
           <a:xfrm>
-            <a:off x="1655064" y="4041648"/>
+            <a:off x="1655064" y="4425696"/>
             <a:ext cx="1517904" cy="347472"/>
           </a:xfrm>
           <a:prstGeom prst="rect">
@@ -8445,7 +8462,7 @@
         </p:nvSpPr>
         <p:spPr>
           <a:xfrm>
-            <a:off x="3172968" y="4041648"/>
+            <a:off x="3172968" y="4425696"/>
             <a:ext cx="1517904" cy="347472"/>
           </a:xfrm>
           <a:prstGeom prst="rect">
@@ -8484,7 +8501,7 @@
         </p:nvSpPr>
         <p:spPr>
           <a:xfrm>
-            <a:off x="4690872" y="4041648"/>
+            <a:off x="4690872" y="4425696"/>
             <a:ext cx="1517904" cy="347472"/>
           </a:xfrm>
           <a:prstGeom prst="rect">
@@ -8523,7 +8540,7 @@
         </p:nvSpPr>
         <p:spPr>
           <a:xfrm>
-            <a:off x="6208776" y="4041648"/>
+            <a:off x="6208776" y="4425696"/>
             <a:ext cx="1517904" cy="347472"/>
           </a:xfrm>
           <a:prstGeom prst="rect">
@@ -9081,7 +9098,24 @@
                 <a:ea typeface="Calibri" pitchFamily="34" charset="-122"/>
                 <a:cs typeface="Calibri" pitchFamily="34" charset="-120"/>
               </a:rPr>
-              <a:t>—</a:t>
+              <a:t>Group total approvals: 27,600.</a:t>
+            </a:r>
+            <a:endParaRPr lang="en-US" sz="900" dirty="0"/>
+          </a:p>
+          <a:p>
+            <a:pPr indent="0" marL="0">
+              <a:buNone/>
+            </a:pPr>
+            <a:r>
+              <a:rPr lang="en-US" sz="900" dirty="0">
+                <a:solidFill>
+                  <a:srgbClr val="2D2A26"/>
+                </a:solidFill>
+                <a:latin typeface="Calibri" pitchFamily="34" charset="0"/>
+                <a:ea typeface="Calibri" pitchFamily="34" charset="-122"/>
+                <a:cs typeface="Calibri" pitchFamily="34" charset="-120"/>
+              </a:rPr>
+              <a:t>Tanzania had the highest approval rate (96.4%).</a:t>
             </a:r>
             <a:endParaRPr lang="en-US" sz="900" dirty="0"/>
           </a:p>
@@ -9401,7 +9435,7 @@
         </p:nvGraphicFramePr>
         <p:xfrm>
           <a:off x="137160" y="841248"/>
-          <a:ext cx="7589520" cy="2834640"/>
+          <a:ext cx="7589520" cy="3200400"/>
         </p:xfrm>
         <a:graphic xmlns:a="http://schemas.openxmlformats.org/drawingml/2006/main">
           <a:graphicData uri="http://schemas.openxmlformats.org/drawingml/2006/chart">
@@ -9417,7 +9451,7 @@
         </p:nvSpPr>
         <p:spPr>
           <a:xfrm>
-            <a:off x="0" y="3730752"/>
+            <a:off x="0" y="4114800"/>
             <a:ext cx="7772400" cy="274320"/>
           </a:xfrm>
           <a:prstGeom prst="rect">
@@ -9442,7 +9476,7 @@
         </p:nvSpPr>
         <p:spPr>
           <a:xfrm>
-            <a:off x="0" y="3730752"/>
+            <a:off x="0" y="4114800"/>
             <a:ext cx="54864" cy="274320"/>
           </a:xfrm>
           <a:prstGeom prst="rect">
@@ -9467,7 +9501,7 @@
         </p:nvSpPr>
         <p:spPr>
           <a:xfrm>
-            <a:off x="109728" y="3730752"/>
+            <a:off x="109728" y="4114800"/>
             <a:ext cx="7662672" cy="274320"/>
           </a:xfrm>
           <a:prstGeom prst="rect">
@@ -9506,7 +9540,7 @@
         </p:nvSpPr>
         <p:spPr>
           <a:xfrm>
-            <a:off x="137160" y="4041648"/>
+            <a:off x="137160" y="4425696"/>
             <a:ext cx="1517904" cy="347472"/>
           </a:xfrm>
           <a:prstGeom prst="rect">
@@ -9545,7 +9579,7 @@
         </p:nvSpPr>
         <p:spPr>
           <a:xfrm>
-            <a:off x="1655064" y="4041648"/>
+            <a:off x="1655064" y="4425696"/>
             <a:ext cx="1517904" cy="347472"/>
           </a:xfrm>
           <a:prstGeom prst="rect">
@@ -9584,7 +9618,7 @@
         </p:nvSpPr>
         <p:spPr>
           <a:xfrm>
-            <a:off x="3172968" y="4041648"/>
+            <a:off x="3172968" y="4425696"/>
             <a:ext cx="1517904" cy="347472"/>
           </a:xfrm>
           <a:prstGeom prst="rect">
@@ -9623,7 +9657,7 @@
         </p:nvSpPr>
         <p:spPr>
           <a:xfrm>
-            <a:off x="4690872" y="4041648"/>
+            <a:off x="4690872" y="4425696"/>
             <a:ext cx="1517904" cy="347472"/>
           </a:xfrm>
           <a:prstGeom prst="rect">
@@ -9662,7 +9696,7 @@
         </p:nvSpPr>
         <p:spPr>
           <a:xfrm>
-            <a:off x="6208776" y="4041648"/>
+            <a:off x="6208776" y="4425696"/>
             <a:ext cx="1517904" cy="347472"/>
           </a:xfrm>
           <a:prstGeom prst="rect">
@@ -10689,7 +10723,24 @@
                 <a:ea typeface="Calibri" pitchFamily="34" charset="-122"/>
                 <a:cs typeface="Calibri" pitchFamily="34" charset="-120"/>
               </a:rPr>
-              <a:t>—</a:t>
+              <a:t>Total disbursed: $3,937,968.</a:t>
+            </a:r>
+            <a:endParaRPr lang="en-US" sz="900" dirty="0"/>
+          </a:p>
+          <a:p>
+            <a:pPr indent="0" marL="0">
+              <a:buNone/>
+            </a:pPr>
+            <a:r>
+              <a:rPr lang="en-US" sz="900" dirty="0">
+                <a:solidFill>
+                  <a:srgbClr val="2D2A26"/>
+                </a:solidFill>
+                <a:latin typeface="Calibri" pitchFamily="34" charset="0"/>
+                <a:ea typeface="Calibri" pitchFamily="34" charset="-122"/>
+                <a:cs typeface="Calibri" pitchFamily="34" charset="-120"/>
+              </a:rPr>
+              <a:t>Tanzania had the highest disbursements ($2,069,729).</a:t>
             </a:r>
             <a:endParaRPr lang="en-US" sz="900" dirty="0"/>
           </a:p>
@@ -11098,7 +11149,7 @@
         </p:nvGraphicFramePr>
         <p:xfrm>
           <a:off x="137160" y="841248"/>
-          <a:ext cx="5806440" cy="2834640"/>
+          <a:ext cx="5806440" cy="3200400"/>
         </p:xfrm>
         <a:graphic xmlns:a="http://schemas.openxmlformats.org/drawingml/2006/main">
           <a:graphicData uri="http://schemas.openxmlformats.org/drawingml/2006/chart">
@@ -11114,7 +11165,7 @@
         </p:nvGraphicFramePr>
         <p:xfrm>
           <a:off x="6172200" y="841248"/>
-          <a:ext cx="5806440" cy="2834640"/>
+          <a:ext cx="5806440" cy="3200400"/>
         </p:xfrm>
         <a:graphic xmlns:a="http://schemas.openxmlformats.org/drawingml/2006/main">
           <a:graphicData uri="http://schemas.openxmlformats.org/drawingml/2006/chart">
@@ -11130,7 +11181,7 @@
         </p:nvSpPr>
         <p:spPr>
           <a:xfrm>
-            <a:off x="0" y="3730752"/>
+            <a:off x="0" y="4114800"/>
             <a:ext cx="5989320" cy="274320"/>
           </a:xfrm>
           <a:prstGeom prst="rect">
@@ -11155,7 +11206,7 @@
         </p:nvSpPr>
         <p:spPr>
           <a:xfrm>
-            <a:off x="0" y="3730752"/>
+            <a:off x="0" y="4114800"/>
             <a:ext cx="54864" cy="274320"/>
           </a:xfrm>
           <a:prstGeom prst="rect">
@@ -11180,7 +11231,7 @@
         </p:nvSpPr>
         <p:spPr>
           <a:xfrm>
-            <a:off x="109728" y="3730752"/>
+            <a:off x="109728" y="4114800"/>
             <a:ext cx="5879592" cy="274320"/>
           </a:xfrm>
           <a:prstGeom prst="rect">
@@ -11219,7 +11270,7 @@
         </p:nvSpPr>
         <p:spPr>
           <a:xfrm>
-            <a:off x="137160" y="4041648"/>
+            <a:off x="137160" y="4425696"/>
             <a:ext cx="1161288" cy="347472"/>
           </a:xfrm>
           <a:prstGeom prst="rect">
@@ -11258,7 +11309,7 @@
         </p:nvSpPr>
         <p:spPr>
           <a:xfrm>
-            <a:off x="1298448" y="4041648"/>
+            <a:off x="1298448" y="4425696"/>
             <a:ext cx="1161288" cy="347472"/>
           </a:xfrm>
           <a:prstGeom prst="rect">
@@ -11297,7 +11348,7 @@
         </p:nvSpPr>
         <p:spPr>
           <a:xfrm>
-            <a:off x="2459736" y="4041648"/>
+            <a:off x="2459736" y="4425696"/>
             <a:ext cx="1161288" cy="347472"/>
           </a:xfrm>
           <a:prstGeom prst="rect">
@@ -11336,7 +11387,7 @@
         </p:nvSpPr>
         <p:spPr>
           <a:xfrm>
-            <a:off x="3621024" y="4041648"/>
+            <a:off x="3621024" y="4425696"/>
             <a:ext cx="1161288" cy="347472"/>
           </a:xfrm>
           <a:prstGeom prst="rect">
@@ -11375,7 +11426,7 @@
         </p:nvSpPr>
         <p:spPr>
           <a:xfrm>
-            <a:off x="4782312" y="4041648"/>
+            <a:off x="4782312" y="4425696"/>
             <a:ext cx="1161288" cy="347472"/>
           </a:xfrm>
           <a:prstGeom prst="rect">
@@ -11414,7 +11465,7 @@
         </p:nvSpPr>
         <p:spPr>
           <a:xfrm>
-            <a:off x="6172200" y="3730752"/>
+            <a:off x="6172200" y="4114800"/>
             <a:ext cx="5852160" cy="274320"/>
           </a:xfrm>
           <a:prstGeom prst="rect">
@@ -11439,7 +11490,7 @@
         </p:nvSpPr>
         <p:spPr>
           <a:xfrm>
-            <a:off x="6172200" y="3730752"/>
+            <a:off x="6172200" y="4114800"/>
             <a:ext cx="54864" cy="274320"/>
           </a:xfrm>
           <a:prstGeom prst="rect">
@@ -11464,7 +11515,7 @@
         </p:nvSpPr>
         <p:spPr>
           <a:xfrm>
-            <a:off x="6281928" y="3730752"/>
+            <a:off x="6281928" y="4114800"/>
             <a:ext cx="5742432" cy="274320"/>
           </a:xfrm>
           <a:prstGeom prst="rect">
@@ -11503,7 +11554,7 @@
         </p:nvSpPr>
         <p:spPr>
           <a:xfrm>
-            <a:off x="6172200" y="4041648"/>
+            <a:off x="6172200" y="4425696"/>
             <a:ext cx="1161288" cy="347472"/>
           </a:xfrm>
           <a:prstGeom prst="rect">
@@ -11542,7 +11593,7 @@
         </p:nvSpPr>
         <p:spPr>
           <a:xfrm>
-            <a:off x="7333488" y="4041648"/>
+            <a:off x="7333488" y="4425696"/>
             <a:ext cx="1161288" cy="347472"/>
           </a:xfrm>
           <a:prstGeom prst="rect">
@@ -11581,7 +11632,7 @@
         </p:nvSpPr>
         <p:spPr>
           <a:xfrm>
-            <a:off x="8494776" y="4041648"/>
+            <a:off x="8494776" y="4425696"/>
             <a:ext cx="1161288" cy="347472"/>
           </a:xfrm>
           <a:prstGeom prst="rect">
@@ -11620,7 +11671,7 @@
         </p:nvSpPr>
         <p:spPr>
           <a:xfrm>
-            <a:off x="9656064" y="4041648"/>
+            <a:off x="9656064" y="4425696"/>
             <a:ext cx="1161288" cy="347472"/>
           </a:xfrm>
           <a:prstGeom prst="rect">
@@ -11659,7 +11710,7 @@
         </p:nvSpPr>
         <p:spPr>
           <a:xfrm>
-            <a:off x="10817352" y="4041648"/>
+            <a:off x="10817352" y="4425696"/>
             <a:ext cx="1161288" cy="347472"/>
           </a:xfrm>
           <a:prstGeom prst="rect">
@@ -12004,7 +12055,7 @@
         </p:nvGraphicFramePr>
         <p:xfrm>
           <a:off x="137160" y="841248"/>
-          <a:ext cx="7589520" cy="2834640"/>
+          <a:ext cx="7589520" cy="3200400"/>
         </p:xfrm>
         <a:graphic xmlns:a="http://schemas.openxmlformats.org/drawingml/2006/main">
           <a:graphicData uri="http://schemas.openxmlformats.org/drawingml/2006/chart">
@@ -12020,7 +12071,7 @@
         </p:nvSpPr>
         <p:spPr>
           <a:xfrm>
-            <a:off x="0" y="3730752"/>
+            <a:off x="0" y="4114800"/>
             <a:ext cx="7772400" cy="274320"/>
           </a:xfrm>
           <a:prstGeom prst="rect">
@@ -12045,7 +12096,7 @@
         </p:nvSpPr>
         <p:spPr>
           <a:xfrm>
-            <a:off x="0" y="3730752"/>
+            <a:off x="0" y="4114800"/>
             <a:ext cx="54864" cy="274320"/>
           </a:xfrm>
           <a:prstGeom prst="rect">
@@ -12070,7 +12121,7 @@
         </p:nvSpPr>
         <p:spPr>
           <a:xfrm>
-            <a:off x="109728" y="3730752"/>
+            <a:off x="109728" y="4114800"/>
             <a:ext cx="7662672" cy="274320"/>
           </a:xfrm>
           <a:prstGeom prst="rect">
@@ -12109,7 +12160,7 @@
         </p:nvSpPr>
         <p:spPr>
           <a:xfrm>
-            <a:off x="137160" y="4041648"/>
+            <a:off x="137160" y="4425696"/>
             <a:ext cx="1517904" cy="347472"/>
           </a:xfrm>
           <a:prstGeom prst="rect">
@@ -12148,7 +12199,7 @@
         </p:nvSpPr>
         <p:spPr>
           <a:xfrm>
-            <a:off x="1655064" y="4041648"/>
+            <a:off x="1655064" y="4425696"/>
             <a:ext cx="1517904" cy="347472"/>
           </a:xfrm>
           <a:prstGeom prst="rect">
@@ -12187,7 +12238,7 @@
         </p:nvSpPr>
         <p:spPr>
           <a:xfrm>
-            <a:off x="3172968" y="4041648"/>
+            <a:off x="3172968" y="4425696"/>
             <a:ext cx="1517904" cy="347472"/>
           </a:xfrm>
           <a:prstGeom prst="rect">
@@ -12226,7 +12277,7 @@
         </p:nvSpPr>
         <p:spPr>
           <a:xfrm>
-            <a:off x="4690872" y="4041648"/>
+            <a:off x="4690872" y="4425696"/>
             <a:ext cx="1517904" cy="347472"/>
           </a:xfrm>
           <a:prstGeom prst="rect">
@@ -12265,7 +12316,7 @@
         </p:nvSpPr>
         <p:spPr>
           <a:xfrm>
-            <a:off x="6208776" y="4041648"/>
+            <a:off x="6208776" y="4425696"/>
             <a:ext cx="1517904" cy="347472"/>
           </a:xfrm>
           <a:prstGeom prst="rect">
@@ -12688,7 +12739,24 @@
                 <a:ea typeface="Calibri" pitchFamily="34" charset="-122"/>
                 <a:cs typeface="Calibri" pitchFamily="34" charset="-120"/>
               </a:rPr>
-              <a:t>—</a:t>
+              <a:t>Total loan book: $12,156,790.</a:t>
+            </a:r>
+            <a:endParaRPr lang="en-US" sz="900" dirty="0"/>
+          </a:p>
+          <a:p>
+            <a:pPr indent="0" marL="0">
+              <a:buNone/>
+            </a:pPr>
+            <a:r>
+              <a:rPr lang="en-US" sz="900" dirty="0">
+                <a:solidFill>
+                  <a:srgbClr val="2D2A26"/>
+                </a:solidFill>
+                <a:latin typeface="Calibri" pitchFamily="34" charset="0"/>
+                <a:ea typeface="Calibri" pitchFamily="34" charset="-122"/>
+                <a:cs typeface="Calibri" pitchFamily="34" charset="-120"/>
+              </a:rPr>
+              <a:t>Tanzania has the largest loan book ($5,610,176).</a:t>
             </a:r>
             <a:endParaRPr lang="en-US" sz="900" dirty="0"/>
           </a:p>

</xml_diff>

<commit_message>
Auto-build: 2026-03-12 02:09 UTC
</commit_message>
<xml_diff>
--- a/reports/2026-01.pptx
+++ b/reports/2026-01.pptx
@@ -158,7 +158,7 @@
               <a:lstStyle/>
               <a:p>
                 <a:pPr>
-                  <a:defRPr b="1" i="0" strike="noStrike" sz="900" u="none">
+                  <a:defRPr b="1" i="0" strike="noStrike" sz="1200" u="none">
                     <a:solidFill>
                       <a:srgbClr val="2D2A26"/>
                     </a:solidFill>
@@ -287,7 +287,7 @@
             <a:lstStyle/>
             <a:p>
               <a:pPr>
-                <a:defRPr b="1" i="0" strike="noStrike" sz="900" u="none">
+                <a:defRPr b="1" i="0" strike="noStrike" sz="1200" u="none">
                   <a:solidFill>
                     <a:srgbClr val="2D2A26"/>
                   </a:solidFill>
@@ -335,7 +335,7 @@
           <a:lstStyle/>
           <a:p>
             <a:pPr>
-              <a:defRPr sz="900" b="1" i="0" u="none" strike="noStrike">
+              <a:defRPr sz="1200" b="1" i="0" u="none" strike="noStrike">
                 <a:solidFill>
                   <a:srgbClr val="2D2A26"/>
                 </a:solidFill>
@@ -387,7 +387,7 @@
           <a:lstStyle/>
           <a:p>
             <a:pPr>
-              <a:defRPr sz="800" b="0" i="0" u="none" strike="noStrike">
+              <a:defRPr sz="1100" b="0" i="0" u="none" strike="noStrike">
                 <a:solidFill>
                   <a:srgbClr val="718096"/>
                 </a:solidFill>
@@ -469,7 +469,7 @@
               <a:lstStyle/>
               <a:p>
                 <a:pPr>
-                  <a:defRPr b="1" i="0" strike="noStrike" sz="900" u="none">
+                  <a:defRPr b="1" i="0" strike="noStrike" sz="1200" u="none">
                     <a:solidFill>
                       <a:srgbClr val="2D2A26"/>
                     </a:solidFill>
@@ -598,7 +598,7 @@
             <a:lstStyle/>
             <a:p>
               <a:pPr>
-                <a:defRPr b="1" i="0" strike="noStrike" sz="900" u="none">
+                <a:defRPr b="1" i="0" strike="noStrike" sz="1200" u="none">
                   <a:solidFill>
                     <a:srgbClr val="2D2A26"/>
                   </a:solidFill>
@@ -646,7 +646,7 @@
           <a:lstStyle/>
           <a:p>
             <a:pPr>
-              <a:defRPr sz="900" b="1" i="0" u="none" strike="noStrike">
+              <a:defRPr sz="1200" b="1" i="0" u="none" strike="noStrike">
                 <a:solidFill>
                   <a:srgbClr val="2D2A26"/>
                 </a:solidFill>
@@ -698,7 +698,7 @@
           <a:lstStyle/>
           <a:p>
             <a:pPr>
-              <a:defRPr sz="800" b="0" i="0" u="none" strike="noStrike">
+              <a:defRPr sz="1100" b="0" i="0" u="none" strike="noStrike">
                 <a:solidFill>
                   <a:srgbClr val="718096"/>
                 </a:solidFill>
@@ -780,7 +780,7 @@
               <a:lstStyle/>
               <a:p>
                 <a:pPr>
-                  <a:defRPr b="1" i="0" strike="noStrike" sz="900" u="none">
+                  <a:defRPr b="1" i="0" strike="noStrike" sz="1200" u="none">
                     <a:solidFill>
                       <a:srgbClr val="2D2A26"/>
                     </a:solidFill>
@@ -909,7 +909,7 @@
             <a:lstStyle/>
             <a:p>
               <a:pPr>
-                <a:defRPr b="1" i="0" strike="noStrike" sz="900" u="none">
+                <a:defRPr b="1" i="0" strike="noStrike" sz="1200" u="none">
                   <a:solidFill>
                     <a:srgbClr val="2D2A26"/>
                   </a:solidFill>
@@ -957,7 +957,7 @@
           <a:lstStyle/>
           <a:p>
             <a:pPr>
-              <a:defRPr sz="900" b="1" i="0" u="none" strike="noStrike">
+              <a:defRPr sz="1200" b="1" i="0" u="none" strike="noStrike">
                 <a:solidFill>
                   <a:srgbClr val="2D2A26"/>
                 </a:solidFill>
@@ -1009,7 +1009,7 @@
           <a:lstStyle/>
           <a:p>
             <a:pPr>
-              <a:defRPr sz="800" b="0" i="0" u="none" strike="noStrike">
+              <a:defRPr sz="1100" b="0" i="0" u="none" strike="noStrike">
                 <a:solidFill>
                   <a:srgbClr val="718096"/>
                 </a:solidFill>
@@ -1091,7 +1091,7 @@
               <a:lstStyle/>
               <a:p>
                 <a:pPr>
-                  <a:defRPr b="1" i="0" strike="noStrike" sz="900" u="none">
+                  <a:defRPr b="1" i="0" strike="noStrike" sz="1200" u="none">
                     <a:solidFill>
                       <a:srgbClr val="2D2A26"/>
                     </a:solidFill>
@@ -1220,7 +1220,7 @@
             <a:lstStyle/>
             <a:p>
               <a:pPr>
-                <a:defRPr b="1" i="0" strike="noStrike" sz="900" u="none">
+                <a:defRPr b="1" i="0" strike="noStrike" sz="1200" u="none">
                   <a:solidFill>
                     <a:srgbClr val="2D2A26"/>
                   </a:solidFill>
@@ -1268,7 +1268,7 @@
           <a:lstStyle/>
           <a:p>
             <a:pPr>
-              <a:defRPr sz="900" b="1" i="0" u="none" strike="noStrike">
+              <a:defRPr sz="1200" b="1" i="0" u="none" strike="noStrike">
                 <a:solidFill>
                   <a:srgbClr val="2D2A26"/>
                 </a:solidFill>
@@ -1320,7 +1320,7 @@
           <a:lstStyle/>
           <a:p>
             <a:pPr>
-              <a:defRPr sz="800" b="0" i="0" u="none" strike="noStrike">
+              <a:defRPr sz="1100" b="0" i="0" u="none" strike="noStrike">
                 <a:solidFill>
                   <a:srgbClr val="718096"/>
                 </a:solidFill>
@@ -1402,7 +1402,7 @@
               <a:lstStyle/>
               <a:p>
                 <a:pPr>
-                  <a:defRPr b="1" i="0" strike="noStrike" sz="900" u="none">
+                  <a:defRPr b="1" i="0" strike="noStrike" sz="1200" u="none">
                     <a:solidFill>
                       <a:srgbClr val="2D2A26"/>
                     </a:solidFill>
@@ -1531,7 +1531,7 @@
             <a:lstStyle/>
             <a:p>
               <a:pPr>
-                <a:defRPr b="1" i="0" strike="noStrike" sz="900" u="none">
+                <a:defRPr b="1" i="0" strike="noStrike" sz="1200" u="none">
                   <a:solidFill>
                     <a:srgbClr val="2D2A26"/>
                   </a:solidFill>
@@ -1579,7 +1579,7 @@
           <a:lstStyle/>
           <a:p>
             <a:pPr>
-              <a:defRPr sz="900" b="1" i="0" u="none" strike="noStrike">
+              <a:defRPr sz="1200" b="1" i="0" u="none" strike="noStrike">
                 <a:solidFill>
                   <a:srgbClr val="2D2A26"/>
                 </a:solidFill>
@@ -1631,7 +1631,7 @@
           <a:lstStyle/>
           <a:p>
             <a:pPr>
-              <a:defRPr sz="800" b="0" i="0" u="none" strike="noStrike">
+              <a:defRPr sz="1100" b="0" i="0" u="none" strike="noStrike">
                 <a:solidFill>
                   <a:srgbClr val="718096"/>
                 </a:solidFill>
@@ -1713,7 +1713,7 @@
               <a:lstStyle/>
               <a:p>
                 <a:pPr>
-                  <a:defRPr b="1" i="0" strike="noStrike" sz="900" u="none">
+                  <a:defRPr b="1" i="0" strike="noStrike" sz="1200" u="none">
                     <a:solidFill>
                       <a:srgbClr val="2D2A26"/>
                     </a:solidFill>
@@ -1842,7 +1842,7 @@
             <a:lstStyle/>
             <a:p>
               <a:pPr>
-                <a:defRPr b="1" i="0" strike="noStrike" sz="900" u="none">
+                <a:defRPr b="1" i="0" strike="noStrike" sz="1200" u="none">
                   <a:solidFill>
                     <a:srgbClr val="2D2A26"/>
                   </a:solidFill>
@@ -1890,7 +1890,7 @@
           <a:lstStyle/>
           <a:p>
             <a:pPr>
-              <a:defRPr sz="900" b="1" i="0" u="none" strike="noStrike">
+              <a:defRPr sz="1200" b="1" i="0" u="none" strike="noStrike">
                 <a:solidFill>
                   <a:srgbClr val="2D2A26"/>
                 </a:solidFill>
@@ -1942,7 +1942,7 @@
           <a:lstStyle/>
           <a:p>
             <a:pPr>
-              <a:defRPr sz="800" b="0" i="0" u="none" strike="noStrike">
+              <a:defRPr sz="1100" b="0" i="0" u="none" strike="noStrike">
                 <a:solidFill>
                   <a:srgbClr val="718096"/>
                 </a:solidFill>
@@ -2024,7 +2024,7 @@
               <a:lstStyle/>
               <a:p>
                 <a:pPr>
-                  <a:defRPr b="1" i="0" strike="noStrike" sz="900" u="none">
+                  <a:defRPr b="1" i="0" strike="noStrike" sz="1200" u="none">
                     <a:solidFill>
                       <a:srgbClr val="2D2A26"/>
                     </a:solidFill>
@@ -2153,7 +2153,7 @@
             <a:lstStyle/>
             <a:p>
               <a:pPr>
-                <a:defRPr b="1" i="0" strike="noStrike" sz="900" u="none">
+                <a:defRPr b="1" i="0" strike="noStrike" sz="1200" u="none">
                   <a:solidFill>
                     <a:srgbClr val="2D2A26"/>
                   </a:solidFill>
@@ -2201,7 +2201,7 @@
           <a:lstStyle/>
           <a:p>
             <a:pPr>
-              <a:defRPr sz="900" b="1" i="0" u="none" strike="noStrike">
+              <a:defRPr sz="1200" b="1" i="0" u="none" strike="noStrike">
                 <a:solidFill>
                   <a:srgbClr val="2D2A26"/>
                 </a:solidFill>
@@ -2253,7 +2253,7 @@
           <a:lstStyle/>
           <a:p>
             <a:pPr>
-              <a:defRPr sz="800" b="0" i="0" u="none" strike="noStrike">
+              <a:defRPr sz="1100" b="0" i="0" u="none" strike="noStrike">
                 <a:solidFill>
                   <a:srgbClr val="718096"/>
                 </a:solidFill>
@@ -2335,7 +2335,7 @@
               <a:lstStyle/>
               <a:p>
                 <a:pPr>
-                  <a:defRPr b="1" i="0" strike="noStrike" sz="900" u="none">
+                  <a:defRPr b="1" i="0" strike="noStrike" sz="1200" u="none">
                     <a:solidFill>
                       <a:srgbClr val="2D2A26"/>
                     </a:solidFill>
@@ -2464,7 +2464,7 @@
             <a:lstStyle/>
             <a:p>
               <a:pPr>
-                <a:defRPr b="1" i="0" strike="noStrike" sz="900" u="none">
+                <a:defRPr b="1" i="0" strike="noStrike" sz="1200" u="none">
                   <a:solidFill>
                     <a:srgbClr val="2D2A26"/>
                   </a:solidFill>
@@ -2512,7 +2512,7 @@
           <a:lstStyle/>
           <a:p>
             <a:pPr>
-              <a:defRPr sz="900" b="1" i="0" u="none" strike="noStrike">
+              <a:defRPr sz="1200" b="1" i="0" u="none" strike="noStrike">
                 <a:solidFill>
                   <a:srgbClr val="2D2A26"/>
                 </a:solidFill>
@@ -2564,7 +2564,7 @@
           <a:lstStyle/>
           <a:p>
             <a:pPr>
-              <a:defRPr sz="800" b="0" i="0" u="none" strike="noStrike">
+              <a:defRPr sz="1100" b="0" i="0" u="none" strike="noStrike">
                 <a:solidFill>
                   <a:srgbClr val="718096"/>
                 </a:solidFill>
@@ -2646,7 +2646,7 @@
               <a:lstStyle/>
               <a:p>
                 <a:pPr>
-                  <a:defRPr b="1" i="0" strike="noStrike" sz="900" u="none">
+                  <a:defRPr b="1" i="0" strike="noStrike" sz="1200" u="none">
                     <a:solidFill>
                       <a:srgbClr val="2D2A26"/>
                     </a:solidFill>
@@ -2775,7 +2775,7 @@
             <a:lstStyle/>
             <a:p>
               <a:pPr>
-                <a:defRPr b="1" i="0" strike="noStrike" sz="900" u="none">
+                <a:defRPr b="1" i="0" strike="noStrike" sz="1200" u="none">
                   <a:solidFill>
                     <a:srgbClr val="2D2A26"/>
                   </a:solidFill>
@@ -2823,7 +2823,7 @@
           <a:lstStyle/>
           <a:p>
             <a:pPr>
-              <a:defRPr sz="900" b="1" i="0" u="none" strike="noStrike">
+              <a:defRPr sz="1200" b="1" i="0" u="none" strike="noStrike">
                 <a:solidFill>
                   <a:srgbClr val="2D2A26"/>
                 </a:solidFill>
@@ -2875,7 +2875,7 @@
           <a:lstStyle/>
           <a:p>
             <a:pPr>
-              <a:defRPr sz="800" b="0" i="0" u="none" strike="noStrike">
+              <a:defRPr sz="1100" b="0" i="0" u="none" strike="noStrike">
                 <a:solidFill>
                   <a:srgbClr val="718096"/>
                 </a:solidFill>
@@ -5217,7 +5217,7 @@
         <p:spPr>
           <a:xfrm>
             <a:off x="0" y="539496"/>
-            <a:ext cx="12161520" cy="274320"/>
+            <a:ext cx="12161520" cy="292608"/>
           </a:xfrm>
           <a:prstGeom prst="rect">
             <a:avLst/>
@@ -5242,7 +5242,7 @@
         <p:spPr>
           <a:xfrm>
             <a:off x="0" y="539496"/>
-            <a:ext cx="54864" cy="274320"/>
+            <a:ext cx="54864" cy="292608"/>
           </a:xfrm>
           <a:prstGeom prst="rect">
             <a:avLst/>
@@ -5267,7 +5267,7 @@
         <p:spPr>
           <a:xfrm>
             <a:off x="109728" y="539496"/>
-            <a:ext cx="12051792" cy="274320"/>
+            <a:ext cx="12051792" cy="292608"/>
           </a:xfrm>
           <a:prstGeom prst="rect">
             <a:avLst/>
@@ -5283,7 +5283,7 @@
               <a:buNone/>
             </a:pPr>
             <a:r>
-              <a:rPr lang="en-US" sz="900" b="1" dirty="0">
+              <a:rPr lang="en-US" sz="1200" b="1" dirty="0">
                 <a:solidFill>
                   <a:srgbClr val="5D300F"/>
                 </a:solidFill>
@@ -5293,7 +5293,7 @@
               </a:rPr>
               <a:t>Average Staff Cost Per Team by Country (USD) – January 2026</a:t>
             </a:r>
-            <a:endParaRPr lang="en-US" sz="900" dirty="0"/>
+            <a:endParaRPr lang="en-US" sz="1200" dirty="0"/>
           </a:p>
         </p:txBody>
       </p:sp>
@@ -5322,7 +5322,7 @@
         <p:spPr>
           <a:xfrm>
             <a:off x="0" y="5641848"/>
-            <a:ext cx="12161520" cy="274320"/>
+            <a:ext cx="12161520" cy="292608"/>
           </a:xfrm>
           <a:prstGeom prst="rect">
             <a:avLst/>
@@ -5347,7 +5347,7 @@
         <p:spPr>
           <a:xfrm>
             <a:off x="0" y="5641848"/>
-            <a:ext cx="54864" cy="274320"/>
+            <a:ext cx="54864" cy="292608"/>
           </a:xfrm>
           <a:prstGeom prst="rect">
             <a:avLst/>
@@ -5372,7 +5372,7 @@
         <p:spPr>
           <a:xfrm>
             <a:off x="109728" y="5641848"/>
-            <a:ext cx="12051792" cy="274320"/>
+            <a:ext cx="12051792" cy="292608"/>
           </a:xfrm>
           <a:prstGeom prst="rect">
             <a:avLst/>
@@ -5388,7 +5388,7 @@
               <a:buNone/>
             </a:pPr>
             <a:r>
-              <a:rPr lang="en-US" sz="900" b="1" dirty="0">
+              <a:rPr lang="en-US" sz="1200" b="1" dirty="0">
                 <a:solidFill>
                   <a:srgbClr val="5D300F"/>
                 </a:solidFill>
@@ -5398,7 +5398,7 @@
               </a:rPr>
               <a:t>% Change from Prior Month</a:t>
             </a:r>
-            <a:endParaRPr lang="en-US" sz="900" dirty="0"/>
+            <a:endParaRPr lang="en-US" sz="1200" dirty="0"/>
           </a:p>
         </p:txBody>
       </p:sp>
@@ -5427,7 +5427,7 @@
               <a:buNone/>
             </a:pPr>
             <a:r>
-              <a:rPr lang="en-US" sz="1000" b="1" dirty="0">
+              <a:rPr lang="en-US" sz="1200" b="1" dirty="0">
                 <a:solidFill>
                   <a:srgbClr val="C0392B"/>
                 </a:solidFill>
@@ -5437,7 +5437,7 @@
               </a:rPr>
               <a:t>-66.8%</a:t>
             </a:r>
-            <a:endParaRPr lang="en-US" sz="1000" dirty="0"/>
+            <a:endParaRPr lang="en-US" sz="1200" dirty="0"/>
           </a:p>
         </p:txBody>
       </p:sp>
@@ -5466,7 +5466,7 @@
               <a:buNone/>
             </a:pPr>
             <a:r>
-              <a:rPr lang="en-US" sz="1000" b="1" dirty="0">
+              <a:rPr lang="en-US" sz="1200" b="1" dirty="0">
                 <a:solidFill>
                   <a:srgbClr val="718096"/>
                 </a:solidFill>
@@ -5476,7 +5476,7 @@
               </a:rPr>
               <a:t>—</a:t>
             </a:r>
-            <a:endParaRPr lang="en-US" sz="1000" dirty="0"/>
+            <a:endParaRPr lang="en-US" sz="1200" dirty="0"/>
           </a:p>
         </p:txBody>
       </p:sp>
@@ -5505,7 +5505,7 @@
               <a:buNone/>
             </a:pPr>
             <a:r>
-              <a:rPr lang="en-US" sz="1000" b="1" dirty="0">
+              <a:rPr lang="en-US" sz="1200" b="1" dirty="0">
                 <a:solidFill>
                   <a:srgbClr val="C0392B"/>
                 </a:solidFill>
@@ -5515,7 +5515,7 @@
               </a:rPr>
               <a:t>-59.3%</a:t>
             </a:r>
-            <a:endParaRPr lang="en-US" sz="1000" dirty="0"/>
+            <a:endParaRPr lang="en-US" sz="1200" dirty="0"/>
           </a:p>
         </p:txBody>
       </p:sp>
@@ -5544,7 +5544,7 @@
               <a:buNone/>
             </a:pPr>
             <a:r>
-              <a:rPr lang="en-US" sz="1000" b="1" dirty="0">
+              <a:rPr lang="en-US" sz="1200" b="1" dirty="0">
                 <a:solidFill>
                   <a:srgbClr val="C0392B"/>
                 </a:solidFill>
@@ -5554,7 +5554,7 @@
               </a:rPr>
               <a:t>-25.7%</a:t>
             </a:r>
-            <a:endParaRPr lang="en-US" sz="1000" dirty="0"/>
+            <a:endParaRPr lang="en-US" sz="1200" dirty="0"/>
           </a:p>
         </p:txBody>
       </p:sp>
@@ -5583,7 +5583,7 @@
               <a:buNone/>
             </a:pPr>
             <a:r>
-              <a:rPr lang="en-US" sz="1000" b="1" dirty="0">
+              <a:rPr lang="en-US" sz="1200" b="1" dirty="0">
                 <a:solidFill>
                   <a:srgbClr val="718096"/>
                 </a:solidFill>
@@ -5593,7 +5593,7 @@
               </a:rPr>
               <a:t>—</a:t>
             </a:r>
-            <a:endParaRPr lang="en-US" sz="1000" dirty="0"/>
+            <a:endParaRPr lang="en-US" sz="1200" dirty="0"/>
           </a:p>
         </p:txBody>
       </p:sp>
@@ -5823,7 +5823,7 @@
         <p:spPr>
           <a:xfrm>
             <a:off x="0" y="539496"/>
-            <a:ext cx="12161520" cy="274320"/>
+            <a:ext cx="12161520" cy="292608"/>
           </a:xfrm>
           <a:prstGeom prst="rect">
             <a:avLst/>
@@ -5848,7 +5848,7 @@
         <p:spPr>
           <a:xfrm>
             <a:off x="0" y="539496"/>
-            <a:ext cx="54864" cy="274320"/>
+            <a:ext cx="54864" cy="292608"/>
           </a:xfrm>
           <a:prstGeom prst="rect">
             <a:avLst/>
@@ -5873,7 +5873,7 @@
         <p:spPr>
           <a:xfrm>
             <a:off x="109728" y="539496"/>
-            <a:ext cx="12051792" cy="274320"/>
+            <a:ext cx="12051792" cy="292608"/>
           </a:xfrm>
           <a:prstGeom prst="rect">
             <a:avLst/>
@@ -5889,7 +5889,7 @@
               <a:buNone/>
             </a:pPr>
             <a:r>
-              <a:rPr lang="en-US" sz="900" b="1" dirty="0">
+              <a:rPr lang="en-US" sz="1200" b="1" dirty="0">
                 <a:solidFill>
                   <a:srgbClr val="5D300F"/>
                 </a:solidFill>
@@ -5899,7 +5899,7 @@
               </a:rPr>
               <a:t>Average Fuel Cost Per Team by Country (USD) – January 2026</a:t>
             </a:r>
-            <a:endParaRPr lang="en-US" sz="900" dirty="0"/>
+            <a:endParaRPr lang="en-US" sz="1200" dirty="0"/>
           </a:p>
         </p:txBody>
       </p:sp>
@@ -5928,7 +5928,7 @@
         <p:spPr>
           <a:xfrm>
             <a:off x="0" y="5641848"/>
-            <a:ext cx="12161520" cy="274320"/>
+            <a:ext cx="12161520" cy="292608"/>
           </a:xfrm>
           <a:prstGeom prst="rect">
             <a:avLst/>
@@ -5953,7 +5953,7 @@
         <p:spPr>
           <a:xfrm>
             <a:off x="0" y="5641848"/>
-            <a:ext cx="54864" cy="274320"/>
+            <a:ext cx="54864" cy="292608"/>
           </a:xfrm>
           <a:prstGeom prst="rect">
             <a:avLst/>
@@ -5978,7 +5978,7 @@
         <p:spPr>
           <a:xfrm>
             <a:off x="109728" y="5641848"/>
-            <a:ext cx="12051792" cy="274320"/>
+            <a:ext cx="12051792" cy="292608"/>
           </a:xfrm>
           <a:prstGeom prst="rect">
             <a:avLst/>
@@ -5994,7 +5994,7 @@
               <a:buNone/>
             </a:pPr>
             <a:r>
-              <a:rPr lang="en-US" sz="900" b="1" dirty="0">
+              <a:rPr lang="en-US" sz="1200" b="1" dirty="0">
                 <a:solidFill>
                   <a:srgbClr val="5D300F"/>
                 </a:solidFill>
@@ -6004,7 +6004,7 @@
               </a:rPr>
               <a:t>% Change from Prior Month</a:t>
             </a:r>
-            <a:endParaRPr lang="en-US" sz="900" dirty="0"/>
+            <a:endParaRPr lang="en-US" sz="1200" dirty="0"/>
           </a:p>
         </p:txBody>
       </p:sp>
@@ -6033,7 +6033,7 @@
               <a:buNone/>
             </a:pPr>
             <a:r>
-              <a:rPr lang="en-US" sz="1000" b="1" dirty="0">
+              <a:rPr lang="en-US" sz="1200" b="1" dirty="0">
                 <a:solidFill>
                   <a:srgbClr val="C0392B"/>
                 </a:solidFill>
@@ -6043,7 +6043,7 @@
               </a:rPr>
               <a:t>-31.5%</a:t>
             </a:r>
-            <a:endParaRPr lang="en-US" sz="1000" dirty="0"/>
+            <a:endParaRPr lang="en-US" sz="1200" dirty="0"/>
           </a:p>
         </p:txBody>
       </p:sp>
@@ -6072,7 +6072,7 @@
               <a:buNone/>
             </a:pPr>
             <a:r>
-              <a:rPr lang="en-US" sz="1000" b="1" dirty="0">
+              <a:rPr lang="en-US" sz="1200" b="1" dirty="0">
                 <a:solidFill>
                   <a:srgbClr val="718096"/>
                 </a:solidFill>
@@ -6082,7 +6082,7 @@
               </a:rPr>
               <a:t>—</a:t>
             </a:r>
-            <a:endParaRPr lang="en-US" sz="1000" dirty="0"/>
+            <a:endParaRPr lang="en-US" sz="1200" dirty="0"/>
           </a:p>
         </p:txBody>
       </p:sp>
@@ -6111,7 +6111,7 @@
               <a:buNone/>
             </a:pPr>
             <a:r>
-              <a:rPr lang="en-US" sz="1000" b="1" dirty="0">
+              <a:rPr lang="en-US" sz="1200" b="1" dirty="0">
                 <a:solidFill>
                   <a:srgbClr val="C0392B"/>
                 </a:solidFill>
@@ -6121,7 +6121,7 @@
               </a:rPr>
               <a:t>-75.6%</a:t>
             </a:r>
-            <a:endParaRPr lang="en-US" sz="1000" dirty="0"/>
+            <a:endParaRPr lang="en-US" sz="1200" dirty="0"/>
           </a:p>
         </p:txBody>
       </p:sp>
@@ -6150,7 +6150,7 @@
               <a:buNone/>
             </a:pPr>
             <a:r>
-              <a:rPr lang="en-US" sz="1000" b="1" dirty="0">
+              <a:rPr lang="en-US" sz="1200" b="1" dirty="0">
                 <a:solidFill>
                   <a:srgbClr val="C0392B"/>
                 </a:solidFill>
@@ -6160,7 +6160,7 @@
               </a:rPr>
               <a:t>-27.3%</a:t>
             </a:r>
-            <a:endParaRPr lang="en-US" sz="1000" dirty="0"/>
+            <a:endParaRPr lang="en-US" sz="1200" dirty="0"/>
           </a:p>
         </p:txBody>
       </p:sp>
@@ -6189,7 +6189,7 @@
               <a:buNone/>
             </a:pPr>
             <a:r>
-              <a:rPr lang="en-US" sz="1000" b="1" dirty="0">
+              <a:rPr lang="en-US" sz="1200" b="1" dirty="0">
                 <a:solidFill>
                   <a:srgbClr val="718096"/>
                 </a:solidFill>
@@ -6199,7 +6199,7 @@
               </a:rPr>
               <a:t>—</a:t>
             </a:r>
-            <a:endParaRPr lang="en-US" sz="1000" dirty="0"/>
+            <a:endParaRPr lang="en-US" sz="1200" dirty="0"/>
           </a:p>
         </p:txBody>
       </p:sp>
@@ -6429,7 +6429,7 @@
         <p:spPr>
           <a:xfrm>
             <a:off x="0" y="539496"/>
-            <a:ext cx="12161520" cy="274320"/>
+            <a:ext cx="12161520" cy="292608"/>
           </a:xfrm>
           <a:prstGeom prst="rect">
             <a:avLst/>
@@ -6454,7 +6454,7 @@
         <p:spPr>
           <a:xfrm>
             <a:off x="0" y="539496"/>
-            <a:ext cx="54864" cy="274320"/>
+            <a:ext cx="54864" cy="292608"/>
           </a:xfrm>
           <a:prstGeom prst="rect">
             <a:avLst/>
@@ -6479,7 +6479,7 @@
         <p:spPr>
           <a:xfrm>
             <a:off x="109728" y="539496"/>
-            <a:ext cx="12051792" cy="274320"/>
+            <a:ext cx="12051792" cy="292608"/>
           </a:xfrm>
           <a:prstGeom prst="rect">
             <a:avLst/>
@@ -6495,7 +6495,7 @@
               <a:buNone/>
             </a:pPr>
             <a:r>
-              <a:rPr lang="en-US" sz="900" b="1" dirty="0">
+              <a:rPr lang="en-US" sz="1200" b="1" dirty="0">
                 <a:solidFill>
                   <a:srgbClr val="5D300F"/>
                 </a:solidFill>
@@ -6505,7 +6505,7 @@
               </a:rPr>
               <a:t>Average Vehicle Maintenance Per Team by Country (USD) – January 2026</a:t>
             </a:r>
-            <a:endParaRPr lang="en-US" sz="900" dirty="0"/>
+            <a:endParaRPr lang="en-US" sz="1200" dirty="0"/>
           </a:p>
         </p:txBody>
       </p:sp>
@@ -6534,7 +6534,7 @@
         <p:spPr>
           <a:xfrm>
             <a:off x="0" y="5641848"/>
-            <a:ext cx="12161520" cy="274320"/>
+            <a:ext cx="12161520" cy="292608"/>
           </a:xfrm>
           <a:prstGeom prst="rect">
             <a:avLst/>
@@ -6559,7 +6559,7 @@
         <p:spPr>
           <a:xfrm>
             <a:off x="0" y="5641848"/>
-            <a:ext cx="54864" cy="274320"/>
+            <a:ext cx="54864" cy="292608"/>
           </a:xfrm>
           <a:prstGeom prst="rect">
             <a:avLst/>
@@ -6584,7 +6584,7 @@
         <p:spPr>
           <a:xfrm>
             <a:off x="109728" y="5641848"/>
-            <a:ext cx="12051792" cy="274320"/>
+            <a:ext cx="12051792" cy="292608"/>
           </a:xfrm>
           <a:prstGeom prst="rect">
             <a:avLst/>
@@ -6600,7 +6600,7 @@
               <a:buNone/>
             </a:pPr>
             <a:r>
-              <a:rPr lang="en-US" sz="900" b="1" dirty="0">
+              <a:rPr lang="en-US" sz="1200" b="1" dirty="0">
                 <a:solidFill>
                   <a:srgbClr val="5D300F"/>
                 </a:solidFill>
@@ -6610,7 +6610,7 @@
               </a:rPr>
               <a:t>% Change from Prior Month</a:t>
             </a:r>
-            <a:endParaRPr lang="en-US" sz="900" dirty="0"/>
+            <a:endParaRPr lang="en-US" sz="1200" dirty="0"/>
           </a:p>
         </p:txBody>
       </p:sp>
@@ -6639,7 +6639,7 @@
               <a:buNone/>
             </a:pPr>
             <a:r>
-              <a:rPr lang="en-US" sz="1000" b="1" dirty="0">
+              <a:rPr lang="en-US" sz="1200" b="1" dirty="0">
                 <a:solidFill>
                   <a:srgbClr val="C0392B"/>
                 </a:solidFill>
@@ -6649,7 +6649,7 @@
               </a:rPr>
               <a:t>-61.5%</a:t>
             </a:r>
-            <a:endParaRPr lang="en-US" sz="1000" dirty="0"/>
+            <a:endParaRPr lang="en-US" sz="1200" dirty="0"/>
           </a:p>
         </p:txBody>
       </p:sp>
@@ -6678,7 +6678,7 @@
               <a:buNone/>
             </a:pPr>
             <a:r>
-              <a:rPr lang="en-US" sz="1000" b="1" dirty="0">
+              <a:rPr lang="en-US" sz="1200" b="1" dirty="0">
                 <a:solidFill>
                   <a:srgbClr val="718096"/>
                 </a:solidFill>
@@ -6688,7 +6688,7 @@
               </a:rPr>
               <a:t>—</a:t>
             </a:r>
-            <a:endParaRPr lang="en-US" sz="1000" dirty="0"/>
+            <a:endParaRPr lang="en-US" sz="1200" dirty="0"/>
           </a:p>
         </p:txBody>
       </p:sp>
@@ -6717,7 +6717,7 @@
               <a:buNone/>
             </a:pPr>
             <a:r>
-              <a:rPr lang="en-US" sz="1000" b="1" dirty="0">
+              <a:rPr lang="en-US" sz="1200" b="1" dirty="0">
                 <a:solidFill>
                   <a:srgbClr val="1A7A6E"/>
                 </a:solidFill>
@@ -6727,7 +6727,7 @@
               </a:rPr>
               <a:t>+21.1%</a:t>
             </a:r>
-            <a:endParaRPr lang="en-US" sz="1000" dirty="0"/>
+            <a:endParaRPr lang="en-US" sz="1200" dirty="0"/>
           </a:p>
         </p:txBody>
       </p:sp>
@@ -6756,7 +6756,7 @@
               <a:buNone/>
             </a:pPr>
             <a:r>
-              <a:rPr lang="en-US" sz="1000" b="1" dirty="0">
+              <a:rPr lang="en-US" sz="1200" b="1" dirty="0">
                 <a:solidFill>
                   <a:srgbClr val="C0392B"/>
                 </a:solidFill>
@@ -6766,7 +6766,7 @@
               </a:rPr>
               <a:t>-66.1%</a:t>
             </a:r>
-            <a:endParaRPr lang="en-US" sz="1000" dirty="0"/>
+            <a:endParaRPr lang="en-US" sz="1200" dirty="0"/>
           </a:p>
         </p:txBody>
       </p:sp>
@@ -6795,7 +6795,7 @@
               <a:buNone/>
             </a:pPr>
             <a:r>
-              <a:rPr lang="en-US" sz="1000" b="1" dirty="0">
+              <a:rPr lang="en-US" sz="1200" b="1" dirty="0">
                 <a:solidFill>
                   <a:srgbClr val="718096"/>
                 </a:solidFill>
@@ -6805,7 +6805,7 @@
               </a:rPr>
               <a:t>—</a:t>
             </a:r>
-            <a:endParaRPr lang="en-US" sz="1000" dirty="0"/>
+            <a:endParaRPr lang="en-US" sz="1200" dirty="0"/>
           </a:p>
         </p:txBody>
       </p:sp>
@@ -7035,7 +7035,7 @@
         <p:spPr>
           <a:xfrm>
             <a:off x="0" y="539496"/>
-            <a:ext cx="7772400" cy="274320"/>
+            <a:ext cx="7772400" cy="292608"/>
           </a:xfrm>
           <a:prstGeom prst="rect">
             <a:avLst/>
@@ -7060,7 +7060,7 @@
         <p:spPr>
           <a:xfrm>
             <a:off x="0" y="539496"/>
-            <a:ext cx="54864" cy="274320"/>
+            <a:ext cx="54864" cy="292608"/>
           </a:xfrm>
           <a:prstGeom prst="rect">
             <a:avLst/>
@@ -7085,7 +7085,7 @@
         <p:spPr>
           <a:xfrm>
             <a:off x="109728" y="539496"/>
-            <a:ext cx="7662672" cy="274320"/>
+            <a:ext cx="7662672" cy="292608"/>
           </a:xfrm>
           <a:prstGeom prst="rect">
             <a:avLst/>
@@ -7101,7 +7101,7 @@
               <a:buNone/>
             </a:pPr>
             <a:r>
-              <a:rPr lang="en-US" sz="900" b="1" dirty="0">
+              <a:rPr lang="en-US" sz="1200" b="1" dirty="0">
                 <a:solidFill>
                   <a:srgbClr val="5D300F"/>
                 </a:solidFill>
@@ -7111,7 +7111,7 @@
               </a:rPr>
               <a:t>Average Number of Applications Per Team – January 2026</a:t>
             </a:r>
-            <a:endParaRPr lang="en-US" sz="900" dirty="0"/>
+            <a:endParaRPr lang="en-US" sz="1200" dirty="0"/>
           </a:p>
         </p:txBody>
       </p:sp>
@@ -7123,7 +7123,7 @@
         </p:nvGraphicFramePr>
         <p:xfrm>
           <a:off x="137160" y="841248"/>
-          <a:ext cx="7589520" cy="3200400"/>
+          <a:ext cx="7589520" cy="4663440"/>
         </p:xfrm>
         <a:graphic xmlns:a="http://schemas.openxmlformats.org/drawingml/2006/main">
           <a:graphicData uri="http://schemas.openxmlformats.org/drawingml/2006/chart">
@@ -7139,8 +7139,8 @@
         </p:nvSpPr>
         <p:spPr>
           <a:xfrm>
-            <a:off x="0" y="4114800"/>
-            <a:ext cx="7772400" cy="274320"/>
+            <a:off x="0" y="5577840"/>
+            <a:ext cx="7772400" cy="292608"/>
           </a:xfrm>
           <a:prstGeom prst="rect">
             <a:avLst/>
@@ -7164,8 +7164,8 @@
         </p:nvSpPr>
         <p:spPr>
           <a:xfrm>
-            <a:off x="0" y="4114800"/>
-            <a:ext cx="54864" cy="274320"/>
+            <a:off x="0" y="5577840"/>
+            <a:ext cx="54864" cy="292608"/>
           </a:xfrm>
           <a:prstGeom prst="rect">
             <a:avLst/>
@@ -7189,8 +7189,8 @@
         </p:nvSpPr>
         <p:spPr>
           <a:xfrm>
-            <a:off x="109728" y="4114800"/>
-            <a:ext cx="7662672" cy="274320"/>
+            <a:off x="109728" y="5577840"/>
+            <a:ext cx="7662672" cy="292608"/>
           </a:xfrm>
           <a:prstGeom prst="rect">
             <a:avLst/>
@@ -7206,7 +7206,7 @@
               <a:buNone/>
             </a:pPr>
             <a:r>
-              <a:rPr lang="en-US" sz="900" b="1" dirty="0">
+              <a:rPr lang="en-US" sz="1200" b="1" dirty="0">
                 <a:solidFill>
                   <a:srgbClr val="5D300F"/>
                 </a:solidFill>
@@ -7216,7 +7216,7 @@
               </a:rPr>
               <a:t>% Change from Prior Month</a:t>
             </a:r>
-            <a:endParaRPr lang="en-US" sz="900" dirty="0"/>
+            <a:endParaRPr lang="en-US" sz="1200" dirty="0"/>
           </a:p>
         </p:txBody>
       </p:sp>
@@ -7228,7 +7228,7 @@
         </p:nvSpPr>
         <p:spPr>
           <a:xfrm>
-            <a:off x="137160" y="4425696"/>
+            <a:off x="137160" y="5925312"/>
             <a:ext cx="1517904" cy="347472"/>
           </a:xfrm>
           <a:prstGeom prst="rect">
@@ -7245,7 +7245,7 @@
               <a:buNone/>
             </a:pPr>
             <a:r>
-              <a:rPr lang="en-US" sz="1000" b="1" dirty="0">
+              <a:rPr lang="en-US" sz="1200" b="1" dirty="0">
                 <a:solidFill>
                   <a:srgbClr val="718096"/>
                 </a:solidFill>
@@ -7255,7 +7255,7 @@
               </a:rPr>
               <a:t>—</a:t>
             </a:r>
-            <a:endParaRPr lang="en-US" sz="1000" dirty="0"/>
+            <a:endParaRPr lang="en-US" sz="1200" dirty="0"/>
           </a:p>
         </p:txBody>
       </p:sp>
@@ -7267,7 +7267,7 @@
         </p:nvSpPr>
         <p:spPr>
           <a:xfrm>
-            <a:off x="1655064" y="4425696"/>
+            <a:off x="1655064" y="5925312"/>
             <a:ext cx="1517904" cy="347472"/>
           </a:xfrm>
           <a:prstGeom prst="rect">
@@ -7284,7 +7284,7 @@
               <a:buNone/>
             </a:pPr>
             <a:r>
-              <a:rPr lang="en-US" sz="1000" b="1" dirty="0">
+              <a:rPr lang="en-US" sz="1200" b="1" dirty="0">
                 <a:solidFill>
                   <a:srgbClr val="718096"/>
                 </a:solidFill>
@@ -7294,7 +7294,7 @@
               </a:rPr>
               <a:t>—</a:t>
             </a:r>
-            <a:endParaRPr lang="en-US" sz="1000" dirty="0"/>
+            <a:endParaRPr lang="en-US" sz="1200" dirty="0"/>
           </a:p>
         </p:txBody>
       </p:sp>
@@ -7306,7 +7306,7 @@
         </p:nvSpPr>
         <p:spPr>
           <a:xfrm>
-            <a:off x="3172968" y="4425696"/>
+            <a:off x="3172968" y="5925312"/>
             <a:ext cx="1517904" cy="347472"/>
           </a:xfrm>
           <a:prstGeom prst="rect">
@@ -7323,7 +7323,7 @@
               <a:buNone/>
             </a:pPr>
             <a:r>
-              <a:rPr lang="en-US" sz="1000" b="1" dirty="0">
+              <a:rPr lang="en-US" sz="1200" b="1" dirty="0">
                 <a:solidFill>
                   <a:srgbClr val="718096"/>
                 </a:solidFill>
@@ -7333,7 +7333,7 @@
               </a:rPr>
               <a:t>—</a:t>
             </a:r>
-            <a:endParaRPr lang="en-US" sz="1000" dirty="0"/>
+            <a:endParaRPr lang="en-US" sz="1200" dirty="0"/>
           </a:p>
         </p:txBody>
       </p:sp>
@@ -7345,7 +7345,7 @@
         </p:nvSpPr>
         <p:spPr>
           <a:xfrm>
-            <a:off x="4690872" y="4425696"/>
+            <a:off x="4690872" y="5925312"/>
             <a:ext cx="1517904" cy="347472"/>
           </a:xfrm>
           <a:prstGeom prst="rect">
@@ -7362,7 +7362,7 @@
               <a:buNone/>
             </a:pPr>
             <a:r>
-              <a:rPr lang="en-US" sz="1000" b="1" dirty="0">
+              <a:rPr lang="en-US" sz="1200" b="1" dirty="0">
                 <a:solidFill>
                   <a:srgbClr val="718096"/>
                 </a:solidFill>
@@ -7372,7 +7372,7 @@
               </a:rPr>
               <a:t>—</a:t>
             </a:r>
-            <a:endParaRPr lang="en-US" sz="1000" dirty="0"/>
+            <a:endParaRPr lang="en-US" sz="1200" dirty="0"/>
           </a:p>
         </p:txBody>
       </p:sp>
@@ -7384,7 +7384,7 @@
         </p:nvSpPr>
         <p:spPr>
           <a:xfrm>
-            <a:off x="6208776" y="4425696"/>
+            <a:off x="6208776" y="5925312"/>
             <a:ext cx="1517904" cy="347472"/>
           </a:xfrm>
           <a:prstGeom prst="rect">
@@ -7401,7 +7401,7 @@
               <a:buNone/>
             </a:pPr>
             <a:r>
-              <a:rPr lang="en-US" sz="1000" b="1" dirty="0">
+              <a:rPr lang="en-US" sz="1200" b="1" dirty="0">
                 <a:solidFill>
                   <a:srgbClr val="718096"/>
                 </a:solidFill>
@@ -7411,7 +7411,7 @@
               </a:rPr>
               <a:t>—</a:t>
             </a:r>
-            <a:endParaRPr lang="en-US" sz="1000" dirty="0"/>
+            <a:endParaRPr lang="en-US" sz="1200" dirty="0"/>
           </a:p>
         </p:txBody>
       </p:sp>
@@ -7497,7 +7497,7 @@
               <a:buNone/>
             </a:pPr>
             <a:r>
-              <a:rPr lang="en-US" sz="2000" b="1" dirty="0">
+              <a:rPr lang="en-US" sz="2600" b="1" dirty="0">
                 <a:solidFill>
                   <a:srgbClr val="5D300F"/>
                 </a:solidFill>
@@ -7507,7 +7507,7 @@
               </a:rPr>
               <a:t>30,291</a:t>
             </a:r>
-            <a:endParaRPr lang="en-US" sz="2000" dirty="0"/>
+            <a:endParaRPr lang="en-US" sz="2600" dirty="0"/>
           </a:p>
         </p:txBody>
       </p:sp>
@@ -7536,7 +7536,7 @@
               <a:buNone/>
             </a:pPr>
             <a:r>
-              <a:rPr lang="en-US" sz="800" dirty="0">
+              <a:rPr lang="en-US" sz="1200" dirty="0">
                 <a:solidFill>
                   <a:srgbClr val="718096"/>
                 </a:solidFill>
@@ -7546,7 +7546,7 @@
               </a:rPr>
               <a:t>Total Applications</a:t>
             </a:r>
-            <a:endParaRPr lang="en-US" sz="800" dirty="0"/>
+            <a:endParaRPr lang="en-US" sz="1200" dirty="0"/>
           </a:p>
         </p:txBody>
       </p:sp>
@@ -7632,7 +7632,7 @@
               <a:buNone/>
             </a:pPr>
             <a:r>
-              <a:rPr lang="en-US" sz="2000" b="1" dirty="0">
+              <a:rPr lang="en-US" sz="2600" b="1" dirty="0">
                 <a:solidFill>
                   <a:srgbClr val="5D300F"/>
                 </a:solidFill>
@@ -7642,7 +7642,7 @@
               </a:rPr>
               <a:t>87</a:t>
             </a:r>
-            <a:endParaRPr lang="en-US" sz="2000" dirty="0"/>
+            <a:endParaRPr lang="en-US" sz="2600" dirty="0"/>
           </a:p>
         </p:txBody>
       </p:sp>
@@ -7671,7 +7671,7 @@
               <a:buNone/>
             </a:pPr>
             <a:r>
-              <a:rPr lang="en-US" sz="800" dirty="0">
+              <a:rPr lang="en-US" sz="1200" dirty="0">
                 <a:solidFill>
                   <a:srgbClr val="718096"/>
                 </a:solidFill>
@@ -7681,7 +7681,7 @@
               </a:rPr>
               <a:t>Group Avg per Team</a:t>
             </a:r>
-            <a:endParaRPr lang="en-US" sz="800" dirty="0"/>
+            <a:endParaRPr lang="en-US" sz="1200" dirty="0"/>
           </a:p>
         </p:txBody>
       </p:sp>
@@ -7767,7 +7767,7 @@
               <a:buNone/>
             </a:pPr>
             <a:r>
-              <a:rPr lang="en-US" sz="2000" b="1" dirty="0">
+              <a:rPr lang="en-US" sz="2600" b="1" dirty="0">
                 <a:solidFill>
                   <a:srgbClr val="5D300F"/>
                 </a:solidFill>
@@ -7777,7 +7777,7 @@
               </a:rPr>
               <a:t>347</a:t>
             </a:r>
-            <a:endParaRPr lang="en-US" sz="2000" dirty="0"/>
+            <a:endParaRPr lang="en-US" sz="2600" dirty="0"/>
           </a:p>
         </p:txBody>
       </p:sp>
@@ -7806,7 +7806,7 @@
               <a:buNone/>
             </a:pPr>
             <a:r>
-              <a:rPr lang="en-US" sz="800" dirty="0">
+              <a:rPr lang="en-US" sz="1200" dirty="0">
                 <a:solidFill>
                   <a:srgbClr val="718096"/>
                 </a:solidFill>
@@ -7816,7 +7816,7 @@
               </a:rPr>
               <a:t>Total Teams</a:t>
             </a:r>
-            <a:endParaRPr lang="en-US" sz="800" dirty="0"/>
+            <a:endParaRPr lang="en-US" sz="1200" dirty="0"/>
           </a:p>
         </p:txBody>
       </p:sp>
@@ -7879,7 +7879,7 @@
         <p:spPr>
           <a:xfrm>
             <a:off x="8065008" y="4032504"/>
-            <a:ext cx="3886200" cy="201168"/>
+            <a:ext cx="3886200" cy="228600"/>
           </a:xfrm>
           <a:prstGeom prst="rect">
             <a:avLst/>
@@ -7895,7 +7895,7 @@
               <a:buNone/>
             </a:pPr>
             <a:r>
-              <a:rPr lang="en-US" sz="750" b="1" spc="100" kern="0" dirty="0">
+              <a:rPr lang="en-US" sz="1200" b="1" spc="100" kern="0" dirty="0">
                 <a:solidFill>
                   <a:srgbClr val="5D300F"/>
                 </a:solidFill>
@@ -7905,7 +7905,7 @@
               </a:rPr>
               <a:t>KEY HIGHLIGHTS</a:t>
             </a:r>
-            <a:endParaRPr lang="en-US" sz="750" dirty="0"/>
+            <a:endParaRPr lang="en-US" sz="1200" dirty="0"/>
           </a:p>
         </p:txBody>
       </p:sp>
@@ -7917,8 +7917,8 @@
         </p:nvSpPr>
         <p:spPr>
           <a:xfrm>
-            <a:off x="8065008" y="4251960"/>
-            <a:ext cx="3886200" cy="2212848"/>
+            <a:off x="8065008" y="4297680"/>
+            <a:ext cx="3886200" cy="2167128"/>
           </a:xfrm>
           <a:prstGeom prst="rect">
             <a:avLst/>
@@ -7934,7 +7934,7 @@
               <a:buNone/>
             </a:pPr>
             <a:r>
-              <a:rPr lang="en-US" sz="900" dirty="0">
+              <a:rPr lang="en-US" sz="1200" dirty="0">
                 <a:solidFill>
                   <a:srgbClr val="2D2A26"/>
                 </a:solidFill>
@@ -7944,14 +7944,14 @@
               </a:rPr>
               <a:t>Group total: 30,291 applications.</a:t>
             </a:r>
-            <a:endParaRPr lang="en-US" sz="900" dirty="0"/>
+            <a:endParaRPr lang="en-US" sz="1200" dirty="0"/>
           </a:p>
           <a:p>
             <a:pPr indent="0" marL="0">
               <a:buNone/>
             </a:pPr>
             <a:r>
-              <a:rPr lang="en-US" sz="900" dirty="0">
+              <a:rPr lang="en-US" sz="1200" dirty="0">
                 <a:solidFill>
                   <a:srgbClr val="2D2A26"/>
                 </a:solidFill>
@@ -7961,7 +7961,7 @@
               </a:rPr>
               <a:t>Kenya had the highest avg applications per team (111).</a:t>
             </a:r>
-            <a:endParaRPr lang="en-US" sz="900" dirty="0"/>
+            <a:endParaRPr lang="en-US" sz="1200" dirty="0"/>
           </a:p>
         </p:txBody>
       </p:sp>
@@ -8191,7 +8191,7 @@
         <p:spPr>
           <a:xfrm>
             <a:off x="0" y="539496"/>
-            <a:ext cx="7772400" cy="274320"/>
+            <a:ext cx="7772400" cy="292608"/>
           </a:xfrm>
           <a:prstGeom prst="rect">
             <a:avLst/>
@@ -8216,7 +8216,7 @@
         <p:spPr>
           <a:xfrm>
             <a:off x="0" y="539496"/>
-            <a:ext cx="54864" cy="274320"/>
+            <a:ext cx="54864" cy="292608"/>
           </a:xfrm>
           <a:prstGeom prst="rect">
             <a:avLst/>
@@ -8241,7 +8241,7 @@
         <p:spPr>
           <a:xfrm>
             <a:off x="109728" y="539496"/>
-            <a:ext cx="7662672" cy="274320"/>
+            <a:ext cx="7662672" cy="292608"/>
           </a:xfrm>
           <a:prstGeom prst="rect">
             <a:avLst/>
@@ -8257,7 +8257,7 @@
               <a:buNone/>
             </a:pPr>
             <a:r>
-              <a:rPr lang="en-US" sz="900" b="1" dirty="0">
+              <a:rPr lang="en-US" sz="1200" b="1" dirty="0">
                 <a:solidFill>
                   <a:srgbClr val="5D300F"/>
                 </a:solidFill>
@@ -8267,7 +8267,7 @@
               </a:rPr>
               <a:t>Loan Approval Rate (%) Per Country – January 2026</a:t>
             </a:r>
-            <a:endParaRPr lang="en-US" sz="900" dirty="0"/>
+            <a:endParaRPr lang="en-US" sz="1200" dirty="0"/>
           </a:p>
         </p:txBody>
       </p:sp>
@@ -8279,7 +8279,7 @@
         </p:nvGraphicFramePr>
         <p:xfrm>
           <a:off x="137160" y="841248"/>
-          <a:ext cx="7589520" cy="3200400"/>
+          <a:ext cx="7589520" cy="4663440"/>
         </p:xfrm>
         <a:graphic xmlns:a="http://schemas.openxmlformats.org/drawingml/2006/main">
           <a:graphicData uri="http://schemas.openxmlformats.org/drawingml/2006/chart">
@@ -8295,8 +8295,8 @@
         </p:nvSpPr>
         <p:spPr>
           <a:xfrm>
-            <a:off x="0" y="4114800"/>
-            <a:ext cx="7772400" cy="274320"/>
+            <a:off x="0" y="5577840"/>
+            <a:ext cx="7772400" cy="292608"/>
           </a:xfrm>
           <a:prstGeom prst="rect">
             <a:avLst/>
@@ -8320,8 +8320,8 @@
         </p:nvSpPr>
         <p:spPr>
           <a:xfrm>
-            <a:off x="0" y="4114800"/>
-            <a:ext cx="54864" cy="274320"/>
+            <a:off x="0" y="5577840"/>
+            <a:ext cx="54864" cy="292608"/>
           </a:xfrm>
           <a:prstGeom prst="rect">
             <a:avLst/>
@@ -8345,8 +8345,8 @@
         </p:nvSpPr>
         <p:spPr>
           <a:xfrm>
-            <a:off x="109728" y="4114800"/>
-            <a:ext cx="7662672" cy="274320"/>
+            <a:off x="109728" y="5577840"/>
+            <a:ext cx="7662672" cy="292608"/>
           </a:xfrm>
           <a:prstGeom prst="rect">
             <a:avLst/>
@@ -8362,7 +8362,7 @@
               <a:buNone/>
             </a:pPr>
             <a:r>
-              <a:rPr lang="en-US" sz="900" b="1" dirty="0">
+              <a:rPr lang="en-US" sz="1200" b="1" dirty="0">
                 <a:solidFill>
                   <a:srgbClr val="5D300F"/>
                 </a:solidFill>
@@ -8372,7 +8372,7 @@
               </a:rPr>
               <a:t>Change from Prior Month (bps)</a:t>
             </a:r>
-            <a:endParaRPr lang="en-US" sz="900" dirty="0"/>
+            <a:endParaRPr lang="en-US" sz="1200" dirty="0"/>
           </a:p>
         </p:txBody>
       </p:sp>
@@ -8384,7 +8384,7 @@
         </p:nvSpPr>
         <p:spPr>
           <a:xfrm>
-            <a:off x="137160" y="4425696"/>
+            <a:off x="137160" y="5925312"/>
             <a:ext cx="1517904" cy="347472"/>
           </a:xfrm>
           <a:prstGeom prst="rect">
@@ -8401,7 +8401,7 @@
               <a:buNone/>
             </a:pPr>
             <a:r>
-              <a:rPr lang="en-US" sz="1000" b="1" dirty="0">
+              <a:rPr lang="en-US" sz="1200" b="1" dirty="0">
                 <a:solidFill>
                   <a:srgbClr val="718096"/>
                 </a:solidFill>
@@ -8411,7 +8411,7 @@
               </a:rPr>
               <a:t>+9645 bps</a:t>
             </a:r>
-            <a:endParaRPr lang="en-US" sz="1000" dirty="0"/>
+            <a:endParaRPr lang="en-US" sz="1200" dirty="0"/>
           </a:p>
         </p:txBody>
       </p:sp>
@@ -8423,7 +8423,7 @@
         </p:nvSpPr>
         <p:spPr>
           <a:xfrm>
-            <a:off x="1655064" y="4425696"/>
+            <a:off x="1655064" y="5925312"/>
             <a:ext cx="1517904" cy="347472"/>
           </a:xfrm>
           <a:prstGeom prst="rect">
@@ -8440,7 +8440,7 @@
               <a:buNone/>
             </a:pPr>
             <a:r>
-              <a:rPr lang="en-US" sz="1000" b="1" dirty="0">
+              <a:rPr lang="en-US" sz="1200" b="1" dirty="0">
                 <a:solidFill>
                   <a:srgbClr val="718096"/>
                 </a:solidFill>
@@ -8450,7 +8450,7 @@
               </a:rPr>
               <a:t>+8911 bps</a:t>
             </a:r>
-            <a:endParaRPr lang="en-US" sz="1000" dirty="0"/>
+            <a:endParaRPr lang="en-US" sz="1200" dirty="0"/>
           </a:p>
         </p:txBody>
       </p:sp>
@@ -8462,7 +8462,7 @@
         </p:nvSpPr>
         <p:spPr>
           <a:xfrm>
-            <a:off x="3172968" y="4425696"/>
+            <a:off x="3172968" y="5925312"/>
             <a:ext cx="1517904" cy="347472"/>
           </a:xfrm>
           <a:prstGeom prst="rect">
@@ -8479,7 +8479,7 @@
               <a:buNone/>
             </a:pPr>
             <a:r>
-              <a:rPr lang="en-US" sz="1000" b="1" dirty="0">
+              <a:rPr lang="en-US" sz="1200" b="1" dirty="0">
                 <a:solidFill>
                   <a:srgbClr val="718096"/>
                 </a:solidFill>
@@ -8489,7 +8489,7 @@
               </a:rPr>
               <a:t>+8858 bps</a:t>
             </a:r>
-            <a:endParaRPr lang="en-US" sz="1000" dirty="0"/>
+            <a:endParaRPr lang="en-US" sz="1200" dirty="0"/>
           </a:p>
         </p:txBody>
       </p:sp>
@@ -8501,7 +8501,7 @@
         </p:nvSpPr>
         <p:spPr>
           <a:xfrm>
-            <a:off x="4690872" y="4425696"/>
+            <a:off x="4690872" y="5925312"/>
             <a:ext cx="1517904" cy="347472"/>
           </a:xfrm>
           <a:prstGeom prst="rect">
@@ -8518,7 +8518,7 @@
               <a:buNone/>
             </a:pPr>
             <a:r>
-              <a:rPr lang="en-US" sz="1000" b="1" dirty="0">
+              <a:rPr lang="en-US" sz="1200" b="1" dirty="0">
                 <a:solidFill>
                   <a:srgbClr val="718096"/>
                 </a:solidFill>
@@ -8528,7 +8528,7 @@
               </a:rPr>
               <a:t>+8310 bps</a:t>
             </a:r>
-            <a:endParaRPr lang="en-US" sz="1000" dirty="0"/>
+            <a:endParaRPr lang="en-US" sz="1200" dirty="0"/>
           </a:p>
         </p:txBody>
       </p:sp>
@@ -8540,7 +8540,7 @@
         </p:nvSpPr>
         <p:spPr>
           <a:xfrm>
-            <a:off x="6208776" y="4425696"/>
+            <a:off x="6208776" y="5925312"/>
             <a:ext cx="1517904" cy="347472"/>
           </a:xfrm>
           <a:prstGeom prst="rect">
@@ -8557,7 +8557,7 @@
               <a:buNone/>
             </a:pPr>
             <a:r>
-              <a:rPr lang="en-US" sz="1000" b="1" dirty="0">
+              <a:rPr lang="en-US" sz="1200" b="1" dirty="0">
                 <a:solidFill>
                   <a:srgbClr val="718096"/>
                 </a:solidFill>
@@ -8567,7 +8567,7 @@
               </a:rPr>
               <a:t>+6186 bps</a:t>
             </a:r>
-            <a:endParaRPr lang="en-US" sz="1000" dirty="0"/>
+            <a:endParaRPr lang="en-US" sz="1200" dirty="0"/>
           </a:p>
         </p:txBody>
       </p:sp>
@@ -8653,7 +8653,7 @@
               <a:buNone/>
             </a:pPr>
             <a:r>
-              <a:rPr lang="en-US" sz="2000" b="1" dirty="0">
+              <a:rPr lang="en-US" sz="2600" b="1" dirty="0">
                 <a:solidFill>
                   <a:srgbClr val="5D300F"/>
                 </a:solidFill>
@@ -8663,7 +8663,7 @@
               </a:rPr>
               <a:t>27,600</a:t>
             </a:r>
-            <a:endParaRPr lang="en-US" sz="2000" dirty="0"/>
+            <a:endParaRPr lang="en-US" sz="2600" dirty="0"/>
           </a:p>
         </p:txBody>
       </p:sp>
@@ -8692,7 +8692,7 @@
               <a:buNone/>
             </a:pPr>
             <a:r>
-              <a:rPr lang="en-US" sz="800" dirty="0">
+              <a:rPr lang="en-US" sz="1200" dirty="0">
                 <a:solidFill>
                   <a:srgbClr val="718096"/>
                 </a:solidFill>
@@ -8702,7 +8702,7 @@
               </a:rPr>
               <a:t>Total Approvals</a:t>
             </a:r>
-            <a:endParaRPr lang="en-US" sz="800" dirty="0"/>
+            <a:endParaRPr lang="en-US" sz="1200" dirty="0"/>
           </a:p>
         </p:txBody>
       </p:sp>
@@ -8788,7 +8788,7 @@
               <a:buNone/>
             </a:pPr>
             <a:r>
-              <a:rPr lang="en-US" sz="2000" b="1" dirty="0">
+              <a:rPr lang="en-US" sz="2600" b="1" dirty="0">
                 <a:solidFill>
                   <a:srgbClr val="5D300F"/>
                 </a:solidFill>
@@ -8798,7 +8798,7 @@
               </a:rPr>
               <a:t>91.1%</a:t>
             </a:r>
-            <a:endParaRPr lang="en-US" sz="2000" dirty="0"/>
+            <a:endParaRPr lang="en-US" sz="2600" dirty="0"/>
           </a:p>
         </p:txBody>
       </p:sp>
@@ -8827,7 +8827,7 @@
               <a:buNone/>
             </a:pPr>
             <a:r>
-              <a:rPr lang="en-US" sz="800" dirty="0">
+              <a:rPr lang="en-US" sz="1200" dirty="0">
                 <a:solidFill>
                   <a:srgbClr val="718096"/>
                 </a:solidFill>
@@ -8837,7 +8837,7 @@
               </a:rPr>
               <a:t>Group Approval Rate</a:t>
             </a:r>
-            <a:endParaRPr lang="en-US" sz="800" dirty="0"/>
+            <a:endParaRPr lang="en-US" sz="1200" dirty="0"/>
           </a:p>
         </p:txBody>
       </p:sp>
@@ -8923,7 +8923,7 @@
               <a:buNone/>
             </a:pPr>
             <a:r>
-              <a:rPr lang="en-US" sz="2000" b="1" dirty="0">
+              <a:rPr lang="en-US" sz="2600" b="1" dirty="0">
                 <a:solidFill>
                   <a:srgbClr val="5D300F"/>
                 </a:solidFill>
@@ -8933,7 +8933,7 @@
               </a:rPr>
               <a:t>+9112 bps</a:t>
             </a:r>
-            <a:endParaRPr lang="en-US" sz="2000" dirty="0"/>
+            <a:endParaRPr lang="en-US" sz="2600" dirty="0"/>
           </a:p>
         </p:txBody>
       </p:sp>
@@ -8962,7 +8962,7 @@
               <a:buNone/>
             </a:pPr>
             <a:r>
-              <a:rPr lang="en-US" sz="800" dirty="0">
+              <a:rPr lang="en-US" sz="1200" dirty="0">
                 <a:solidFill>
                   <a:srgbClr val="718096"/>
                 </a:solidFill>
@@ -8972,7 +8972,7 @@
               </a:rPr>
               <a:t>Change from Prior Month</a:t>
             </a:r>
-            <a:endParaRPr lang="en-US" sz="800" dirty="0"/>
+            <a:endParaRPr lang="en-US" sz="1200" dirty="0"/>
           </a:p>
         </p:txBody>
       </p:sp>
@@ -9035,7 +9035,7 @@
         <p:spPr>
           <a:xfrm>
             <a:off x="8065008" y="4032504"/>
-            <a:ext cx="3886200" cy="201168"/>
+            <a:ext cx="3886200" cy="228600"/>
           </a:xfrm>
           <a:prstGeom prst="rect">
             <a:avLst/>
@@ -9051,7 +9051,7 @@
               <a:buNone/>
             </a:pPr>
             <a:r>
-              <a:rPr lang="en-US" sz="750" b="1" spc="100" kern="0" dirty="0">
+              <a:rPr lang="en-US" sz="1200" b="1" spc="100" kern="0" dirty="0">
                 <a:solidFill>
                   <a:srgbClr val="5D300F"/>
                 </a:solidFill>
@@ -9061,7 +9061,7 @@
               </a:rPr>
               <a:t>KEY HIGHLIGHTS</a:t>
             </a:r>
-            <a:endParaRPr lang="en-US" sz="750" dirty="0"/>
+            <a:endParaRPr lang="en-US" sz="1200" dirty="0"/>
           </a:p>
         </p:txBody>
       </p:sp>
@@ -9073,8 +9073,8 @@
         </p:nvSpPr>
         <p:spPr>
           <a:xfrm>
-            <a:off x="8065008" y="4251960"/>
-            <a:ext cx="3886200" cy="2212848"/>
+            <a:off x="8065008" y="4297680"/>
+            <a:ext cx="3886200" cy="2167128"/>
           </a:xfrm>
           <a:prstGeom prst="rect">
             <a:avLst/>
@@ -9090,7 +9090,7 @@
               <a:buNone/>
             </a:pPr>
             <a:r>
-              <a:rPr lang="en-US" sz="900" dirty="0">
+              <a:rPr lang="en-US" sz="1200" dirty="0">
                 <a:solidFill>
                   <a:srgbClr val="2D2A26"/>
                 </a:solidFill>
@@ -9100,14 +9100,14 @@
               </a:rPr>
               <a:t>Group total approvals: 27,600.</a:t>
             </a:r>
-            <a:endParaRPr lang="en-US" sz="900" dirty="0"/>
+            <a:endParaRPr lang="en-US" sz="1200" dirty="0"/>
           </a:p>
           <a:p>
             <a:pPr indent="0" marL="0">
               <a:buNone/>
             </a:pPr>
             <a:r>
-              <a:rPr lang="en-US" sz="900" dirty="0">
+              <a:rPr lang="en-US" sz="1200" dirty="0">
                 <a:solidFill>
                   <a:srgbClr val="2D2A26"/>
                 </a:solidFill>
@@ -9117,7 +9117,7 @@
               </a:rPr>
               <a:t>Tanzania had the highest approval rate (96.4%).</a:t>
             </a:r>
-            <a:endParaRPr lang="en-US" sz="900" dirty="0"/>
+            <a:endParaRPr lang="en-US" sz="1200" dirty="0"/>
           </a:p>
         </p:txBody>
       </p:sp>
@@ -9347,7 +9347,7 @@
         <p:spPr>
           <a:xfrm>
             <a:off x="0" y="539496"/>
-            <a:ext cx="7772400" cy="274320"/>
+            <a:ext cx="7772400" cy="292608"/>
           </a:xfrm>
           <a:prstGeom prst="rect">
             <a:avLst/>
@@ -9372,7 +9372,7 @@
         <p:spPr>
           <a:xfrm>
             <a:off x="0" y="539496"/>
-            <a:ext cx="54864" cy="274320"/>
+            <a:ext cx="54864" cy="292608"/>
           </a:xfrm>
           <a:prstGeom prst="rect">
             <a:avLst/>
@@ -9397,7 +9397,7 @@
         <p:spPr>
           <a:xfrm>
             <a:off x="109728" y="539496"/>
-            <a:ext cx="7662672" cy="274320"/>
+            <a:ext cx="7662672" cy="292608"/>
           </a:xfrm>
           <a:prstGeom prst="rect">
             <a:avLst/>
@@ -9413,7 +9413,7 @@
               <a:buNone/>
             </a:pPr>
             <a:r>
-              <a:rPr lang="en-US" sz="900" b="1" dirty="0">
+              <a:rPr lang="en-US" sz="1200" b="1" dirty="0">
                 <a:solidFill>
                   <a:srgbClr val="5D300F"/>
                 </a:solidFill>
@@ -9423,7 +9423,7 @@
               </a:rPr>
               <a:t>Total Disbursements Per Country (USD) – January 2026</a:t>
             </a:r>
-            <a:endParaRPr lang="en-US" sz="900" dirty="0"/>
+            <a:endParaRPr lang="en-US" sz="1200" dirty="0"/>
           </a:p>
         </p:txBody>
       </p:sp>
@@ -9435,7 +9435,7 @@
         </p:nvGraphicFramePr>
         <p:xfrm>
           <a:off x="137160" y="841248"/>
-          <a:ext cx="7589520" cy="3200400"/>
+          <a:ext cx="7589520" cy="4663440"/>
         </p:xfrm>
         <a:graphic xmlns:a="http://schemas.openxmlformats.org/drawingml/2006/main">
           <a:graphicData uri="http://schemas.openxmlformats.org/drawingml/2006/chart">
@@ -9451,8 +9451,8 @@
         </p:nvSpPr>
         <p:spPr>
           <a:xfrm>
-            <a:off x="0" y="4114800"/>
-            <a:ext cx="7772400" cy="274320"/>
+            <a:off x="0" y="5577840"/>
+            <a:ext cx="7772400" cy="292608"/>
           </a:xfrm>
           <a:prstGeom prst="rect">
             <a:avLst/>
@@ -9476,8 +9476,8 @@
         </p:nvSpPr>
         <p:spPr>
           <a:xfrm>
-            <a:off x="0" y="4114800"/>
-            <a:ext cx="54864" cy="274320"/>
+            <a:off x="0" y="5577840"/>
+            <a:ext cx="54864" cy="292608"/>
           </a:xfrm>
           <a:prstGeom prst="rect">
             <a:avLst/>
@@ -9501,8 +9501,8 @@
         </p:nvSpPr>
         <p:spPr>
           <a:xfrm>
-            <a:off x="109728" y="4114800"/>
-            <a:ext cx="7662672" cy="274320"/>
+            <a:off x="109728" y="5577840"/>
+            <a:ext cx="7662672" cy="292608"/>
           </a:xfrm>
           <a:prstGeom prst="rect">
             <a:avLst/>
@@ -9518,7 +9518,7 @@
               <a:buNone/>
             </a:pPr>
             <a:r>
-              <a:rPr lang="en-US" sz="900" b="1" dirty="0">
+              <a:rPr lang="en-US" sz="1200" b="1" dirty="0">
                 <a:solidFill>
                   <a:srgbClr val="5D300F"/>
                 </a:solidFill>
@@ -9528,7 +9528,7 @@
               </a:rPr>
               <a:t>% Change from Prior Month</a:t>
             </a:r>
-            <a:endParaRPr lang="en-US" sz="900" dirty="0"/>
+            <a:endParaRPr lang="en-US" sz="1200" dirty="0"/>
           </a:p>
         </p:txBody>
       </p:sp>
@@ -9540,7 +9540,7 @@
         </p:nvSpPr>
         <p:spPr>
           <a:xfrm>
-            <a:off x="137160" y="4425696"/>
+            <a:off x="137160" y="5925312"/>
             <a:ext cx="1517904" cy="347472"/>
           </a:xfrm>
           <a:prstGeom prst="rect">
@@ -9557,7 +9557,7 @@
               <a:buNone/>
             </a:pPr>
             <a:r>
-              <a:rPr lang="en-US" sz="1000" b="1" dirty="0">
+              <a:rPr lang="en-US" sz="1200" b="1" dirty="0">
                 <a:solidFill>
                   <a:srgbClr val="718096"/>
                 </a:solidFill>
@@ -9567,7 +9567,7 @@
               </a:rPr>
               <a:t>—</a:t>
             </a:r>
-            <a:endParaRPr lang="en-US" sz="1000" dirty="0"/>
+            <a:endParaRPr lang="en-US" sz="1200" dirty="0"/>
           </a:p>
         </p:txBody>
       </p:sp>
@@ -9579,7 +9579,7 @@
         </p:nvSpPr>
         <p:spPr>
           <a:xfrm>
-            <a:off x="1655064" y="4425696"/>
+            <a:off x="1655064" y="5925312"/>
             <a:ext cx="1517904" cy="347472"/>
           </a:xfrm>
           <a:prstGeom prst="rect">
@@ -9596,7 +9596,7 @@
               <a:buNone/>
             </a:pPr>
             <a:r>
-              <a:rPr lang="en-US" sz="1000" b="1" dirty="0">
+              <a:rPr lang="en-US" sz="1200" b="1" dirty="0">
                 <a:solidFill>
                   <a:srgbClr val="718096"/>
                 </a:solidFill>
@@ -9606,7 +9606,7 @@
               </a:rPr>
               <a:t>—</a:t>
             </a:r>
-            <a:endParaRPr lang="en-US" sz="1000" dirty="0"/>
+            <a:endParaRPr lang="en-US" sz="1200" dirty="0"/>
           </a:p>
         </p:txBody>
       </p:sp>
@@ -9618,7 +9618,7 @@
         </p:nvSpPr>
         <p:spPr>
           <a:xfrm>
-            <a:off x="3172968" y="4425696"/>
+            <a:off x="3172968" y="5925312"/>
             <a:ext cx="1517904" cy="347472"/>
           </a:xfrm>
           <a:prstGeom prst="rect">
@@ -9635,7 +9635,7 @@
               <a:buNone/>
             </a:pPr>
             <a:r>
-              <a:rPr lang="en-US" sz="1000" b="1" dirty="0">
+              <a:rPr lang="en-US" sz="1200" b="1" dirty="0">
                 <a:solidFill>
                   <a:srgbClr val="718096"/>
                 </a:solidFill>
@@ -9645,7 +9645,7 @@
               </a:rPr>
               <a:t>—</a:t>
             </a:r>
-            <a:endParaRPr lang="en-US" sz="1000" dirty="0"/>
+            <a:endParaRPr lang="en-US" sz="1200" dirty="0"/>
           </a:p>
         </p:txBody>
       </p:sp>
@@ -9657,7 +9657,7 @@
         </p:nvSpPr>
         <p:spPr>
           <a:xfrm>
-            <a:off x="4690872" y="4425696"/>
+            <a:off x="4690872" y="5925312"/>
             <a:ext cx="1517904" cy="347472"/>
           </a:xfrm>
           <a:prstGeom prst="rect">
@@ -9674,7 +9674,7 @@
               <a:buNone/>
             </a:pPr>
             <a:r>
-              <a:rPr lang="en-US" sz="1000" b="1" dirty="0">
+              <a:rPr lang="en-US" sz="1200" b="1" dirty="0">
                 <a:solidFill>
                   <a:srgbClr val="718096"/>
                 </a:solidFill>
@@ -9684,7 +9684,7 @@
               </a:rPr>
               <a:t>—</a:t>
             </a:r>
-            <a:endParaRPr lang="en-US" sz="1000" dirty="0"/>
+            <a:endParaRPr lang="en-US" sz="1200" dirty="0"/>
           </a:p>
         </p:txBody>
       </p:sp>
@@ -9696,7 +9696,7 @@
         </p:nvSpPr>
         <p:spPr>
           <a:xfrm>
-            <a:off x="6208776" y="4425696"/>
+            <a:off x="6208776" y="5925312"/>
             <a:ext cx="1517904" cy="347472"/>
           </a:xfrm>
           <a:prstGeom prst="rect">
@@ -9713,7 +9713,7 @@
               <a:buNone/>
             </a:pPr>
             <a:r>
-              <a:rPr lang="en-US" sz="1000" b="1" dirty="0">
+              <a:rPr lang="en-US" sz="1200" b="1" dirty="0">
                 <a:solidFill>
                   <a:srgbClr val="718096"/>
                 </a:solidFill>
@@ -9723,7 +9723,7 @@
               </a:rPr>
               <a:t>—</a:t>
             </a:r>
-            <a:endParaRPr lang="en-US" sz="1000" dirty="0"/>
+            <a:endParaRPr lang="en-US" sz="1200" dirty="0"/>
           </a:p>
         </p:txBody>
       </p:sp>
@@ -9809,7 +9809,7 @@
               <a:buNone/>
             </a:pPr>
             <a:r>
-              <a:rPr lang="en-US" sz="2000" b="1" dirty="0">
+              <a:rPr lang="en-US" sz="2600" b="1" dirty="0">
                 <a:solidFill>
                   <a:srgbClr val="5D300F"/>
                 </a:solidFill>
@@ -9819,7 +9819,7 @@
               </a:rPr>
               <a:t>$3,937,968</a:t>
             </a:r>
-            <a:endParaRPr lang="en-US" sz="2000" dirty="0"/>
+            <a:endParaRPr lang="en-US" sz="2600" dirty="0"/>
           </a:p>
         </p:txBody>
       </p:sp>
@@ -9848,7 +9848,7 @@
               <a:buNone/>
             </a:pPr>
             <a:r>
-              <a:rPr lang="en-US" sz="800" dirty="0">
+              <a:rPr lang="en-US" sz="1200" dirty="0">
                 <a:solidFill>
                   <a:srgbClr val="718096"/>
                 </a:solidFill>
@@ -9858,7 +9858,7 @@
               </a:rPr>
               <a:t>Total Disbursed (USD)</a:t>
             </a:r>
-            <a:endParaRPr lang="en-US" sz="800" dirty="0"/>
+            <a:endParaRPr lang="en-US" sz="1200" dirty="0"/>
           </a:p>
         </p:txBody>
       </p:sp>
@@ -9944,7 +9944,7 @@
               <a:buNone/>
             </a:pPr>
             <a:r>
-              <a:rPr lang="en-US" sz="2000" b="1" dirty="0">
+              <a:rPr lang="en-US" sz="2600" b="1" dirty="0">
                 <a:solidFill>
                   <a:srgbClr val="5D300F"/>
                 </a:solidFill>
@@ -9954,7 +9954,7 @@
               </a:rPr>
               <a:t>—</a:t>
             </a:r>
-            <a:endParaRPr lang="en-US" sz="2000" dirty="0"/>
+            <a:endParaRPr lang="en-US" sz="2600" dirty="0"/>
           </a:p>
         </p:txBody>
       </p:sp>
@@ -9983,7 +9983,7 @@
               <a:buNone/>
             </a:pPr>
             <a:r>
-              <a:rPr lang="en-US" sz="800" dirty="0">
+              <a:rPr lang="en-US" sz="1200" dirty="0">
                 <a:solidFill>
                   <a:srgbClr val="718096"/>
                 </a:solidFill>
@@ -9993,7 +9993,7 @@
               </a:rPr>
               <a:t>Change vs Prior Month</a:t>
             </a:r>
-            <a:endParaRPr lang="en-US" sz="800" dirty="0"/>
+            <a:endParaRPr lang="en-US" sz="1200" dirty="0"/>
           </a:p>
         </p:txBody>
       </p:sp>
@@ -10006,7 +10006,7 @@
         <p:spPr>
           <a:xfrm>
             <a:off x="7955280" y="2926080"/>
-            <a:ext cx="4069080" cy="274320"/>
+            <a:ext cx="4069080" cy="292608"/>
           </a:xfrm>
           <a:prstGeom prst="rect">
             <a:avLst/>
@@ -10031,7 +10031,7 @@
         <p:spPr>
           <a:xfrm>
             <a:off x="7955280" y="2926080"/>
-            <a:ext cx="54864" cy="274320"/>
+            <a:ext cx="54864" cy="292608"/>
           </a:xfrm>
           <a:prstGeom prst="rect">
             <a:avLst/>
@@ -10056,7 +10056,7 @@
         <p:spPr>
           <a:xfrm>
             <a:off x="8065008" y="2926080"/>
-            <a:ext cx="3959352" cy="274320"/>
+            <a:ext cx="3959352" cy="292608"/>
           </a:xfrm>
           <a:prstGeom prst="rect">
             <a:avLst/>
@@ -10072,7 +10072,7 @@
               <a:buNone/>
             </a:pPr>
             <a:r>
-              <a:rPr lang="en-US" sz="900" b="1" dirty="0">
+              <a:rPr lang="en-US" sz="1200" b="1" dirty="0">
                 <a:solidFill>
                   <a:srgbClr val="5D300F"/>
                 </a:solidFill>
@@ -10082,7 +10082,7 @@
               </a:rPr>
               <a:t>Number of Teams</a:t>
             </a:r>
-            <a:endParaRPr lang="en-US" sz="900" dirty="0"/>
+            <a:endParaRPr lang="en-US" sz="1200" dirty="0"/>
           </a:p>
         </p:txBody>
       </p:sp>
@@ -10660,7 +10660,7 @@
         <p:spPr>
           <a:xfrm>
             <a:off x="8065008" y="4059936"/>
-            <a:ext cx="3886200" cy="201168"/>
+            <a:ext cx="3886200" cy="228600"/>
           </a:xfrm>
           <a:prstGeom prst="rect">
             <a:avLst/>
@@ -10676,7 +10676,7 @@
               <a:buNone/>
             </a:pPr>
             <a:r>
-              <a:rPr lang="en-US" sz="750" b="1" spc="100" kern="0" dirty="0">
+              <a:rPr lang="en-US" sz="1200" b="1" spc="100" kern="0" dirty="0">
                 <a:solidFill>
                   <a:srgbClr val="5D300F"/>
                 </a:solidFill>
@@ -10686,7 +10686,7 @@
               </a:rPr>
               <a:t>KEY HIGHLIGHTS</a:t>
             </a:r>
-            <a:endParaRPr lang="en-US" sz="750" dirty="0"/>
+            <a:endParaRPr lang="en-US" sz="1200" dirty="0"/>
           </a:p>
         </p:txBody>
       </p:sp>
@@ -10698,8 +10698,8 @@
         </p:nvSpPr>
         <p:spPr>
           <a:xfrm>
-            <a:off x="8065008" y="4279392"/>
-            <a:ext cx="3886200" cy="2185416"/>
+            <a:off x="8065008" y="4325112"/>
+            <a:ext cx="3886200" cy="2139696"/>
           </a:xfrm>
           <a:prstGeom prst="rect">
             <a:avLst/>
@@ -10715,7 +10715,7 @@
               <a:buNone/>
             </a:pPr>
             <a:r>
-              <a:rPr lang="en-US" sz="900" dirty="0">
+              <a:rPr lang="en-US" sz="1200" dirty="0">
                 <a:solidFill>
                   <a:srgbClr val="2D2A26"/>
                 </a:solidFill>
@@ -10725,14 +10725,14 @@
               </a:rPr>
               <a:t>Total disbursed: $3,937,968.</a:t>
             </a:r>
-            <a:endParaRPr lang="en-US" sz="900" dirty="0"/>
+            <a:endParaRPr lang="en-US" sz="1200" dirty="0"/>
           </a:p>
           <a:p>
             <a:pPr indent="0" marL="0">
               <a:buNone/>
             </a:pPr>
             <a:r>
-              <a:rPr lang="en-US" sz="900" dirty="0">
+              <a:rPr lang="en-US" sz="1200" dirty="0">
                 <a:solidFill>
                   <a:srgbClr val="2D2A26"/>
                 </a:solidFill>
@@ -10742,7 +10742,7 @@
               </a:rPr>
               <a:t>Tanzania had the highest disbursements ($2,069,729).</a:t>
             </a:r>
-            <a:endParaRPr lang="en-US" sz="900" dirty="0"/>
+            <a:endParaRPr lang="en-US" sz="1200" dirty="0"/>
           </a:p>
         </p:txBody>
       </p:sp>
@@ -10972,7 +10972,7 @@
         <p:spPr>
           <a:xfrm>
             <a:off x="0" y="539496"/>
-            <a:ext cx="5989320" cy="274320"/>
+            <a:ext cx="5989320" cy="292608"/>
           </a:xfrm>
           <a:prstGeom prst="rect">
             <a:avLst/>
@@ -10997,7 +10997,7 @@
         <p:spPr>
           <a:xfrm>
             <a:off x="0" y="539496"/>
-            <a:ext cx="54864" cy="274320"/>
+            <a:ext cx="54864" cy="292608"/>
           </a:xfrm>
           <a:prstGeom prst="rect">
             <a:avLst/>
@@ -11022,7 +11022,7 @@
         <p:spPr>
           <a:xfrm>
             <a:off x="109728" y="539496"/>
-            <a:ext cx="5879592" cy="274320"/>
+            <a:ext cx="5879592" cy="292608"/>
           </a:xfrm>
           <a:prstGeom prst="rect">
             <a:avLst/>
@@ -11038,7 +11038,7 @@
               <a:buNone/>
             </a:pPr>
             <a:r>
-              <a:rPr lang="en-US" sz="900" b="1" dirty="0">
+              <a:rPr lang="en-US" sz="1200" b="1" dirty="0">
                 <a:solidFill>
                   <a:srgbClr val="5D300F"/>
                 </a:solidFill>
@@ -11048,7 +11048,7 @@
               </a:rPr>
               <a:t>Average Loan Size (USD) – January 2026</a:t>
             </a:r>
-            <a:endParaRPr lang="en-US" sz="900" dirty="0"/>
+            <a:endParaRPr lang="en-US" sz="1200" dirty="0"/>
           </a:p>
         </p:txBody>
       </p:sp>
@@ -11061,7 +11061,7 @@
         <p:spPr>
           <a:xfrm>
             <a:off x="6172200" y="539496"/>
-            <a:ext cx="5852160" cy="274320"/>
+            <a:ext cx="5852160" cy="292608"/>
           </a:xfrm>
           <a:prstGeom prst="rect">
             <a:avLst/>
@@ -11086,7 +11086,7 @@
         <p:spPr>
           <a:xfrm>
             <a:off x="6172200" y="539496"/>
-            <a:ext cx="54864" cy="274320"/>
+            <a:ext cx="54864" cy="292608"/>
           </a:xfrm>
           <a:prstGeom prst="rect">
             <a:avLst/>
@@ -11111,7 +11111,7 @@
         <p:spPr>
           <a:xfrm>
             <a:off x="6281928" y="539496"/>
-            <a:ext cx="5742432" cy="274320"/>
+            <a:ext cx="5742432" cy="292608"/>
           </a:xfrm>
           <a:prstGeom prst="rect">
             <a:avLst/>
@@ -11127,7 +11127,7 @@
               <a:buNone/>
             </a:pPr>
             <a:r>
-              <a:rPr lang="en-US" sz="900" b="1" dirty="0">
+              <a:rPr lang="en-US" sz="1200" b="1" dirty="0">
                 <a:solidFill>
                   <a:srgbClr val="5D300F"/>
                 </a:solidFill>
@@ -11137,7 +11137,7 @@
               </a:rPr>
               <a:t>Avg Disbursements Per Team – January 2026</a:t>
             </a:r>
-            <a:endParaRPr lang="en-US" sz="900" dirty="0"/>
+            <a:endParaRPr lang="en-US" sz="1200" dirty="0"/>
           </a:p>
         </p:txBody>
       </p:sp>
@@ -11149,7 +11149,7 @@
         </p:nvGraphicFramePr>
         <p:xfrm>
           <a:off x="137160" y="841248"/>
-          <a:ext cx="5806440" cy="3200400"/>
+          <a:ext cx="5806440" cy="4663440"/>
         </p:xfrm>
         <a:graphic xmlns:a="http://schemas.openxmlformats.org/drawingml/2006/main">
           <a:graphicData uri="http://schemas.openxmlformats.org/drawingml/2006/chart">
@@ -11165,7 +11165,7 @@
         </p:nvGraphicFramePr>
         <p:xfrm>
           <a:off x="6172200" y="841248"/>
-          <a:ext cx="5806440" cy="3200400"/>
+          <a:ext cx="5806440" cy="4663440"/>
         </p:xfrm>
         <a:graphic xmlns:a="http://schemas.openxmlformats.org/drawingml/2006/main">
           <a:graphicData uri="http://schemas.openxmlformats.org/drawingml/2006/chart">
@@ -11181,8 +11181,8 @@
         </p:nvSpPr>
         <p:spPr>
           <a:xfrm>
-            <a:off x="0" y="4114800"/>
-            <a:ext cx="5989320" cy="274320"/>
+            <a:off x="0" y="5577840"/>
+            <a:ext cx="5989320" cy="292608"/>
           </a:xfrm>
           <a:prstGeom prst="rect">
             <a:avLst/>
@@ -11206,8 +11206,8 @@
         </p:nvSpPr>
         <p:spPr>
           <a:xfrm>
-            <a:off x="0" y="4114800"/>
-            <a:ext cx="54864" cy="274320"/>
+            <a:off x="0" y="5577840"/>
+            <a:ext cx="54864" cy="292608"/>
           </a:xfrm>
           <a:prstGeom prst="rect">
             <a:avLst/>
@@ -11231,8 +11231,8 @@
         </p:nvSpPr>
         <p:spPr>
           <a:xfrm>
-            <a:off x="109728" y="4114800"/>
-            <a:ext cx="5879592" cy="274320"/>
+            <a:off x="109728" y="5577840"/>
+            <a:ext cx="5879592" cy="292608"/>
           </a:xfrm>
           <a:prstGeom prst="rect">
             <a:avLst/>
@@ -11248,7 +11248,7 @@
               <a:buNone/>
             </a:pPr>
             <a:r>
-              <a:rPr lang="en-US" sz="900" b="1" dirty="0">
+              <a:rPr lang="en-US" sz="1200" b="1" dirty="0">
                 <a:solidFill>
                   <a:srgbClr val="5D300F"/>
                 </a:solidFill>
@@ -11258,7 +11258,7 @@
               </a:rPr>
               <a:t>% Change from Prior Month</a:t>
             </a:r>
-            <a:endParaRPr lang="en-US" sz="900" dirty="0"/>
+            <a:endParaRPr lang="en-US" sz="1200" dirty="0"/>
           </a:p>
         </p:txBody>
       </p:sp>
@@ -11270,7 +11270,7 @@
         </p:nvSpPr>
         <p:spPr>
           <a:xfrm>
-            <a:off x="137160" y="4425696"/>
+            <a:off x="137160" y="5925312"/>
             <a:ext cx="1161288" cy="347472"/>
           </a:xfrm>
           <a:prstGeom prst="rect">
@@ -11287,7 +11287,7 @@
               <a:buNone/>
             </a:pPr>
             <a:r>
-              <a:rPr lang="en-US" sz="1000" b="1" dirty="0">
+              <a:rPr lang="en-US" sz="1200" b="1" dirty="0">
                 <a:solidFill>
                   <a:srgbClr val="718096"/>
                 </a:solidFill>
@@ -11297,7 +11297,7 @@
               </a:rPr>
               <a:t>—</a:t>
             </a:r>
-            <a:endParaRPr lang="en-US" sz="1000" dirty="0"/>
+            <a:endParaRPr lang="en-US" sz="1200" dirty="0"/>
           </a:p>
         </p:txBody>
       </p:sp>
@@ -11309,7 +11309,7 @@
         </p:nvSpPr>
         <p:spPr>
           <a:xfrm>
-            <a:off x="1298448" y="4425696"/>
+            <a:off x="1298448" y="5925312"/>
             <a:ext cx="1161288" cy="347472"/>
           </a:xfrm>
           <a:prstGeom prst="rect">
@@ -11326,7 +11326,7 @@
               <a:buNone/>
             </a:pPr>
             <a:r>
-              <a:rPr lang="en-US" sz="1000" b="1" dirty="0">
+              <a:rPr lang="en-US" sz="1200" b="1" dirty="0">
                 <a:solidFill>
                   <a:srgbClr val="718096"/>
                 </a:solidFill>
@@ -11336,7 +11336,7 @@
               </a:rPr>
               <a:t>—</a:t>
             </a:r>
-            <a:endParaRPr lang="en-US" sz="1000" dirty="0"/>
+            <a:endParaRPr lang="en-US" sz="1200" dirty="0"/>
           </a:p>
         </p:txBody>
       </p:sp>
@@ -11348,7 +11348,7 @@
         </p:nvSpPr>
         <p:spPr>
           <a:xfrm>
-            <a:off x="2459736" y="4425696"/>
+            <a:off x="2459736" y="5925312"/>
             <a:ext cx="1161288" cy="347472"/>
           </a:xfrm>
           <a:prstGeom prst="rect">
@@ -11365,7 +11365,7 @@
               <a:buNone/>
             </a:pPr>
             <a:r>
-              <a:rPr lang="en-US" sz="1000" b="1" dirty="0">
+              <a:rPr lang="en-US" sz="1200" b="1" dirty="0">
                 <a:solidFill>
                   <a:srgbClr val="718096"/>
                 </a:solidFill>
@@ -11375,7 +11375,7 @@
               </a:rPr>
               <a:t>—</a:t>
             </a:r>
-            <a:endParaRPr lang="en-US" sz="1000" dirty="0"/>
+            <a:endParaRPr lang="en-US" sz="1200" dirty="0"/>
           </a:p>
         </p:txBody>
       </p:sp>
@@ -11387,7 +11387,7 @@
         </p:nvSpPr>
         <p:spPr>
           <a:xfrm>
-            <a:off x="3621024" y="4425696"/>
+            <a:off x="3621024" y="5925312"/>
             <a:ext cx="1161288" cy="347472"/>
           </a:xfrm>
           <a:prstGeom prst="rect">
@@ -11404,7 +11404,7 @@
               <a:buNone/>
             </a:pPr>
             <a:r>
-              <a:rPr lang="en-US" sz="1000" b="1" dirty="0">
+              <a:rPr lang="en-US" sz="1200" b="1" dirty="0">
                 <a:solidFill>
                   <a:srgbClr val="718096"/>
                 </a:solidFill>
@@ -11414,7 +11414,7 @@
               </a:rPr>
               <a:t>—</a:t>
             </a:r>
-            <a:endParaRPr lang="en-US" sz="1000" dirty="0"/>
+            <a:endParaRPr lang="en-US" sz="1200" dirty="0"/>
           </a:p>
         </p:txBody>
       </p:sp>
@@ -11426,7 +11426,7 @@
         </p:nvSpPr>
         <p:spPr>
           <a:xfrm>
-            <a:off x="4782312" y="4425696"/>
+            <a:off x="4782312" y="5925312"/>
             <a:ext cx="1161288" cy="347472"/>
           </a:xfrm>
           <a:prstGeom prst="rect">
@@ -11443,7 +11443,7 @@
               <a:buNone/>
             </a:pPr>
             <a:r>
-              <a:rPr lang="en-US" sz="1000" b="1" dirty="0">
+              <a:rPr lang="en-US" sz="1200" b="1" dirty="0">
                 <a:solidFill>
                   <a:srgbClr val="718096"/>
                 </a:solidFill>
@@ -11453,7 +11453,7 @@
               </a:rPr>
               <a:t>—</a:t>
             </a:r>
-            <a:endParaRPr lang="en-US" sz="1000" dirty="0"/>
+            <a:endParaRPr lang="en-US" sz="1200" dirty="0"/>
           </a:p>
         </p:txBody>
       </p:sp>
@@ -11465,8 +11465,8 @@
         </p:nvSpPr>
         <p:spPr>
           <a:xfrm>
-            <a:off x="6172200" y="4114800"/>
-            <a:ext cx="5852160" cy="274320"/>
+            <a:off x="6172200" y="5577840"/>
+            <a:ext cx="5852160" cy="292608"/>
           </a:xfrm>
           <a:prstGeom prst="rect">
             <a:avLst/>
@@ -11490,8 +11490,8 @@
         </p:nvSpPr>
         <p:spPr>
           <a:xfrm>
-            <a:off x="6172200" y="4114800"/>
-            <a:ext cx="54864" cy="274320"/>
+            <a:off x="6172200" y="5577840"/>
+            <a:ext cx="54864" cy="292608"/>
           </a:xfrm>
           <a:prstGeom prst="rect">
             <a:avLst/>
@@ -11515,8 +11515,8 @@
         </p:nvSpPr>
         <p:spPr>
           <a:xfrm>
-            <a:off x="6281928" y="4114800"/>
-            <a:ext cx="5742432" cy="274320"/>
+            <a:off x="6281928" y="5577840"/>
+            <a:ext cx="5742432" cy="292608"/>
           </a:xfrm>
           <a:prstGeom prst="rect">
             <a:avLst/>
@@ -11532,7 +11532,7 @@
               <a:buNone/>
             </a:pPr>
             <a:r>
-              <a:rPr lang="en-US" sz="900" b="1" dirty="0">
+              <a:rPr lang="en-US" sz="1200" b="1" dirty="0">
                 <a:solidFill>
                   <a:srgbClr val="5D300F"/>
                 </a:solidFill>
@@ -11542,7 +11542,7 @@
               </a:rPr>
               <a:t>% Change from Prior Month</a:t>
             </a:r>
-            <a:endParaRPr lang="en-US" sz="900" dirty="0"/>
+            <a:endParaRPr lang="en-US" sz="1200" dirty="0"/>
           </a:p>
         </p:txBody>
       </p:sp>
@@ -11554,7 +11554,7 @@
         </p:nvSpPr>
         <p:spPr>
           <a:xfrm>
-            <a:off x="6172200" y="4425696"/>
+            <a:off x="6172200" y="5925312"/>
             <a:ext cx="1161288" cy="347472"/>
           </a:xfrm>
           <a:prstGeom prst="rect">
@@ -11571,7 +11571,7 @@
               <a:buNone/>
             </a:pPr>
             <a:r>
-              <a:rPr lang="en-US" sz="1000" b="1" dirty="0">
+              <a:rPr lang="en-US" sz="1200" b="1" dirty="0">
                 <a:solidFill>
                   <a:srgbClr val="718096"/>
                 </a:solidFill>
@@ -11581,7 +11581,7 @@
               </a:rPr>
               <a:t>—</a:t>
             </a:r>
-            <a:endParaRPr lang="en-US" sz="1000" dirty="0"/>
+            <a:endParaRPr lang="en-US" sz="1200" dirty="0"/>
           </a:p>
         </p:txBody>
       </p:sp>
@@ -11593,7 +11593,7 @@
         </p:nvSpPr>
         <p:spPr>
           <a:xfrm>
-            <a:off x="7333488" y="4425696"/>
+            <a:off x="7333488" y="5925312"/>
             <a:ext cx="1161288" cy="347472"/>
           </a:xfrm>
           <a:prstGeom prst="rect">
@@ -11610,7 +11610,7 @@
               <a:buNone/>
             </a:pPr>
             <a:r>
-              <a:rPr lang="en-US" sz="1000" b="1" dirty="0">
+              <a:rPr lang="en-US" sz="1200" b="1" dirty="0">
                 <a:solidFill>
                   <a:srgbClr val="718096"/>
                 </a:solidFill>
@@ -11620,7 +11620,7 @@
               </a:rPr>
               <a:t>—</a:t>
             </a:r>
-            <a:endParaRPr lang="en-US" sz="1000" dirty="0"/>
+            <a:endParaRPr lang="en-US" sz="1200" dirty="0"/>
           </a:p>
         </p:txBody>
       </p:sp>
@@ -11632,7 +11632,7 @@
         </p:nvSpPr>
         <p:spPr>
           <a:xfrm>
-            <a:off x="8494776" y="4425696"/>
+            <a:off x="8494776" y="5925312"/>
             <a:ext cx="1161288" cy="347472"/>
           </a:xfrm>
           <a:prstGeom prst="rect">
@@ -11649,7 +11649,7 @@
               <a:buNone/>
             </a:pPr>
             <a:r>
-              <a:rPr lang="en-US" sz="1000" b="1" dirty="0">
+              <a:rPr lang="en-US" sz="1200" b="1" dirty="0">
                 <a:solidFill>
                   <a:srgbClr val="718096"/>
                 </a:solidFill>
@@ -11659,7 +11659,7 @@
               </a:rPr>
               <a:t>—</a:t>
             </a:r>
-            <a:endParaRPr lang="en-US" sz="1000" dirty="0"/>
+            <a:endParaRPr lang="en-US" sz="1200" dirty="0"/>
           </a:p>
         </p:txBody>
       </p:sp>
@@ -11671,7 +11671,7 @@
         </p:nvSpPr>
         <p:spPr>
           <a:xfrm>
-            <a:off x="9656064" y="4425696"/>
+            <a:off x="9656064" y="5925312"/>
             <a:ext cx="1161288" cy="347472"/>
           </a:xfrm>
           <a:prstGeom prst="rect">
@@ -11688,7 +11688,7 @@
               <a:buNone/>
             </a:pPr>
             <a:r>
-              <a:rPr lang="en-US" sz="1000" b="1" dirty="0">
+              <a:rPr lang="en-US" sz="1200" b="1" dirty="0">
                 <a:solidFill>
                   <a:srgbClr val="718096"/>
                 </a:solidFill>
@@ -11698,7 +11698,7 @@
               </a:rPr>
               <a:t>—</a:t>
             </a:r>
-            <a:endParaRPr lang="en-US" sz="1000" dirty="0"/>
+            <a:endParaRPr lang="en-US" sz="1200" dirty="0"/>
           </a:p>
         </p:txBody>
       </p:sp>
@@ -11710,7 +11710,7 @@
         </p:nvSpPr>
         <p:spPr>
           <a:xfrm>
-            <a:off x="10817352" y="4425696"/>
+            <a:off x="10817352" y="5925312"/>
             <a:ext cx="1161288" cy="347472"/>
           </a:xfrm>
           <a:prstGeom prst="rect">
@@ -11727,7 +11727,7 @@
               <a:buNone/>
             </a:pPr>
             <a:r>
-              <a:rPr lang="en-US" sz="1000" b="1" dirty="0">
+              <a:rPr lang="en-US" sz="1200" b="1" dirty="0">
                 <a:solidFill>
                   <a:srgbClr val="718096"/>
                 </a:solidFill>
@@ -11737,7 +11737,7 @@
               </a:rPr>
               <a:t>—</a:t>
             </a:r>
-            <a:endParaRPr lang="en-US" sz="1000" dirty="0"/>
+            <a:endParaRPr lang="en-US" sz="1200" dirty="0"/>
           </a:p>
         </p:txBody>
       </p:sp>
@@ -11967,7 +11967,7 @@
         <p:spPr>
           <a:xfrm>
             <a:off x="0" y="539496"/>
-            <a:ext cx="7772400" cy="274320"/>
+            <a:ext cx="7772400" cy="292608"/>
           </a:xfrm>
           <a:prstGeom prst="rect">
             <a:avLst/>
@@ -11992,7 +11992,7 @@
         <p:spPr>
           <a:xfrm>
             <a:off x="0" y="539496"/>
-            <a:ext cx="54864" cy="274320"/>
+            <a:ext cx="54864" cy="292608"/>
           </a:xfrm>
           <a:prstGeom prst="rect">
             <a:avLst/>
@@ -12017,7 +12017,7 @@
         <p:spPr>
           <a:xfrm>
             <a:off x="109728" y="539496"/>
-            <a:ext cx="7662672" cy="274320"/>
+            <a:ext cx="7662672" cy="292608"/>
           </a:xfrm>
           <a:prstGeom prst="rect">
             <a:avLst/>
@@ -12033,7 +12033,7 @@
               <a:buNone/>
             </a:pPr>
             <a:r>
-              <a:rPr lang="en-US" sz="900" b="1" dirty="0">
+              <a:rPr lang="en-US" sz="1200" b="1" dirty="0">
                 <a:solidFill>
                   <a:srgbClr val="5D300F"/>
                 </a:solidFill>
@@ -12043,7 +12043,7 @@
               </a:rPr>
               <a:t>Loan Book – P+I Outstanding (≤60 Days Overdue) – January 2026</a:t>
             </a:r>
-            <a:endParaRPr lang="en-US" sz="900" dirty="0"/>
+            <a:endParaRPr lang="en-US" sz="1200" dirty="0"/>
           </a:p>
         </p:txBody>
       </p:sp>
@@ -12055,7 +12055,7 @@
         </p:nvGraphicFramePr>
         <p:xfrm>
           <a:off x="137160" y="841248"/>
-          <a:ext cx="7589520" cy="3200400"/>
+          <a:ext cx="7589520" cy="4663440"/>
         </p:xfrm>
         <a:graphic xmlns:a="http://schemas.openxmlformats.org/drawingml/2006/main">
           <a:graphicData uri="http://schemas.openxmlformats.org/drawingml/2006/chart">
@@ -12071,8 +12071,8 @@
         </p:nvSpPr>
         <p:spPr>
           <a:xfrm>
-            <a:off x="0" y="4114800"/>
-            <a:ext cx="7772400" cy="274320"/>
+            <a:off x="0" y="5577840"/>
+            <a:ext cx="7772400" cy="292608"/>
           </a:xfrm>
           <a:prstGeom prst="rect">
             <a:avLst/>
@@ -12096,8 +12096,8 @@
         </p:nvSpPr>
         <p:spPr>
           <a:xfrm>
-            <a:off x="0" y="4114800"/>
-            <a:ext cx="54864" cy="274320"/>
+            <a:off x="0" y="5577840"/>
+            <a:ext cx="54864" cy="292608"/>
           </a:xfrm>
           <a:prstGeom prst="rect">
             <a:avLst/>
@@ -12121,8 +12121,8 @@
         </p:nvSpPr>
         <p:spPr>
           <a:xfrm>
-            <a:off x="109728" y="4114800"/>
-            <a:ext cx="7662672" cy="274320"/>
+            <a:off x="109728" y="5577840"/>
+            <a:ext cx="7662672" cy="292608"/>
           </a:xfrm>
           <a:prstGeom prst="rect">
             <a:avLst/>
@@ -12138,7 +12138,7 @@
               <a:buNone/>
             </a:pPr>
             <a:r>
-              <a:rPr lang="en-US" sz="900" b="1" dirty="0">
+              <a:rPr lang="en-US" sz="1200" b="1" dirty="0">
                 <a:solidFill>
                   <a:srgbClr val="5D300F"/>
                 </a:solidFill>
@@ -12148,7 +12148,7 @@
               </a:rPr>
               <a:t>% Change from Prior Month</a:t>
             </a:r>
-            <a:endParaRPr lang="en-US" sz="900" dirty="0"/>
+            <a:endParaRPr lang="en-US" sz="1200" dirty="0"/>
           </a:p>
         </p:txBody>
       </p:sp>
@@ -12160,7 +12160,7 @@
         </p:nvSpPr>
         <p:spPr>
           <a:xfrm>
-            <a:off x="137160" y="4425696"/>
+            <a:off x="137160" y="5925312"/>
             <a:ext cx="1517904" cy="347472"/>
           </a:xfrm>
           <a:prstGeom prst="rect">
@@ -12177,7 +12177,7 @@
               <a:buNone/>
             </a:pPr>
             <a:r>
-              <a:rPr lang="en-US" sz="1000" b="1" dirty="0">
+              <a:rPr lang="en-US" sz="1200" b="1" dirty="0">
                 <a:solidFill>
                   <a:srgbClr val="718096"/>
                 </a:solidFill>
@@ -12187,7 +12187,7 @@
               </a:rPr>
               <a:t>—</a:t>
             </a:r>
-            <a:endParaRPr lang="en-US" sz="1000" dirty="0"/>
+            <a:endParaRPr lang="en-US" sz="1200" dirty="0"/>
           </a:p>
         </p:txBody>
       </p:sp>
@@ -12199,7 +12199,7 @@
         </p:nvSpPr>
         <p:spPr>
           <a:xfrm>
-            <a:off x="1655064" y="4425696"/>
+            <a:off x="1655064" y="5925312"/>
             <a:ext cx="1517904" cy="347472"/>
           </a:xfrm>
           <a:prstGeom prst="rect">
@@ -12216,7 +12216,7 @@
               <a:buNone/>
             </a:pPr>
             <a:r>
-              <a:rPr lang="en-US" sz="1000" b="1" dirty="0">
+              <a:rPr lang="en-US" sz="1200" b="1" dirty="0">
                 <a:solidFill>
                   <a:srgbClr val="718096"/>
                 </a:solidFill>
@@ -12226,7 +12226,7 @@
               </a:rPr>
               <a:t>—</a:t>
             </a:r>
-            <a:endParaRPr lang="en-US" sz="1000" dirty="0"/>
+            <a:endParaRPr lang="en-US" sz="1200" dirty="0"/>
           </a:p>
         </p:txBody>
       </p:sp>
@@ -12238,7 +12238,7 @@
         </p:nvSpPr>
         <p:spPr>
           <a:xfrm>
-            <a:off x="3172968" y="4425696"/>
+            <a:off x="3172968" y="5925312"/>
             <a:ext cx="1517904" cy="347472"/>
           </a:xfrm>
           <a:prstGeom prst="rect">
@@ -12255,7 +12255,7 @@
               <a:buNone/>
             </a:pPr>
             <a:r>
-              <a:rPr lang="en-US" sz="1000" b="1" dirty="0">
+              <a:rPr lang="en-US" sz="1200" b="1" dirty="0">
                 <a:solidFill>
                   <a:srgbClr val="718096"/>
                 </a:solidFill>
@@ -12265,7 +12265,7 @@
               </a:rPr>
               <a:t>—</a:t>
             </a:r>
-            <a:endParaRPr lang="en-US" sz="1000" dirty="0"/>
+            <a:endParaRPr lang="en-US" sz="1200" dirty="0"/>
           </a:p>
         </p:txBody>
       </p:sp>
@@ -12277,7 +12277,7 @@
         </p:nvSpPr>
         <p:spPr>
           <a:xfrm>
-            <a:off x="4690872" y="4425696"/>
+            <a:off x="4690872" y="5925312"/>
             <a:ext cx="1517904" cy="347472"/>
           </a:xfrm>
           <a:prstGeom prst="rect">
@@ -12294,7 +12294,7 @@
               <a:buNone/>
             </a:pPr>
             <a:r>
-              <a:rPr lang="en-US" sz="1000" b="1" dirty="0">
+              <a:rPr lang="en-US" sz="1200" b="1" dirty="0">
                 <a:solidFill>
                   <a:srgbClr val="718096"/>
                 </a:solidFill>
@@ -12304,7 +12304,7 @@
               </a:rPr>
               <a:t>—</a:t>
             </a:r>
-            <a:endParaRPr lang="en-US" sz="1000" dirty="0"/>
+            <a:endParaRPr lang="en-US" sz="1200" dirty="0"/>
           </a:p>
         </p:txBody>
       </p:sp>
@@ -12316,7 +12316,7 @@
         </p:nvSpPr>
         <p:spPr>
           <a:xfrm>
-            <a:off x="6208776" y="4425696"/>
+            <a:off x="6208776" y="5925312"/>
             <a:ext cx="1517904" cy="347472"/>
           </a:xfrm>
           <a:prstGeom prst="rect">
@@ -12333,7 +12333,7 @@
               <a:buNone/>
             </a:pPr>
             <a:r>
-              <a:rPr lang="en-US" sz="1000" b="1" dirty="0">
+              <a:rPr lang="en-US" sz="1200" b="1" dirty="0">
                 <a:solidFill>
                   <a:srgbClr val="718096"/>
                 </a:solidFill>
@@ -12343,7 +12343,7 @@
               </a:rPr>
               <a:t>—</a:t>
             </a:r>
-            <a:endParaRPr lang="en-US" sz="1000" dirty="0"/>
+            <a:endParaRPr lang="en-US" sz="1200" dirty="0"/>
           </a:p>
         </p:txBody>
       </p:sp>
@@ -12429,7 +12429,7 @@
               <a:buNone/>
             </a:pPr>
             <a:r>
-              <a:rPr lang="en-US" sz="2000" b="1" dirty="0">
+              <a:rPr lang="en-US" sz="2600" b="1" dirty="0">
                 <a:solidFill>
                   <a:srgbClr val="5D300F"/>
                 </a:solidFill>
@@ -12439,7 +12439,7 @@
               </a:rPr>
               <a:t>$12,156,790</a:t>
             </a:r>
-            <a:endParaRPr lang="en-US" sz="2000" dirty="0"/>
+            <a:endParaRPr lang="en-US" sz="2600" dirty="0"/>
           </a:p>
         </p:txBody>
       </p:sp>
@@ -12468,7 +12468,7 @@
               <a:buNone/>
             </a:pPr>
             <a:r>
-              <a:rPr lang="en-US" sz="800" dirty="0">
+              <a:rPr lang="en-US" sz="1200" dirty="0">
                 <a:solidFill>
                   <a:srgbClr val="718096"/>
                 </a:solidFill>
@@ -12478,7 +12478,7 @@
               </a:rPr>
               <a:t>Total Loan Book (USD)</a:t>
             </a:r>
-            <a:endParaRPr lang="en-US" sz="800" dirty="0"/>
+            <a:endParaRPr lang="en-US" sz="1200" dirty="0"/>
           </a:p>
         </p:txBody>
       </p:sp>
@@ -12564,7 +12564,7 @@
               <a:buNone/>
             </a:pPr>
             <a:r>
-              <a:rPr lang="en-US" sz="2000" b="1" dirty="0">
+              <a:rPr lang="en-US" sz="2600" b="1" dirty="0">
                 <a:solidFill>
                   <a:srgbClr val="5D300F"/>
                 </a:solidFill>
@@ -12574,7 +12574,7 @@
               </a:rPr>
               <a:t>—</a:t>
             </a:r>
-            <a:endParaRPr lang="en-US" sz="2000" dirty="0"/>
+            <a:endParaRPr lang="en-US" sz="2600" dirty="0"/>
           </a:p>
         </p:txBody>
       </p:sp>
@@ -12603,7 +12603,7 @@
               <a:buNone/>
             </a:pPr>
             <a:r>
-              <a:rPr lang="en-US" sz="800" dirty="0">
+              <a:rPr lang="en-US" sz="1200" dirty="0">
                 <a:solidFill>
                   <a:srgbClr val="718096"/>
                 </a:solidFill>
@@ -12613,7 +12613,7 @@
               </a:rPr>
               <a:t>Change vs Prior Month</a:t>
             </a:r>
-            <a:endParaRPr lang="en-US" sz="800" dirty="0"/>
+            <a:endParaRPr lang="en-US" sz="1200" dirty="0"/>
           </a:p>
         </p:txBody>
       </p:sp>
@@ -12676,7 +12676,7 @@
         <p:spPr>
           <a:xfrm>
             <a:off x="8065008" y="2935224"/>
-            <a:ext cx="3886200" cy="201168"/>
+            <a:ext cx="3886200" cy="228600"/>
           </a:xfrm>
           <a:prstGeom prst="rect">
             <a:avLst/>
@@ -12692,7 +12692,7 @@
               <a:buNone/>
             </a:pPr>
             <a:r>
-              <a:rPr lang="en-US" sz="750" b="1" spc="100" kern="0" dirty="0">
+              <a:rPr lang="en-US" sz="1200" b="1" spc="100" kern="0" dirty="0">
                 <a:solidFill>
                   <a:srgbClr val="5D300F"/>
                 </a:solidFill>
@@ -12702,7 +12702,7 @@
               </a:rPr>
               <a:t>KEY HIGHLIGHTS</a:t>
             </a:r>
-            <a:endParaRPr lang="en-US" sz="750" dirty="0"/>
+            <a:endParaRPr lang="en-US" sz="1200" dirty="0"/>
           </a:p>
         </p:txBody>
       </p:sp>
@@ -12714,8 +12714,8 @@
         </p:nvSpPr>
         <p:spPr>
           <a:xfrm>
-            <a:off x="8065008" y="3154680"/>
-            <a:ext cx="3886200" cy="3310128"/>
+            <a:off x="8065008" y="3200400"/>
+            <a:ext cx="3886200" cy="3264408"/>
           </a:xfrm>
           <a:prstGeom prst="rect">
             <a:avLst/>
@@ -12731,7 +12731,7 @@
               <a:buNone/>
             </a:pPr>
             <a:r>
-              <a:rPr lang="en-US" sz="900" dirty="0">
+              <a:rPr lang="en-US" sz="1200" dirty="0">
                 <a:solidFill>
                   <a:srgbClr val="2D2A26"/>
                 </a:solidFill>
@@ -12741,14 +12741,14 @@
               </a:rPr>
               <a:t>Total loan book: $12,156,790.</a:t>
             </a:r>
-            <a:endParaRPr lang="en-US" sz="900" dirty="0"/>
+            <a:endParaRPr lang="en-US" sz="1200" dirty="0"/>
           </a:p>
           <a:p>
             <a:pPr indent="0" marL="0">
               <a:buNone/>
             </a:pPr>
             <a:r>
-              <a:rPr lang="en-US" sz="900" dirty="0">
+              <a:rPr lang="en-US" sz="1200" dirty="0">
                 <a:solidFill>
                   <a:srgbClr val="2D2A26"/>
                 </a:solidFill>
@@ -12758,7 +12758,7 @@
               </a:rPr>
               <a:t>Tanzania has the largest loan book ($5,610,176).</a:t>
             </a:r>
-            <a:endParaRPr lang="en-US" sz="900" dirty="0"/>
+            <a:endParaRPr lang="en-US" sz="1200" dirty="0"/>
           </a:p>
         </p:txBody>
       </p:sp>
@@ -12988,7 +12988,7 @@
         <p:spPr>
           <a:xfrm>
             <a:off x="0" y="539496"/>
-            <a:ext cx="12161520" cy="274320"/>
+            <a:ext cx="12161520" cy="292608"/>
           </a:xfrm>
           <a:prstGeom prst="rect">
             <a:avLst/>
@@ -13013,7 +13013,7 @@
         <p:spPr>
           <a:xfrm>
             <a:off x="0" y="539496"/>
-            <a:ext cx="54864" cy="274320"/>
+            <a:ext cx="54864" cy="292608"/>
           </a:xfrm>
           <a:prstGeom prst="rect">
             <a:avLst/>
@@ -13038,7 +13038,7 @@
         <p:spPr>
           <a:xfrm>
             <a:off x="109728" y="539496"/>
-            <a:ext cx="12051792" cy="274320"/>
+            <a:ext cx="12051792" cy="292608"/>
           </a:xfrm>
           <a:prstGeom prst="rect">
             <a:avLst/>
@@ -13054,7 +13054,7 @@
               <a:buNone/>
             </a:pPr>
             <a:r>
-              <a:rPr lang="en-US" sz="900" b="1" dirty="0">
+              <a:rPr lang="en-US" sz="1200" b="1" dirty="0">
                 <a:solidFill>
                   <a:srgbClr val="5D300F"/>
                 </a:solidFill>
@@ -13064,7 +13064,7 @@
               </a:rPr>
               <a:t>Year to Date Chronic Rates (P+I) – January 2026</a:t>
             </a:r>
-            <a:endParaRPr lang="en-US" sz="900" dirty="0"/>
+            <a:endParaRPr lang="en-US" sz="1200" dirty="0"/>
           </a:p>
         </p:txBody>
       </p:sp>
@@ -14970,7 +14970,7 @@
         <p:spPr>
           <a:xfrm>
             <a:off x="0" y="539496"/>
-            <a:ext cx="12161520" cy="274320"/>
+            <a:ext cx="12161520" cy="292608"/>
           </a:xfrm>
           <a:prstGeom prst="rect">
             <a:avLst/>
@@ -14995,7 +14995,7 @@
         <p:spPr>
           <a:xfrm>
             <a:off x="0" y="539496"/>
-            <a:ext cx="54864" cy="274320"/>
+            <a:ext cx="54864" cy="292608"/>
           </a:xfrm>
           <a:prstGeom prst="rect">
             <a:avLst/>
@@ -15020,7 +15020,7 @@
         <p:spPr>
           <a:xfrm>
             <a:off x="109728" y="539496"/>
-            <a:ext cx="12051792" cy="274320"/>
+            <a:ext cx="12051792" cy="292608"/>
           </a:xfrm>
           <a:prstGeom prst="rect">
             <a:avLst/>
@@ -15036,7 +15036,7 @@
               <a:buNone/>
             </a:pPr>
             <a:r>
-              <a:rPr lang="en-US" sz="900" b="1" dirty="0">
+              <a:rPr lang="en-US" sz="1200" b="1" dirty="0">
                 <a:solidFill>
                   <a:srgbClr val="5D300F"/>
                 </a:solidFill>
@@ -15046,7 +15046,7 @@
               </a:rPr>
               <a:t>PAR 30 – January 2026</a:t>
             </a:r>
-            <a:endParaRPr lang="en-US" sz="900" dirty="0"/>
+            <a:endParaRPr lang="en-US" sz="1200" dirty="0"/>
           </a:p>
         </p:txBody>
       </p:sp>
@@ -16952,7 +16952,7 @@
         <p:spPr>
           <a:xfrm>
             <a:off x="0" y="539496"/>
-            <a:ext cx="12161520" cy="274320"/>
+            <a:ext cx="12161520" cy="292608"/>
           </a:xfrm>
           <a:prstGeom prst="rect">
             <a:avLst/>
@@ -16977,7 +16977,7 @@
         <p:spPr>
           <a:xfrm>
             <a:off x="0" y="539496"/>
-            <a:ext cx="54864" cy="274320"/>
+            <a:ext cx="54864" cy="292608"/>
           </a:xfrm>
           <a:prstGeom prst="rect">
             <a:avLst/>
@@ -17002,7 +17002,7 @@
         <p:spPr>
           <a:xfrm>
             <a:off x="109728" y="539496"/>
-            <a:ext cx="12051792" cy="274320"/>
+            <a:ext cx="12051792" cy="292608"/>
           </a:xfrm>
           <a:prstGeom prst="rect">
             <a:avLst/>
@@ -17018,7 +17018,7 @@
               <a:buNone/>
             </a:pPr>
             <a:r>
-              <a:rPr lang="en-US" sz="900" b="1" dirty="0">
+              <a:rPr lang="en-US" sz="1200" b="1" dirty="0">
                 <a:solidFill>
                   <a:srgbClr val="5D300F"/>
                 </a:solidFill>
@@ -17028,7 +17028,7 @@
               </a:rPr>
               <a:t>Income &amp; Expenses (USD) – January 2026</a:t>
             </a:r>
-            <a:endParaRPr lang="en-US" sz="900" dirty="0"/>
+            <a:endParaRPr lang="en-US" sz="1200" dirty="0"/>
           </a:p>
         </p:txBody>
       </p:sp>
@@ -20534,7 +20534,7 @@
               <a:buNone/>
             </a:pPr>
             <a:r>
-              <a:rPr lang="en-US" sz="2000" b="1" dirty="0">
+              <a:rPr lang="en-US" sz="2600" b="1" dirty="0">
                 <a:solidFill>
                   <a:srgbClr val="5D300F"/>
                 </a:solidFill>
@@ -20544,7 +20544,7 @@
               </a:rPr>
               <a:t>$1,885,356</a:t>
             </a:r>
-            <a:endParaRPr lang="en-US" sz="2000" dirty="0"/>
+            <a:endParaRPr lang="en-US" sz="2600" dirty="0"/>
           </a:p>
         </p:txBody>
       </p:sp>
@@ -20573,7 +20573,7 @@
               <a:buNone/>
             </a:pPr>
             <a:r>
-              <a:rPr lang="en-US" sz="800" dirty="0">
+              <a:rPr lang="en-US" sz="1200" dirty="0">
                 <a:solidFill>
                   <a:srgbClr val="718096"/>
                 </a:solidFill>
@@ -20583,7 +20583,7 @@
               </a:rPr>
               <a:t>Group Revenue</a:t>
             </a:r>
-            <a:endParaRPr lang="en-US" sz="800" dirty="0"/>
+            <a:endParaRPr lang="en-US" sz="1200" dirty="0"/>
           </a:p>
         </p:txBody>
       </p:sp>
@@ -20669,7 +20669,7 @@
               <a:buNone/>
             </a:pPr>
             <a:r>
-              <a:rPr lang="en-US" sz="2000" b="1" dirty="0">
+              <a:rPr lang="en-US" sz="2600" b="1" dirty="0">
                 <a:solidFill>
                   <a:srgbClr val="5D300F"/>
                 </a:solidFill>
@@ -20679,7 +20679,7 @@
               </a:rPr>
               <a:t>$314,841</a:t>
             </a:r>
-            <a:endParaRPr lang="en-US" sz="2000" dirty="0"/>
+            <a:endParaRPr lang="en-US" sz="2600" dirty="0"/>
           </a:p>
         </p:txBody>
       </p:sp>
@@ -20708,7 +20708,7 @@
               <a:buNone/>
             </a:pPr>
             <a:r>
-              <a:rPr lang="en-US" sz="800" dirty="0">
+              <a:rPr lang="en-US" sz="1200" dirty="0">
                 <a:solidFill>
                   <a:srgbClr val="718096"/>
                 </a:solidFill>
@@ -20718,7 +20718,7 @@
               </a:rPr>
               <a:t>Group Operating Income</a:t>
             </a:r>
-            <a:endParaRPr lang="en-US" sz="800" dirty="0"/>
+            <a:endParaRPr lang="en-US" sz="1200" dirty="0"/>
           </a:p>
         </p:txBody>
       </p:sp>
@@ -20804,7 +20804,7 @@
               <a:buNone/>
             </a:pPr>
             <a:r>
-              <a:rPr lang="en-US" sz="2000" b="1" dirty="0">
+              <a:rPr lang="en-US" sz="2600" b="1" dirty="0">
                 <a:solidFill>
                   <a:srgbClr val="5D300F"/>
                 </a:solidFill>
@@ -20814,7 +20814,7 @@
               </a:rPr>
               <a:t>16.7%</a:t>
             </a:r>
-            <a:endParaRPr lang="en-US" sz="2000" dirty="0"/>
+            <a:endParaRPr lang="en-US" sz="2600" dirty="0"/>
           </a:p>
         </p:txBody>
       </p:sp>
@@ -20843,7 +20843,7 @@
               <a:buNone/>
             </a:pPr>
             <a:r>
-              <a:rPr lang="en-US" sz="800" dirty="0">
+              <a:rPr lang="en-US" sz="1200" dirty="0">
                 <a:solidFill>
                   <a:srgbClr val="718096"/>
                 </a:solidFill>
@@ -20853,7 +20853,7 @@
               </a:rPr>
               <a:t>Group Margin</a:t>
             </a:r>
-            <a:endParaRPr lang="en-US" sz="800" dirty="0"/>
+            <a:endParaRPr lang="en-US" sz="1200" dirty="0"/>
           </a:p>
         </p:txBody>
       </p:sp>

</xml_diff>

<commit_message>
Auto-build: 2026-03-12 02:21 UTC
</commit_message>
<xml_diff>
--- a/reports/2026-01.pptx
+++ b/reports/2026-01.pptx
@@ -356,19 +356,8 @@
         <c:scaling>
           <c:orientation val="minMax"/>
         </c:scaling>
-        <c:delete val="0"/>
+        <c:delete val="1"/>
         <c:axPos val="l"/>
-        <c:majorGridlines>
-          <c:spPr>
-            <a:ln w="6350" cap="flat">
-              <a:solidFill>
-                <a:srgbClr val="D6CFC4"/>
-              </a:solidFill>
-              <a:prstDash val="solid"/>
-              <a:round/>
-            </a:ln>
-          </c:spPr>
-        </c:majorGridlines>
         <c:numFmt formatCode="General" sourceLinked="0"/>
         <c:majorTickMark val="out"/>
         <c:minorTickMark val="none"/>
@@ -387,9 +376,9 @@
           <a:lstStyle/>
           <a:p>
             <a:pPr>
-              <a:defRPr sz="1100" b="0" i="0" u="none" strike="noStrike">
+              <a:defRPr sz="1200" b="0" i="0" u="none" strike="noStrike">
                 <a:solidFill>
-                  <a:srgbClr val="718096"/>
+                  <a:srgbClr val="000000"/>
                 </a:solidFill>
                 <a:latin typeface="Arial"/>
               </a:defRPr>
@@ -667,19 +656,8 @@
         <c:scaling>
           <c:orientation val="minMax"/>
         </c:scaling>
-        <c:delete val="0"/>
+        <c:delete val="1"/>
         <c:axPos val="l"/>
-        <c:majorGridlines>
-          <c:spPr>
-            <a:ln w="6350" cap="flat">
-              <a:solidFill>
-                <a:srgbClr val="D6CFC4"/>
-              </a:solidFill>
-              <a:prstDash val="solid"/>
-              <a:round/>
-            </a:ln>
-          </c:spPr>
-        </c:majorGridlines>
         <c:numFmt formatCode="General" sourceLinked="0"/>
         <c:majorTickMark val="out"/>
         <c:minorTickMark val="none"/>
@@ -698,9 +676,9 @@
           <a:lstStyle/>
           <a:p>
             <a:pPr>
-              <a:defRPr sz="1100" b="0" i="0" u="none" strike="noStrike">
+              <a:defRPr sz="1200" b="0" i="0" u="none" strike="noStrike">
                 <a:solidFill>
-                  <a:srgbClr val="718096"/>
+                  <a:srgbClr val="000000"/>
                 </a:solidFill>
                 <a:latin typeface="Arial"/>
               </a:defRPr>
@@ -978,19 +956,8 @@
         <c:scaling>
           <c:orientation val="minMax"/>
         </c:scaling>
-        <c:delete val="0"/>
+        <c:delete val="1"/>
         <c:axPos val="l"/>
-        <c:majorGridlines>
-          <c:spPr>
-            <a:ln w="6350" cap="flat">
-              <a:solidFill>
-                <a:srgbClr val="D6CFC4"/>
-              </a:solidFill>
-              <a:prstDash val="solid"/>
-              <a:round/>
-            </a:ln>
-          </c:spPr>
-        </c:majorGridlines>
         <c:numFmt formatCode="General" sourceLinked="0"/>
         <c:majorTickMark val="out"/>
         <c:minorTickMark val="none"/>
@@ -1009,9 +976,9 @@
           <a:lstStyle/>
           <a:p>
             <a:pPr>
-              <a:defRPr sz="1100" b="0" i="0" u="none" strike="noStrike">
+              <a:defRPr sz="1200" b="0" i="0" u="none" strike="noStrike">
                 <a:solidFill>
-                  <a:srgbClr val="718096"/>
+                  <a:srgbClr val="000000"/>
                 </a:solidFill>
                 <a:latin typeface="Arial"/>
               </a:defRPr>
@@ -1289,19 +1256,8 @@
         <c:scaling>
           <c:orientation val="minMax"/>
         </c:scaling>
-        <c:delete val="0"/>
+        <c:delete val="1"/>
         <c:axPos val="l"/>
-        <c:majorGridlines>
-          <c:spPr>
-            <a:ln w="6350" cap="flat">
-              <a:solidFill>
-                <a:srgbClr val="D6CFC4"/>
-              </a:solidFill>
-              <a:prstDash val="solid"/>
-              <a:round/>
-            </a:ln>
-          </c:spPr>
-        </c:majorGridlines>
         <c:numFmt formatCode="General" sourceLinked="0"/>
         <c:majorTickMark val="out"/>
         <c:minorTickMark val="none"/>
@@ -1320,9 +1276,9 @@
           <a:lstStyle/>
           <a:p>
             <a:pPr>
-              <a:defRPr sz="1100" b="0" i="0" u="none" strike="noStrike">
+              <a:defRPr sz="1200" b="0" i="0" u="none" strike="noStrike">
                 <a:solidFill>
-                  <a:srgbClr val="718096"/>
+                  <a:srgbClr val="000000"/>
                 </a:solidFill>
                 <a:latin typeface="Arial"/>
               </a:defRPr>
@@ -1600,19 +1556,8 @@
         <c:scaling>
           <c:orientation val="minMax"/>
         </c:scaling>
-        <c:delete val="0"/>
+        <c:delete val="1"/>
         <c:axPos val="l"/>
-        <c:majorGridlines>
-          <c:spPr>
-            <a:ln w="6350" cap="flat">
-              <a:solidFill>
-                <a:srgbClr val="D6CFC4"/>
-              </a:solidFill>
-              <a:prstDash val="solid"/>
-              <a:round/>
-            </a:ln>
-          </c:spPr>
-        </c:majorGridlines>
         <c:numFmt formatCode="General" sourceLinked="0"/>
         <c:majorTickMark val="out"/>
         <c:minorTickMark val="none"/>
@@ -1631,9 +1576,9 @@
           <a:lstStyle/>
           <a:p>
             <a:pPr>
-              <a:defRPr sz="1100" b="0" i="0" u="none" strike="noStrike">
+              <a:defRPr sz="1200" b="0" i="0" u="none" strike="noStrike">
                 <a:solidFill>
-                  <a:srgbClr val="718096"/>
+                  <a:srgbClr val="000000"/>
                 </a:solidFill>
                 <a:latin typeface="Arial"/>
               </a:defRPr>
@@ -1911,19 +1856,8 @@
         <c:scaling>
           <c:orientation val="minMax"/>
         </c:scaling>
-        <c:delete val="0"/>
+        <c:delete val="1"/>
         <c:axPos val="l"/>
-        <c:majorGridlines>
-          <c:spPr>
-            <a:ln w="6350" cap="flat">
-              <a:solidFill>
-                <a:srgbClr val="D6CFC4"/>
-              </a:solidFill>
-              <a:prstDash val="solid"/>
-              <a:round/>
-            </a:ln>
-          </c:spPr>
-        </c:majorGridlines>
         <c:numFmt formatCode="General" sourceLinked="0"/>
         <c:majorTickMark val="out"/>
         <c:minorTickMark val="none"/>
@@ -1942,9 +1876,9 @@
           <a:lstStyle/>
           <a:p>
             <a:pPr>
-              <a:defRPr sz="1100" b="0" i="0" u="none" strike="noStrike">
+              <a:defRPr sz="1200" b="0" i="0" u="none" strike="noStrike">
                 <a:solidFill>
-                  <a:srgbClr val="718096"/>
+                  <a:srgbClr val="000000"/>
                 </a:solidFill>
                 <a:latin typeface="Arial"/>
               </a:defRPr>
@@ -2222,19 +2156,8 @@
         <c:scaling>
           <c:orientation val="minMax"/>
         </c:scaling>
-        <c:delete val="0"/>
+        <c:delete val="1"/>
         <c:axPos val="l"/>
-        <c:majorGridlines>
-          <c:spPr>
-            <a:ln w="6350" cap="flat">
-              <a:solidFill>
-                <a:srgbClr val="D6CFC4"/>
-              </a:solidFill>
-              <a:prstDash val="solid"/>
-              <a:round/>
-            </a:ln>
-          </c:spPr>
-        </c:majorGridlines>
         <c:numFmt formatCode="General" sourceLinked="0"/>
         <c:majorTickMark val="out"/>
         <c:minorTickMark val="none"/>
@@ -2253,9 +2176,9 @@
           <a:lstStyle/>
           <a:p>
             <a:pPr>
-              <a:defRPr sz="1100" b="0" i="0" u="none" strike="noStrike">
+              <a:defRPr sz="1200" b="0" i="0" u="none" strike="noStrike">
                 <a:solidFill>
-                  <a:srgbClr val="718096"/>
+                  <a:srgbClr val="000000"/>
                 </a:solidFill>
                 <a:latin typeface="Arial"/>
               </a:defRPr>
@@ -2533,19 +2456,8 @@
         <c:scaling>
           <c:orientation val="minMax"/>
         </c:scaling>
-        <c:delete val="0"/>
+        <c:delete val="1"/>
         <c:axPos val="l"/>
-        <c:majorGridlines>
-          <c:spPr>
-            <a:ln w="6350" cap="flat">
-              <a:solidFill>
-                <a:srgbClr val="D6CFC4"/>
-              </a:solidFill>
-              <a:prstDash val="solid"/>
-              <a:round/>
-            </a:ln>
-          </c:spPr>
-        </c:majorGridlines>
         <c:numFmt formatCode="General" sourceLinked="0"/>
         <c:majorTickMark val="out"/>
         <c:minorTickMark val="none"/>
@@ -2564,9 +2476,9 @@
           <a:lstStyle/>
           <a:p>
             <a:pPr>
-              <a:defRPr sz="1100" b="0" i="0" u="none" strike="noStrike">
+              <a:defRPr sz="1200" b="0" i="0" u="none" strike="noStrike">
                 <a:solidFill>
-                  <a:srgbClr val="718096"/>
+                  <a:srgbClr val="000000"/>
                 </a:solidFill>
                 <a:latin typeface="Arial"/>
               </a:defRPr>
@@ -2844,19 +2756,8 @@
         <c:scaling>
           <c:orientation val="minMax"/>
         </c:scaling>
-        <c:delete val="0"/>
+        <c:delete val="1"/>
         <c:axPos val="l"/>
-        <c:majorGridlines>
-          <c:spPr>
-            <a:ln w="6350" cap="flat">
-              <a:solidFill>
-                <a:srgbClr val="D6CFC4"/>
-              </a:solidFill>
-              <a:prstDash val="solid"/>
-              <a:round/>
-            </a:ln>
-          </c:spPr>
-        </c:majorGridlines>
         <c:numFmt formatCode="General" sourceLinked="0"/>
         <c:majorTickMark val="out"/>
         <c:minorTickMark val="none"/>
@@ -2875,9 +2776,9 @@
           <a:lstStyle/>
           <a:p>
             <a:pPr>
-              <a:defRPr sz="1100" b="0" i="0" u="none" strike="noStrike">
+              <a:defRPr sz="1200" b="0" i="0" u="none" strike="noStrike">
                 <a:solidFill>
-                  <a:srgbClr val="718096"/>
+                  <a:srgbClr val="000000"/>
                 </a:solidFill>
                 <a:latin typeface="Arial"/>
               </a:defRPr>
@@ -4938,7 +4839,7 @@
               <a:buNone/>
             </a:pPr>
             <a:r>
-              <a:rPr lang="en-US" sz="1100" dirty="0">
+              <a:rPr lang="en-US" sz="1200" dirty="0">
                 <a:solidFill>
                   <a:srgbClr val="F0E0B8"/>
                 </a:solidFill>
@@ -4948,7 +4849,7 @@
               </a:rPr>
               <a:t>Prepared: March 12, 2026</a:t>
             </a:r>
-            <a:endParaRPr lang="en-US" sz="1100" dirty="0"/>
+            <a:endParaRPr lang="en-US" sz="1200" dirty="0"/>
           </a:p>
         </p:txBody>
       </p:sp>
@@ -4977,7 +4878,7 @@
               <a:buNone/>
             </a:pPr>
             <a:r>
-              <a:rPr lang="en-US" sz="1000" dirty="0">
+              <a:rPr lang="en-US" sz="1200" dirty="0">
                 <a:solidFill>
                   <a:srgbClr val="F0E0B8"/>
                 </a:solidFill>
@@ -4987,7 +4888,7 @@
               </a:rPr>
               <a:t>Tanzania  ·  Kenya  ·  Uganda  ·  Sierra Leone  ·  Nigeria</a:t>
             </a:r>
-            <a:endParaRPr lang="en-US" sz="1000" dirty="0"/>
+            <a:endParaRPr lang="en-US" sz="1200" dirty="0"/>
           </a:p>
         </p:txBody>
       </p:sp>
@@ -5066,7 +4967,7 @@
               <a:buNone/>
             </a:pPr>
             <a:r>
-              <a:rPr lang="en-US" sz="1400" b="1" dirty="0">
+              <a:rPr lang="en-US" sz="2200" b="1" dirty="0">
                 <a:solidFill>
                   <a:srgbClr val="FFF9D9"/>
                 </a:solidFill>
@@ -5076,7 +4977,7 @@
               </a:rPr>
               <a:t>Operating Expenses – Staff Cost</a:t>
             </a:r>
-            <a:endParaRPr lang="en-US" sz="1400" dirty="0"/>
+            <a:endParaRPr lang="en-US" sz="2200" dirty="0"/>
           </a:p>
         </p:txBody>
       </p:sp>
@@ -5672,7 +5573,7 @@
               <a:buNone/>
             </a:pPr>
             <a:r>
-              <a:rPr lang="en-US" sz="1400" b="1" dirty="0">
+              <a:rPr lang="en-US" sz="2200" b="1" dirty="0">
                 <a:solidFill>
                   <a:srgbClr val="FFF9D9"/>
                 </a:solidFill>
@@ -5682,7 +5583,7 @@
               </a:rPr>
               <a:t>Operating Expenses – Fuel Cost</a:t>
             </a:r>
-            <a:endParaRPr lang="en-US" sz="1400" dirty="0"/>
+            <a:endParaRPr lang="en-US" sz="2200" dirty="0"/>
           </a:p>
         </p:txBody>
       </p:sp>
@@ -6278,7 +6179,7 @@
               <a:buNone/>
             </a:pPr>
             <a:r>
-              <a:rPr lang="en-US" sz="1400" b="1" dirty="0">
+              <a:rPr lang="en-US" sz="2200" b="1" dirty="0">
                 <a:solidFill>
                   <a:srgbClr val="FFF9D9"/>
                 </a:solidFill>
@@ -6288,7 +6189,7 @@
               </a:rPr>
               <a:t>Operating Expenses – Vehicle Maintenance</a:t>
             </a:r>
-            <a:endParaRPr lang="en-US" sz="1400" dirty="0"/>
+            <a:endParaRPr lang="en-US" sz="2200" dirty="0"/>
           </a:p>
         </p:txBody>
       </p:sp>
@@ -6884,7 +6785,7 @@
               <a:buNone/>
             </a:pPr>
             <a:r>
-              <a:rPr lang="en-US" sz="1400" b="1" dirty="0">
+              <a:rPr lang="en-US" sz="2200" b="1" dirty="0">
                 <a:solidFill>
                   <a:srgbClr val="FFF9D9"/>
                 </a:solidFill>
@@ -6894,7 +6795,7 @@
               </a:rPr>
               <a:t>Loan Applications</a:t>
             </a:r>
-            <a:endParaRPr lang="en-US" sz="1400" dirty="0"/>
+            <a:endParaRPr lang="en-US" sz="2200" dirty="0"/>
           </a:p>
         </p:txBody>
       </p:sp>
@@ -8040,7 +7941,7 @@
               <a:buNone/>
             </a:pPr>
             <a:r>
-              <a:rPr lang="en-US" sz="1400" b="1" dirty="0">
+              <a:rPr lang="en-US" sz="2200" b="1" dirty="0">
                 <a:solidFill>
                   <a:srgbClr val="FFF9D9"/>
                 </a:solidFill>
@@ -8050,7 +7951,7 @@
               </a:rPr>
               <a:t>Assessment Efficiency</a:t>
             </a:r>
-            <a:endParaRPr lang="en-US" sz="1400" dirty="0"/>
+            <a:endParaRPr lang="en-US" sz="2200" dirty="0"/>
           </a:p>
         </p:txBody>
       </p:sp>
@@ -9196,7 +9097,7 @@
               <a:buNone/>
             </a:pPr>
             <a:r>
-              <a:rPr lang="en-US" sz="1400" b="1" dirty="0">
+              <a:rPr lang="en-US" sz="2200" b="1" dirty="0">
                 <a:solidFill>
                   <a:srgbClr val="FFF9D9"/>
                 </a:solidFill>
@@ -9206,7 +9107,7 @@
               </a:rPr>
               <a:t>Disbursement Trend</a:t>
             </a:r>
-            <a:endParaRPr lang="en-US" sz="1400" dirty="0"/>
+            <a:endParaRPr lang="en-US" sz="2200" dirty="0"/>
           </a:p>
         </p:txBody>
       </p:sp>
@@ -9736,7 +9637,7 @@
         <p:spPr>
           <a:xfrm>
             <a:off x="7955280" y="685800"/>
-            <a:ext cx="4069080" cy="1005840"/>
+            <a:ext cx="4069080" cy="1051560"/>
           </a:xfrm>
           <a:prstGeom prst="rect">
             <a:avLst/>
@@ -9793,7 +9694,7 @@
         <p:spPr>
           <a:xfrm>
             <a:off x="7955280" y="777240"/>
-            <a:ext cx="4069080" cy="553212"/>
+            <a:ext cx="4069080" cy="578358"/>
           </a:xfrm>
           <a:prstGeom prst="rect">
             <a:avLst/>
@@ -9831,8 +9732,8 @@
         </p:nvSpPr>
         <p:spPr>
           <a:xfrm>
-            <a:off x="8001000" y="1289304"/>
-            <a:ext cx="3977640" cy="402336"/>
+            <a:off x="8001000" y="1316736"/>
+            <a:ext cx="3977640" cy="420624"/>
           </a:xfrm>
           <a:prstGeom prst="rect">
             <a:avLst/>
@@ -9870,8 +9771,8 @@
         </p:nvSpPr>
         <p:spPr>
           <a:xfrm>
-            <a:off x="7955280" y="1783080"/>
-            <a:ext cx="4069080" cy="1005840"/>
+            <a:off x="7955280" y="1828800"/>
+            <a:ext cx="4069080" cy="1051560"/>
           </a:xfrm>
           <a:prstGeom prst="rect">
             <a:avLst/>
@@ -9902,7 +9803,7 @@
         </p:nvSpPr>
         <p:spPr>
           <a:xfrm>
-            <a:off x="7955280" y="1783080"/>
+            <a:off x="7955280" y="1828800"/>
             <a:ext cx="4069080" cy="45720"/>
           </a:xfrm>
           <a:prstGeom prst="rect">
@@ -9927,8 +9828,8 @@
         </p:nvSpPr>
         <p:spPr>
           <a:xfrm>
-            <a:off x="7955280" y="1874520"/>
-            <a:ext cx="4069080" cy="553212"/>
+            <a:off x="7955280" y="1920240"/>
+            <a:ext cx="4069080" cy="578358"/>
           </a:xfrm>
           <a:prstGeom prst="rect">
             <a:avLst/>
@@ -9966,8 +9867,8 @@
         </p:nvSpPr>
         <p:spPr>
           <a:xfrm>
-            <a:off x="8001000" y="2386584"/>
-            <a:ext cx="3977640" cy="402336"/>
+            <a:off x="8001000" y="2459736"/>
+            <a:ext cx="3977640" cy="420624"/>
           </a:xfrm>
           <a:prstGeom prst="rect">
             <a:avLst/>
@@ -10005,7 +9906,7 @@
         </p:nvSpPr>
         <p:spPr>
           <a:xfrm>
-            <a:off x="7955280" y="2926080"/>
+            <a:off x="7955280" y="2971800"/>
             <a:ext cx="4069080" cy="292608"/>
           </a:xfrm>
           <a:prstGeom prst="rect">
@@ -10030,7 +9931,7 @@
         </p:nvSpPr>
         <p:spPr>
           <a:xfrm>
-            <a:off x="7955280" y="2926080"/>
+            <a:off x="7955280" y="2971800"/>
             <a:ext cx="54864" cy="292608"/>
           </a:xfrm>
           <a:prstGeom prst="rect">
@@ -10055,7 +9956,7 @@
         </p:nvSpPr>
         <p:spPr>
           <a:xfrm>
-            <a:off x="8065008" y="2926080"/>
+            <a:off x="8065008" y="2971800"/>
             <a:ext cx="3959352" cy="292608"/>
           </a:xfrm>
           <a:prstGeom prst="rect">
@@ -10094,8 +9995,8 @@
         </p:nvSpPr>
         <p:spPr>
           <a:xfrm>
-            <a:off x="7955280" y="3246120"/>
-            <a:ext cx="1234440" cy="530352"/>
+            <a:off x="7955280" y="3310128"/>
+            <a:ext cx="1234440" cy="566928"/>
           </a:xfrm>
           <a:prstGeom prst="rect">
             <a:avLst/>
@@ -10119,7 +10020,7 @@
         </p:nvSpPr>
         <p:spPr>
           <a:xfrm>
-            <a:off x="7955280" y="3246120"/>
+            <a:off x="7955280" y="3310128"/>
             <a:ext cx="1234440" cy="256032"/>
           </a:xfrm>
           <a:prstGeom prst="rect">
@@ -10136,7 +10037,7 @@
               <a:buNone/>
             </a:pPr>
             <a:r>
-              <a:rPr lang="en-US" sz="750" dirty="0">
+              <a:rPr lang="en-US" sz="1200" dirty="0">
                 <a:solidFill>
                   <a:srgbClr val="718096"/>
                 </a:solidFill>
@@ -10146,7 +10047,7 @@
               </a:rPr>
               <a:t>Tanzania</a:t>
             </a:r>
-            <a:endParaRPr lang="en-US" sz="750" dirty="0"/>
+            <a:endParaRPr lang="en-US" sz="1200" dirty="0"/>
           </a:p>
         </p:txBody>
       </p:sp>
@@ -10158,8 +10059,8 @@
         </p:nvSpPr>
         <p:spPr>
           <a:xfrm>
-            <a:off x="7955280" y="3502152"/>
-            <a:ext cx="1234440" cy="274320"/>
+            <a:off x="7955280" y="3566160"/>
+            <a:ext cx="1234440" cy="310896"/>
           </a:xfrm>
           <a:prstGeom prst="rect">
             <a:avLst/>
@@ -10197,8 +10098,8 @@
         </p:nvSpPr>
         <p:spPr>
           <a:xfrm>
-            <a:off x="9308592" y="3246120"/>
-            <a:ext cx="1234440" cy="530352"/>
+            <a:off x="9308592" y="3310128"/>
+            <a:ext cx="1234440" cy="566928"/>
           </a:xfrm>
           <a:prstGeom prst="rect">
             <a:avLst/>
@@ -10222,7 +10123,7 @@
         </p:nvSpPr>
         <p:spPr>
           <a:xfrm>
-            <a:off x="9308592" y="3246120"/>
+            <a:off x="9308592" y="3310128"/>
             <a:ext cx="1234440" cy="256032"/>
           </a:xfrm>
           <a:prstGeom prst="rect">
@@ -10239,7 +10140,7 @@
               <a:buNone/>
             </a:pPr>
             <a:r>
-              <a:rPr lang="en-US" sz="750" dirty="0">
+              <a:rPr lang="en-US" sz="1200" dirty="0">
                 <a:solidFill>
                   <a:srgbClr val="718096"/>
                 </a:solidFill>
@@ -10249,7 +10150,7 @@
               </a:rPr>
               <a:t>Kenya</a:t>
             </a:r>
-            <a:endParaRPr lang="en-US" sz="750" dirty="0"/>
+            <a:endParaRPr lang="en-US" sz="1200" dirty="0"/>
           </a:p>
         </p:txBody>
       </p:sp>
@@ -10261,8 +10162,8 @@
         </p:nvSpPr>
         <p:spPr>
           <a:xfrm>
-            <a:off x="9308592" y="3502152"/>
-            <a:ext cx="1234440" cy="274320"/>
+            <a:off x="9308592" y="3566160"/>
+            <a:ext cx="1234440" cy="310896"/>
           </a:xfrm>
           <a:prstGeom prst="rect">
             <a:avLst/>
@@ -10300,8 +10201,8 @@
         </p:nvSpPr>
         <p:spPr>
           <a:xfrm>
-            <a:off x="10661904" y="3246120"/>
-            <a:ext cx="1234440" cy="530352"/>
+            <a:off x="10661904" y="3310128"/>
+            <a:ext cx="1234440" cy="566928"/>
           </a:xfrm>
           <a:prstGeom prst="rect">
             <a:avLst/>
@@ -10325,7 +10226,7 @@
         </p:nvSpPr>
         <p:spPr>
           <a:xfrm>
-            <a:off x="10661904" y="3246120"/>
+            <a:off x="10661904" y="3310128"/>
             <a:ext cx="1234440" cy="256032"/>
           </a:xfrm>
           <a:prstGeom prst="rect">
@@ -10342,7 +10243,7 @@
               <a:buNone/>
             </a:pPr>
             <a:r>
-              <a:rPr lang="en-US" sz="750" dirty="0">
+              <a:rPr lang="en-US" sz="1200" dirty="0">
                 <a:solidFill>
                   <a:srgbClr val="718096"/>
                 </a:solidFill>
@@ -10352,7 +10253,7 @@
               </a:rPr>
               <a:t>Uganda</a:t>
             </a:r>
-            <a:endParaRPr lang="en-US" sz="750" dirty="0"/>
+            <a:endParaRPr lang="en-US" sz="1200" dirty="0"/>
           </a:p>
         </p:txBody>
       </p:sp>
@@ -10364,8 +10265,8 @@
         </p:nvSpPr>
         <p:spPr>
           <a:xfrm>
-            <a:off x="10661904" y="3502152"/>
-            <a:ext cx="1234440" cy="274320"/>
+            <a:off x="10661904" y="3566160"/>
+            <a:ext cx="1234440" cy="310896"/>
           </a:xfrm>
           <a:prstGeom prst="rect">
             <a:avLst/>
@@ -10403,8 +10304,8 @@
         </p:nvSpPr>
         <p:spPr>
           <a:xfrm>
-            <a:off x="7955280" y="3867912"/>
-            <a:ext cx="1234440" cy="530352"/>
+            <a:off x="7955280" y="3968496"/>
+            <a:ext cx="1234440" cy="566928"/>
           </a:xfrm>
           <a:prstGeom prst="rect">
             <a:avLst/>
@@ -10428,7 +10329,7 @@
         </p:nvSpPr>
         <p:spPr>
           <a:xfrm>
-            <a:off x="7955280" y="3867912"/>
+            <a:off x="7955280" y="3968496"/>
             <a:ext cx="1234440" cy="256032"/>
           </a:xfrm>
           <a:prstGeom prst="rect">
@@ -10445,7 +10346,7 @@
               <a:buNone/>
             </a:pPr>
             <a:r>
-              <a:rPr lang="en-US" sz="750" dirty="0">
+              <a:rPr lang="en-US" sz="1200" dirty="0">
                 <a:solidFill>
                   <a:srgbClr val="718096"/>
                 </a:solidFill>
@@ -10455,7 +10356,7 @@
               </a:rPr>
               <a:t>Sierra Leone</a:t>
             </a:r>
-            <a:endParaRPr lang="en-US" sz="750" dirty="0"/>
+            <a:endParaRPr lang="en-US" sz="1200" dirty="0"/>
           </a:p>
         </p:txBody>
       </p:sp>
@@ -10467,8 +10368,8 @@
         </p:nvSpPr>
         <p:spPr>
           <a:xfrm>
-            <a:off x="7955280" y="4123944"/>
-            <a:ext cx="1234440" cy="274320"/>
+            <a:off x="7955280" y="4224528"/>
+            <a:ext cx="1234440" cy="310896"/>
           </a:xfrm>
           <a:prstGeom prst="rect">
             <a:avLst/>
@@ -10506,8 +10407,8 @@
         </p:nvSpPr>
         <p:spPr>
           <a:xfrm>
-            <a:off x="9308592" y="3867912"/>
-            <a:ext cx="1234440" cy="530352"/>
+            <a:off x="9308592" y="3968496"/>
+            <a:ext cx="1234440" cy="566928"/>
           </a:xfrm>
           <a:prstGeom prst="rect">
             <a:avLst/>
@@ -10531,7 +10432,7 @@
         </p:nvSpPr>
         <p:spPr>
           <a:xfrm>
-            <a:off x="9308592" y="3867912"/>
+            <a:off x="9308592" y="3968496"/>
             <a:ext cx="1234440" cy="256032"/>
           </a:xfrm>
           <a:prstGeom prst="rect">
@@ -10548,7 +10449,7 @@
               <a:buNone/>
             </a:pPr>
             <a:r>
-              <a:rPr lang="en-US" sz="750" dirty="0">
+              <a:rPr lang="en-US" sz="1200" dirty="0">
                 <a:solidFill>
                   <a:srgbClr val="718096"/>
                 </a:solidFill>
@@ -10558,7 +10459,7 @@
               </a:rPr>
               <a:t>Nigeria</a:t>
             </a:r>
-            <a:endParaRPr lang="en-US" sz="750" dirty="0"/>
+            <a:endParaRPr lang="en-US" sz="1200" dirty="0"/>
           </a:p>
         </p:txBody>
       </p:sp>
@@ -10570,8 +10471,8 @@
         </p:nvSpPr>
         <p:spPr>
           <a:xfrm>
-            <a:off x="9308592" y="4123944"/>
-            <a:ext cx="1234440" cy="274320"/>
+            <a:off x="9308592" y="4224528"/>
+            <a:ext cx="1234440" cy="310896"/>
           </a:xfrm>
           <a:prstGeom prst="rect">
             <a:avLst/>
@@ -10609,8 +10510,8 @@
         </p:nvSpPr>
         <p:spPr>
           <a:xfrm>
-            <a:off x="7955280" y="4005072"/>
-            <a:ext cx="4069080" cy="2551176"/>
+            <a:off x="7955280" y="4663440"/>
+            <a:ext cx="4069080" cy="1892808"/>
           </a:xfrm>
           <a:prstGeom prst="rect">
             <a:avLst/>
@@ -10634,8 +10535,8 @@
         </p:nvSpPr>
         <p:spPr>
           <a:xfrm>
-            <a:off x="7955280" y="4005072"/>
-            <a:ext cx="54864" cy="2551176"/>
+            <a:off x="7955280" y="4663440"/>
+            <a:ext cx="54864" cy="1892808"/>
           </a:xfrm>
           <a:prstGeom prst="rect">
             <a:avLst/>
@@ -10659,7 +10560,7 @@
         </p:nvSpPr>
         <p:spPr>
           <a:xfrm>
-            <a:off x="8065008" y="4059936"/>
+            <a:off x="8065008" y="4718304"/>
             <a:ext cx="3886200" cy="228600"/>
           </a:xfrm>
           <a:prstGeom prst="rect">
@@ -10698,8 +10599,8 @@
         </p:nvSpPr>
         <p:spPr>
           <a:xfrm>
-            <a:off x="8065008" y="4325112"/>
-            <a:ext cx="3886200" cy="2139696"/>
+            <a:off x="8065008" y="4983480"/>
+            <a:ext cx="3886200" cy="1481328"/>
           </a:xfrm>
           <a:prstGeom prst="rect">
             <a:avLst/>
@@ -10821,7 +10722,7 @@
               <a:buNone/>
             </a:pPr>
             <a:r>
-              <a:rPr lang="en-US" sz="1400" b="1" dirty="0">
+              <a:rPr lang="en-US" sz="2200" b="1" dirty="0">
                 <a:solidFill>
                   <a:srgbClr val="FFF9D9"/>
                 </a:solidFill>
@@ -10831,7 +10732,7 @@
               </a:rPr>
               <a:t>Disbursement Stats</a:t>
             </a:r>
-            <a:endParaRPr lang="en-US" sz="1400" dirty="0"/>
+            <a:endParaRPr lang="en-US" sz="2200" dirty="0"/>
           </a:p>
         </p:txBody>
       </p:sp>
@@ -11816,7 +11717,7 @@
               <a:buNone/>
             </a:pPr>
             <a:r>
-              <a:rPr lang="en-US" sz="1400" b="1" dirty="0">
+              <a:rPr lang="en-US" sz="2200" b="1" dirty="0">
                 <a:solidFill>
                   <a:srgbClr val="FFF9D9"/>
                 </a:solidFill>
@@ -11826,7 +11727,7 @@
               </a:rPr>
               <a:t>Loan Book Size</a:t>
             </a:r>
-            <a:endParaRPr lang="en-US" sz="1400" dirty="0"/>
+            <a:endParaRPr lang="en-US" sz="2200" dirty="0"/>
           </a:p>
         </p:txBody>
       </p:sp>
@@ -12837,7 +12738,7 @@
               <a:buNone/>
             </a:pPr>
             <a:r>
-              <a:rPr lang="en-US" sz="1400" b="1" dirty="0">
+              <a:rPr lang="en-US" sz="2200" b="1" dirty="0">
                 <a:solidFill>
                   <a:srgbClr val="FFF9D9"/>
                 </a:solidFill>
@@ -12847,7 +12748,7 @@
               </a:rPr>
               <a:t>Default Rates</a:t>
             </a:r>
-            <a:endParaRPr lang="en-US" sz="1400" dirty="0"/>
+            <a:endParaRPr lang="en-US" sz="2200" dirty="0"/>
           </a:p>
         </p:txBody>
       </p:sp>
@@ -13106,7 +13007,7 @@
                         <a:buNone/>
                       </a:pPr>
                       <a:r>
-                        <a:rPr lang="en-US" sz="900" b="1" dirty="0">
+                        <a:rPr lang="en-US" sz="1200" b="1" dirty="0">
                           <a:solidFill>
                             <a:srgbClr val="FFF9D9"/>
                           </a:solidFill>
@@ -13116,7 +13017,7 @@
                         </a:rPr>
                         <a:t>Country</a:t>
                       </a:r>
-                      <a:endParaRPr lang="en-US" sz="900" dirty="0">
+                      <a:endParaRPr lang="en-US" sz="1200" dirty="0">
                         <a:latin typeface="Century Gothic" charset="0"/>
                         <a:ea typeface="Century Gothic" charset="0"/>
                         <a:cs typeface="Century Gothic" charset="0"/>
@@ -13174,7 +13075,7 @@
                         <a:buNone/>
                       </a:pPr>
                       <a:r>
-                        <a:rPr lang="en-US" sz="900" b="1" dirty="0">
+                        <a:rPr lang="en-US" sz="1200" b="1" dirty="0">
                           <a:solidFill>
                             <a:srgbClr val="FFF9D9"/>
                           </a:solidFill>
@@ -13184,7 +13085,7 @@
                         </a:rPr>
                         <a:t>Chronic Rate – Prior Month</a:t>
                       </a:r>
-                      <a:endParaRPr lang="en-US" sz="900" dirty="0">
+                      <a:endParaRPr lang="en-US" sz="1200" dirty="0">
                         <a:latin typeface="Century Gothic" charset="0"/>
                         <a:ea typeface="Century Gothic" charset="0"/>
                         <a:cs typeface="Century Gothic" charset="0"/>
@@ -13242,7 +13143,7 @@
                         <a:buNone/>
                       </a:pPr>
                       <a:r>
-                        <a:rPr lang="en-US" sz="900" b="1" dirty="0">
+                        <a:rPr lang="en-US" sz="1200" b="1" dirty="0">
                           <a:solidFill>
                             <a:srgbClr val="FFF9D9"/>
                           </a:solidFill>
@@ -13252,7 +13153,7 @@
                         </a:rPr>
                         <a:t>Chronic Rate – Month Under Review</a:t>
                       </a:r>
-                      <a:endParaRPr lang="en-US" sz="900" dirty="0">
+                      <a:endParaRPr lang="en-US" sz="1200" dirty="0">
                         <a:latin typeface="Century Gothic" charset="0"/>
                         <a:ea typeface="Century Gothic" charset="0"/>
                         <a:cs typeface="Century Gothic" charset="0"/>
@@ -13310,7 +13211,7 @@
                         <a:buNone/>
                       </a:pPr>
                       <a:r>
-                        <a:rPr lang="en-US" sz="900" b="1" dirty="0">
+                        <a:rPr lang="en-US" sz="1200" b="1" dirty="0">
                           <a:solidFill>
                             <a:srgbClr val="FFF9D9"/>
                           </a:solidFill>
@@ -13320,7 +13221,7 @@
                         </a:rPr>
                         <a:t>Change (bps)</a:t>
                       </a:r>
-                      <a:endParaRPr lang="en-US" sz="900" dirty="0">
+                      <a:endParaRPr lang="en-US" sz="1200" dirty="0">
                         <a:latin typeface="Century Gothic" charset="0"/>
                         <a:ea typeface="Century Gothic" charset="0"/>
                         <a:cs typeface="Century Gothic" charset="0"/>
@@ -13380,7 +13281,7 @@
                         <a:buNone/>
                       </a:pPr>
                       <a:r>
-                        <a:rPr lang="en-US" sz="950" b="1" dirty="0">
+                        <a:rPr lang="en-US" sz="1200" b="1" dirty="0">
                           <a:solidFill>
                             <a:srgbClr val="2D2A26"/>
                           </a:solidFill>
@@ -13390,7 +13291,7 @@
                         </a:rPr>
                         <a:t>Tanzania</a:t>
                       </a:r>
-                      <a:endParaRPr lang="en-US" sz="950" dirty="0">
+                      <a:endParaRPr lang="en-US" sz="1200" dirty="0">
                         <a:latin typeface="Century Gothic" charset="0"/>
                         <a:ea typeface="Century Gothic" charset="0"/>
                         <a:cs typeface="Century Gothic" charset="0"/>
@@ -13448,7 +13349,7 @@
                         <a:buNone/>
                       </a:pPr>
                       <a:r>
-                        <a:rPr lang="en-US" sz="950" dirty="0">
+                        <a:rPr lang="en-US" sz="1200" dirty="0">
                           <a:solidFill>
                             <a:srgbClr val="2D2A26"/>
                           </a:solidFill>
@@ -13458,7 +13359,7 @@
                         </a:rPr>
                         <a:t>0.0%</a:t>
                       </a:r>
-                      <a:endParaRPr lang="en-US" sz="950" dirty="0">
+                      <a:endParaRPr lang="en-US" sz="1200" dirty="0">
                         <a:latin typeface="Calibri" charset="0"/>
                         <a:ea typeface="Calibri" charset="0"/>
                         <a:cs typeface="Calibri" charset="0"/>
@@ -13516,7 +13417,7 @@
                         <a:buNone/>
                       </a:pPr>
                       <a:r>
-                        <a:rPr lang="en-US" sz="950" dirty="0">
+                        <a:rPr lang="en-US" sz="1200" dirty="0">
                           <a:solidFill>
                             <a:srgbClr val="2D2A26"/>
                           </a:solidFill>
@@ -13526,7 +13427,7 @@
                         </a:rPr>
                         <a:t>4.5%</a:t>
                       </a:r>
-                      <a:endParaRPr lang="en-US" sz="950" dirty="0">
+                      <a:endParaRPr lang="en-US" sz="1200" dirty="0">
                         <a:latin typeface="Calibri" charset="0"/>
                         <a:ea typeface="Calibri" charset="0"/>
                         <a:cs typeface="Calibri" charset="0"/>
@@ -13584,7 +13485,7 @@
                         <a:buNone/>
                       </a:pPr>
                       <a:r>
-                        <a:rPr lang="en-US" sz="950" dirty="0">
+                        <a:rPr lang="en-US" sz="1200" dirty="0">
                           <a:solidFill>
                             <a:srgbClr val="C0392B"/>
                           </a:solidFill>
@@ -13594,7 +13495,7 @@
                         </a:rPr>
                         <a:t>+452 bps</a:t>
                       </a:r>
-                      <a:endParaRPr lang="en-US" sz="950" dirty="0">
+                      <a:endParaRPr lang="en-US" sz="1200" dirty="0">
                         <a:latin typeface="Calibri" charset="0"/>
                         <a:ea typeface="Calibri" charset="0"/>
                         <a:cs typeface="Calibri" charset="0"/>
@@ -13654,7 +13555,7 @@
                         <a:buNone/>
                       </a:pPr>
                       <a:r>
-                        <a:rPr lang="en-US" sz="950" b="1" dirty="0">
+                        <a:rPr lang="en-US" sz="1200" b="1" dirty="0">
                           <a:solidFill>
                             <a:srgbClr val="2D2A26"/>
                           </a:solidFill>
@@ -13664,7 +13565,7 @@
                         </a:rPr>
                         <a:t>Kenya</a:t>
                       </a:r>
-                      <a:endParaRPr lang="en-US" sz="950" dirty="0">
+                      <a:endParaRPr lang="en-US" sz="1200" dirty="0">
                         <a:latin typeface="Century Gothic" charset="0"/>
                         <a:ea typeface="Century Gothic" charset="0"/>
                         <a:cs typeface="Century Gothic" charset="0"/>
@@ -13722,7 +13623,7 @@
                         <a:buNone/>
                       </a:pPr>
                       <a:r>
-                        <a:rPr lang="en-US" sz="950" dirty="0">
+                        <a:rPr lang="en-US" sz="1200" dirty="0">
                           <a:solidFill>
                             <a:srgbClr val="2D2A26"/>
                           </a:solidFill>
@@ -13732,7 +13633,7 @@
                         </a:rPr>
                         <a:t>0.0%</a:t>
                       </a:r>
-                      <a:endParaRPr lang="en-US" sz="950" dirty="0">
+                      <a:endParaRPr lang="en-US" sz="1200" dirty="0">
                         <a:latin typeface="Calibri" charset="0"/>
                         <a:ea typeface="Calibri" charset="0"/>
                         <a:cs typeface="Calibri" charset="0"/>
@@ -13790,7 +13691,7 @@
                         <a:buNone/>
                       </a:pPr>
                       <a:r>
-                        <a:rPr lang="en-US" sz="950" dirty="0">
+                        <a:rPr lang="en-US" sz="1200" dirty="0">
                           <a:solidFill>
                             <a:srgbClr val="2D2A26"/>
                           </a:solidFill>
@@ -13800,7 +13701,7 @@
                         </a:rPr>
                         <a:t>5.1%</a:t>
                       </a:r>
-                      <a:endParaRPr lang="en-US" sz="950" dirty="0">
+                      <a:endParaRPr lang="en-US" sz="1200" dirty="0">
                         <a:latin typeface="Calibri" charset="0"/>
                         <a:ea typeface="Calibri" charset="0"/>
                         <a:cs typeface="Calibri" charset="0"/>
@@ -13858,7 +13759,7 @@
                         <a:buNone/>
                       </a:pPr>
                       <a:r>
-                        <a:rPr lang="en-US" sz="950" dirty="0">
+                        <a:rPr lang="en-US" sz="1200" dirty="0">
                           <a:solidFill>
                             <a:srgbClr val="C0392B"/>
                           </a:solidFill>
@@ -13868,7 +13769,7 @@
                         </a:rPr>
                         <a:t>+514 bps</a:t>
                       </a:r>
-                      <a:endParaRPr lang="en-US" sz="950" dirty="0">
+                      <a:endParaRPr lang="en-US" sz="1200" dirty="0">
                         <a:latin typeface="Calibri" charset="0"/>
                         <a:ea typeface="Calibri" charset="0"/>
                         <a:cs typeface="Calibri" charset="0"/>
@@ -13928,7 +13829,7 @@
                         <a:buNone/>
                       </a:pPr>
                       <a:r>
-                        <a:rPr lang="en-US" sz="950" b="1" dirty="0">
+                        <a:rPr lang="en-US" sz="1200" b="1" dirty="0">
                           <a:solidFill>
                             <a:srgbClr val="2D2A26"/>
                           </a:solidFill>
@@ -13938,7 +13839,7 @@
                         </a:rPr>
                         <a:t>Uganda</a:t>
                       </a:r>
-                      <a:endParaRPr lang="en-US" sz="950" dirty="0">
+                      <a:endParaRPr lang="en-US" sz="1200" dirty="0">
                         <a:latin typeface="Century Gothic" charset="0"/>
                         <a:ea typeface="Century Gothic" charset="0"/>
                         <a:cs typeface="Century Gothic" charset="0"/>
@@ -13996,7 +13897,7 @@
                         <a:buNone/>
                       </a:pPr>
                       <a:r>
-                        <a:rPr lang="en-US" sz="950" dirty="0">
+                        <a:rPr lang="en-US" sz="1200" dirty="0">
                           <a:solidFill>
                             <a:srgbClr val="2D2A26"/>
                           </a:solidFill>
@@ -14006,7 +13907,7 @@
                         </a:rPr>
                         <a:t>0.0%</a:t>
                       </a:r>
-                      <a:endParaRPr lang="en-US" sz="950" dirty="0">
+                      <a:endParaRPr lang="en-US" sz="1200" dirty="0">
                         <a:latin typeface="Calibri" charset="0"/>
                         <a:ea typeface="Calibri" charset="0"/>
                         <a:cs typeface="Calibri" charset="0"/>
@@ -14064,7 +13965,7 @@
                         <a:buNone/>
                       </a:pPr>
                       <a:r>
-                        <a:rPr lang="en-US" sz="950" dirty="0">
+                        <a:rPr lang="en-US" sz="1200" dirty="0">
                           <a:solidFill>
                             <a:srgbClr val="2D2A26"/>
                           </a:solidFill>
@@ -14074,7 +13975,7 @@
                         </a:rPr>
                         <a:t>11.1%</a:t>
                       </a:r>
-                      <a:endParaRPr lang="en-US" sz="950" dirty="0">
+                      <a:endParaRPr lang="en-US" sz="1200" dirty="0">
                         <a:latin typeface="Calibri" charset="0"/>
                         <a:ea typeface="Calibri" charset="0"/>
                         <a:cs typeface="Calibri" charset="0"/>
@@ -14132,7 +14033,7 @@
                         <a:buNone/>
                       </a:pPr>
                       <a:r>
-                        <a:rPr lang="en-US" sz="950" dirty="0">
+                        <a:rPr lang="en-US" sz="1200" dirty="0">
                           <a:solidFill>
                             <a:srgbClr val="C0392B"/>
                           </a:solidFill>
@@ -14142,7 +14043,7 @@
                         </a:rPr>
                         <a:t>+1107 bps</a:t>
                       </a:r>
-                      <a:endParaRPr lang="en-US" sz="950" dirty="0">
+                      <a:endParaRPr lang="en-US" sz="1200" dirty="0">
                         <a:latin typeface="Calibri" charset="0"/>
                         <a:ea typeface="Calibri" charset="0"/>
                         <a:cs typeface="Calibri" charset="0"/>
@@ -14202,7 +14103,7 @@
                         <a:buNone/>
                       </a:pPr>
                       <a:r>
-                        <a:rPr lang="en-US" sz="950" b="1" dirty="0">
+                        <a:rPr lang="en-US" sz="1200" b="1" dirty="0">
                           <a:solidFill>
                             <a:srgbClr val="2D2A26"/>
                           </a:solidFill>
@@ -14212,7 +14113,7 @@
                         </a:rPr>
                         <a:t>Sierra Leone</a:t>
                       </a:r>
-                      <a:endParaRPr lang="en-US" sz="950" dirty="0">
+                      <a:endParaRPr lang="en-US" sz="1200" dirty="0">
                         <a:latin typeface="Century Gothic" charset="0"/>
                         <a:ea typeface="Century Gothic" charset="0"/>
                         <a:cs typeface="Century Gothic" charset="0"/>
@@ -14270,7 +14171,7 @@
                         <a:buNone/>
                       </a:pPr>
                       <a:r>
-                        <a:rPr lang="en-US" sz="950" dirty="0">
+                        <a:rPr lang="en-US" sz="1200" dirty="0">
                           <a:solidFill>
                             <a:srgbClr val="2D2A26"/>
                           </a:solidFill>
@@ -14280,7 +14181,7 @@
                         </a:rPr>
                         <a:t>0.0%</a:t>
                       </a:r>
-                      <a:endParaRPr lang="en-US" sz="950" dirty="0">
+                      <a:endParaRPr lang="en-US" sz="1200" dirty="0">
                         <a:latin typeface="Calibri" charset="0"/>
                         <a:ea typeface="Calibri" charset="0"/>
                         <a:cs typeface="Calibri" charset="0"/>
@@ -14338,7 +14239,7 @@
                         <a:buNone/>
                       </a:pPr>
                       <a:r>
-                        <a:rPr lang="en-US" sz="950" dirty="0">
+                        <a:rPr lang="en-US" sz="1200" dirty="0">
                           <a:solidFill>
                             <a:srgbClr val="2D2A26"/>
                           </a:solidFill>
@@ -14348,7 +14249,7 @@
                         </a:rPr>
                         <a:t>2.7%</a:t>
                       </a:r>
-                      <a:endParaRPr lang="en-US" sz="950" dirty="0">
+                      <a:endParaRPr lang="en-US" sz="1200" dirty="0">
                         <a:latin typeface="Calibri" charset="0"/>
                         <a:ea typeface="Calibri" charset="0"/>
                         <a:cs typeface="Calibri" charset="0"/>
@@ -14406,7 +14307,7 @@
                         <a:buNone/>
                       </a:pPr>
                       <a:r>
-                        <a:rPr lang="en-US" sz="950" dirty="0">
+                        <a:rPr lang="en-US" sz="1200" dirty="0">
                           <a:solidFill>
                             <a:srgbClr val="C0392B"/>
                           </a:solidFill>
@@ -14416,7 +14317,7 @@
                         </a:rPr>
                         <a:t>+268 bps</a:t>
                       </a:r>
-                      <a:endParaRPr lang="en-US" sz="950" dirty="0">
+                      <a:endParaRPr lang="en-US" sz="1200" dirty="0">
                         <a:latin typeface="Calibri" charset="0"/>
                         <a:ea typeface="Calibri" charset="0"/>
                         <a:cs typeface="Calibri" charset="0"/>
@@ -14476,7 +14377,7 @@
                         <a:buNone/>
                       </a:pPr>
                       <a:r>
-                        <a:rPr lang="en-US" sz="950" b="1" dirty="0">
+                        <a:rPr lang="en-US" sz="1200" b="1" dirty="0">
                           <a:solidFill>
                             <a:srgbClr val="2D2A26"/>
                           </a:solidFill>
@@ -14486,7 +14387,7 @@
                         </a:rPr>
                         <a:t>Nigeria</a:t>
                       </a:r>
-                      <a:endParaRPr lang="en-US" sz="950" dirty="0">
+                      <a:endParaRPr lang="en-US" sz="1200" dirty="0">
                         <a:latin typeface="Century Gothic" charset="0"/>
                         <a:ea typeface="Century Gothic" charset="0"/>
                         <a:cs typeface="Century Gothic" charset="0"/>
@@ -14544,7 +14445,7 @@
                         <a:buNone/>
                       </a:pPr>
                       <a:r>
-                        <a:rPr lang="en-US" sz="950" dirty="0">
+                        <a:rPr lang="en-US" sz="1200" dirty="0">
                           <a:solidFill>
                             <a:srgbClr val="2D2A26"/>
                           </a:solidFill>
@@ -14554,7 +14455,7 @@
                         </a:rPr>
                         <a:t>0.0%</a:t>
                       </a:r>
-                      <a:endParaRPr lang="en-US" sz="950" dirty="0">
+                      <a:endParaRPr lang="en-US" sz="1200" dirty="0">
                         <a:latin typeface="Calibri" charset="0"/>
                         <a:ea typeface="Calibri" charset="0"/>
                         <a:cs typeface="Calibri" charset="0"/>
@@ -14612,7 +14513,7 @@
                         <a:buNone/>
                       </a:pPr>
                       <a:r>
-                        <a:rPr lang="en-US" sz="950" dirty="0">
+                        <a:rPr lang="en-US" sz="1200" dirty="0">
                           <a:solidFill>
                             <a:srgbClr val="2D2A26"/>
                           </a:solidFill>
@@ -14622,7 +14523,7 @@
                         </a:rPr>
                         <a:t>15.7%</a:t>
                       </a:r>
-                      <a:endParaRPr lang="en-US" sz="950" dirty="0">
+                      <a:endParaRPr lang="en-US" sz="1200" dirty="0">
                         <a:latin typeface="Calibri" charset="0"/>
                         <a:ea typeface="Calibri" charset="0"/>
                         <a:cs typeface="Calibri" charset="0"/>
@@ -14680,7 +14581,7 @@
                         <a:buNone/>
                       </a:pPr>
                       <a:r>
-                        <a:rPr lang="en-US" sz="950" dirty="0">
+                        <a:rPr lang="en-US" sz="1200" dirty="0">
                           <a:solidFill>
                             <a:srgbClr val="C0392B"/>
                           </a:solidFill>
@@ -14690,7 +14591,7 @@
                         </a:rPr>
                         <a:t>+1572 bps</a:t>
                       </a:r>
-                      <a:endParaRPr lang="en-US" sz="950" dirty="0">
+                      <a:endParaRPr lang="en-US" sz="1200" dirty="0">
                         <a:latin typeface="Calibri" charset="0"/>
                         <a:ea typeface="Calibri" charset="0"/>
                         <a:cs typeface="Calibri" charset="0"/>
@@ -14819,7 +14720,7 @@
               <a:buNone/>
             </a:pPr>
             <a:r>
-              <a:rPr lang="en-US" sz="1400" b="1" dirty="0">
+              <a:rPr lang="en-US" sz="2200" b="1" dirty="0">
                 <a:solidFill>
                   <a:srgbClr val="FFF9D9"/>
                 </a:solidFill>
@@ -14829,7 +14730,7 @@
               </a:rPr>
               <a:t>Default Rates</a:t>
             </a:r>
-            <a:endParaRPr lang="en-US" sz="1400" dirty="0"/>
+            <a:endParaRPr lang="en-US" sz="2200" dirty="0"/>
           </a:p>
         </p:txBody>
       </p:sp>
@@ -15088,7 +14989,7 @@
                         <a:buNone/>
                       </a:pPr>
                       <a:r>
-                        <a:rPr lang="en-US" sz="900" b="1" dirty="0">
+                        <a:rPr lang="en-US" sz="1200" b="1" dirty="0">
                           <a:solidFill>
                             <a:srgbClr val="FFF9D9"/>
                           </a:solidFill>
@@ -15098,7 +14999,7 @@
                         </a:rPr>
                         <a:t>Country</a:t>
                       </a:r>
-                      <a:endParaRPr lang="en-US" sz="900" dirty="0">
+                      <a:endParaRPr lang="en-US" sz="1200" dirty="0">
                         <a:latin typeface="Century Gothic" charset="0"/>
                         <a:ea typeface="Century Gothic" charset="0"/>
                         <a:cs typeface="Century Gothic" charset="0"/>
@@ -15156,7 +15057,7 @@
                         <a:buNone/>
                       </a:pPr>
                       <a:r>
-                        <a:rPr lang="en-US" sz="900" b="1" dirty="0">
+                        <a:rPr lang="en-US" sz="1200" b="1" dirty="0">
                           <a:solidFill>
                             <a:srgbClr val="FFF9D9"/>
                           </a:solidFill>
@@ -15166,7 +15067,7 @@
                         </a:rPr>
                         <a:t>PAR 30 – Prior Month</a:t>
                       </a:r>
-                      <a:endParaRPr lang="en-US" sz="900" dirty="0">
+                      <a:endParaRPr lang="en-US" sz="1200" dirty="0">
                         <a:latin typeface="Century Gothic" charset="0"/>
                         <a:ea typeface="Century Gothic" charset="0"/>
                         <a:cs typeface="Century Gothic" charset="0"/>
@@ -15224,7 +15125,7 @@
                         <a:buNone/>
                       </a:pPr>
                       <a:r>
-                        <a:rPr lang="en-US" sz="900" b="1" dirty="0">
+                        <a:rPr lang="en-US" sz="1200" b="1" dirty="0">
                           <a:solidFill>
                             <a:srgbClr val="FFF9D9"/>
                           </a:solidFill>
@@ -15234,7 +15135,7 @@
                         </a:rPr>
                         <a:t>PAR 30 – Month Under Review</a:t>
                       </a:r>
-                      <a:endParaRPr lang="en-US" sz="900" dirty="0">
+                      <a:endParaRPr lang="en-US" sz="1200" dirty="0">
                         <a:latin typeface="Century Gothic" charset="0"/>
                         <a:ea typeface="Century Gothic" charset="0"/>
                         <a:cs typeface="Century Gothic" charset="0"/>
@@ -15292,7 +15193,7 @@
                         <a:buNone/>
                       </a:pPr>
                       <a:r>
-                        <a:rPr lang="en-US" sz="900" b="1" dirty="0">
+                        <a:rPr lang="en-US" sz="1200" b="1" dirty="0">
                           <a:solidFill>
                             <a:srgbClr val="FFF9D9"/>
                           </a:solidFill>
@@ -15302,7 +15203,7 @@
                         </a:rPr>
                         <a:t>Change (bps)</a:t>
                       </a:r>
-                      <a:endParaRPr lang="en-US" sz="900" dirty="0">
+                      <a:endParaRPr lang="en-US" sz="1200" dirty="0">
                         <a:latin typeface="Century Gothic" charset="0"/>
                         <a:ea typeface="Century Gothic" charset="0"/>
                         <a:cs typeface="Century Gothic" charset="0"/>
@@ -15362,7 +15263,7 @@
                         <a:buNone/>
                       </a:pPr>
                       <a:r>
-                        <a:rPr lang="en-US" sz="950" b="1" dirty="0">
+                        <a:rPr lang="en-US" sz="1200" b="1" dirty="0">
                           <a:solidFill>
                             <a:srgbClr val="2D2A26"/>
                           </a:solidFill>
@@ -15372,7 +15273,7 @@
                         </a:rPr>
                         <a:t>Tanzania</a:t>
                       </a:r>
-                      <a:endParaRPr lang="en-US" sz="950" dirty="0">
+                      <a:endParaRPr lang="en-US" sz="1200" dirty="0">
                         <a:latin typeface="Century Gothic" charset="0"/>
                         <a:ea typeface="Century Gothic" charset="0"/>
                         <a:cs typeface="Century Gothic" charset="0"/>
@@ -15430,7 +15331,7 @@
                         <a:buNone/>
                       </a:pPr>
                       <a:r>
-                        <a:rPr lang="en-US" sz="950" dirty="0">
+                        <a:rPr lang="en-US" sz="1200" dirty="0">
                           <a:solidFill>
                             <a:srgbClr val="2D2A26"/>
                           </a:solidFill>
@@ -15440,7 +15341,7 @@
                         </a:rPr>
                         <a:t>0.0%</a:t>
                       </a:r>
-                      <a:endParaRPr lang="en-US" sz="950" dirty="0">
+                      <a:endParaRPr lang="en-US" sz="1200" dirty="0">
                         <a:latin typeface="Calibri" charset="0"/>
                         <a:ea typeface="Calibri" charset="0"/>
                         <a:cs typeface="Calibri" charset="0"/>
@@ -15498,7 +15399,7 @@
                         <a:buNone/>
                       </a:pPr>
                       <a:r>
-                        <a:rPr lang="en-US" sz="950" dirty="0">
+                        <a:rPr lang="en-US" sz="1200" dirty="0">
                           <a:solidFill>
                             <a:srgbClr val="2D2A26"/>
                           </a:solidFill>
@@ -15508,7 +15409,7 @@
                         </a:rPr>
                         <a:t>8.2%</a:t>
                       </a:r>
-                      <a:endParaRPr lang="en-US" sz="950" dirty="0">
+                      <a:endParaRPr lang="en-US" sz="1200" dirty="0">
                         <a:latin typeface="Calibri" charset="0"/>
                         <a:ea typeface="Calibri" charset="0"/>
                         <a:cs typeface="Calibri" charset="0"/>
@@ -15566,7 +15467,7 @@
                         <a:buNone/>
                       </a:pPr>
                       <a:r>
-                        <a:rPr lang="en-US" sz="950" dirty="0">
+                        <a:rPr lang="en-US" sz="1200" dirty="0">
                           <a:solidFill>
                             <a:srgbClr val="C0392B"/>
                           </a:solidFill>
@@ -15576,7 +15477,7 @@
                         </a:rPr>
                         <a:t>+815 bps</a:t>
                       </a:r>
-                      <a:endParaRPr lang="en-US" sz="950" dirty="0">
+                      <a:endParaRPr lang="en-US" sz="1200" dirty="0">
                         <a:latin typeface="Calibri" charset="0"/>
                         <a:ea typeface="Calibri" charset="0"/>
                         <a:cs typeface="Calibri" charset="0"/>
@@ -15636,7 +15537,7 @@
                         <a:buNone/>
                       </a:pPr>
                       <a:r>
-                        <a:rPr lang="en-US" sz="950" b="1" dirty="0">
+                        <a:rPr lang="en-US" sz="1200" b="1" dirty="0">
                           <a:solidFill>
                             <a:srgbClr val="2D2A26"/>
                           </a:solidFill>
@@ -15646,7 +15547,7 @@
                         </a:rPr>
                         <a:t>Kenya</a:t>
                       </a:r>
-                      <a:endParaRPr lang="en-US" sz="950" dirty="0">
+                      <a:endParaRPr lang="en-US" sz="1200" dirty="0">
                         <a:latin typeface="Century Gothic" charset="0"/>
                         <a:ea typeface="Century Gothic" charset="0"/>
                         <a:cs typeface="Century Gothic" charset="0"/>
@@ -15704,7 +15605,7 @@
                         <a:buNone/>
                       </a:pPr>
                       <a:r>
-                        <a:rPr lang="en-US" sz="950" dirty="0">
+                        <a:rPr lang="en-US" sz="1200" dirty="0">
                           <a:solidFill>
                             <a:srgbClr val="2D2A26"/>
                           </a:solidFill>
@@ -15714,7 +15615,7 @@
                         </a:rPr>
                         <a:t>0.0%</a:t>
                       </a:r>
-                      <a:endParaRPr lang="en-US" sz="950" dirty="0">
+                      <a:endParaRPr lang="en-US" sz="1200" dirty="0">
                         <a:latin typeface="Calibri" charset="0"/>
                         <a:ea typeface="Calibri" charset="0"/>
                         <a:cs typeface="Calibri" charset="0"/>
@@ -15772,7 +15673,7 @@
                         <a:buNone/>
                       </a:pPr>
                       <a:r>
-                        <a:rPr lang="en-US" sz="950" dirty="0">
+                        <a:rPr lang="en-US" sz="1200" dirty="0">
                           <a:solidFill>
                             <a:srgbClr val="2D2A26"/>
                           </a:solidFill>
@@ -15782,7 +15683,7 @@
                         </a:rPr>
                         <a:t>6.2%</a:t>
                       </a:r>
-                      <a:endParaRPr lang="en-US" sz="950" dirty="0">
+                      <a:endParaRPr lang="en-US" sz="1200" dirty="0">
                         <a:latin typeface="Calibri" charset="0"/>
                         <a:ea typeface="Calibri" charset="0"/>
                         <a:cs typeface="Calibri" charset="0"/>
@@ -15840,7 +15741,7 @@
                         <a:buNone/>
                       </a:pPr>
                       <a:r>
-                        <a:rPr lang="en-US" sz="950" dirty="0">
+                        <a:rPr lang="en-US" sz="1200" dirty="0">
                           <a:solidFill>
                             <a:srgbClr val="C0392B"/>
                           </a:solidFill>
@@ -15850,7 +15751,7 @@
                         </a:rPr>
                         <a:t>+619 bps</a:t>
                       </a:r>
-                      <a:endParaRPr lang="en-US" sz="950" dirty="0">
+                      <a:endParaRPr lang="en-US" sz="1200" dirty="0">
                         <a:latin typeface="Calibri" charset="0"/>
                         <a:ea typeface="Calibri" charset="0"/>
                         <a:cs typeface="Calibri" charset="0"/>
@@ -15910,7 +15811,7 @@
                         <a:buNone/>
                       </a:pPr>
                       <a:r>
-                        <a:rPr lang="en-US" sz="950" b="1" dirty="0">
+                        <a:rPr lang="en-US" sz="1200" b="1" dirty="0">
                           <a:solidFill>
                             <a:srgbClr val="2D2A26"/>
                           </a:solidFill>
@@ -15920,7 +15821,7 @@
                         </a:rPr>
                         <a:t>Uganda</a:t>
                       </a:r>
-                      <a:endParaRPr lang="en-US" sz="950" dirty="0">
+                      <a:endParaRPr lang="en-US" sz="1200" dirty="0">
                         <a:latin typeface="Century Gothic" charset="0"/>
                         <a:ea typeface="Century Gothic" charset="0"/>
                         <a:cs typeface="Century Gothic" charset="0"/>
@@ -15978,7 +15879,7 @@
                         <a:buNone/>
                       </a:pPr>
                       <a:r>
-                        <a:rPr lang="en-US" sz="950" dirty="0">
+                        <a:rPr lang="en-US" sz="1200" dirty="0">
                           <a:solidFill>
                             <a:srgbClr val="2D2A26"/>
                           </a:solidFill>
@@ -15988,7 +15889,7 @@
                         </a:rPr>
                         <a:t>0.0%</a:t>
                       </a:r>
-                      <a:endParaRPr lang="en-US" sz="950" dirty="0">
+                      <a:endParaRPr lang="en-US" sz="1200" dirty="0">
                         <a:latin typeface="Calibri" charset="0"/>
                         <a:ea typeface="Calibri" charset="0"/>
                         <a:cs typeface="Calibri" charset="0"/>
@@ -16046,7 +15947,7 @@
                         <a:buNone/>
                       </a:pPr>
                       <a:r>
-                        <a:rPr lang="en-US" sz="950" dirty="0">
+                        <a:rPr lang="en-US" sz="1200" dirty="0">
                           <a:solidFill>
                             <a:srgbClr val="2D2A26"/>
                           </a:solidFill>
@@ -16056,7 +15957,7 @@
                         </a:rPr>
                         <a:t>17.4%</a:t>
                       </a:r>
-                      <a:endParaRPr lang="en-US" sz="950" dirty="0">
+                      <a:endParaRPr lang="en-US" sz="1200" dirty="0">
                         <a:latin typeface="Calibri" charset="0"/>
                         <a:ea typeface="Calibri" charset="0"/>
                         <a:cs typeface="Calibri" charset="0"/>
@@ -16114,7 +16015,7 @@
                         <a:buNone/>
                       </a:pPr>
                       <a:r>
-                        <a:rPr lang="en-US" sz="950" dirty="0">
+                        <a:rPr lang="en-US" sz="1200" dirty="0">
                           <a:solidFill>
                             <a:srgbClr val="C0392B"/>
                           </a:solidFill>
@@ -16124,7 +16025,7 @@
                         </a:rPr>
                         <a:t>+1736 bps</a:t>
                       </a:r>
-                      <a:endParaRPr lang="en-US" sz="950" dirty="0">
+                      <a:endParaRPr lang="en-US" sz="1200" dirty="0">
                         <a:latin typeface="Calibri" charset="0"/>
                         <a:ea typeface="Calibri" charset="0"/>
                         <a:cs typeface="Calibri" charset="0"/>
@@ -16184,7 +16085,7 @@
                         <a:buNone/>
                       </a:pPr>
                       <a:r>
-                        <a:rPr lang="en-US" sz="950" b="1" dirty="0">
+                        <a:rPr lang="en-US" sz="1200" b="1" dirty="0">
                           <a:solidFill>
                             <a:srgbClr val="2D2A26"/>
                           </a:solidFill>
@@ -16194,7 +16095,7 @@
                         </a:rPr>
                         <a:t>Sierra Leone</a:t>
                       </a:r>
-                      <a:endParaRPr lang="en-US" sz="950" dirty="0">
+                      <a:endParaRPr lang="en-US" sz="1200" dirty="0">
                         <a:latin typeface="Century Gothic" charset="0"/>
                         <a:ea typeface="Century Gothic" charset="0"/>
                         <a:cs typeface="Century Gothic" charset="0"/>
@@ -16252,7 +16153,7 @@
                         <a:buNone/>
                       </a:pPr>
                       <a:r>
-                        <a:rPr lang="en-US" sz="950" dirty="0">
+                        <a:rPr lang="en-US" sz="1200" dirty="0">
                           <a:solidFill>
                             <a:srgbClr val="2D2A26"/>
                           </a:solidFill>
@@ -16262,7 +16163,7 @@
                         </a:rPr>
                         <a:t>0.0%</a:t>
                       </a:r>
-                      <a:endParaRPr lang="en-US" sz="950" dirty="0">
+                      <a:endParaRPr lang="en-US" sz="1200" dirty="0">
                         <a:latin typeface="Calibri" charset="0"/>
                         <a:ea typeface="Calibri" charset="0"/>
                         <a:cs typeface="Calibri" charset="0"/>
@@ -16320,7 +16221,7 @@
                         <a:buNone/>
                       </a:pPr>
                       <a:r>
-                        <a:rPr lang="en-US" sz="950" dirty="0">
+                        <a:rPr lang="en-US" sz="1200" dirty="0">
                           <a:solidFill>
                             <a:srgbClr val="2D2A26"/>
                           </a:solidFill>
@@ -16330,7 +16231,7 @@
                         </a:rPr>
                         <a:t>2.0%</a:t>
                       </a:r>
-                      <a:endParaRPr lang="en-US" sz="950" dirty="0">
+                      <a:endParaRPr lang="en-US" sz="1200" dirty="0">
                         <a:latin typeface="Calibri" charset="0"/>
                         <a:ea typeface="Calibri" charset="0"/>
                         <a:cs typeface="Calibri" charset="0"/>
@@ -16388,7 +16289,7 @@
                         <a:buNone/>
                       </a:pPr>
                       <a:r>
-                        <a:rPr lang="en-US" sz="950" dirty="0">
+                        <a:rPr lang="en-US" sz="1200" dirty="0">
                           <a:solidFill>
                             <a:srgbClr val="C0392B"/>
                           </a:solidFill>
@@ -16398,7 +16299,7 @@
                         </a:rPr>
                         <a:t>+201 bps</a:t>
                       </a:r>
-                      <a:endParaRPr lang="en-US" sz="950" dirty="0">
+                      <a:endParaRPr lang="en-US" sz="1200" dirty="0">
                         <a:latin typeface="Calibri" charset="0"/>
                         <a:ea typeface="Calibri" charset="0"/>
                         <a:cs typeface="Calibri" charset="0"/>
@@ -16458,7 +16359,7 @@
                         <a:buNone/>
                       </a:pPr>
                       <a:r>
-                        <a:rPr lang="en-US" sz="950" b="1" dirty="0">
+                        <a:rPr lang="en-US" sz="1200" b="1" dirty="0">
                           <a:solidFill>
                             <a:srgbClr val="2D2A26"/>
                           </a:solidFill>
@@ -16468,7 +16369,7 @@
                         </a:rPr>
                         <a:t>Nigeria</a:t>
                       </a:r>
-                      <a:endParaRPr lang="en-US" sz="950" dirty="0">
+                      <a:endParaRPr lang="en-US" sz="1200" dirty="0">
                         <a:latin typeface="Century Gothic" charset="0"/>
                         <a:ea typeface="Century Gothic" charset="0"/>
                         <a:cs typeface="Century Gothic" charset="0"/>
@@ -16526,7 +16427,7 @@
                         <a:buNone/>
                       </a:pPr>
                       <a:r>
-                        <a:rPr lang="en-US" sz="950" dirty="0">
+                        <a:rPr lang="en-US" sz="1200" dirty="0">
                           <a:solidFill>
                             <a:srgbClr val="2D2A26"/>
                           </a:solidFill>
@@ -16536,7 +16437,7 @@
                         </a:rPr>
                         <a:t>0.0%</a:t>
                       </a:r>
-                      <a:endParaRPr lang="en-US" sz="950" dirty="0">
+                      <a:endParaRPr lang="en-US" sz="1200" dirty="0">
                         <a:latin typeface="Calibri" charset="0"/>
                         <a:ea typeface="Calibri" charset="0"/>
                         <a:cs typeface="Calibri" charset="0"/>
@@ -16594,7 +16495,7 @@
                         <a:buNone/>
                       </a:pPr>
                       <a:r>
-                        <a:rPr lang="en-US" sz="950" dirty="0">
+                        <a:rPr lang="en-US" sz="1200" dirty="0">
                           <a:solidFill>
                             <a:srgbClr val="2D2A26"/>
                           </a:solidFill>
@@ -16604,7 +16505,7 @@
                         </a:rPr>
                         <a:t>17.0%</a:t>
                       </a:r>
-                      <a:endParaRPr lang="en-US" sz="950" dirty="0">
+                      <a:endParaRPr lang="en-US" sz="1200" dirty="0">
                         <a:latin typeface="Calibri" charset="0"/>
                         <a:ea typeface="Calibri" charset="0"/>
                         <a:cs typeface="Calibri" charset="0"/>
@@ -16662,7 +16563,7 @@
                         <a:buNone/>
                       </a:pPr>
                       <a:r>
-                        <a:rPr lang="en-US" sz="950" dirty="0">
+                        <a:rPr lang="en-US" sz="1200" dirty="0">
                           <a:solidFill>
                             <a:srgbClr val="C0392B"/>
                           </a:solidFill>
@@ -16672,7 +16573,7 @@
                         </a:rPr>
                         <a:t>+1700 bps</a:t>
                       </a:r>
-                      <a:endParaRPr lang="en-US" sz="950" dirty="0">
+                      <a:endParaRPr lang="en-US" sz="1200" dirty="0">
                         <a:latin typeface="Calibri" charset="0"/>
                         <a:ea typeface="Calibri" charset="0"/>
                         <a:cs typeface="Calibri" charset="0"/>
@@ -16801,7 +16702,7 @@
               <a:buNone/>
             </a:pPr>
             <a:r>
-              <a:rPr lang="en-US" sz="1400" b="1" dirty="0">
+              <a:rPr lang="en-US" sz="2200" b="1" dirty="0">
                 <a:solidFill>
                   <a:srgbClr val="FFF9D9"/>
                 </a:solidFill>
@@ -16811,7 +16712,7 @@
               </a:rPr>
               <a:t>Summary Financial Results</a:t>
             </a:r>
-            <a:endParaRPr lang="en-US" sz="1400" dirty="0"/>
+            <a:endParaRPr lang="en-US" sz="2200" dirty="0"/>
           </a:p>
         </p:txBody>
       </p:sp>
@@ -17073,7 +16974,7 @@
                         <a:buNone/>
                       </a:pPr>
                       <a:r>
-                        <a:rPr lang="en-US" sz="900" b="1" dirty="0">
+                        <a:rPr lang="en-US" sz="1200" b="1" dirty="0">
                           <a:solidFill>
                             <a:srgbClr val="FFF9D9"/>
                           </a:solidFill>
@@ -17083,7 +16984,7 @@
                         </a:rPr>
                         <a:t>Country</a:t>
                       </a:r>
-                      <a:endParaRPr lang="en-US" sz="900" dirty="0">
+                      <a:endParaRPr lang="en-US" sz="1200" dirty="0">
                         <a:latin typeface="Century Gothic" charset="0"/>
                         <a:ea typeface="Century Gothic" charset="0"/>
                         <a:cs typeface="Century Gothic" charset="0"/>
@@ -17141,7 +17042,7 @@
                         <a:buNone/>
                       </a:pPr>
                       <a:r>
-                        <a:rPr lang="en-US" sz="900" b="1" dirty="0">
+                        <a:rPr lang="en-US" sz="1200" b="1" dirty="0">
                           <a:solidFill>
                             <a:srgbClr val="FFF9D9"/>
                           </a:solidFill>
@@ -17151,7 +17052,7 @@
                         </a:rPr>
                         <a:t>Revenue</a:t>
                       </a:r>
-                      <a:endParaRPr lang="en-US" sz="900" dirty="0">
+                      <a:endParaRPr lang="en-US" sz="1200" dirty="0">
                         <a:latin typeface="Century Gothic" charset="0"/>
                         <a:ea typeface="Century Gothic" charset="0"/>
                         <a:cs typeface="Century Gothic" charset="0"/>
@@ -17209,7 +17110,7 @@
                         <a:buNone/>
                       </a:pPr>
                       <a:r>
-                        <a:rPr lang="en-US" sz="900" b="1" dirty="0">
+                        <a:rPr lang="en-US" sz="1200" b="1" dirty="0">
                           <a:solidFill>
                             <a:srgbClr val="FFF9D9"/>
                           </a:solidFill>
@@ -17219,7 +17120,7 @@
                         </a:rPr>
                         <a:t>Provision</a:t>
                       </a:r>
-                      <a:endParaRPr lang="en-US" sz="900" dirty="0">
+                      <a:endParaRPr lang="en-US" sz="1200" dirty="0">
                         <a:latin typeface="Century Gothic" charset="0"/>
                         <a:ea typeface="Century Gothic" charset="0"/>
                         <a:cs typeface="Century Gothic" charset="0"/>
@@ -17277,7 +17178,7 @@
                         <a:buNone/>
                       </a:pPr>
                       <a:r>
-                        <a:rPr lang="en-US" sz="900" b="1" dirty="0">
+                        <a:rPr lang="en-US" sz="1200" b="1" dirty="0">
                           <a:solidFill>
                             <a:srgbClr val="FFF9D9"/>
                           </a:solidFill>
@@ -17287,7 +17188,7 @@
                         </a:rPr>
                         <a:t>Opex</a:t>
                       </a:r>
-                      <a:endParaRPr lang="en-US" sz="900" dirty="0">
+                      <a:endParaRPr lang="en-US" sz="1200" dirty="0">
                         <a:latin typeface="Century Gothic" charset="0"/>
                         <a:ea typeface="Century Gothic" charset="0"/>
                         <a:cs typeface="Century Gothic" charset="0"/>
@@ -17345,7 +17246,7 @@
                         <a:buNone/>
                       </a:pPr>
                       <a:r>
-                        <a:rPr lang="en-US" sz="900" b="1" dirty="0">
+                        <a:rPr lang="en-US" sz="1200" b="1" dirty="0">
                           <a:solidFill>
                             <a:srgbClr val="FFF9D9"/>
                           </a:solidFill>
@@ -17355,7 +17256,7 @@
                         </a:rPr>
                         <a:t>Operating Income</a:t>
                       </a:r>
-                      <a:endParaRPr lang="en-US" sz="900" dirty="0">
+                      <a:endParaRPr lang="en-US" sz="1200" dirty="0">
                         <a:latin typeface="Century Gothic" charset="0"/>
                         <a:ea typeface="Century Gothic" charset="0"/>
                         <a:cs typeface="Century Gothic" charset="0"/>
@@ -17413,7 +17314,7 @@
                         <a:buNone/>
                       </a:pPr>
                       <a:r>
-                        <a:rPr lang="en-US" sz="900" b="1" dirty="0">
+                        <a:rPr lang="en-US" sz="1200" b="1" dirty="0">
                           <a:solidFill>
                             <a:srgbClr val="FFF9D9"/>
                           </a:solidFill>
@@ -17423,7 +17324,7 @@
                         </a:rPr>
                         <a:t>Op. Margin</a:t>
                       </a:r>
-                      <a:endParaRPr lang="en-US" sz="900" dirty="0">
+                      <a:endParaRPr lang="en-US" sz="1200" dirty="0">
                         <a:latin typeface="Century Gothic" charset="0"/>
                         <a:ea typeface="Century Gothic" charset="0"/>
                         <a:cs typeface="Century Gothic" charset="0"/>
@@ -17481,7 +17382,7 @@
                         <a:buNone/>
                       </a:pPr>
                       <a:r>
-                        <a:rPr lang="en-US" sz="900" b="1" dirty="0">
+                        <a:rPr lang="en-US" sz="1200" b="1" dirty="0">
                           <a:solidFill>
                             <a:srgbClr val="FFF9D9"/>
                           </a:solidFill>
@@ -17491,7 +17392,7 @@
                         </a:rPr>
                         <a:t>Prior Month OI</a:t>
                       </a:r>
-                      <a:endParaRPr lang="en-US" sz="900" dirty="0">
+                      <a:endParaRPr lang="en-US" sz="1200" dirty="0">
                         <a:latin typeface="Century Gothic" charset="0"/>
                         <a:ea typeface="Century Gothic" charset="0"/>
                         <a:cs typeface="Century Gothic" charset="0"/>
@@ -20438,7 +20339,7 @@
               <a:buNone/>
             </a:pPr>
             <a:r>
-              <a:rPr lang="en-US" sz="750" i="1" dirty="0">
+              <a:rPr lang="en-US" sz="1200" i="1" dirty="0">
                 <a:solidFill>
                   <a:srgbClr val="718096"/>
                 </a:solidFill>
@@ -20448,7 +20349,7 @@
               </a:rPr>
               <a:t>Revenue = Interest Income + Processing Fees  |  Opex includes Interest Expense  |  Figures in USD</a:t>
             </a:r>
-            <a:endParaRPr lang="en-US" sz="750" dirty="0"/>
+            <a:endParaRPr lang="en-US" sz="1200" dirty="0"/>
           </a:p>
         </p:txBody>
       </p:sp>

</xml_diff>

<commit_message>
Auto-build: 2026-03-12 02:28 UTC
</commit_message>
<xml_diff>
--- a/reports/2026-01.pptx
+++ b/reports/2026-01.pptx
@@ -17452,7 +17452,7 @@
                         <a:buNone/>
                       </a:pPr>
                       <a:r>
-                        <a:rPr lang="en-US" sz="900" b="1" dirty="0">
+                        <a:rPr lang="en-US" sz="1200" b="1" dirty="0">
                           <a:solidFill>
                             <a:srgbClr val="2D2A26"/>
                           </a:solidFill>
@@ -17462,7 +17462,7 @@
                         </a:rPr>
                         <a:t>Tanzania</a:t>
                       </a:r>
-                      <a:endParaRPr lang="en-US" sz="900" dirty="0">
+                      <a:endParaRPr lang="en-US" sz="1200" dirty="0">
                         <a:latin typeface="Century Gothic" charset="0"/>
                         <a:ea typeface="Century Gothic" charset="0"/>
                         <a:cs typeface="Century Gothic" charset="0"/>
@@ -17520,7 +17520,7 @@
                         <a:buNone/>
                       </a:pPr>
                       <a:r>
-                        <a:rPr lang="en-US" sz="900" dirty="0">
+                        <a:rPr lang="en-US" sz="1200" dirty="0">
                           <a:solidFill>
                             <a:srgbClr val="2D2A26"/>
                           </a:solidFill>
@@ -17530,7 +17530,7 @@
                         </a:rPr>
                         <a:t>$871,059</a:t>
                       </a:r>
-                      <a:endParaRPr lang="en-US" sz="900" dirty="0">
+                      <a:endParaRPr lang="en-US" sz="1200" dirty="0">
                         <a:latin typeface="Calibri" charset="0"/>
                         <a:ea typeface="Calibri" charset="0"/>
                         <a:cs typeface="Calibri" charset="0"/>
@@ -17588,7 +17588,7 @@
                         <a:buNone/>
                       </a:pPr>
                       <a:r>
-                        <a:rPr lang="en-US" sz="900" dirty="0">
+                        <a:rPr lang="en-US" sz="1200" dirty="0">
                           <a:solidFill>
                             <a:srgbClr val="2D2A26"/>
                           </a:solidFill>
@@ -17598,7 +17598,7 @@
                         </a:rPr>
                         <a:t>$-147,088</a:t>
                       </a:r>
-                      <a:endParaRPr lang="en-US" sz="900" dirty="0">
+                      <a:endParaRPr lang="en-US" sz="1200" dirty="0">
                         <a:latin typeface="Calibri" charset="0"/>
                         <a:ea typeface="Calibri" charset="0"/>
                         <a:cs typeface="Calibri" charset="0"/>
@@ -17656,7 +17656,7 @@
                         <a:buNone/>
                       </a:pPr>
                       <a:r>
-                        <a:rPr lang="en-US" sz="900" dirty="0">
+                        <a:rPr lang="en-US" sz="1200" dirty="0">
                           <a:solidFill>
                             <a:srgbClr val="2D2A26"/>
                           </a:solidFill>
@@ -17666,7 +17666,7 @@
                         </a:rPr>
                         <a:t>$-495,207</a:t>
                       </a:r>
-                      <a:endParaRPr lang="en-US" sz="900" dirty="0">
+                      <a:endParaRPr lang="en-US" sz="1200" dirty="0">
                         <a:latin typeface="Calibri" charset="0"/>
                         <a:ea typeface="Calibri" charset="0"/>
                         <a:cs typeface="Calibri" charset="0"/>
@@ -17724,7 +17724,7 @@
                         <a:buNone/>
                       </a:pPr>
                       <a:r>
-                        <a:rPr lang="en-US" sz="900" dirty="0">
+                        <a:rPr lang="en-US" sz="1200" dirty="0">
                           <a:solidFill>
                             <a:srgbClr val="2D2A26"/>
                           </a:solidFill>
@@ -17734,7 +17734,7 @@
                         </a:rPr>
                         <a:t>$228,764</a:t>
                       </a:r>
-                      <a:endParaRPr lang="en-US" sz="900" dirty="0">
+                      <a:endParaRPr lang="en-US" sz="1200" dirty="0">
                         <a:latin typeface="Calibri" charset="0"/>
                         <a:ea typeface="Calibri" charset="0"/>
                         <a:cs typeface="Calibri" charset="0"/>
@@ -17792,7 +17792,7 @@
                         <a:buNone/>
                       </a:pPr>
                       <a:r>
-                        <a:rPr lang="en-US" sz="900" dirty="0">
+                        <a:rPr lang="en-US" sz="1200" dirty="0">
                           <a:solidFill>
                             <a:srgbClr val="2D2A26"/>
                           </a:solidFill>
@@ -17802,7 +17802,7 @@
                         </a:rPr>
                         <a:t>26.3%</a:t>
                       </a:r>
-                      <a:endParaRPr lang="en-US" sz="900" dirty="0">
+                      <a:endParaRPr lang="en-US" sz="1200" dirty="0">
                         <a:latin typeface="Calibri" charset="0"/>
                         <a:ea typeface="Calibri" charset="0"/>
                         <a:cs typeface="Calibri" charset="0"/>
@@ -17860,7 +17860,7 @@
                         <a:buNone/>
                       </a:pPr>
                       <a:r>
-                        <a:rPr lang="en-US" sz="900" dirty="0">
+                        <a:rPr lang="en-US" sz="1200" dirty="0">
                           <a:solidFill>
                             <a:srgbClr val="2D2A26"/>
                           </a:solidFill>
@@ -17870,7 +17870,7 @@
                         </a:rPr>
                         <a:t>$-334,214</a:t>
                       </a:r>
-                      <a:endParaRPr lang="en-US" sz="900" dirty="0">
+                      <a:endParaRPr lang="en-US" sz="1200" dirty="0">
                         <a:latin typeface="Calibri" charset="0"/>
                         <a:ea typeface="Calibri" charset="0"/>
                         <a:cs typeface="Calibri" charset="0"/>
@@ -17930,7 +17930,7 @@
                         <a:buNone/>
                       </a:pPr>
                       <a:r>
-                        <a:rPr lang="en-US" sz="900" b="1" dirty="0">
+                        <a:rPr lang="en-US" sz="1200" b="1" dirty="0">
                           <a:solidFill>
                             <a:srgbClr val="2D2A26"/>
                           </a:solidFill>
@@ -17940,7 +17940,7 @@
                         </a:rPr>
                         <a:t>Kenya</a:t>
                       </a:r>
-                      <a:endParaRPr lang="en-US" sz="900" dirty="0">
+                      <a:endParaRPr lang="en-US" sz="1200" dirty="0">
                         <a:latin typeface="Century Gothic" charset="0"/>
                         <a:ea typeface="Century Gothic" charset="0"/>
                         <a:cs typeface="Century Gothic" charset="0"/>
@@ -17998,7 +17998,7 @@
                         <a:buNone/>
                       </a:pPr>
                       <a:r>
-                        <a:rPr lang="en-US" sz="900" dirty="0">
+                        <a:rPr lang="en-US" sz="1200" dirty="0">
                           <a:solidFill>
                             <a:srgbClr val="2D2A26"/>
                           </a:solidFill>
@@ -18008,7 +18008,7 @@
                         </a:rPr>
                         <a:t>$615,703</a:t>
                       </a:r>
-                      <a:endParaRPr lang="en-US" sz="900" dirty="0">
+                      <a:endParaRPr lang="en-US" sz="1200" dirty="0">
                         <a:latin typeface="Calibri" charset="0"/>
                         <a:ea typeface="Calibri" charset="0"/>
                         <a:cs typeface="Calibri" charset="0"/>
@@ -18066,7 +18066,7 @@
                         <a:buNone/>
                       </a:pPr>
                       <a:r>
-                        <a:rPr lang="en-US" sz="900" dirty="0">
+                        <a:rPr lang="en-US" sz="1200" dirty="0">
                           <a:solidFill>
                             <a:srgbClr val="2D2A26"/>
                           </a:solidFill>
@@ -18076,7 +18076,7 @@
                         </a:rPr>
                         <a:t>$-70,862</a:t>
                       </a:r>
-                      <a:endParaRPr lang="en-US" sz="900" dirty="0">
+                      <a:endParaRPr lang="en-US" sz="1200" dirty="0">
                         <a:latin typeface="Calibri" charset="0"/>
                         <a:ea typeface="Calibri" charset="0"/>
                         <a:cs typeface="Calibri" charset="0"/>
@@ -18134,7 +18134,7 @@
                         <a:buNone/>
                       </a:pPr>
                       <a:r>
-                        <a:rPr lang="en-US" sz="900" dirty="0">
+                        <a:rPr lang="en-US" sz="1200" dirty="0">
                           <a:solidFill>
                             <a:srgbClr val="2D2A26"/>
                           </a:solidFill>
@@ -18144,7 +18144,7 @@
                         </a:rPr>
                         <a:t>$-382,270</a:t>
                       </a:r>
-                      <a:endParaRPr lang="en-US" sz="900" dirty="0">
+                      <a:endParaRPr lang="en-US" sz="1200" dirty="0">
                         <a:latin typeface="Calibri" charset="0"/>
                         <a:ea typeface="Calibri" charset="0"/>
                         <a:cs typeface="Calibri" charset="0"/>
@@ -18202,7 +18202,7 @@
                         <a:buNone/>
                       </a:pPr>
                       <a:r>
-                        <a:rPr lang="en-US" sz="900" dirty="0">
+                        <a:rPr lang="en-US" sz="1200" dirty="0">
                           <a:solidFill>
                             <a:srgbClr val="2D2A26"/>
                           </a:solidFill>
@@ -18212,7 +18212,7 @@
                         </a:rPr>
                         <a:t>$162,571</a:t>
                       </a:r>
-                      <a:endParaRPr lang="en-US" sz="900" dirty="0">
+                      <a:endParaRPr lang="en-US" sz="1200" dirty="0">
                         <a:latin typeface="Calibri" charset="0"/>
                         <a:ea typeface="Calibri" charset="0"/>
                         <a:cs typeface="Calibri" charset="0"/>
@@ -18270,7 +18270,7 @@
                         <a:buNone/>
                       </a:pPr>
                       <a:r>
-                        <a:rPr lang="en-US" sz="900" dirty="0">
+                        <a:rPr lang="en-US" sz="1200" dirty="0">
                           <a:solidFill>
                             <a:srgbClr val="2D2A26"/>
                           </a:solidFill>
@@ -18280,7 +18280,7 @@
                         </a:rPr>
                         <a:t>26.4%</a:t>
                       </a:r>
-                      <a:endParaRPr lang="en-US" sz="900" dirty="0">
+                      <a:endParaRPr lang="en-US" sz="1200" dirty="0">
                         <a:latin typeface="Calibri" charset="0"/>
                         <a:ea typeface="Calibri" charset="0"/>
                         <a:cs typeface="Calibri" charset="0"/>
@@ -18338,7 +18338,7 @@
                         <a:buNone/>
                       </a:pPr>
                       <a:r>
-                        <a:rPr lang="en-US" sz="900" dirty="0">
+                        <a:rPr lang="en-US" sz="1200" dirty="0">
                           <a:solidFill>
                             <a:srgbClr val="2D2A26"/>
                           </a:solidFill>
@@ -18348,7 +18348,7 @@
                         </a:rPr>
                         <a:t>$0</a:t>
                       </a:r>
-                      <a:endParaRPr lang="en-US" sz="900" dirty="0">
+                      <a:endParaRPr lang="en-US" sz="1200" dirty="0">
                         <a:latin typeface="Calibri" charset="0"/>
                         <a:ea typeface="Calibri" charset="0"/>
                         <a:cs typeface="Calibri" charset="0"/>
@@ -18408,7 +18408,7 @@
                         <a:buNone/>
                       </a:pPr>
                       <a:r>
-                        <a:rPr lang="en-US" sz="900" b="1" dirty="0">
+                        <a:rPr lang="en-US" sz="1200" b="1" dirty="0">
                           <a:solidFill>
                             <a:srgbClr val="2D2A26"/>
                           </a:solidFill>
@@ -18418,7 +18418,7 @@
                         </a:rPr>
                         <a:t>Uganda</a:t>
                       </a:r>
-                      <a:endParaRPr lang="en-US" sz="900" dirty="0">
+                      <a:endParaRPr lang="en-US" sz="1200" dirty="0">
                         <a:latin typeface="Century Gothic" charset="0"/>
                         <a:ea typeface="Century Gothic" charset="0"/>
                         <a:cs typeface="Century Gothic" charset="0"/>
@@ -18476,7 +18476,7 @@
                         <a:buNone/>
                       </a:pPr>
                       <a:r>
-                        <a:rPr lang="en-US" sz="900" dirty="0">
+                        <a:rPr lang="en-US" sz="1200" dirty="0">
                           <a:solidFill>
                             <a:srgbClr val="2D2A26"/>
                           </a:solidFill>
@@ -18486,7 +18486,7 @@
                         </a:rPr>
                         <a:t>$148,399</a:t>
                       </a:r>
-                      <a:endParaRPr lang="en-US" sz="900" dirty="0">
+                      <a:endParaRPr lang="en-US" sz="1200" dirty="0">
                         <a:latin typeface="Calibri" charset="0"/>
                         <a:ea typeface="Calibri" charset="0"/>
                         <a:cs typeface="Calibri" charset="0"/>
@@ -18544,7 +18544,7 @@
                         <a:buNone/>
                       </a:pPr>
                       <a:r>
-                        <a:rPr lang="en-US" sz="900" dirty="0">
+                        <a:rPr lang="en-US" sz="1200" dirty="0">
                           <a:solidFill>
                             <a:srgbClr val="2D2A26"/>
                           </a:solidFill>
@@ -18554,7 +18554,7 @@
                         </a:rPr>
                         <a:t>$-70,540</a:t>
                       </a:r>
-                      <a:endParaRPr lang="en-US" sz="900" dirty="0">
+                      <a:endParaRPr lang="en-US" sz="1200" dirty="0">
                         <a:latin typeface="Calibri" charset="0"/>
                         <a:ea typeface="Calibri" charset="0"/>
                         <a:cs typeface="Calibri" charset="0"/>
@@ -18612,7 +18612,7 @@
                         <a:buNone/>
                       </a:pPr>
                       <a:r>
-                        <a:rPr lang="en-US" sz="900" dirty="0">
+                        <a:rPr lang="en-US" sz="1200" dirty="0">
                           <a:solidFill>
                             <a:srgbClr val="2D2A26"/>
                           </a:solidFill>
@@ -18622,7 +18622,7 @@
                         </a:rPr>
                         <a:t>$-140,209</a:t>
                       </a:r>
-                      <a:endParaRPr lang="en-US" sz="900" dirty="0">
+                      <a:endParaRPr lang="en-US" sz="1200" dirty="0">
                         <a:latin typeface="Calibri" charset="0"/>
                         <a:ea typeface="Calibri" charset="0"/>
                         <a:cs typeface="Calibri" charset="0"/>
@@ -18680,7 +18680,7 @@
                         <a:buNone/>
                       </a:pPr>
                       <a:r>
-                        <a:rPr lang="en-US" sz="900" dirty="0">
+                        <a:rPr lang="en-US" sz="1200" dirty="0">
                           <a:solidFill>
                             <a:srgbClr val="C0392B"/>
                           </a:solidFill>
@@ -18690,7 +18690,7 @@
                         </a:rPr>
                         <a:t>$-62,350</a:t>
                       </a:r>
-                      <a:endParaRPr lang="en-US" sz="900" dirty="0">
+                      <a:endParaRPr lang="en-US" sz="1200" dirty="0">
                         <a:latin typeface="Calibri" charset="0"/>
                         <a:ea typeface="Calibri" charset="0"/>
                         <a:cs typeface="Calibri" charset="0"/>
@@ -18748,7 +18748,7 @@
                         <a:buNone/>
                       </a:pPr>
                       <a:r>
-                        <a:rPr lang="en-US" sz="900" dirty="0">
+                        <a:rPr lang="en-US" sz="1200" dirty="0">
                           <a:solidFill>
                             <a:srgbClr val="2D2A26"/>
                           </a:solidFill>
@@ -18758,7 +18758,7 @@
                         </a:rPr>
                         <a:t>-42.0%</a:t>
                       </a:r>
-                      <a:endParaRPr lang="en-US" sz="900" dirty="0">
+                      <a:endParaRPr lang="en-US" sz="1200" dirty="0">
                         <a:latin typeface="Calibri" charset="0"/>
                         <a:ea typeface="Calibri" charset="0"/>
                         <a:cs typeface="Calibri" charset="0"/>
@@ -18816,7 +18816,7 @@
                         <a:buNone/>
                       </a:pPr>
                       <a:r>
-                        <a:rPr lang="en-US" sz="900" dirty="0">
+                        <a:rPr lang="en-US" sz="1200" dirty="0">
                           <a:solidFill>
                             <a:srgbClr val="2D2A26"/>
                           </a:solidFill>
@@ -18826,7 +18826,7 @@
                         </a:rPr>
                         <a:t>$-113,329</a:t>
                       </a:r>
-                      <a:endParaRPr lang="en-US" sz="900" dirty="0">
+                      <a:endParaRPr lang="en-US" sz="1200" dirty="0">
                         <a:latin typeface="Calibri" charset="0"/>
                         <a:ea typeface="Calibri" charset="0"/>
                         <a:cs typeface="Calibri" charset="0"/>
@@ -18886,7 +18886,7 @@
                         <a:buNone/>
                       </a:pPr>
                       <a:r>
-                        <a:rPr lang="en-US" sz="900" b="1" dirty="0">
+                        <a:rPr lang="en-US" sz="1200" b="1" dirty="0">
                           <a:solidFill>
                             <a:srgbClr val="2D2A26"/>
                           </a:solidFill>
@@ -18896,7 +18896,7 @@
                         </a:rPr>
                         <a:t>Sierra Leone</a:t>
                       </a:r>
-                      <a:endParaRPr lang="en-US" sz="900" dirty="0">
+                      <a:endParaRPr lang="en-US" sz="1200" dirty="0">
                         <a:latin typeface="Century Gothic" charset="0"/>
                         <a:ea typeface="Century Gothic" charset="0"/>
                         <a:cs typeface="Century Gothic" charset="0"/>
@@ -18954,7 +18954,7 @@
                         <a:buNone/>
                       </a:pPr>
                       <a:r>
-                        <a:rPr lang="en-US" sz="900" dirty="0">
+                        <a:rPr lang="en-US" sz="1200" dirty="0">
                           <a:solidFill>
                             <a:srgbClr val="2D2A26"/>
                           </a:solidFill>
@@ -18964,7 +18964,7 @@
                         </a:rPr>
                         <a:t>$183,186</a:t>
                       </a:r>
-                      <a:endParaRPr lang="en-US" sz="900" dirty="0">
+                      <a:endParaRPr lang="en-US" sz="1200" dirty="0">
                         <a:latin typeface="Calibri" charset="0"/>
                         <a:ea typeface="Calibri" charset="0"/>
                         <a:cs typeface="Calibri" charset="0"/>
@@ -19022,7 +19022,7 @@
                         <a:buNone/>
                       </a:pPr>
                       <a:r>
-                        <a:rPr lang="en-US" sz="900" dirty="0">
+                        <a:rPr lang="en-US" sz="1200" dirty="0">
                           <a:solidFill>
                             <a:srgbClr val="2D2A26"/>
                           </a:solidFill>
@@ -19032,7 +19032,7 @@
                         </a:rPr>
                         <a:t>$-7,306</a:t>
                       </a:r>
-                      <a:endParaRPr lang="en-US" sz="900" dirty="0">
+                      <a:endParaRPr lang="en-US" sz="1200" dirty="0">
                         <a:latin typeface="Calibri" charset="0"/>
                         <a:ea typeface="Calibri" charset="0"/>
                         <a:cs typeface="Calibri" charset="0"/>
@@ -19090,7 +19090,7 @@
                         <a:buNone/>
                       </a:pPr>
                       <a:r>
-                        <a:rPr lang="en-US" sz="900" dirty="0">
+                        <a:rPr lang="en-US" sz="1200" dirty="0">
                           <a:solidFill>
                             <a:srgbClr val="2D2A26"/>
                           </a:solidFill>
@@ -19100,7 +19100,7 @@
                         </a:rPr>
                         <a:t>$-120,605</a:t>
                       </a:r>
-                      <a:endParaRPr lang="en-US" sz="900" dirty="0">
+                      <a:endParaRPr lang="en-US" sz="1200" dirty="0">
                         <a:latin typeface="Calibri" charset="0"/>
                         <a:ea typeface="Calibri" charset="0"/>
                         <a:cs typeface="Calibri" charset="0"/>
@@ -19158,7 +19158,7 @@
                         <a:buNone/>
                       </a:pPr>
                       <a:r>
-                        <a:rPr lang="en-US" sz="900" dirty="0">
+                        <a:rPr lang="en-US" sz="1200" dirty="0">
                           <a:solidFill>
                             <a:srgbClr val="2D2A26"/>
                           </a:solidFill>
@@ -19168,7 +19168,7 @@
                         </a:rPr>
                         <a:t>$55,275</a:t>
                       </a:r>
-                      <a:endParaRPr lang="en-US" sz="900" dirty="0">
+                      <a:endParaRPr lang="en-US" sz="1200" dirty="0">
                         <a:latin typeface="Calibri" charset="0"/>
                         <a:ea typeface="Calibri" charset="0"/>
                         <a:cs typeface="Calibri" charset="0"/>
@@ -19226,7 +19226,7 @@
                         <a:buNone/>
                       </a:pPr>
                       <a:r>
-                        <a:rPr lang="en-US" sz="900" dirty="0">
+                        <a:rPr lang="en-US" sz="1200" dirty="0">
                           <a:solidFill>
                             <a:srgbClr val="2D2A26"/>
                           </a:solidFill>
@@ -19236,7 +19236,7 @@
                         </a:rPr>
                         <a:t>30.2%</a:t>
                       </a:r>
-                      <a:endParaRPr lang="en-US" sz="900" dirty="0">
+                      <a:endParaRPr lang="en-US" sz="1200" dirty="0">
                         <a:latin typeface="Calibri" charset="0"/>
                         <a:ea typeface="Calibri" charset="0"/>
                         <a:cs typeface="Calibri" charset="0"/>
@@ -19294,7 +19294,7 @@
                         <a:buNone/>
                       </a:pPr>
                       <a:r>
-                        <a:rPr lang="en-US" sz="900" dirty="0">
+                        <a:rPr lang="en-US" sz="1200" dirty="0">
                           <a:solidFill>
                             <a:srgbClr val="2D2A26"/>
                           </a:solidFill>
@@ -19304,7 +19304,7 @@
                         </a:rPr>
                         <a:t>$-59,801</a:t>
                       </a:r>
-                      <a:endParaRPr lang="en-US" sz="900" dirty="0">
+                      <a:endParaRPr lang="en-US" sz="1200" dirty="0">
                         <a:latin typeface="Calibri" charset="0"/>
                         <a:ea typeface="Calibri" charset="0"/>
                         <a:cs typeface="Calibri" charset="0"/>
@@ -19364,7 +19364,7 @@
                         <a:buNone/>
                       </a:pPr>
                       <a:r>
-                        <a:rPr lang="en-US" sz="900" b="1" dirty="0">
+                        <a:rPr lang="en-US" sz="1200" b="1" dirty="0">
                           <a:solidFill>
                             <a:srgbClr val="2D2A26"/>
                           </a:solidFill>
@@ -19374,7 +19374,7 @@
                         </a:rPr>
                         <a:t>Nigeria</a:t>
                       </a:r>
-                      <a:endParaRPr lang="en-US" sz="900" dirty="0">
+                      <a:endParaRPr lang="en-US" sz="1200" dirty="0">
                         <a:latin typeface="Century Gothic" charset="0"/>
                         <a:ea typeface="Century Gothic" charset="0"/>
                         <a:cs typeface="Century Gothic" charset="0"/>
@@ -19432,7 +19432,7 @@
                         <a:buNone/>
                       </a:pPr>
                       <a:r>
-                        <a:rPr lang="en-US" sz="900" dirty="0">
+                        <a:rPr lang="en-US" sz="1200" dirty="0">
                           <a:solidFill>
                             <a:srgbClr val="2D2A26"/>
                           </a:solidFill>
@@ -19442,7 +19442,7 @@
                         </a:rPr>
                         <a:t>$67,009</a:t>
                       </a:r>
-                      <a:endParaRPr lang="en-US" sz="900" dirty="0">
+                      <a:endParaRPr lang="en-US" sz="1200" dirty="0">
                         <a:latin typeface="Calibri" charset="0"/>
                         <a:ea typeface="Calibri" charset="0"/>
                         <a:cs typeface="Calibri" charset="0"/>
@@ -19500,7 +19500,7 @@
                         <a:buNone/>
                       </a:pPr>
                       <a:r>
-                        <a:rPr lang="en-US" sz="900" dirty="0">
+                        <a:rPr lang="en-US" sz="1200" dirty="0">
                           <a:solidFill>
                             <a:srgbClr val="2D2A26"/>
                           </a:solidFill>
@@ -19510,7 +19510,7 @@
                         </a:rPr>
                         <a:t>$-34,270</a:t>
                       </a:r>
-                      <a:endParaRPr lang="en-US" sz="900" dirty="0">
+                      <a:endParaRPr lang="en-US" sz="1200" dirty="0">
                         <a:latin typeface="Calibri" charset="0"/>
                         <a:ea typeface="Calibri" charset="0"/>
                         <a:cs typeface="Calibri" charset="0"/>
@@ -19568,7 +19568,7 @@
                         <a:buNone/>
                       </a:pPr>
                       <a:r>
-                        <a:rPr lang="en-US" sz="900" dirty="0">
+                        <a:rPr lang="en-US" sz="1200" dirty="0">
                           <a:solidFill>
                             <a:srgbClr val="2D2A26"/>
                           </a:solidFill>
@@ -19578,7 +19578,7 @@
                         </a:rPr>
                         <a:t>$-102,159</a:t>
                       </a:r>
-                      <a:endParaRPr lang="en-US" sz="900" dirty="0">
+                      <a:endParaRPr lang="en-US" sz="1200" dirty="0">
                         <a:latin typeface="Calibri" charset="0"/>
                         <a:ea typeface="Calibri" charset="0"/>
                         <a:cs typeface="Calibri" charset="0"/>
@@ -19636,7 +19636,7 @@
                         <a:buNone/>
                       </a:pPr>
                       <a:r>
-                        <a:rPr lang="en-US" sz="900" dirty="0">
+                        <a:rPr lang="en-US" sz="1200" dirty="0">
                           <a:solidFill>
                             <a:srgbClr val="C0392B"/>
                           </a:solidFill>
@@ -19646,7 +19646,7 @@
                         </a:rPr>
                         <a:t>$-69,419</a:t>
                       </a:r>
-                      <a:endParaRPr lang="en-US" sz="900" dirty="0">
+                      <a:endParaRPr lang="en-US" sz="1200" dirty="0">
                         <a:latin typeface="Calibri" charset="0"/>
                         <a:ea typeface="Calibri" charset="0"/>
                         <a:cs typeface="Calibri" charset="0"/>
@@ -19704,7 +19704,7 @@
                         <a:buNone/>
                       </a:pPr>
                       <a:r>
-                        <a:rPr lang="en-US" sz="900" dirty="0">
+                        <a:rPr lang="en-US" sz="1200" dirty="0">
                           <a:solidFill>
                             <a:srgbClr val="2D2A26"/>
                           </a:solidFill>
@@ -19714,7 +19714,7 @@
                         </a:rPr>
                         <a:t>-103.6%</a:t>
                       </a:r>
-                      <a:endParaRPr lang="en-US" sz="900" dirty="0">
+                      <a:endParaRPr lang="en-US" sz="1200" dirty="0">
                         <a:latin typeface="Calibri" charset="0"/>
                         <a:ea typeface="Calibri" charset="0"/>
                         <a:cs typeface="Calibri" charset="0"/>
@@ -19772,7 +19772,7 @@
                         <a:buNone/>
                       </a:pPr>
                       <a:r>
-                        <a:rPr lang="en-US" sz="900" dirty="0">
+                        <a:rPr lang="en-US" sz="1200" dirty="0">
                           <a:solidFill>
                             <a:srgbClr val="2D2A26"/>
                           </a:solidFill>
@@ -19782,7 +19782,7 @@
                         </a:rPr>
                         <a:t>$0</a:t>
                       </a:r>
-                      <a:endParaRPr lang="en-US" sz="900" dirty="0">
+                      <a:endParaRPr lang="en-US" sz="1200" dirty="0">
                         <a:latin typeface="Calibri" charset="0"/>
                         <a:ea typeface="Calibri" charset="0"/>
                         <a:cs typeface="Calibri" charset="0"/>
@@ -19842,7 +19842,7 @@
                         <a:buNone/>
                       </a:pPr>
                       <a:r>
-                        <a:rPr lang="en-US" sz="950" b="1" dirty="0">
+                        <a:rPr lang="en-US" sz="1200" b="1" dirty="0">
                           <a:solidFill>
                             <a:srgbClr val="5D300F"/>
                           </a:solidFill>
@@ -19852,7 +19852,7 @@
                         </a:rPr>
                         <a:t>GROUP TOTAL</a:t>
                       </a:r>
-                      <a:endParaRPr lang="en-US" sz="950" dirty="0">
+                      <a:endParaRPr lang="en-US" sz="1200" dirty="0">
                         <a:latin typeface="Century Gothic" charset="0"/>
                         <a:ea typeface="Century Gothic" charset="0"/>
                         <a:cs typeface="Century Gothic" charset="0"/>
@@ -19910,7 +19910,7 @@
                         <a:buNone/>
                       </a:pPr>
                       <a:r>
-                        <a:rPr lang="en-US" sz="950" b="1" dirty="0">
+                        <a:rPr lang="en-US" sz="1200" b="1" dirty="0">
                           <a:solidFill>
                             <a:srgbClr val="5D300F"/>
                           </a:solidFill>
@@ -19920,7 +19920,7 @@
                         </a:rPr>
                         <a:t>$1,885,356</a:t>
                       </a:r>
-                      <a:endParaRPr lang="en-US" sz="950" dirty="0">
+                      <a:endParaRPr lang="en-US" sz="1200" dirty="0">
                         <a:latin typeface="Calibri" charset="0"/>
                         <a:ea typeface="Calibri" charset="0"/>
                         <a:cs typeface="Calibri" charset="0"/>
@@ -19978,7 +19978,7 @@
                         <a:buNone/>
                       </a:pPr>
                       <a:r>
-                        <a:rPr lang="en-US" sz="950" b="1" dirty="0">
+                        <a:rPr lang="en-US" sz="1200" b="1" dirty="0">
                           <a:solidFill>
                             <a:srgbClr val="5D300F"/>
                           </a:solidFill>
@@ -19988,7 +19988,7 @@
                         </a:rPr>
                         <a:t>$-330,066</a:t>
                       </a:r>
-                      <a:endParaRPr lang="en-US" sz="950" dirty="0">
+                      <a:endParaRPr lang="en-US" sz="1200" dirty="0">
                         <a:latin typeface="Calibri" charset="0"/>
                         <a:ea typeface="Calibri" charset="0"/>
                         <a:cs typeface="Calibri" charset="0"/>
@@ -20046,7 +20046,7 @@
                         <a:buNone/>
                       </a:pPr>
                       <a:r>
-                        <a:rPr lang="en-US" sz="950" b="1" dirty="0">
+                        <a:rPr lang="en-US" sz="1200" b="1" dirty="0">
                           <a:solidFill>
                             <a:srgbClr val="5D300F"/>
                           </a:solidFill>
@@ -20056,7 +20056,7 @@
                         </a:rPr>
                         <a:t>$-1,240,449</a:t>
                       </a:r>
-                      <a:endParaRPr lang="en-US" sz="950" dirty="0">
+                      <a:endParaRPr lang="en-US" sz="1200" dirty="0">
                         <a:latin typeface="Calibri" charset="0"/>
                         <a:ea typeface="Calibri" charset="0"/>
                         <a:cs typeface="Calibri" charset="0"/>
@@ -20114,7 +20114,7 @@
                         <a:buNone/>
                       </a:pPr>
                       <a:r>
-                        <a:rPr lang="en-US" sz="950" b="1" dirty="0">
+                        <a:rPr lang="en-US" sz="1200" b="1" dirty="0">
                           <a:solidFill>
                             <a:srgbClr val="2D2A26"/>
                           </a:solidFill>
@@ -20124,7 +20124,7 @@
                         </a:rPr>
                         <a:t>$314,841</a:t>
                       </a:r>
-                      <a:endParaRPr lang="en-US" sz="950" dirty="0">
+                      <a:endParaRPr lang="en-US" sz="1200" dirty="0">
                         <a:latin typeface="Calibri" charset="0"/>
                         <a:ea typeface="Calibri" charset="0"/>
                         <a:cs typeface="Calibri" charset="0"/>
@@ -20182,7 +20182,7 @@
                         <a:buNone/>
                       </a:pPr>
                       <a:r>
-                        <a:rPr lang="en-US" sz="950" b="1" dirty="0">
+                        <a:rPr lang="en-US" sz="1200" b="1" dirty="0">
                           <a:solidFill>
                             <a:srgbClr val="5D300F"/>
                           </a:solidFill>
@@ -20192,7 +20192,7 @@
                         </a:rPr>
                         <a:t>16.7%</a:t>
                       </a:r>
-                      <a:endParaRPr lang="en-US" sz="950" dirty="0">
+                      <a:endParaRPr lang="en-US" sz="1200" dirty="0">
                         <a:latin typeface="Calibri" charset="0"/>
                         <a:ea typeface="Calibri" charset="0"/>
                         <a:cs typeface="Calibri" charset="0"/>
@@ -20250,7 +20250,7 @@
                         <a:buNone/>
                       </a:pPr>
                       <a:r>
-                        <a:rPr lang="en-US" sz="950" b="1" dirty="0">
+                        <a:rPr lang="en-US" sz="1200" b="1" dirty="0">
                           <a:solidFill>
                             <a:srgbClr val="5D300F"/>
                           </a:solidFill>
@@ -20260,7 +20260,7 @@
                         </a:rPr>
                         <a:t>$-507,344</a:t>
                       </a:r>
-                      <a:endParaRPr lang="en-US" sz="950" dirty="0">
+                      <a:endParaRPr lang="en-US" sz="1200" dirty="0">
                         <a:latin typeface="Calibri" charset="0"/>
                         <a:ea typeface="Calibri" charset="0"/>
                         <a:cs typeface="Calibri" charset="0"/>

</xml_diff>

<commit_message>
Auto-build: 2026-03-12 02:41 UTC
</commit_message>
<xml_diff>
--- a/reports/2026-01.pptx
+++ b/reports/2026-01.pptx
@@ -17862,7 +17862,7 @@
                       <a:r>
                         <a:rPr lang="en-US" sz="1200" dirty="0">
                           <a:solidFill>
-                            <a:srgbClr val="2D2A26"/>
+                            <a:srgbClr val="C0392B"/>
                           </a:solidFill>
                           <a:latin typeface="Calibri" pitchFamily="34" charset="0"/>
                           <a:ea typeface="Calibri" pitchFamily="34" charset="-122"/>
@@ -18750,7 +18750,7 @@
                       <a:r>
                         <a:rPr lang="en-US" sz="1200" dirty="0">
                           <a:solidFill>
-                            <a:srgbClr val="2D2A26"/>
+                            <a:srgbClr val="C0392B"/>
                           </a:solidFill>
                           <a:latin typeface="Calibri" pitchFamily="34" charset="0"/>
                           <a:ea typeface="Calibri" pitchFamily="34" charset="-122"/>
@@ -18818,7 +18818,7 @@
                       <a:r>
                         <a:rPr lang="en-US" sz="1200" dirty="0">
                           <a:solidFill>
-                            <a:srgbClr val="2D2A26"/>
+                            <a:srgbClr val="C0392B"/>
                           </a:solidFill>
                           <a:latin typeface="Calibri" pitchFamily="34" charset="0"/>
                           <a:ea typeface="Calibri" pitchFamily="34" charset="-122"/>
@@ -19296,7 +19296,7 @@
                       <a:r>
                         <a:rPr lang="en-US" sz="1200" dirty="0">
                           <a:solidFill>
-                            <a:srgbClr val="2D2A26"/>
+                            <a:srgbClr val="C0392B"/>
                           </a:solidFill>
                           <a:latin typeface="Calibri" pitchFamily="34" charset="0"/>
                           <a:ea typeface="Calibri" pitchFamily="34" charset="-122"/>
@@ -19706,7 +19706,7 @@
                       <a:r>
                         <a:rPr lang="en-US" sz="1200" dirty="0">
                           <a:solidFill>
-                            <a:srgbClr val="2D2A26"/>
+                            <a:srgbClr val="C0392B"/>
                           </a:solidFill>
                           <a:latin typeface="Calibri" pitchFamily="34" charset="0"/>
                           <a:ea typeface="Calibri" pitchFamily="34" charset="-122"/>
@@ -20116,7 +20116,7 @@
                       <a:r>
                         <a:rPr lang="en-US" sz="1200" b="1" dirty="0">
                           <a:solidFill>
-                            <a:srgbClr val="2D2A26"/>
+                            <a:srgbClr val="5D300F"/>
                           </a:solidFill>
                           <a:latin typeface="Calibri" pitchFamily="34" charset="0"/>
                           <a:ea typeface="Calibri" pitchFamily="34" charset="-122"/>
@@ -20252,7 +20252,7 @@
                       <a:r>
                         <a:rPr lang="en-US" sz="1200" b="1" dirty="0">
                           <a:solidFill>
-                            <a:srgbClr val="5D300F"/>
+                            <a:srgbClr val="C0392B"/>
                           </a:solidFill>
                           <a:latin typeface="Calibri" pitchFamily="34" charset="0"/>
                           <a:ea typeface="Calibri" pitchFamily="34" charset="-122"/>

</xml_diff>

<commit_message>
Auto-build: 2026-03-12 15:29 UTC
</commit_message>
<xml_diff>
--- a/reports/2026-01.pptx
+++ b/reports/2026-01.pptx
@@ -118,7 +118,7 @@
 </p:presentation>
 </file>
 
-<file path=ppt/charts/chart1.xml><?xml version="1.0" encoding="utf-8"?>
+<file path=ppt/charts/chart10.xml><?xml version="1.0" encoding="utf-8"?>
 <c:chartSpace xmlns:c="http://schemas.openxmlformats.org/drawingml/2006/chart" xmlns:a="http://schemas.openxmlformats.org/drawingml/2006/main" xmlns:r="http://schemas.openxmlformats.org/officeDocument/2006/relationships">
   <c:date1904 val="0"/>
   <c:roundedCorners val="0"/>
@@ -418,7 +418,7 @@
 </c:chartSpace>
 </file>
 
-<file path=ppt/charts/chart2.xml><?xml version="1.0" encoding="utf-8"?>
+<file path=ppt/charts/chart11.xml><?xml version="1.0" encoding="utf-8"?>
 <c:chartSpace xmlns:c="http://schemas.openxmlformats.org/drawingml/2006/chart" xmlns:a="http://schemas.openxmlformats.org/drawingml/2006/main" xmlns:r="http://schemas.openxmlformats.org/officeDocument/2006/relationships">
   <c:date1904 val="0"/>
   <c:roundedCorners val="0"/>
@@ -718,7 +718,7 @@
 </c:chartSpace>
 </file>
 
-<file path=ppt/charts/chart3.xml><?xml version="1.0" encoding="utf-8"?>
+<file path=ppt/charts/chart12.xml><?xml version="1.0" encoding="utf-8"?>
 <c:chartSpace xmlns:c="http://schemas.openxmlformats.org/drawingml/2006/chart" xmlns:a="http://schemas.openxmlformats.org/drawingml/2006/main" xmlns:r="http://schemas.openxmlformats.org/officeDocument/2006/relationships">
   <c:date1904 val="0"/>
   <c:roundedCorners val="0"/>
@@ -1018,7 +1018,7 @@
 </c:chartSpace>
 </file>
 
-<file path=ppt/charts/chart4.xml><?xml version="1.0" encoding="utf-8"?>
+<file path=ppt/charts/chart13.xml><?xml version="1.0" encoding="utf-8"?>
 <c:chartSpace xmlns:c="http://schemas.openxmlformats.org/drawingml/2006/chart" xmlns:a="http://schemas.openxmlformats.org/drawingml/2006/main" xmlns:r="http://schemas.openxmlformats.org/officeDocument/2006/relationships">
   <c:date1904 val="0"/>
   <c:roundedCorners val="0"/>
@@ -1318,7 +1318,7 @@
 </c:chartSpace>
 </file>
 
-<file path=ppt/charts/chart5.xml><?xml version="1.0" encoding="utf-8"?>
+<file path=ppt/charts/chart14.xml><?xml version="1.0" encoding="utf-8"?>
 <c:chartSpace xmlns:c="http://schemas.openxmlformats.org/drawingml/2006/chart" xmlns:a="http://schemas.openxmlformats.org/drawingml/2006/main" xmlns:r="http://schemas.openxmlformats.org/officeDocument/2006/relationships">
   <c:date1904 val="0"/>
   <c:roundedCorners val="0"/>
@@ -1618,7 +1618,7 @@
 </c:chartSpace>
 </file>
 
-<file path=ppt/charts/chart6.xml><?xml version="1.0" encoding="utf-8"?>
+<file path=ppt/charts/chart15.xml><?xml version="1.0" encoding="utf-8"?>
 <c:chartSpace xmlns:c="http://schemas.openxmlformats.org/drawingml/2006/chart" xmlns:a="http://schemas.openxmlformats.org/drawingml/2006/main" xmlns:r="http://schemas.openxmlformats.org/officeDocument/2006/relationships">
   <c:date1904 val="0"/>
   <c:roundedCorners val="0"/>
@@ -1918,7 +1918,7 @@
 </c:chartSpace>
 </file>
 
-<file path=ppt/charts/chart7.xml><?xml version="1.0" encoding="utf-8"?>
+<file path=ppt/charts/chart16.xml><?xml version="1.0" encoding="utf-8"?>
 <c:chartSpace xmlns:c="http://schemas.openxmlformats.org/drawingml/2006/chart" xmlns:a="http://schemas.openxmlformats.org/drawingml/2006/main" xmlns:r="http://schemas.openxmlformats.org/officeDocument/2006/relationships">
   <c:date1904 val="0"/>
   <c:roundedCorners val="0"/>
@@ -2218,7 +2218,7 @@
 </c:chartSpace>
 </file>
 
-<file path=ppt/charts/chart8.xml><?xml version="1.0" encoding="utf-8"?>
+<file path=ppt/charts/chart17.xml><?xml version="1.0" encoding="utf-8"?>
 <c:chartSpace xmlns:c="http://schemas.openxmlformats.org/drawingml/2006/chart" xmlns:a="http://schemas.openxmlformats.org/drawingml/2006/main" xmlns:r="http://schemas.openxmlformats.org/officeDocument/2006/relationships">
   <c:date1904 val="0"/>
   <c:roundedCorners val="0"/>
@@ -2518,7 +2518,7 @@
 </c:chartSpace>
 </file>
 
-<file path=ppt/charts/chart9.xml><?xml version="1.0" encoding="utf-8"?>
+<file path=ppt/charts/chart18.xml><?xml version="1.0" encoding="utf-8"?>
 <c:chartSpace xmlns:c="http://schemas.openxmlformats.org/drawingml/2006/chart" xmlns:a="http://schemas.openxmlformats.org/drawingml/2006/main" xmlns:r="http://schemas.openxmlformats.org/officeDocument/2006/relationships">
   <c:date1904 val="0"/>
   <c:roundedCorners val="0"/>
@@ -7676,7 +7676,7 @@
                 <a:ea typeface="Century Gothic" pitchFamily="34" charset="-122"/>
                 <a:cs typeface="Century Gothic" pitchFamily="34" charset="-120"/>
               </a:rPr>
-              <a:t>347</a:t>
+              <a:t>—</a:t>
             </a:r>
             <a:endParaRPr lang="en-US" sz="2600" dirty="0"/>
           </a:p>
@@ -7715,7 +7715,7 @@
                 <a:ea typeface="Calibri" pitchFamily="34" charset="-122"/>
                 <a:cs typeface="Calibri" pitchFamily="34" charset="-120"/>
               </a:rPr>
-              <a:t>Total Teams</a:t>
+              <a:t>Change vs Prior Month</a:t>
             </a:r>
             <a:endParaRPr lang="en-US" sz="1200" dirty="0"/>
           </a:p>
@@ -9853,6 +9853,141 @@
                 <a:ea typeface="Century Gothic" pitchFamily="34" charset="-122"/>
                 <a:cs typeface="Century Gothic" pitchFamily="34" charset="-120"/>
               </a:rPr>
+              <a:t>$11,349</a:t>
+            </a:r>
+            <a:endParaRPr lang="en-US" sz="2600" dirty="0"/>
+          </a:p>
+        </p:txBody>
+      </p:sp>
+      <p:sp>
+        <p:nvSpPr>
+          <p:cNvPr id="27" name="Text 24"/>
+          <p:cNvSpPr/>
+          <p:nvPr/>
+        </p:nvSpPr>
+        <p:spPr>
+          <a:xfrm>
+            <a:off x="8001000" y="2459736"/>
+            <a:ext cx="3977640" cy="420624"/>
+          </a:xfrm>
+          <a:prstGeom prst="rect">
+            <a:avLst/>
+          </a:prstGeom>
+          <a:noFill/>
+          <a:ln/>
+        </p:spPr>
+        <p:txBody>
+          <a:bodyPr wrap="square" rtlCol="0" anchor="ctr"/>
+          <a:lstStyle/>
+          <a:p>
+            <a:pPr algn="ctr" indent="0" marL="0">
+              <a:buNone/>
+            </a:pPr>
+            <a:r>
+              <a:rPr lang="en-US" sz="1200" dirty="0">
+                <a:solidFill>
+                  <a:srgbClr val="718096"/>
+                </a:solidFill>
+                <a:latin typeface="Calibri" pitchFamily="34" charset="0"/>
+                <a:ea typeface="Calibri" pitchFamily="34" charset="-122"/>
+                <a:cs typeface="Calibri" pitchFamily="34" charset="-120"/>
+              </a:rPr>
+              <a:t>Group Disb per Team</a:t>
+            </a:r>
+            <a:endParaRPr lang="en-US" sz="1200" dirty="0"/>
+          </a:p>
+        </p:txBody>
+      </p:sp>
+      <p:sp>
+        <p:nvSpPr>
+          <p:cNvPr id="28" name="Shape 25"/>
+          <p:cNvSpPr/>
+          <p:nvPr/>
+        </p:nvSpPr>
+        <p:spPr>
+          <a:xfrm>
+            <a:off x="7955280" y="2971800"/>
+            <a:ext cx="4069080" cy="731520"/>
+          </a:xfrm>
+          <a:prstGeom prst="rect">
+            <a:avLst/>
+          </a:prstGeom>
+          <a:solidFill>
+            <a:srgbClr val="FFFFFF"/>
+          </a:solidFill>
+          <a:ln w="12700">
+            <a:solidFill>
+              <a:srgbClr val="D6CFC4"/>
+            </a:solidFill>
+            <a:prstDash val="solid"/>
+          </a:ln>
+          <a:effectLst>
+            <a:outerShdw sx="100000" sy="100000" kx="0" ky="0" algn="bl" rotWithShape="0" blurRad="50800" dist="25400" dir="8100000">
+              <a:srgbClr val="000000">
+                <a:alpha val="8000"/>
+              </a:srgbClr>
+            </a:outerShdw>
+          </a:effectLst>
+        </p:spPr>
+      </p:sp>
+      <p:sp>
+        <p:nvSpPr>
+          <p:cNvPr id="29" name="Shape 26"/>
+          <p:cNvSpPr/>
+          <p:nvPr/>
+        </p:nvSpPr>
+        <p:spPr>
+          <a:xfrm>
+            <a:off x="7955280" y="2971800"/>
+            <a:ext cx="4069080" cy="45720"/>
+          </a:xfrm>
+          <a:prstGeom prst="rect">
+            <a:avLst/>
+          </a:prstGeom>
+          <a:solidFill>
+            <a:srgbClr val="5D300F"/>
+          </a:solidFill>
+          <a:ln w="12700">
+            <a:solidFill>
+              <a:srgbClr val="5D300F"/>
+            </a:solidFill>
+            <a:prstDash val="solid"/>
+          </a:ln>
+        </p:spPr>
+      </p:sp>
+      <p:sp>
+        <p:nvSpPr>
+          <p:cNvPr id="30" name="Text 27"/>
+          <p:cNvSpPr/>
+          <p:nvPr/>
+        </p:nvSpPr>
+        <p:spPr>
+          <a:xfrm>
+            <a:off x="7955280" y="3063240"/>
+            <a:ext cx="4069080" cy="402336"/>
+          </a:xfrm>
+          <a:prstGeom prst="rect">
+            <a:avLst/>
+          </a:prstGeom>
+          <a:noFill/>
+          <a:ln/>
+        </p:spPr>
+        <p:txBody>
+          <a:bodyPr wrap="square" rtlCol="0" anchor="ctr"/>
+          <a:lstStyle/>
+          <a:p>
+            <a:pPr algn="ctr" indent="0" marL="0">
+              <a:buNone/>
+            </a:pPr>
+            <a:r>
+              <a:rPr lang="en-US" sz="2600" b="1" dirty="0">
+                <a:solidFill>
+                  <a:srgbClr val="5D300F"/>
+                </a:solidFill>
+                <a:latin typeface="Century Gothic" pitchFamily="34" charset="0"/>
+                <a:ea typeface="Century Gothic" pitchFamily="34" charset="-122"/>
+                <a:cs typeface="Century Gothic" pitchFamily="34" charset="-120"/>
+              </a:rPr>
               <a:t>—</a:t>
             </a:r>
             <a:endParaRPr lang="en-US" sz="2600" dirty="0"/>
@@ -9861,14 +9996,14 @@
       </p:sp>
       <p:sp>
         <p:nvSpPr>
-          <p:cNvPr id="27" name="Text 24"/>
-          <p:cNvSpPr/>
-          <p:nvPr/>
-        </p:nvSpPr>
-        <p:spPr>
-          <a:xfrm>
-            <a:off x="8001000" y="2459736"/>
-            <a:ext cx="3977640" cy="420624"/>
+          <p:cNvPr id="31" name="Text 28"/>
+          <p:cNvSpPr/>
+          <p:nvPr/>
+        </p:nvSpPr>
+        <p:spPr>
+          <a:xfrm>
+            <a:off x="8001000" y="3410712"/>
+            <a:ext cx="3977640" cy="292608"/>
           </a:xfrm>
           <a:prstGeom prst="rect">
             <a:avLst/>
@@ -9900,13 +10035,13 @@
       </p:sp>
       <p:sp>
         <p:nvSpPr>
-          <p:cNvPr id="28" name="Shape 25"/>
-          <p:cNvSpPr/>
-          <p:nvPr/>
-        </p:nvSpPr>
-        <p:spPr>
-          <a:xfrm>
-            <a:off x="7955280" y="2971800"/>
+          <p:cNvPr id="32" name="Shape 29"/>
+          <p:cNvSpPr/>
+          <p:nvPr/>
+        </p:nvSpPr>
+        <p:spPr>
+          <a:xfrm>
+            <a:off x="7955280" y="3794760"/>
             <a:ext cx="4069080" cy="292608"/>
           </a:xfrm>
           <a:prstGeom prst="rect">
@@ -9925,13 +10060,13 @@
       </p:sp>
       <p:sp>
         <p:nvSpPr>
-          <p:cNvPr id="29" name="Shape 26"/>
-          <p:cNvSpPr/>
-          <p:nvPr/>
-        </p:nvSpPr>
-        <p:spPr>
-          <a:xfrm>
-            <a:off x="7955280" y="2971800"/>
+          <p:cNvPr id="33" name="Shape 30"/>
+          <p:cNvSpPr/>
+          <p:nvPr/>
+        </p:nvSpPr>
+        <p:spPr>
+          <a:xfrm>
+            <a:off x="7955280" y="3794760"/>
             <a:ext cx="54864" cy="292608"/>
           </a:xfrm>
           <a:prstGeom prst="rect">
@@ -9950,13 +10085,13 @@
       </p:sp>
       <p:sp>
         <p:nvSpPr>
-          <p:cNvPr id="30" name="Text 27"/>
-          <p:cNvSpPr/>
-          <p:nvPr/>
-        </p:nvSpPr>
-        <p:spPr>
-          <a:xfrm>
-            <a:off x="8065008" y="2971800"/>
+          <p:cNvPr id="34" name="Text 31"/>
+          <p:cNvSpPr/>
+          <p:nvPr/>
+        </p:nvSpPr>
+        <p:spPr>
+          <a:xfrm>
+            <a:off x="8065008" y="3794760"/>
             <a:ext cx="3959352" cy="292608"/>
           </a:xfrm>
           <a:prstGeom prst="rect">
@@ -9989,13 +10124,13 @@
       </p:sp>
       <p:sp>
         <p:nvSpPr>
-          <p:cNvPr id="31" name="Shape 28"/>
-          <p:cNvSpPr/>
-          <p:nvPr/>
-        </p:nvSpPr>
-        <p:spPr>
-          <a:xfrm>
-            <a:off x="7955280" y="3310128"/>
+          <p:cNvPr id="35" name="Shape 32"/>
+          <p:cNvSpPr/>
+          <p:nvPr/>
+        </p:nvSpPr>
+        <p:spPr>
+          <a:xfrm>
+            <a:off x="7955280" y="4133088"/>
             <a:ext cx="1234440" cy="566928"/>
           </a:xfrm>
           <a:prstGeom prst="rect">
@@ -10014,13 +10149,13 @@
       </p:sp>
       <p:sp>
         <p:nvSpPr>
-          <p:cNvPr id="32" name="Text 29"/>
-          <p:cNvSpPr/>
-          <p:nvPr/>
-        </p:nvSpPr>
-        <p:spPr>
-          <a:xfrm>
-            <a:off x="7955280" y="3310128"/>
+          <p:cNvPr id="36" name="Text 33"/>
+          <p:cNvSpPr/>
+          <p:nvPr/>
+        </p:nvSpPr>
+        <p:spPr>
+          <a:xfrm>
+            <a:off x="7955280" y="4133088"/>
             <a:ext cx="1234440" cy="256032"/>
           </a:xfrm>
           <a:prstGeom prst="rect">
@@ -10053,13 +10188,13 @@
       </p:sp>
       <p:sp>
         <p:nvSpPr>
-          <p:cNvPr id="33" name="Text 30"/>
-          <p:cNvSpPr/>
-          <p:nvPr/>
-        </p:nvSpPr>
-        <p:spPr>
-          <a:xfrm>
-            <a:off x="7955280" y="3566160"/>
+          <p:cNvPr id="37" name="Text 34"/>
+          <p:cNvSpPr/>
+          <p:nvPr/>
+        </p:nvSpPr>
+        <p:spPr>
+          <a:xfrm>
+            <a:off x="7955280" y="4389120"/>
             <a:ext cx="1234440" cy="310896"/>
           </a:xfrm>
           <a:prstGeom prst="rect">
@@ -10092,13 +10227,13 @@
       </p:sp>
       <p:sp>
         <p:nvSpPr>
-          <p:cNvPr id="34" name="Shape 31"/>
-          <p:cNvSpPr/>
-          <p:nvPr/>
-        </p:nvSpPr>
-        <p:spPr>
-          <a:xfrm>
-            <a:off x="9308592" y="3310128"/>
+          <p:cNvPr id="38" name="Shape 35"/>
+          <p:cNvSpPr/>
+          <p:nvPr/>
+        </p:nvSpPr>
+        <p:spPr>
+          <a:xfrm>
+            <a:off x="9308592" y="4133088"/>
             <a:ext cx="1234440" cy="566928"/>
           </a:xfrm>
           <a:prstGeom prst="rect">
@@ -10117,13 +10252,13 @@
       </p:sp>
       <p:sp>
         <p:nvSpPr>
-          <p:cNvPr id="35" name="Text 32"/>
-          <p:cNvSpPr/>
-          <p:nvPr/>
-        </p:nvSpPr>
-        <p:spPr>
-          <a:xfrm>
-            <a:off x="9308592" y="3310128"/>
+          <p:cNvPr id="39" name="Text 36"/>
+          <p:cNvSpPr/>
+          <p:nvPr/>
+        </p:nvSpPr>
+        <p:spPr>
+          <a:xfrm>
+            <a:off x="9308592" y="4133088"/>
             <a:ext cx="1234440" cy="256032"/>
           </a:xfrm>
           <a:prstGeom prst="rect">
@@ -10156,13 +10291,13 @@
       </p:sp>
       <p:sp>
         <p:nvSpPr>
-          <p:cNvPr id="36" name="Text 33"/>
-          <p:cNvSpPr/>
-          <p:nvPr/>
-        </p:nvSpPr>
-        <p:spPr>
-          <a:xfrm>
-            <a:off x="9308592" y="3566160"/>
+          <p:cNvPr id="40" name="Text 37"/>
+          <p:cNvSpPr/>
+          <p:nvPr/>
+        </p:nvSpPr>
+        <p:spPr>
+          <a:xfrm>
+            <a:off x="9308592" y="4389120"/>
             <a:ext cx="1234440" cy="310896"/>
           </a:xfrm>
           <a:prstGeom prst="rect">
@@ -10195,13 +10330,13 @@
       </p:sp>
       <p:sp>
         <p:nvSpPr>
-          <p:cNvPr id="37" name="Shape 34"/>
-          <p:cNvSpPr/>
-          <p:nvPr/>
-        </p:nvSpPr>
-        <p:spPr>
-          <a:xfrm>
-            <a:off x="10661904" y="3310128"/>
+          <p:cNvPr id="41" name="Shape 38"/>
+          <p:cNvSpPr/>
+          <p:nvPr/>
+        </p:nvSpPr>
+        <p:spPr>
+          <a:xfrm>
+            <a:off x="10661904" y="4133088"/>
             <a:ext cx="1234440" cy="566928"/>
           </a:xfrm>
           <a:prstGeom prst="rect">
@@ -10220,13 +10355,13 @@
       </p:sp>
       <p:sp>
         <p:nvSpPr>
-          <p:cNvPr id="38" name="Text 35"/>
-          <p:cNvSpPr/>
-          <p:nvPr/>
-        </p:nvSpPr>
-        <p:spPr>
-          <a:xfrm>
-            <a:off x="10661904" y="3310128"/>
+          <p:cNvPr id="42" name="Text 39"/>
+          <p:cNvSpPr/>
+          <p:nvPr/>
+        </p:nvSpPr>
+        <p:spPr>
+          <a:xfrm>
+            <a:off x="10661904" y="4133088"/>
             <a:ext cx="1234440" cy="256032"/>
           </a:xfrm>
           <a:prstGeom prst="rect">
@@ -10259,13 +10394,13 @@
       </p:sp>
       <p:sp>
         <p:nvSpPr>
-          <p:cNvPr id="39" name="Text 36"/>
-          <p:cNvSpPr/>
-          <p:nvPr/>
-        </p:nvSpPr>
-        <p:spPr>
-          <a:xfrm>
-            <a:off x="10661904" y="3566160"/>
+          <p:cNvPr id="43" name="Text 40"/>
+          <p:cNvSpPr/>
+          <p:nvPr/>
+        </p:nvSpPr>
+        <p:spPr>
+          <a:xfrm>
+            <a:off x="10661904" y="4389120"/>
             <a:ext cx="1234440" cy="310896"/>
           </a:xfrm>
           <a:prstGeom prst="rect">
@@ -10298,13 +10433,13 @@
       </p:sp>
       <p:sp>
         <p:nvSpPr>
-          <p:cNvPr id="40" name="Shape 37"/>
-          <p:cNvSpPr/>
-          <p:nvPr/>
-        </p:nvSpPr>
-        <p:spPr>
-          <a:xfrm>
-            <a:off x="7955280" y="3968496"/>
+          <p:cNvPr id="44" name="Shape 41"/>
+          <p:cNvSpPr/>
+          <p:nvPr/>
+        </p:nvSpPr>
+        <p:spPr>
+          <a:xfrm>
+            <a:off x="7955280" y="4791456"/>
             <a:ext cx="1234440" cy="566928"/>
           </a:xfrm>
           <a:prstGeom prst="rect">
@@ -10323,13 +10458,13 @@
       </p:sp>
       <p:sp>
         <p:nvSpPr>
-          <p:cNvPr id="41" name="Text 38"/>
-          <p:cNvSpPr/>
-          <p:nvPr/>
-        </p:nvSpPr>
-        <p:spPr>
-          <a:xfrm>
-            <a:off x="7955280" y="3968496"/>
+          <p:cNvPr id="45" name="Text 42"/>
+          <p:cNvSpPr/>
+          <p:nvPr/>
+        </p:nvSpPr>
+        <p:spPr>
+          <a:xfrm>
+            <a:off x="7955280" y="4791456"/>
             <a:ext cx="1234440" cy="256032"/>
           </a:xfrm>
           <a:prstGeom prst="rect">
@@ -10362,13 +10497,13 @@
       </p:sp>
       <p:sp>
         <p:nvSpPr>
-          <p:cNvPr id="42" name="Text 39"/>
-          <p:cNvSpPr/>
-          <p:nvPr/>
-        </p:nvSpPr>
-        <p:spPr>
-          <a:xfrm>
-            <a:off x="7955280" y="4224528"/>
+          <p:cNvPr id="46" name="Text 43"/>
+          <p:cNvSpPr/>
+          <p:nvPr/>
+        </p:nvSpPr>
+        <p:spPr>
+          <a:xfrm>
+            <a:off x="7955280" y="5047488"/>
             <a:ext cx="1234440" cy="310896"/>
           </a:xfrm>
           <a:prstGeom prst="rect">
@@ -10401,13 +10536,13 @@
       </p:sp>
       <p:sp>
         <p:nvSpPr>
-          <p:cNvPr id="43" name="Shape 40"/>
-          <p:cNvSpPr/>
-          <p:nvPr/>
-        </p:nvSpPr>
-        <p:spPr>
-          <a:xfrm>
-            <a:off x="9308592" y="3968496"/>
+          <p:cNvPr id="47" name="Shape 44"/>
+          <p:cNvSpPr/>
+          <p:nvPr/>
+        </p:nvSpPr>
+        <p:spPr>
+          <a:xfrm>
+            <a:off x="9308592" y="4791456"/>
             <a:ext cx="1234440" cy="566928"/>
           </a:xfrm>
           <a:prstGeom prst="rect">
@@ -10426,13 +10561,13 @@
       </p:sp>
       <p:sp>
         <p:nvSpPr>
-          <p:cNvPr id="44" name="Text 41"/>
-          <p:cNvSpPr/>
-          <p:nvPr/>
-        </p:nvSpPr>
-        <p:spPr>
-          <a:xfrm>
-            <a:off x="9308592" y="3968496"/>
+          <p:cNvPr id="48" name="Text 45"/>
+          <p:cNvSpPr/>
+          <p:nvPr/>
+        </p:nvSpPr>
+        <p:spPr>
+          <a:xfrm>
+            <a:off x="9308592" y="4791456"/>
             <a:ext cx="1234440" cy="256032"/>
           </a:xfrm>
           <a:prstGeom prst="rect">
@@ -10465,13 +10600,13 @@
       </p:sp>
       <p:sp>
         <p:nvSpPr>
-          <p:cNvPr id="45" name="Text 42"/>
-          <p:cNvSpPr/>
-          <p:nvPr/>
-        </p:nvSpPr>
-        <p:spPr>
-          <a:xfrm>
-            <a:off x="9308592" y="4224528"/>
+          <p:cNvPr id="49" name="Text 46"/>
+          <p:cNvSpPr/>
+          <p:nvPr/>
+        </p:nvSpPr>
+        <p:spPr>
+          <a:xfrm>
+            <a:off x="9308592" y="5047488"/>
             <a:ext cx="1234440" cy="310896"/>
           </a:xfrm>
           <a:prstGeom prst="rect">
@@ -10504,14 +10639,14 @@
       </p:sp>
       <p:sp>
         <p:nvSpPr>
-          <p:cNvPr id="46" name="Shape 43"/>
-          <p:cNvSpPr/>
-          <p:nvPr/>
-        </p:nvSpPr>
-        <p:spPr>
-          <a:xfrm>
-            <a:off x="7955280" y="4663440"/>
-            <a:ext cx="4069080" cy="1892808"/>
+          <p:cNvPr id="50" name="Shape 47"/>
+          <p:cNvSpPr/>
+          <p:nvPr/>
+        </p:nvSpPr>
+        <p:spPr>
+          <a:xfrm>
+            <a:off x="7955280" y="5577840"/>
+            <a:ext cx="4069080" cy="978408"/>
           </a:xfrm>
           <a:prstGeom prst="rect">
             <a:avLst/>
@@ -10529,14 +10664,14 @@
       </p:sp>
       <p:sp>
         <p:nvSpPr>
-          <p:cNvPr id="47" name="Shape 44"/>
-          <p:cNvSpPr/>
-          <p:nvPr/>
-        </p:nvSpPr>
-        <p:spPr>
-          <a:xfrm>
-            <a:off x="7955280" y="4663440"/>
-            <a:ext cx="54864" cy="1892808"/>
+          <p:cNvPr id="51" name="Shape 48"/>
+          <p:cNvSpPr/>
+          <p:nvPr/>
+        </p:nvSpPr>
+        <p:spPr>
+          <a:xfrm>
+            <a:off x="7955280" y="5577840"/>
+            <a:ext cx="54864" cy="978408"/>
           </a:xfrm>
           <a:prstGeom prst="rect">
             <a:avLst/>
@@ -10554,13 +10689,13 @@
       </p:sp>
       <p:sp>
         <p:nvSpPr>
-          <p:cNvPr id="48" name="Text 45"/>
-          <p:cNvSpPr/>
-          <p:nvPr/>
-        </p:nvSpPr>
-        <p:spPr>
-          <a:xfrm>
-            <a:off x="8065008" y="4718304"/>
+          <p:cNvPr id="52" name="Text 49"/>
+          <p:cNvSpPr/>
+          <p:nvPr/>
+        </p:nvSpPr>
+        <p:spPr>
+          <a:xfrm>
+            <a:off x="8065008" y="5632704"/>
             <a:ext cx="3886200" cy="228600"/>
           </a:xfrm>
           <a:prstGeom prst="rect">
@@ -10593,14 +10728,14 @@
       </p:sp>
       <p:sp>
         <p:nvSpPr>
-          <p:cNvPr id="49" name="Text 46"/>
-          <p:cNvSpPr/>
-          <p:nvPr/>
-        </p:nvSpPr>
-        <p:spPr>
-          <a:xfrm>
-            <a:off x="8065008" y="4983480"/>
-            <a:ext cx="3886200" cy="1481328"/>
+          <p:cNvPr id="53" name="Text 50"/>
+          <p:cNvSpPr/>
+          <p:nvPr/>
+        </p:nvSpPr>
+        <p:spPr>
+          <a:xfrm>
+            <a:off x="8065008" y="5897880"/>
+            <a:ext cx="3886200" cy="566928"/>
           </a:xfrm>
           <a:prstGeom prst="rect">
             <a:avLst/>
@@ -14641,6 +14776,280 @@
                   </a:tcPr>
                 </a:tc>
               </a:tr>
+              <a:tr h="384048">
+                <a:tc>
+                  <a:txBody>
+                    <a:bodyPr/>
+                    <a:lstStyle/>
+                    <a:p>
+                      <a:pPr algn="l" indent="0" marL="0">
+                        <a:buNone/>
+                      </a:pPr>
+                      <a:r>
+                        <a:rPr lang="en-US" sz="1200" b="1" dirty="0">
+                          <a:solidFill>
+                            <a:srgbClr val="5D300F"/>
+                          </a:solidFill>
+                          <a:latin typeface="Century Gothic" pitchFamily="34" charset="0"/>
+                          <a:ea typeface="Century Gothic" pitchFamily="34" charset="-122"/>
+                          <a:cs typeface="Century Gothic" pitchFamily="34" charset="-120"/>
+                        </a:rPr>
+                        <a:t>GROUP TOTAL</a:t>
+                      </a:r>
+                      <a:endParaRPr lang="en-US" sz="1200" dirty="0">
+                        <a:latin typeface="Century Gothic" charset="0"/>
+                        <a:ea typeface="Century Gothic" charset="0"/>
+                        <a:cs typeface="Century Gothic" charset="0"/>
+                      </a:endParaRPr>
+                    </a:p>
+                  </a:txBody>
+                  <a:tcPr marL="91440" marR="91440" marT="45720" marB="45720" anchor="ctr">
+                    <a:lnL w="6350" cap="flat" cmpd="sng" algn="ctr">
+                      <a:solidFill>
+                        <a:srgbClr val="D6CFC4"/>
+                      </a:solidFill>
+                      <a:prstDash val="solid"/>
+                      <a:round/>
+                      <a:headEnd type="none" w="med" len="med"/>
+                      <a:tailEnd type="none" w="med" len="med"/>
+                    </a:lnL>
+                    <a:lnR w="6350" cap="flat" cmpd="sng" algn="ctr">
+                      <a:solidFill>
+                        <a:srgbClr val="D6CFC4"/>
+                      </a:solidFill>
+                      <a:prstDash val="solid"/>
+                      <a:round/>
+                      <a:headEnd type="none" w="med" len="med"/>
+                      <a:tailEnd type="none" w="med" len="med"/>
+                    </a:lnR>
+                    <a:lnT w="6350" cap="flat" cmpd="sng" algn="ctr">
+                      <a:solidFill>
+                        <a:srgbClr val="D6CFC4"/>
+                      </a:solidFill>
+                      <a:prstDash val="solid"/>
+                      <a:round/>
+                      <a:headEnd type="none" w="med" len="med"/>
+                      <a:tailEnd type="none" w="med" len="med"/>
+                    </a:lnT>
+                    <a:lnB w="6350" cap="flat" cmpd="sng" algn="ctr">
+                      <a:solidFill>
+                        <a:srgbClr val="D6CFC4"/>
+                      </a:solidFill>
+                      <a:prstDash val="solid"/>
+                      <a:round/>
+                      <a:headEnd type="none" w="med" len="med"/>
+                      <a:tailEnd type="none" w="med" len="med"/>
+                    </a:lnB>
+                    <a:solidFill>
+                      <a:srgbClr val="FFF9D9"/>
+                    </a:solidFill>
+                  </a:tcPr>
+                </a:tc>
+                <a:tc>
+                  <a:txBody>
+                    <a:bodyPr/>
+                    <a:lstStyle/>
+                    <a:p>
+                      <a:pPr algn="ctr" indent="0" marL="0">
+                        <a:buNone/>
+                      </a:pPr>
+                      <a:r>
+                        <a:rPr lang="en-US" sz="1200" b="1" dirty="0">
+                          <a:solidFill>
+                            <a:srgbClr val="5D300F"/>
+                          </a:solidFill>
+                          <a:latin typeface="Calibri" pitchFamily="34" charset="0"/>
+                          <a:ea typeface="Calibri" pitchFamily="34" charset="-122"/>
+                          <a:cs typeface="Calibri" pitchFamily="34" charset="-120"/>
+                        </a:rPr>
+                        <a:t>—</a:t>
+                      </a:r>
+                      <a:endParaRPr lang="en-US" sz="1200" dirty="0">
+                        <a:latin typeface="Calibri" charset="0"/>
+                        <a:ea typeface="Calibri" charset="0"/>
+                        <a:cs typeface="Calibri" charset="0"/>
+                      </a:endParaRPr>
+                    </a:p>
+                  </a:txBody>
+                  <a:tcPr marL="91440" marR="91440" marT="45720" marB="45720" anchor="ctr">
+                    <a:lnL w="6350" cap="flat" cmpd="sng" algn="ctr">
+                      <a:solidFill>
+                        <a:srgbClr val="D6CFC4"/>
+                      </a:solidFill>
+                      <a:prstDash val="solid"/>
+                      <a:round/>
+                      <a:headEnd type="none" w="med" len="med"/>
+                      <a:tailEnd type="none" w="med" len="med"/>
+                    </a:lnL>
+                    <a:lnR w="6350" cap="flat" cmpd="sng" algn="ctr">
+                      <a:solidFill>
+                        <a:srgbClr val="D6CFC4"/>
+                      </a:solidFill>
+                      <a:prstDash val="solid"/>
+                      <a:round/>
+                      <a:headEnd type="none" w="med" len="med"/>
+                      <a:tailEnd type="none" w="med" len="med"/>
+                    </a:lnR>
+                    <a:lnT w="6350" cap="flat" cmpd="sng" algn="ctr">
+                      <a:solidFill>
+                        <a:srgbClr val="D6CFC4"/>
+                      </a:solidFill>
+                      <a:prstDash val="solid"/>
+                      <a:round/>
+                      <a:headEnd type="none" w="med" len="med"/>
+                      <a:tailEnd type="none" w="med" len="med"/>
+                    </a:lnT>
+                    <a:lnB w="6350" cap="flat" cmpd="sng" algn="ctr">
+                      <a:solidFill>
+                        <a:srgbClr val="D6CFC4"/>
+                      </a:solidFill>
+                      <a:prstDash val="solid"/>
+                      <a:round/>
+                      <a:headEnd type="none" w="med" len="med"/>
+                      <a:tailEnd type="none" w="med" len="med"/>
+                    </a:lnB>
+                    <a:solidFill>
+                      <a:srgbClr val="FFF9D9"/>
+                    </a:solidFill>
+                  </a:tcPr>
+                </a:tc>
+                <a:tc>
+                  <a:txBody>
+                    <a:bodyPr/>
+                    <a:lstStyle/>
+                    <a:p>
+                      <a:pPr algn="ctr" indent="0" marL="0">
+                        <a:buNone/>
+                      </a:pPr>
+                      <a:r>
+                        <a:rPr lang="en-US" sz="1200" b="1" dirty="0">
+                          <a:solidFill>
+                            <a:srgbClr val="5D300F"/>
+                          </a:solidFill>
+                          <a:latin typeface="Calibri" pitchFamily="34" charset="0"/>
+                          <a:ea typeface="Calibri" pitchFamily="34" charset="-122"/>
+                          <a:cs typeface="Calibri" pitchFamily="34" charset="-120"/>
+                        </a:rPr>
+                        <a:t>5.6%</a:t>
+                      </a:r>
+                      <a:endParaRPr lang="en-US" sz="1200" dirty="0">
+                        <a:latin typeface="Calibri" charset="0"/>
+                        <a:ea typeface="Calibri" charset="0"/>
+                        <a:cs typeface="Calibri" charset="0"/>
+                      </a:endParaRPr>
+                    </a:p>
+                  </a:txBody>
+                  <a:tcPr marL="91440" marR="91440" marT="45720" marB="45720" anchor="ctr">
+                    <a:lnL w="6350" cap="flat" cmpd="sng" algn="ctr">
+                      <a:solidFill>
+                        <a:srgbClr val="D6CFC4"/>
+                      </a:solidFill>
+                      <a:prstDash val="solid"/>
+                      <a:round/>
+                      <a:headEnd type="none" w="med" len="med"/>
+                      <a:tailEnd type="none" w="med" len="med"/>
+                    </a:lnL>
+                    <a:lnR w="6350" cap="flat" cmpd="sng" algn="ctr">
+                      <a:solidFill>
+                        <a:srgbClr val="D6CFC4"/>
+                      </a:solidFill>
+                      <a:prstDash val="solid"/>
+                      <a:round/>
+                      <a:headEnd type="none" w="med" len="med"/>
+                      <a:tailEnd type="none" w="med" len="med"/>
+                    </a:lnR>
+                    <a:lnT w="6350" cap="flat" cmpd="sng" algn="ctr">
+                      <a:solidFill>
+                        <a:srgbClr val="D6CFC4"/>
+                      </a:solidFill>
+                      <a:prstDash val="solid"/>
+                      <a:round/>
+                      <a:headEnd type="none" w="med" len="med"/>
+                      <a:tailEnd type="none" w="med" len="med"/>
+                    </a:lnT>
+                    <a:lnB w="6350" cap="flat" cmpd="sng" algn="ctr">
+                      <a:solidFill>
+                        <a:srgbClr val="D6CFC4"/>
+                      </a:solidFill>
+                      <a:prstDash val="solid"/>
+                      <a:round/>
+                      <a:headEnd type="none" w="med" len="med"/>
+                      <a:tailEnd type="none" w="med" len="med"/>
+                    </a:lnB>
+                    <a:solidFill>
+                      <a:srgbClr val="FFF9D9"/>
+                    </a:solidFill>
+                  </a:tcPr>
+                </a:tc>
+                <a:tc>
+                  <a:txBody>
+                    <a:bodyPr/>
+                    <a:lstStyle/>
+                    <a:p>
+                      <a:pPr algn="ctr" indent="0" marL="0">
+                        <a:buNone/>
+                      </a:pPr>
+                      <a:r>
+                        <a:rPr lang="en-US" sz="1200" b="1" dirty="0">
+                          <a:solidFill>
+                            <a:srgbClr val="718096"/>
+                          </a:solidFill>
+                          <a:latin typeface="Calibri" pitchFamily="34" charset="0"/>
+                          <a:ea typeface="Calibri" pitchFamily="34" charset="-122"/>
+                          <a:cs typeface="Calibri" pitchFamily="34" charset="-120"/>
+                        </a:rPr>
+                        <a:t>—</a:t>
+                      </a:r>
+                      <a:endParaRPr lang="en-US" sz="1200" dirty="0">
+                        <a:latin typeface="Calibri" charset="0"/>
+                        <a:ea typeface="Calibri" charset="0"/>
+                        <a:cs typeface="Calibri" charset="0"/>
+                      </a:endParaRPr>
+                    </a:p>
+                  </a:txBody>
+                  <a:tcPr marL="91440" marR="91440" marT="45720" marB="45720" anchor="ctr">
+                    <a:lnL w="6350" cap="flat" cmpd="sng" algn="ctr">
+                      <a:solidFill>
+                        <a:srgbClr val="D6CFC4"/>
+                      </a:solidFill>
+                      <a:prstDash val="solid"/>
+                      <a:round/>
+                      <a:headEnd type="none" w="med" len="med"/>
+                      <a:tailEnd type="none" w="med" len="med"/>
+                    </a:lnL>
+                    <a:lnR w="6350" cap="flat" cmpd="sng" algn="ctr">
+                      <a:solidFill>
+                        <a:srgbClr val="D6CFC4"/>
+                      </a:solidFill>
+                      <a:prstDash val="solid"/>
+                      <a:round/>
+                      <a:headEnd type="none" w="med" len="med"/>
+                      <a:tailEnd type="none" w="med" len="med"/>
+                    </a:lnR>
+                    <a:lnT w="6350" cap="flat" cmpd="sng" algn="ctr">
+                      <a:solidFill>
+                        <a:srgbClr val="D6CFC4"/>
+                      </a:solidFill>
+                      <a:prstDash val="solid"/>
+                      <a:round/>
+                      <a:headEnd type="none" w="med" len="med"/>
+                      <a:tailEnd type="none" w="med" len="med"/>
+                    </a:lnT>
+                    <a:lnB w="6350" cap="flat" cmpd="sng" algn="ctr">
+                      <a:solidFill>
+                        <a:srgbClr val="D6CFC4"/>
+                      </a:solidFill>
+                      <a:prstDash val="solid"/>
+                      <a:round/>
+                      <a:headEnd type="none" w="med" len="med"/>
+                      <a:tailEnd type="none" w="med" len="med"/>
+                    </a:lnB>
+                    <a:solidFill>
+                      <a:srgbClr val="FFF9D9"/>
+                    </a:solidFill>
+                  </a:tcPr>
+                </a:tc>
+              </a:tr>
             </a:tbl>
           </a:graphicData>
         </a:graphic>
@@ -16619,6 +17028,280 @@
                     </a:lnB>
                     <a:solidFill>
                       <a:srgbClr val="FFFFFF"/>
+                    </a:solidFill>
+                  </a:tcPr>
+                </a:tc>
+              </a:tr>
+              <a:tr h="384048">
+                <a:tc>
+                  <a:txBody>
+                    <a:bodyPr/>
+                    <a:lstStyle/>
+                    <a:p>
+                      <a:pPr algn="l" indent="0" marL="0">
+                        <a:buNone/>
+                      </a:pPr>
+                      <a:r>
+                        <a:rPr lang="en-US" sz="1200" b="1" dirty="0">
+                          <a:solidFill>
+                            <a:srgbClr val="5D300F"/>
+                          </a:solidFill>
+                          <a:latin typeface="Century Gothic" pitchFamily="34" charset="0"/>
+                          <a:ea typeface="Century Gothic" pitchFamily="34" charset="-122"/>
+                          <a:cs typeface="Century Gothic" pitchFamily="34" charset="-120"/>
+                        </a:rPr>
+                        <a:t>GROUP TOTAL</a:t>
+                      </a:r>
+                      <a:endParaRPr lang="en-US" sz="1200" dirty="0">
+                        <a:latin typeface="Century Gothic" charset="0"/>
+                        <a:ea typeface="Century Gothic" charset="0"/>
+                        <a:cs typeface="Century Gothic" charset="0"/>
+                      </a:endParaRPr>
+                    </a:p>
+                  </a:txBody>
+                  <a:tcPr marL="91440" marR="91440" marT="45720" marB="45720" anchor="ctr">
+                    <a:lnL w="6350" cap="flat" cmpd="sng" algn="ctr">
+                      <a:solidFill>
+                        <a:srgbClr val="D6CFC4"/>
+                      </a:solidFill>
+                      <a:prstDash val="solid"/>
+                      <a:round/>
+                      <a:headEnd type="none" w="med" len="med"/>
+                      <a:tailEnd type="none" w="med" len="med"/>
+                    </a:lnL>
+                    <a:lnR w="6350" cap="flat" cmpd="sng" algn="ctr">
+                      <a:solidFill>
+                        <a:srgbClr val="D6CFC4"/>
+                      </a:solidFill>
+                      <a:prstDash val="solid"/>
+                      <a:round/>
+                      <a:headEnd type="none" w="med" len="med"/>
+                      <a:tailEnd type="none" w="med" len="med"/>
+                    </a:lnR>
+                    <a:lnT w="6350" cap="flat" cmpd="sng" algn="ctr">
+                      <a:solidFill>
+                        <a:srgbClr val="D6CFC4"/>
+                      </a:solidFill>
+                      <a:prstDash val="solid"/>
+                      <a:round/>
+                      <a:headEnd type="none" w="med" len="med"/>
+                      <a:tailEnd type="none" w="med" len="med"/>
+                    </a:lnT>
+                    <a:lnB w="6350" cap="flat" cmpd="sng" algn="ctr">
+                      <a:solidFill>
+                        <a:srgbClr val="D6CFC4"/>
+                      </a:solidFill>
+                      <a:prstDash val="solid"/>
+                      <a:round/>
+                      <a:headEnd type="none" w="med" len="med"/>
+                      <a:tailEnd type="none" w="med" len="med"/>
+                    </a:lnB>
+                    <a:solidFill>
+                      <a:srgbClr val="FFF9D9"/>
+                    </a:solidFill>
+                  </a:tcPr>
+                </a:tc>
+                <a:tc>
+                  <a:txBody>
+                    <a:bodyPr/>
+                    <a:lstStyle/>
+                    <a:p>
+                      <a:pPr algn="ctr" indent="0" marL="0">
+                        <a:buNone/>
+                      </a:pPr>
+                      <a:r>
+                        <a:rPr lang="en-US" sz="1200" b="1" dirty="0">
+                          <a:solidFill>
+                            <a:srgbClr val="5D300F"/>
+                          </a:solidFill>
+                          <a:latin typeface="Calibri" pitchFamily="34" charset="0"/>
+                          <a:ea typeface="Calibri" pitchFamily="34" charset="-122"/>
+                          <a:cs typeface="Calibri" pitchFamily="34" charset="-120"/>
+                        </a:rPr>
+                        <a:t>—</a:t>
+                      </a:r>
+                      <a:endParaRPr lang="en-US" sz="1200" dirty="0">
+                        <a:latin typeface="Calibri" charset="0"/>
+                        <a:ea typeface="Calibri" charset="0"/>
+                        <a:cs typeface="Calibri" charset="0"/>
+                      </a:endParaRPr>
+                    </a:p>
+                  </a:txBody>
+                  <a:tcPr marL="91440" marR="91440" marT="45720" marB="45720" anchor="ctr">
+                    <a:lnL w="6350" cap="flat" cmpd="sng" algn="ctr">
+                      <a:solidFill>
+                        <a:srgbClr val="D6CFC4"/>
+                      </a:solidFill>
+                      <a:prstDash val="solid"/>
+                      <a:round/>
+                      <a:headEnd type="none" w="med" len="med"/>
+                      <a:tailEnd type="none" w="med" len="med"/>
+                    </a:lnL>
+                    <a:lnR w="6350" cap="flat" cmpd="sng" algn="ctr">
+                      <a:solidFill>
+                        <a:srgbClr val="D6CFC4"/>
+                      </a:solidFill>
+                      <a:prstDash val="solid"/>
+                      <a:round/>
+                      <a:headEnd type="none" w="med" len="med"/>
+                      <a:tailEnd type="none" w="med" len="med"/>
+                    </a:lnR>
+                    <a:lnT w="6350" cap="flat" cmpd="sng" algn="ctr">
+                      <a:solidFill>
+                        <a:srgbClr val="D6CFC4"/>
+                      </a:solidFill>
+                      <a:prstDash val="solid"/>
+                      <a:round/>
+                      <a:headEnd type="none" w="med" len="med"/>
+                      <a:tailEnd type="none" w="med" len="med"/>
+                    </a:lnT>
+                    <a:lnB w="6350" cap="flat" cmpd="sng" algn="ctr">
+                      <a:solidFill>
+                        <a:srgbClr val="D6CFC4"/>
+                      </a:solidFill>
+                      <a:prstDash val="solid"/>
+                      <a:round/>
+                      <a:headEnd type="none" w="med" len="med"/>
+                      <a:tailEnd type="none" w="med" len="med"/>
+                    </a:lnB>
+                    <a:solidFill>
+                      <a:srgbClr val="FFF9D9"/>
+                    </a:solidFill>
+                  </a:tcPr>
+                </a:tc>
+                <a:tc>
+                  <a:txBody>
+                    <a:bodyPr/>
+                    <a:lstStyle/>
+                    <a:p>
+                      <a:pPr algn="ctr" indent="0" marL="0">
+                        <a:buNone/>
+                      </a:pPr>
+                      <a:r>
+                        <a:rPr lang="en-US" sz="1200" b="1" dirty="0">
+                          <a:solidFill>
+                            <a:srgbClr val="5D300F"/>
+                          </a:solidFill>
+                          <a:latin typeface="Calibri" pitchFamily="34" charset="0"/>
+                          <a:ea typeface="Calibri" pitchFamily="34" charset="-122"/>
+                          <a:cs typeface="Calibri" pitchFamily="34" charset="-120"/>
+                        </a:rPr>
+                        <a:t>8.1%</a:t>
+                      </a:r>
+                      <a:endParaRPr lang="en-US" sz="1200" dirty="0">
+                        <a:latin typeface="Calibri" charset="0"/>
+                        <a:ea typeface="Calibri" charset="0"/>
+                        <a:cs typeface="Calibri" charset="0"/>
+                      </a:endParaRPr>
+                    </a:p>
+                  </a:txBody>
+                  <a:tcPr marL="91440" marR="91440" marT="45720" marB="45720" anchor="ctr">
+                    <a:lnL w="6350" cap="flat" cmpd="sng" algn="ctr">
+                      <a:solidFill>
+                        <a:srgbClr val="D6CFC4"/>
+                      </a:solidFill>
+                      <a:prstDash val="solid"/>
+                      <a:round/>
+                      <a:headEnd type="none" w="med" len="med"/>
+                      <a:tailEnd type="none" w="med" len="med"/>
+                    </a:lnL>
+                    <a:lnR w="6350" cap="flat" cmpd="sng" algn="ctr">
+                      <a:solidFill>
+                        <a:srgbClr val="D6CFC4"/>
+                      </a:solidFill>
+                      <a:prstDash val="solid"/>
+                      <a:round/>
+                      <a:headEnd type="none" w="med" len="med"/>
+                      <a:tailEnd type="none" w="med" len="med"/>
+                    </a:lnR>
+                    <a:lnT w="6350" cap="flat" cmpd="sng" algn="ctr">
+                      <a:solidFill>
+                        <a:srgbClr val="D6CFC4"/>
+                      </a:solidFill>
+                      <a:prstDash val="solid"/>
+                      <a:round/>
+                      <a:headEnd type="none" w="med" len="med"/>
+                      <a:tailEnd type="none" w="med" len="med"/>
+                    </a:lnT>
+                    <a:lnB w="6350" cap="flat" cmpd="sng" algn="ctr">
+                      <a:solidFill>
+                        <a:srgbClr val="D6CFC4"/>
+                      </a:solidFill>
+                      <a:prstDash val="solid"/>
+                      <a:round/>
+                      <a:headEnd type="none" w="med" len="med"/>
+                      <a:tailEnd type="none" w="med" len="med"/>
+                    </a:lnB>
+                    <a:solidFill>
+                      <a:srgbClr val="FFF9D9"/>
+                    </a:solidFill>
+                  </a:tcPr>
+                </a:tc>
+                <a:tc>
+                  <a:txBody>
+                    <a:bodyPr/>
+                    <a:lstStyle/>
+                    <a:p>
+                      <a:pPr algn="ctr" indent="0" marL="0">
+                        <a:buNone/>
+                      </a:pPr>
+                      <a:r>
+                        <a:rPr lang="en-US" sz="1200" b="1" dirty="0">
+                          <a:solidFill>
+                            <a:srgbClr val="718096"/>
+                          </a:solidFill>
+                          <a:latin typeface="Calibri" pitchFamily="34" charset="0"/>
+                          <a:ea typeface="Calibri" pitchFamily="34" charset="-122"/>
+                          <a:cs typeface="Calibri" pitchFamily="34" charset="-120"/>
+                        </a:rPr>
+                        <a:t>—</a:t>
+                      </a:r>
+                      <a:endParaRPr lang="en-US" sz="1200" dirty="0">
+                        <a:latin typeface="Calibri" charset="0"/>
+                        <a:ea typeface="Calibri" charset="0"/>
+                        <a:cs typeface="Calibri" charset="0"/>
+                      </a:endParaRPr>
+                    </a:p>
+                  </a:txBody>
+                  <a:tcPr marL="91440" marR="91440" marT="45720" marB="45720" anchor="ctr">
+                    <a:lnL w="6350" cap="flat" cmpd="sng" algn="ctr">
+                      <a:solidFill>
+                        <a:srgbClr val="D6CFC4"/>
+                      </a:solidFill>
+                      <a:prstDash val="solid"/>
+                      <a:round/>
+                      <a:headEnd type="none" w="med" len="med"/>
+                      <a:tailEnd type="none" w="med" len="med"/>
+                    </a:lnL>
+                    <a:lnR w="6350" cap="flat" cmpd="sng" algn="ctr">
+                      <a:solidFill>
+                        <a:srgbClr val="D6CFC4"/>
+                      </a:solidFill>
+                      <a:prstDash val="solid"/>
+                      <a:round/>
+                      <a:headEnd type="none" w="med" len="med"/>
+                      <a:tailEnd type="none" w="med" len="med"/>
+                    </a:lnR>
+                    <a:lnT w="6350" cap="flat" cmpd="sng" algn="ctr">
+                      <a:solidFill>
+                        <a:srgbClr val="D6CFC4"/>
+                      </a:solidFill>
+                      <a:prstDash val="solid"/>
+                      <a:round/>
+                      <a:headEnd type="none" w="med" len="med"/>
+                      <a:tailEnd type="none" w="med" len="med"/>
+                    </a:lnT>
+                    <a:lnB w="6350" cap="flat" cmpd="sng" algn="ctr">
+                      <a:solidFill>
+                        <a:srgbClr val="D6CFC4"/>
+                      </a:solidFill>
+                      <a:prstDash val="solid"/>
+                      <a:round/>
+                      <a:headEnd type="none" w="med" len="med"/>
+                      <a:tailEnd type="none" w="med" len="med"/>
+                    </a:lnB>
+                    <a:solidFill>
+                      <a:srgbClr val="FFF9D9"/>
                     </a:solidFill>
                   </a:tcPr>
                 </a:tc>

</xml_diff>

<commit_message>
Auto-build: 2026-03-12 16:01 UTC
</commit_message>
<xml_diff>
--- a/reports/2026-01.pptx
+++ b/reports/2026-01.pptx
@@ -118,7 +118,7 @@
 </p:presentation>
 </file>
 
-<file path=ppt/charts/chart10.xml><?xml version="1.0" encoding="utf-8"?>
+<file path=ppt/charts/chart1.xml><?xml version="1.0" encoding="utf-8"?>
 <c:chartSpace xmlns:c="http://schemas.openxmlformats.org/drawingml/2006/chart" xmlns:a="http://schemas.openxmlformats.org/drawingml/2006/main" xmlns:r="http://schemas.openxmlformats.org/officeDocument/2006/relationships">
   <c:date1904 val="0"/>
   <c:roundedCorners val="0"/>
@@ -418,7 +418,7 @@
 </c:chartSpace>
 </file>
 
-<file path=ppt/charts/chart11.xml><?xml version="1.0" encoding="utf-8"?>
+<file path=ppt/charts/chart2.xml><?xml version="1.0" encoding="utf-8"?>
 <c:chartSpace xmlns:c="http://schemas.openxmlformats.org/drawingml/2006/chart" xmlns:a="http://schemas.openxmlformats.org/drawingml/2006/main" xmlns:r="http://schemas.openxmlformats.org/officeDocument/2006/relationships">
   <c:date1904 val="0"/>
   <c:roundedCorners val="0"/>
@@ -718,7 +718,7 @@
 </c:chartSpace>
 </file>
 
-<file path=ppt/charts/chart12.xml><?xml version="1.0" encoding="utf-8"?>
+<file path=ppt/charts/chart3.xml><?xml version="1.0" encoding="utf-8"?>
 <c:chartSpace xmlns:c="http://schemas.openxmlformats.org/drawingml/2006/chart" xmlns:a="http://schemas.openxmlformats.org/drawingml/2006/main" xmlns:r="http://schemas.openxmlformats.org/officeDocument/2006/relationships">
   <c:date1904 val="0"/>
   <c:roundedCorners val="0"/>
@@ -1018,7 +1018,7 @@
 </c:chartSpace>
 </file>
 
-<file path=ppt/charts/chart13.xml><?xml version="1.0" encoding="utf-8"?>
+<file path=ppt/charts/chart4.xml><?xml version="1.0" encoding="utf-8"?>
 <c:chartSpace xmlns:c="http://schemas.openxmlformats.org/drawingml/2006/chart" xmlns:a="http://schemas.openxmlformats.org/drawingml/2006/main" xmlns:r="http://schemas.openxmlformats.org/officeDocument/2006/relationships">
   <c:date1904 val="0"/>
   <c:roundedCorners val="0"/>
@@ -1318,7 +1318,7 @@
 </c:chartSpace>
 </file>
 
-<file path=ppt/charts/chart14.xml><?xml version="1.0" encoding="utf-8"?>
+<file path=ppt/charts/chart5.xml><?xml version="1.0" encoding="utf-8"?>
 <c:chartSpace xmlns:c="http://schemas.openxmlformats.org/drawingml/2006/chart" xmlns:a="http://schemas.openxmlformats.org/drawingml/2006/main" xmlns:r="http://schemas.openxmlformats.org/officeDocument/2006/relationships">
   <c:date1904 val="0"/>
   <c:roundedCorners val="0"/>
@@ -1618,7 +1618,7 @@
 </c:chartSpace>
 </file>
 
-<file path=ppt/charts/chart15.xml><?xml version="1.0" encoding="utf-8"?>
+<file path=ppt/charts/chart6.xml><?xml version="1.0" encoding="utf-8"?>
 <c:chartSpace xmlns:c="http://schemas.openxmlformats.org/drawingml/2006/chart" xmlns:a="http://schemas.openxmlformats.org/drawingml/2006/main" xmlns:r="http://schemas.openxmlformats.org/officeDocument/2006/relationships">
   <c:date1904 val="0"/>
   <c:roundedCorners val="0"/>
@@ -1918,7 +1918,7 @@
 </c:chartSpace>
 </file>
 
-<file path=ppt/charts/chart16.xml><?xml version="1.0" encoding="utf-8"?>
+<file path=ppt/charts/chart7.xml><?xml version="1.0" encoding="utf-8"?>
 <c:chartSpace xmlns:c="http://schemas.openxmlformats.org/drawingml/2006/chart" xmlns:a="http://schemas.openxmlformats.org/drawingml/2006/main" xmlns:r="http://schemas.openxmlformats.org/officeDocument/2006/relationships">
   <c:date1904 val="0"/>
   <c:roundedCorners val="0"/>
@@ -2218,7 +2218,7 @@
 </c:chartSpace>
 </file>
 
-<file path=ppt/charts/chart17.xml><?xml version="1.0" encoding="utf-8"?>
+<file path=ppt/charts/chart8.xml><?xml version="1.0" encoding="utf-8"?>
 <c:chartSpace xmlns:c="http://schemas.openxmlformats.org/drawingml/2006/chart" xmlns:a="http://schemas.openxmlformats.org/drawingml/2006/main" xmlns:r="http://schemas.openxmlformats.org/officeDocument/2006/relationships">
   <c:date1904 val="0"/>
   <c:roundedCorners val="0"/>
@@ -2518,7 +2518,7 @@
 </c:chartSpace>
 </file>
 
-<file path=ppt/charts/chart18.xml><?xml version="1.0" encoding="utf-8"?>
+<file path=ppt/charts/chart9.xml><?xml version="1.0" encoding="utf-8"?>
 <c:chartSpace xmlns:c="http://schemas.openxmlformats.org/drawingml/2006/chart" xmlns:a="http://schemas.openxmlformats.org/drawingml/2006/main" xmlns:r="http://schemas.openxmlformats.org/officeDocument/2006/relationships">
   <c:date1904 val="0"/>
   <c:roundedCorners val="0"/>

</xml_diff>

<commit_message>
Auto-build: 2026-03-12 17:22 UTC
</commit_message>
<xml_diff>
--- a/reports/2026-01.pptx
+++ b/reports/2026-01.pptx
@@ -118,7 +118,7 @@
 </p:presentation>
 </file>
 
-<file path=ppt/charts/chart1.xml><?xml version="1.0" encoding="utf-8"?>
+<file path=ppt/charts/chart10.xml><?xml version="1.0" encoding="utf-8"?>
 <c:chartSpace xmlns:c="http://schemas.openxmlformats.org/drawingml/2006/chart" xmlns:a="http://schemas.openxmlformats.org/drawingml/2006/main" xmlns:r="http://schemas.openxmlformats.org/officeDocument/2006/relationships">
   <c:date1904 val="0"/>
   <c:roundedCorners val="0"/>
@@ -418,7 +418,7 @@
 </c:chartSpace>
 </file>
 
-<file path=ppt/charts/chart2.xml><?xml version="1.0" encoding="utf-8"?>
+<file path=ppt/charts/chart11.xml><?xml version="1.0" encoding="utf-8"?>
 <c:chartSpace xmlns:c="http://schemas.openxmlformats.org/drawingml/2006/chart" xmlns:a="http://schemas.openxmlformats.org/drawingml/2006/main" xmlns:r="http://schemas.openxmlformats.org/officeDocument/2006/relationships">
   <c:date1904 val="0"/>
   <c:roundedCorners val="0"/>
@@ -718,7 +718,7 @@
 </c:chartSpace>
 </file>
 
-<file path=ppt/charts/chart3.xml><?xml version="1.0" encoding="utf-8"?>
+<file path=ppt/charts/chart12.xml><?xml version="1.0" encoding="utf-8"?>
 <c:chartSpace xmlns:c="http://schemas.openxmlformats.org/drawingml/2006/chart" xmlns:a="http://schemas.openxmlformats.org/drawingml/2006/main" xmlns:r="http://schemas.openxmlformats.org/officeDocument/2006/relationships">
   <c:date1904 val="0"/>
   <c:roundedCorners val="0"/>
@@ -1018,7 +1018,7 @@
 </c:chartSpace>
 </file>
 
-<file path=ppt/charts/chart4.xml><?xml version="1.0" encoding="utf-8"?>
+<file path=ppt/charts/chart13.xml><?xml version="1.0" encoding="utf-8"?>
 <c:chartSpace xmlns:c="http://schemas.openxmlformats.org/drawingml/2006/chart" xmlns:a="http://schemas.openxmlformats.org/drawingml/2006/main" xmlns:r="http://schemas.openxmlformats.org/officeDocument/2006/relationships">
   <c:date1904 val="0"/>
   <c:roundedCorners val="0"/>
@@ -1318,7 +1318,7 @@
 </c:chartSpace>
 </file>
 
-<file path=ppt/charts/chart5.xml><?xml version="1.0" encoding="utf-8"?>
+<file path=ppt/charts/chart14.xml><?xml version="1.0" encoding="utf-8"?>
 <c:chartSpace xmlns:c="http://schemas.openxmlformats.org/drawingml/2006/chart" xmlns:a="http://schemas.openxmlformats.org/drawingml/2006/main" xmlns:r="http://schemas.openxmlformats.org/officeDocument/2006/relationships">
   <c:date1904 val="0"/>
   <c:roundedCorners val="0"/>
@@ -1618,7 +1618,7 @@
 </c:chartSpace>
 </file>
 
-<file path=ppt/charts/chart6.xml><?xml version="1.0" encoding="utf-8"?>
+<file path=ppt/charts/chart15.xml><?xml version="1.0" encoding="utf-8"?>
 <c:chartSpace xmlns:c="http://schemas.openxmlformats.org/drawingml/2006/chart" xmlns:a="http://schemas.openxmlformats.org/drawingml/2006/main" xmlns:r="http://schemas.openxmlformats.org/officeDocument/2006/relationships">
   <c:date1904 val="0"/>
   <c:roundedCorners val="0"/>
@@ -1918,7 +1918,7 @@
 </c:chartSpace>
 </file>
 
-<file path=ppt/charts/chart7.xml><?xml version="1.0" encoding="utf-8"?>
+<file path=ppt/charts/chart16.xml><?xml version="1.0" encoding="utf-8"?>
 <c:chartSpace xmlns:c="http://schemas.openxmlformats.org/drawingml/2006/chart" xmlns:a="http://schemas.openxmlformats.org/drawingml/2006/main" xmlns:r="http://schemas.openxmlformats.org/officeDocument/2006/relationships">
   <c:date1904 val="0"/>
   <c:roundedCorners val="0"/>
@@ -2218,7 +2218,7 @@
 </c:chartSpace>
 </file>
 
-<file path=ppt/charts/chart8.xml><?xml version="1.0" encoding="utf-8"?>
+<file path=ppt/charts/chart17.xml><?xml version="1.0" encoding="utf-8"?>
 <c:chartSpace xmlns:c="http://schemas.openxmlformats.org/drawingml/2006/chart" xmlns:a="http://schemas.openxmlformats.org/drawingml/2006/main" xmlns:r="http://schemas.openxmlformats.org/officeDocument/2006/relationships">
   <c:date1904 val="0"/>
   <c:roundedCorners val="0"/>
@@ -2518,7 +2518,7 @@
 </c:chartSpace>
 </file>
 
-<file path=ppt/charts/chart9.xml><?xml version="1.0" encoding="utf-8"?>
+<file path=ppt/charts/chart18.xml><?xml version="1.0" encoding="utf-8"?>
 <c:chartSpace xmlns:c="http://schemas.openxmlformats.org/drawingml/2006/chart" xmlns:a="http://schemas.openxmlformats.org/drawingml/2006/main" xmlns:r="http://schemas.openxmlformats.org/officeDocument/2006/relationships">
   <c:date1904 val="0"/>
   <c:roundedCorners val="0"/>

</xml_diff>

<commit_message>
Auto-build: 2026-03-12 18:51 UTC
</commit_message>
<xml_diff>
--- a/reports/2026-01.pptx
+++ b/reports/2026-01.pptx
@@ -118,7 +118,7 @@
 </p:presentation>
 </file>
 
-<file path=ppt/charts/chart10.xml><?xml version="1.0" encoding="utf-8"?>
+<file path=ppt/charts/chart1.xml><?xml version="1.0" encoding="utf-8"?>
 <c:chartSpace xmlns:c="http://schemas.openxmlformats.org/drawingml/2006/chart" xmlns:a="http://schemas.openxmlformats.org/drawingml/2006/main" xmlns:r="http://schemas.openxmlformats.org/officeDocument/2006/relationships">
   <c:date1904 val="0"/>
   <c:roundedCorners val="0"/>
@@ -418,7 +418,7 @@
 </c:chartSpace>
 </file>
 
-<file path=ppt/charts/chart11.xml><?xml version="1.0" encoding="utf-8"?>
+<file path=ppt/charts/chart2.xml><?xml version="1.0" encoding="utf-8"?>
 <c:chartSpace xmlns:c="http://schemas.openxmlformats.org/drawingml/2006/chart" xmlns:a="http://schemas.openxmlformats.org/drawingml/2006/main" xmlns:r="http://schemas.openxmlformats.org/officeDocument/2006/relationships">
   <c:date1904 val="0"/>
   <c:roundedCorners val="0"/>
@@ -718,7 +718,7 @@
 </c:chartSpace>
 </file>
 
-<file path=ppt/charts/chart12.xml><?xml version="1.0" encoding="utf-8"?>
+<file path=ppt/charts/chart3.xml><?xml version="1.0" encoding="utf-8"?>
 <c:chartSpace xmlns:c="http://schemas.openxmlformats.org/drawingml/2006/chart" xmlns:a="http://schemas.openxmlformats.org/drawingml/2006/main" xmlns:r="http://schemas.openxmlformats.org/officeDocument/2006/relationships">
   <c:date1904 val="0"/>
   <c:roundedCorners val="0"/>
@@ -1018,7 +1018,7 @@
 </c:chartSpace>
 </file>
 
-<file path=ppt/charts/chart13.xml><?xml version="1.0" encoding="utf-8"?>
+<file path=ppt/charts/chart4.xml><?xml version="1.0" encoding="utf-8"?>
 <c:chartSpace xmlns:c="http://schemas.openxmlformats.org/drawingml/2006/chart" xmlns:a="http://schemas.openxmlformats.org/drawingml/2006/main" xmlns:r="http://schemas.openxmlformats.org/officeDocument/2006/relationships">
   <c:date1904 val="0"/>
   <c:roundedCorners val="0"/>
@@ -1318,7 +1318,7 @@
 </c:chartSpace>
 </file>
 
-<file path=ppt/charts/chart14.xml><?xml version="1.0" encoding="utf-8"?>
+<file path=ppt/charts/chart5.xml><?xml version="1.0" encoding="utf-8"?>
 <c:chartSpace xmlns:c="http://schemas.openxmlformats.org/drawingml/2006/chart" xmlns:a="http://schemas.openxmlformats.org/drawingml/2006/main" xmlns:r="http://schemas.openxmlformats.org/officeDocument/2006/relationships">
   <c:date1904 val="0"/>
   <c:roundedCorners val="0"/>
@@ -1618,7 +1618,7 @@
 </c:chartSpace>
 </file>
 
-<file path=ppt/charts/chart15.xml><?xml version="1.0" encoding="utf-8"?>
+<file path=ppt/charts/chart6.xml><?xml version="1.0" encoding="utf-8"?>
 <c:chartSpace xmlns:c="http://schemas.openxmlformats.org/drawingml/2006/chart" xmlns:a="http://schemas.openxmlformats.org/drawingml/2006/main" xmlns:r="http://schemas.openxmlformats.org/officeDocument/2006/relationships">
   <c:date1904 val="0"/>
   <c:roundedCorners val="0"/>
@@ -1918,7 +1918,7 @@
 </c:chartSpace>
 </file>
 
-<file path=ppt/charts/chart16.xml><?xml version="1.0" encoding="utf-8"?>
+<file path=ppt/charts/chart7.xml><?xml version="1.0" encoding="utf-8"?>
 <c:chartSpace xmlns:c="http://schemas.openxmlformats.org/drawingml/2006/chart" xmlns:a="http://schemas.openxmlformats.org/drawingml/2006/main" xmlns:r="http://schemas.openxmlformats.org/officeDocument/2006/relationships">
   <c:date1904 val="0"/>
   <c:roundedCorners val="0"/>
@@ -2218,7 +2218,7 @@
 </c:chartSpace>
 </file>
 
-<file path=ppt/charts/chart17.xml><?xml version="1.0" encoding="utf-8"?>
+<file path=ppt/charts/chart8.xml><?xml version="1.0" encoding="utf-8"?>
 <c:chartSpace xmlns:c="http://schemas.openxmlformats.org/drawingml/2006/chart" xmlns:a="http://schemas.openxmlformats.org/drawingml/2006/main" xmlns:r="http://schemas.openxmlformats.org/officeDocument/2006/relationships">
   <c:date1904 val="0"/>
   <c:roundedCorners val="0"/>
@@ -2518,7 +2518,7 @@
 </c:chartSpace>
 </file>
 
-<file path=ppt/charts/chart18.xml><?xml version="1.0" encoding="utf-8"?>
+<file path=ppt/charts/chart9.xml><?xml version="1.0" encoding="utf-8"?>
 <c:chartSpace xmlns:c="http://schemas.openxmlformats.org/drawingml/2006/chart" xmlns:a="http://schemas.openxmlformats.org/drawingml/2006/main" xmlns:r="http://schemas.openxmlformats.org/officeDocument/2006/relationships">
   <c:date1904 val="0"/>
   <c:roundedCorners val="0"/>

</xml_diff>

<commit_message>
Auto-build: 2026-03-13 12:37 UTC
</commit_message>
<xml_diff>
--- a/reports/2026-01.pptx
+++ b/reports/2026-01.pptx
@@ -5330,7 +5330,7 @@
             <a:r>
               <a:rPr lang="en-US" sz="1200" b="1" dirty="0">
                 <a:solidFill>
-                  <a:srgbClr val="C0392B"/>
+                  <a:srgbClr val="1A7A6E"/>
                 </a:solidFill>
                 <a:latin typeface="Calibri" pitchFamily="34" charset="0"/>
                 <a:ea typeface="Calibri" pitchFamily="34" charset="-122"/>
@@ -5408,7 +5408,7 @@
             <a:r>
               <a:rPr lang="en-US" sz="1200" b="1" dirty="0">
                 <a:solidFill>
-                  <a:srgbClr val="C0392B"/>
+                  <a:srgbClr val="1A7A6E"/>
                 </a:solidFill>
                 <a:latin typeface="Calibri" pitchFamily="34" charset="0"/>
                 <a:ea typeface="Calibri" pitchFamily="34" charset="-122"/>
@@ -5447,7 +5447,7 @@
             <a:r>
               <a:rPr lang="en-US" sz="1200" b="1" dirty="0">
                 <a:solidFill>
-                  <a:srgbClr val="C0392B"/>
+                  <a:srgbClr val="1A7A6E"/>
                 </a:solidFill>
                 <a:latin typeface="Calibri" pitchFamily="34" charset="0"/>
                 <a:ea typeface="Calibri" pitchFamily="34" charset="-122"/>
@@ -5936,7 +5936,7 @@
             <a:r>
               <a:rPr lang="en-US" sz="1200" b="1" dirty="0">
                 <a:solidFill>
-                  <a:srgbClr val="C0392B"/>
+                  <a:srgbClr val="1A7A6E"/>
                 </a:solidFill>
                 <a:latin typeface="Calibri" pitchFamily="34" charset="0"/>
                 <a:ea typeface="Calibri" pitchFamily="34" charset="-122"/>
@@ -6014,7 +6014,7 @@
             <a:r>
               <a:rPr lang="en-US" sz="1200" b="1" dirty="0">
                 <a:solidFill>
-                  <a:srgbClr val="C0392B"/>
+                  <a:srgbClr val="1A7A6E"/>
                 </a:solidFill>
                 <a:latin typeface="Calibri" pitchFamily="34" charset="0"/>
                 <a:ea typeface="Calibri" pitchFamily="34" charset="-122"/>
@@ -6053,7 +6053,7 @@
             <a:r>
               <a:rPr lang="en-US" sz="1200" b="1" dirty="0">
                 <a:solidFill>
-                  <a:srgbClr val="C0392B"/>
+                  <a:srgbClr val="1A7A6E"/>
                 </a:solidFill>
                 <a:latin typeface="Calibri" pitchFamily="34" charset="0"/>
                 <a:ea typeface="Calibri" pitchFamily="34" charset="-122"/>
@@ -6542,7 +6542,7 @@
             <a:r>
               <a:rPr lang="en-US" sz="1200" b="1" dirty="0">
                 <a:solidFill>
-                  <a:srgbClr val="C0392B"/>
+                  <a:srgbClr val="1A7A6E"/>
                 </a:solidFill>
                 <a:latin typeface="Calibri" pitchFamily="34" charset="0"/>
                 <a:ea typeface="Calibri" pitchFamily="34" charset="-122"/>
@@ -6620,7 +6620,7 @@
             <a:r>
               <a:rPr lang="en-US" sz="1200" b="1" dirty="0">
                 <a:solidFill>
-                  <a:srgbClr val="1A7A6E"/>
+                  <a:srgbClr val="C0392B"/>
                 </a:solidFill>
                 <a:latin typeface="Calibri" pitchFamily="34" charset="0"/>
                 <a:ea typeface="Calibri" pitchFamily="34" charset="-122"/>
@@ -6659,7 +6659,7 @@
             <a:r>
               <a:rPr lang="en-US" sz="1200" b="1" dirty="0">
                 <a:solidFill>
-                  <a:srgbClr val="C0392B"/>
+                  <a:srgbClr val="1A7A6E"/>
                 </a:solidFill>
                 <a:latin typeface="Calibri" pitchFamily="34" charset="0"/>
                 <a:ea typeface="Calibri" pitchFamily="34" charset="-122"/>
@@ -8271,7 +8271,7 @@
                 <a:ea typeface="Century Gothic" pitchFamily="34" charset="-122"/>
                 <a:cs typeface="Century Gothic" pitchFamily="34" charset="-120"/>
               </a:rPr>
-              <a:t>Change from Prior Month (bps)</a:t>
+              <a:t>Trend vs Prior Month</a:t>
             </a:r>
             <a:endParaRPr lang="en-US" sz="1200" dirty="0"/>
           </a:p>
@@ -8310,7 +8310,7 @@
                 <a:ea typeface="Calibri" pitchFamily="34" charset="-122"/>
                 <a:cs typeface="Calibri" pitchFamily="34" charset="-120"/>
               </a:rPr>
-              <a:t>+9645 bps</a:t>
+              <a:t>—</a:t>
             </a:r>
             <a:endParaRPr lang="en-US" sz="1200" dirty="0"/>
           </a:p>
@@ -8349,7 +8349,7 @@
                 <a:ea typeface="Calibri" pitchFamily="34" charset="-122"/>
                 <a:cs typeface="Calibri" pitchFamily="34" charset="-120"/>
               </a:rPr>
-              <a:t>+8911 bps</a:t>
+              <a:t>—</a:t>
             </a:r>
             <a:endParaRPr lang="en-US" sz="1200" dirty="0"/>
           </a:p>
@@ -8388,7 +8388,7 @@
                 <a:ea typeface="Calibri" pitchFamily="34" charset="-122"/>
                 <a:cs typeface="Calibri" pitchFamily="34" charset="-120"/>
               </a:rPr>
-              <a:t>+8858 bps</a:t>
+              <a:t>—</a:t>
             </a:r>
             <a:endParaRPr lang="en-US" sz="1200" dirty="0"/>
           </a:p>
@@ -8427,7 +8427,7 @@
                 <a:ea typeface="Calibri" pitchFamily="34" charset="-122"/>
                 <a:cs typeface="Calibri" pitchFamily="34" charset="-120"/>
               </a:rPr>
-              <a:t>+8310 bps</a:t>
+              <a:t>—</a:t>
             </a:r>
             <a:endParaRPr lang="en-US" sz="1200" dirty="0"/>
           </a:p>
@@ -8466,7 +8466,7 @@
                 <a:ea typeface="Calibri" pitchFamily="34" charset="-122"/>
                 <a:cs typeface="Calibri" pitchFamily="34" charset="-120"/>
               </a:rPr>
-              <a:t>+6186 bps</a:t>
+              <a:t>—</a:t>
             </a:r>
             <a:endParaRPr lang="en-US" sz="1200" dirty="0"/>
           </a:p>
@@ -8826,13 +8826,13 @@
             <a:r>
               <a:rPr lang="en-US" sz="2600" b="1" dirty="0">
                 <a:solidFill>
-                  <a:srgbClr val="5D300F"/>
+                  <a:srgbClr val="1A7A6E"/>
                 </a:solidFill>
                 <a:latin typeface="Century Gothic" pitchFamily="34" charset="0"/>
                 <a:ea typeface="Century Gothic" pitchFamily="34" charset="-122"/>
                 <a:cs typeface="Century Gothic" pitchFamily="34" charset="-120"/>
               </a:rPr>
-              <a:t>+9112 bps</a:t>
+              <a:t>—</a:t>
             </a:r>
             <a:endParaRPr lang="en-US" sz="2600" dirty="0"/>
           </a:p>
@@ -8871,7 +8871,7 @@
                 <a:ea typeface="Calibri" pitchFamily="34" charset="-122"/>
                 <a:cs typeface="Calibri" pitchFamily="34" charset="-120"/>
               </a:rPr>
-              <a:t>Change from Prior Month</a:t>
+              <a:t>Trend vs Prior Month</a:t>
             </a:r>
             <a:endParaRPr lang="en-US" sz="1200" dirty="0"/>
           </a:p>
@@ -9853,7 +9853,7 @@
                 <a:ea typeface="Century Gothic" pitchFamily="34" charset="-122"/>
                 <a:cs typeface="Century Gothic" pitchFamily="34" charset="-120"/>
               </a:rPr>
-              <a:t>$11,349</a:t>
+              <a:t>50</a:t>
             </a:r>
             <a:endParaRPr lang="en-US" sz="2600" dirty="0"/>
           </a:p>

</xml_diff>

<commit_message>
Auto-build: 2026-03-13 16:46 UTC
</commit_message>
<xml_diff>
--- a/reports/2026-01.pptx
+++ b/reports/2026-01.pptx
@@ -2062,19 +2062,19 @@
                 <c:formatCode>General</c:formatCode>
                 <c:ptCount val="5"/>
                 <c:pt idx="0">
-                  <c:v>2498</c:v>
+                  <c:v>1249</c:v>
                 </c:pt>
                 <c:pt idx="1">
-                  <c:v>2895</c:v>
+                  <c:v>1447</c:v>
                 </c:pt>
                 <c:pt idx="2">
-                  <c:v>2145</c:v>
+                  <c:v>1073</c:v>
                 </c:pt>
                 <c:pt idx="3">
-                  <c:v>1517</c:v>
+                  <c:v>758</c:v>
                 </c:pt>
                 <c:pt idx="4">
-                  <c:v>676</c:v>
+                  <c:v>338</c:v>
                 </c:pt>
               </c:numCache>
             </c:numRef>
@@ -2362,19 +2362,19 @@
                 <c:formatCode>General</c:formatCode>
                 <c:ptCount val="5"/>
                 <c:pt idx="0">
-                  <c:v>576</c:v>
+                  <c:v>288</c:v>
                 </c:pt>
                 <c:pt idx="1">
-                  <c:v>346</c:v>
+                  <c:v>173</c:v>
                 </c:pt>
                 <c:pt idx="2">
-                  <c:v>175</c:v>
+                  <c:v>88</c:v>
                 </c:pt>
                 <c:pt idx="3">
-                  <c:v>282</c:v>
+                  <c:v>141</c:v>
                 </c:pt>
                 <c:pt idx="4">
-                  <c:v>106</c:v>
+                  <c:v>53</c:v>
                 </c:pt>
               </c:numCache>
             </c:numRef>
@@ -5414,7 +5414,7 @@
                 <a:ea typeface="Calibri" pitchFamily="34" charset="-122"/>
                 <a:cs typeface="Calibri" pitchFamily="34" charset="-120"/>
               </a:rPr>
-              <a:t>-59.3%</a:t>
+              <a:t>-59.2%</a:t>
             </a:r>
             <a:endParaRPr lang="en-US" sz="1200" dirty="0"/>
           </a:p>
@@ -5453,7 +5453,7 @@
                 <a:ea typeface="Calibri" pitchFamily="34" charset="-122"/>
                 <a:cs typeface="Calibri" pitchFamily="34" charset="-120"/>
               </a:rPr>
-              <a:t>-25.7%</a:t>
+              <a:t>-25.8%</a:t>
             </a:r>
             <a:endParaRPr lang="en-US" sz="1200" dirty="0"/>
           </a:p>
@@ -5942,7 +5942,7 @@
                 <a:ea typeface="Calibri" pitchFamily="34" charset="-122"/>
                 <a:cs typeface="Calibri" pitchFamily="34" charset="-120"/>
               </a:rPr>
-              <a:t>-31.5%</a:t>
+              <a:t>-31.6%</a:t>
             </a:r>
             <a:endParaRPr lang="en-US" sz="1200" dirty="0"/>
           </a:p>
@@ -6020,7 +6020,7 @@
                 <a:ea typeface="Calibri" pitchFamily="34" charset="-122"/>
                 <a:cs typeface="Calibri" pitchFamily="34" charset="-120"/>
               </a:rPr>
-              <a:t>-75.6%</a:t>
+              <a:t>-75.4%</a:t>
             </a:r>
             <a:endParaRPr lang="en-US" sz="1200" dirty="0"/>
           </a:p>
@@ -13354,7 +13354,7 @@
                           <a:ea typeface="Century Gothic" pitchFamily="34" charset="-122"/>
                           <a:cs typeface="Century Gothic" pitchFamily="34" charset="-120"/>
                         </a:rPr>
-                        <a:t>Change (bps)</a:t>
+                        <a:t>Trend</a:t>
                       </a:r>
                       <a:endParaRPr lang="en-US" sz="1200" dirty="0">
                         <a:latin typeface="Century Gothic" charset="0"/>
@@ -13628,7 +13628,7 @@
                           <a:ea typeface="Calibri" pitchFamily="34" charset="-122"/>
                           <a:cs typeface="Calibri" pitchFamily="34" charset="-120"/>
                         </a:rPr>
-                        <a:t>+452 bps</a:t>
+                        <a:t>↑</a:t>
                       </a:r>
                       <a:endParaRPr lang="en-US" sz="1200" dirty="0">
                         <a:latin typeface="Calibri" charset="0"/>
@@ -13902,7 +13902,7 @@
                           <a:ea typeface="Calibri" pitchFamily="34" charset="-122"/>
                           <a:cs typeface="Calibri" pitchFamily="34" charset="-120"/>
                         </a:rPr>
-                        <a:t>+514 bps</a:t>
+                        <a:t>↑</a:t>
                       </a:r>
                       <a:endParaRPr lang="en-US" sz="1200" dirty="0">
                         <a:latin typeface="Calibri" charset="0"/>
@@ -14176,7 +14176,7 @@
                           <a:ea typeface="Calibri" pitchFamily="34" charset="-122"/>
                           <a:cs typeface="Calibri" pitchFamily="34" charset="-120"/>
                         </a:rPr>
-                        <a:t>+1107 bps</a:t>
+                        <a:t>↑</a:t>
                       </a:r>
                       <a:endParaRPr lang="en-US" sz="1200" dirty="0">
                         <a:latin typeface="Calibri" charset="0"/>
@@ -14450,7 +14450,7 @@
                           <a:ea typeface="Calibri" pitchFamily="34" charset="-122"/>
                           <a:cs typeface="Calibri" pitchFamily="34" charset="-120"/>
                         </a:rPr>
-                        <a:t>+268 bps</a:t>
+                        <a:t>↑</a:t>
                       </a:r>
                       <a:endParaRPr lang="en-US" sz="1200" dirty="0">
                         <a:latin typeface="Calibri" charset="0"/>
@@ -14724,7 +14724,7 @@
                           <a:ea typeface="Calibri" pitchFamily="34" charset="-122"/>
                           <a:cs typeface="Calibri" pitchFamily="34" charset="-120"/>
                         </a:rPr>
-                        <a:t>+1572 bps</a:t>
+                        <a:t>↑</a:t>
                       </a:r>
                       <a:endParaRPr lang="en-US" sz="1200" dirty="0">
                         <a:latin typeface="Calibri" charset="0"/>
@@ -15610,7 +15610,7 @@
                           <a:ea typeface="Century Gothic" pitchFamily="34" charset="-122"/>
                           <a:cs typeface="Century Gothic" pitchFamily="34" charset="-120"/>
                         </a:rPr>
-                        <a:t>Change (bps)</a:t>
+                        <a:t>Trend</a:t>
                       </a:r>
                       <a:endParaRPr lang="en-US" sz="1200" dirty="0">
                         <a:latin typeface="Century Gothic" charset="0"/>
@@ -15884,7 +15884,7 @@
                           <a:ea typeface="Calibri" pitchFamily="34" charset="-122"/>
                           <a:cs typeface="Calibri" pitchFamily="34" charset="-120"/>
                         </a:rPr>
-                        <a:t>+815 bps</a:t>
+                        <a:t>↑</a:t>
                       </a:r>
                       <a:endParaRPr lang="en-US" sz="1200" dirty="0">
                         <a:latin typeface="Calibri" charset="0"/>
@@ -16158,7 +16158,7 @@
                           <a:ea typeface="Calibri" pitchFamily="34" charset="-122"/>
                           <a:cs typeface="Calibri" pitchFamily="34" charset="-120"/>
                         </a:rPr>
-                        <a:t>+619 bps</a:t>
+                        <a:t>↑</a:t>
                       </a:r>
                       <a:endParaRPr lang="en-US" sz="1200" dirty="0">
                         <a:latin typeface="Calibri" charset="0"/>
@@ -16432,7 +16432,7 @@
                           <a:ea typeface="Calibri" pitchFamily="34" charset="-122"/>
                           <a:cs typeface="Calibri" pitchFamily="34" charset="-120"/>
                         </a:rPr>
-                        <a:t>+1736 bps</a:t>
+                        <a:t>↑</a:t>
                       </a:r>
                       <a:endParaRPr lang="en-US" sz="1200" dirty="0">
                         <a:latin typeface="Calibri" charset="0"/>
@@ -16706,7 +16706,7 @@
                           <a:ea typeface="Calibri" pitchFamily="34" charset="-122"/>
                           <a:cs typeface="Calibri" pitchFamily="34" charset="-120"/>
                         </a:rPr>
-                        <a:t>+201 bps</a:t>
+                        <a:t>↑</a:t>
                       </a:r>
                       <a:endParaRPr lang="en-US" sz="1200" dirty="0">
                         <a:latin typeface="Calibri" charset="0"/>
@@ -16980,7 +16980,7 @@
                           <a:ea typeface="Calibri" pitchFamily="34" charset="-122"/>
                           <a:cs typeface="Calibri" pitchFamily="34" charset="-120"/>
                         </a:rPr>
-                        <a:t>+1700 bps</a:t>
+                        <a:t>↑</a:t>
                       </a:r>
                       <a:endParaRPr lang="en-US" sz="1200" dirty="0">
                         <a:latin typeface="Calibri" charset="0"/>

</xml_diff>

<commit_message>
Auto-build: 2026-03-14 09:56 UTC
</commit_message>
<xml_diff>
--- a/reports/2026-01.pptx
+++ b/reports/2026-01.pptx
@@ -237,16 +237,16 @@
                 <c:ptCount val="5"/>
                 <c:lvl>
                   <c:pt idx="0">
+                    <c:v>Kenya</c:v>
+                  </c:pt>
+                  <c:pt idx="1">
                     <c:v>Tanzania</c:v>
                   </c:pt>
-                  <c:pt idx="1">
-                    <c:v>Kenya</c:v>
-                  </c:pt>
                   <c:pt idx="2">
-                    <c:v>Uganda</c:v>
+                    <c:v>Sierra Leone</c:v>
                   </c:pt>
                   <c:pt idx="3">
-                    <c:v>Sierra Leone</c:v>
+                    <c:v>Uganda</c:v>
                   </c:pt>
                   <c:pt idx="4">
                     <c:v>Nigeria</c:v>
@@ -262,16 +262,16 @@
                 <c:formatCode>General</c:formatCode>
                 <c:ptCount val="5"/>
                 <c:pt idx="0">
+                  <c:v>111</c:v>
+                </c:pt>
+                <c:pt idx="1">
                   <c:v>103</c:v>
                 </c:pt>
-                <c:pt idx="1">
-                  <c:v>111</c:v>
-                </c:pt>
                 <c:pt idx="2">
-                  <c:v>45</c:v>
+                  <c:v>57</c:v>
                 </c:pt>
                 <c:pt idx="3">
-                  <c:v>57</c:v>
+                  <c:v>45</c:v>
                 </c:pt>
                 <c:pt idx="4">
                   <c:v>33</c:v>
@@ -843,10 +843,10 @@
                     <c:v>Kenya</c:v>
                   </c:pt>
                   <c:pt idx="2">
-                    <c:v>Uganda</c:v>
+                    <c:v>Sierra Leone</c:v>
                   </c:pt>
                   <c:pt idx="3">
-                    <c:v>Sierra Leone</c:v>
+                    <c:v>Uganda</c:v>
                   </c:pt>
                   <c:pt idx="4">
                     <c:v>Nigeria</c:v>
@@ -868,10 +868,10 @@
                   <c:v>1080878.933</c:v>
                 </c:pt>
                 <c:pt idx="2">
-                  <c:v>210518.4175</c:v>
+                  <c:v>493834.2037</c:v>
                 </c:pt>
                 <c:pt idx="3">
-                  <c:v>493834.2037</c:v>
+                  <c:v>210518.4175</c:v>
                 </c:pt>
                 <c:pt idx="4">
                   <c:v>83007.24638</c:v>
@@ -1143,10 +1143,10 @@
                     <c:v>Kenya</c:v>
                   </c:pt>
                   <c:pt idx="2">
-                    <c:v>Uganda</c:v>
+                    <c:v>Sierra Leone</c:v>
                   </c:pt>
                   <c:pt idx="3">
-                    <c:v>Sierra Leone</c:v>
+                    <c:v>Uganda</c:v>
                   </c:pt>
                   <c:pt idx="4">
                     <c:v>Nigeria</c:v>
@@ -1168,10 +1168,10 @@
                   <c:v>218.315276</c:v>
                 </c:pt>
                 <c:pt idx="2">
-                  <c:v>233.132245</c:v>
+                  <c:v>423.165556</c:v>
                 </c:pt>
                 <c:pt idx="3">
-                  <c:v>423.165556</c:v>
+                  <c:v>233.132245</c:v>
                 </c:pt>
                 <c:pt idx="4">
                   <c:v>226.795755</c:v>
@@ -1443,10 +1443,10 @@
                     <c:v>Kenya</c:v>
                   </c:pt>
                   <c:pt idx="2">
-                    <c:v>Uganda</c:v>
+                    <c:v>Sierra Leone</c:v>
                   </c:pt>
                   <c:pt idx="3">
-                    <c:v>Sierra Leone</c:v>
+                    <c:v>Uganda</c:v>
                   </c:pt>
                   <c:pt idx="4">
                     <c:v>Nigeria</c:v>
@@ -1468,10 +1468,10 @@
                   <c:v>134</c:v>
                 </c:pt>
                 <c:pt idx="2">
-                  <c:v>41</c:v>
+                  <c:v>39</c:v>
                 </c:pt>
                 <c:pt idx="3">
-                  <c:v>39</c:v>
+                  <c:v>41</c:v>
                 </c:pt>
                 <c:pt idx="4">
                   <c:v>23</c:v>
@@ -1743,10 +1743,10 @@
                     <c:v>Kenya</c:v>
                   </c:pt>
                   <c:pt idx="2">
-                    <c:v>Uganda</c:v>
+                    <c:v>Sierra Leone</c:v>
                   </c:pt>
                   <c:pt idx="3">
-                    <c:v>Sierra Leone</c:v>
+                    <c:v>Uganda</c:v>
                   </c:pt>
                   <c:pt idx="4">
                     <c:v>Nigeria</c:v>
@@ -1768,10 +1768,10 @@
                   <c:v>3784306.511</c:v>
                 </c:pt>
                 <c:pt idx="2">
-                  <c:v>1124088.812</c:v>
+                  <c:v>1169213.148</c:v>
                 </c:pt>
                 <c:pt idx="3">
-                  <c:v>1169213.148</c:v>
+                  <c:v>1124088.812</c:v>
                 </c:pt>
                 <c:pt idx="4">
                   <c:v>469005.4218</c:v>
@@ -2037,19 +2037,19 @@
                 <c:ptCount val="5"/>
                 <c:lvl>
                   <c:pt idx="0">
-                    <c:v>Tanzania</c:v>
+                    <c:v>Nigeria</c:v>
                   </c:pt>
                   <c:pt idx="1">
-                    <c:v>Kenya</c:v>
+                    <c:v>Sierra Leone</c:v>
                   </c:pt>
                   <c:pt idx="2">
                     <c:v>Uganda</c:v>
                   </c:pt>
                   <c:pt idx="3">
-                    <c:v>Sierra Leone</c:v>
+                    <c:v>Tanzania</c:v>
                   </c:pt>
                   <c:pt idx="4">
-                    <c:v>Nigeria</c:v>
+                    <c:v>Kenya</c:v>
                   </c:pt>
                 </c:lvl>
               </c:multiLvlStrCache>
@@ -2062,19 +2062,19 @@
                 <c:formatCode>General</c:formatCode>
                 <c:ptCount val="5"/>
                 <c:pt idx="0">
-                  <c:v>1249</c:v>
+                  <c:v>338</c:v>
                 </c:pt>
                 <c:pt idx="1">
-                  <c:v>1447</c:v>
+                  <c:v>758</c:v>
                 </c:pt>
                 <c:pt idx="2">
                   <c:v>1073</c:v>
                 </c:pt>
                 <c:pt idx="3">
-                  <c:v>758</c:v>
+                  <c:v>1249</c:v>
                 </c:pt>
                 <c:pt idx="4">
-                  <c:v>338</c:v>
+                  <c:v>1447</c:v>
                 </c:pt>
               </c:numCache>
             </c:numRef>
@@ -2337,19 +2337,19 @@
                 <c:ptCount val="5"/>
                 <c:lvl>
                   <c:pt idx="0">
-                    <c:v>Tanzania</c:v>
+                    <c:v>Nigeria</c:v>
                   </c:pt>
                   <c:pt idx="1">
+                    <c:v>Uganda</c:v>
+                  </c:pt>
+                  <c:pt idx="2">
+                    <c:v>Sierra Leone</c:v>
+                  </c:pt>
+                  <c:pt idx="3">
                     <c:v>Kenya</c:v>
                   </c:pt>
-                  <c:pt idx="2">
-                    <c:v>Uganda</c:v>
-                  </c:pt>
-                  <c:pt idx="3">
-                    <c:v>Sierra Leone</c:v>
-                  </c:pt>
                   <c:pt idx="4">
-                    <c:v>Nigeria</c:v>
+                    <c:v>Tanzania</c:v>
                   </c:pt>
                 </c:lvl>
               </c:multiLvlStrCache>
@@ -2362,19 +2362,19 @@
                 <c:formatCode>General</c:formatCode>
                 <c:ptCount val="5"/>
                 <c:pt idx="0">
-                  <c:v>288</c:v>
+                  <c:v>53</c:v>
                 </c:pt>
                 <c:pt idx="1">
+                  <c:v>88</c:v>
+                </c:pt>
+                <c:pt idx="2">
+                  <c:v>141</c:v>
+                </c:pt>
+                <c:pt idx="3">
                   <c:v>173</c:v>
                 </c:pt>
-                <c:pt idx="2">
-                  <c:v>88</c:v>
-                </c:pt>
-                <c:pt idx="3">
-                  <c:v>141</c:v>
-                </c:pt>
                 <c:pt idx="4">
-                  <c:v>53</c:v>
+                  <c:v>288</c:v>
                 </c:pt>
               </c:numCache>
             </c:numRef>
@@ -2637,7 +2637,7 @@
                 <c:ptCount val="5"/>
                 <c:lvl>
                   <c:pt idx="0">
-                    <c:v>Tanzania</c:v>
+                    <c:v>Sierra Leone</c:v>
                   </c:pt>
                   <c:pt idx="1">
                     <c:v>Kenya</c:v>
@@ -2646,7 +2646,7 @@
                     <c:v>Uganda</c:v>
                   </c:pt>
                   <c:pt idx="3">
-                    <c:v>Sierra Leone</c:v>
+                    <c:v>Tanzania</c:v>
                   </c:pt>
                   <c:pt idx="4">
                     <c:v>Nigeria</c:v>
@@ -2662,7 +2662,7 @@
                 <c:formatCode>General</c:formatCode>
                 <c:ptCount val="5"/>
                 <c:pt idx="0">
-                  <c:v>60</c:v>
+                  <c:v>21</c:v>
                 </c:pt>
                 <c:pt idx="1">
                   <c:v>23</c:v>
@@ -2671,7 +2671,7 @@
                   <c:v>23</c:v>
                 </c:pt>
                 <c:pt idx="3">
-                  <c:v>21</c:v>
+                  <c:v>60</c:v>
                 </c:pt>
                 <c:pt idx="4">
                   <c:v>68</c:v>
@@ -4847,7 +4847,7 @@
                 <a:ea typeface="Calibri" pitchFamily="34" charset="-122"/>
                 <a:cs typeface="Calibri" pitchFamily="34" charset="-120"/>
               </a:rPr>
-              <a:t>Prepared: March 13, 2026</a:t>
+              <a:t>Prepared: March 14, 2026</a:t>
             </a:r>
             <a:endParaRPr lang="en-US" sz="1200" dirty="0"/>
           </a:p>
@@ -5297,7 +5297,7 @@
                 <a:ea typeface="Century Gothic" pitchFamily="34" charset="-122"/>
                 <a:cs typeface="Century Gothic" pitchFamily="34" charset="-120"/>
               </a:rPr>
-              <a:t>% Change from Prior Month</a:t>
+              <a:t>% Change in Cost per Team vs Prior Month</a:t>
             </a:r>
             <a:endParaRPr lang="en-US" sz="1200" dirty="0"/>
           </a:p>
@@ -5312,45 +5312,6 @@
         <p:spPr>
           <a:xfrm>
             <a:off x="137160" y="5943600"/>
-            <a:ext cx="2377440" cy="347472"/>
-          </a:xfrm>
-          <a:prstGeom prst="rect">
-            <a:avLst/>
-          </a:prstGeom>
-          <a:noFill/>
-          <a:ln/>
-        </p:spPr>
-        <p:txBody>
-          <a:bodyPr wrap="square" rtlCol="0" anchor="ctr"/>
-          <a:lstStyle/>
-          <a:p>
-            <a:pPr algn="ctr" indent="0" marL="0">
-              <a:buNone/>
-            </a:pPr>
-            <a:r>
-              <a:rPr lang="en-US" sz="1200" b="1" dirty="0">
-                <a:solidFill>
-                  <a:srgbClr val="1A7A6E"/>
-                </a:solidFill>
-                <a:latin typeface="Calibri" pitchFamily="34" charset="0"/>
-                <a:ea typeface="Calibri" pitchFamily="34" charset="-122"/>
-                <a:cs typeface="Calibri" pitchFamily="34" charset="-120"/>
-              </a:rPr>
-              <a:t>-66.8%</a:t>
-            </a:r>
-            <a:endParaRPr lang="en-US" sz="1200" dirty="0"/>
-          </a:p>
-        </p:txBody>
-      </p:sp>
-      <p:sp>
-        <p:nvSpPr>
-          <p:cNvPr id="16" name="Text 13"/>
-          <p:cNvSpPr/>
-          <p:nvPr/>
-        </p:nvSpPr>
-        <p:spPr>
-          <a:xfrm>
-            <a:off x="2514600" y="5943600"/>
             <a:ext cx="2377440" cy="347472"/>
           </a:xfrm>
           <a:prstGeom prst="rect">
@@ -5383,6 +5344,45 @@
       </p:sp>
       <p:sp>
         <p:nvSpPr>
+          <p:cNvPr id="16" name="Text 13"/>
+          <p:cNvSpPr/>
+          <p:nvPr/>
+        </p:nvSpPr>
+        <p:spPr>
+          <a:xfrm>
+            <a:off x="2514600" y="5943600"/>
+            <a:ext cx="2377440" cy="347472"/>
+          </a:xfrm>
+          <a:prstGeom prst="rect">
+            <a:avLst/>
+          </a:prstGeom>
+          <a:noFill/>
+          <a:ln/>
+        </p:spPr>
+        <p:txBody>
+          <a:bodyPr wrap="square" rtlCol="0" anchor="ctr"/>
+          <a:lstStyle/>
+          <a:p>
+            <a:pPr algn="ctr" indent="0" marL="0">
+              <a:buNone/>
+            </a:pPr>
+            <a:r>
+              <a:rPr lang="en-US" sz="1200" b="1" dirty="0">
+                <a:solidFill>
+                  <a:srgbClr val="1A7A6E"/>
+                </a:solidFill>
+                <a:latin typeface="Calibri" pitchFamily="34" charset="0"/>
+                <a:ea typeface="Calibri" pitchFamily="34" charset="-122"/>
+                <a:cs typeface="Calibri" pitchFamily="34" charset="-120"/>
+              </a:rPr>
+              <a:t>-25.8%</a:t>
+            </a:r>
+            <a:endParaRPr lang="en-US" sz="1200" dirty="0"/>
+          </a:p>
+        </p:txBody>
+      </p:sp>
+      <p:sp>
+        <p:nvSpPr>
           <p:cNvPr id="17" name="Text 14"/>
           <p:cNvSpPr/>
           <p:nvPr/>
@@ -5453,7 +5453,7 @@
                 <a:ea typeface="Calibri" pitchFamily="34" charset="-122"/>
                 <a:cs typeface="Calibri" pitchFamily="34" charset="-120"/>
               </a:rPr>
-              <a:t>-25.8%</a:t>
+              <a:t>-66.8%</a:t>
             </a:r>
             <a:endParaRPr lang="en-US" sz="1200" dirty="0"/>
           </a:p>
@@ -5812,7 +5812,7 @@
         </p:nvGraphicFramePr>
         <p:xfrm>
           <a:off x="137160" y="841248"/>
-          <a:ext cx="11887200" cy="4754880"/>
+          <a:ext cx="11887200" cy="4297680"/>
         </p:xfrm>
         <a:graphic xmlns:a="http://schemas.openxmlformats.org/drawingml/2006/main">
           <a:graphicData uri="http://schemas.openxmlformats.org/drawingml/2006/chart">
@@ -5828,7 +5828,7 @@
         </p:nvSpPr>
         <p:spPr>
           <a:xfrm>
-            <a:off x="0" y="5641848"/>
+            <a:off x="0" y="5184648"/>
             <a:ext cx="12161520" cy="292608"/>
           </a:xfrm>
           <a:prstGeom prst="rect">
@@ -5853,7 +5853,7 @@
         </p:nvSpPr>
         <p:spPr>
           <a:xfrm>
-            <a:off x="0" y="5641848"/>
+            <a:off x="0" y="5184648"/>
             <a:ext cx="54864" cy="292608"/>
           </a:xfrm>
           <a:prstGeom prst="rect">
@@ -5878,7 +5878,7 @@
         </p:nvSpPr>
         <p:spPr>
           <a:xfrm>
-            <a:off x="109728" y="5641848"/>
+            <a:off x="109728" y="5184648"/>
             <a:ext cx="12051792" cy="292608"/>
           </a:xfrm>
           <a:prstGeom prst="rect">
@@ -5903,7 +5903,7 @@
                 <a:ea typeface="Century Gothic" pitchFamily="34" charset="-122"/>
                 <a:cs typeface="Century Gothic" pitchFamily="34" charset="-120"/>
               </a:rPr>
-              <a:t>% Change from Prior Month</a:t>
+              <a:t>% Change in Cost per Team vs Prior Month</a:t>
             </a:r>
             <a:endParaRPr lang="en-US" sz="1200" dirty="0"/>
           </a:p>
@@ -5917,7 +5917,163 @@
         </p:nvSpPr>
         <p:spPr>
           <a:xfrm>
-            <a:off x="137160" y="5943600"/>
+            <a:off x="137160" y="5486400"/>
+            <a:ext cx="2377440" cy="347472"/>
+          </a:xfrm>
+          <a:prstGeom prst="rect">
+            <a:avLst/>
+          </a:prstGeom>
+          <a:noFill/>
+          <a:ln/>
+        </p:spPr>
+        <p:txBody>
+          <a:bodyPr wrap="square" rtlCol="0" anchor="ctr"/>
+          <a:lstStyle/>
+          <a:p>
+            <a:pPr algn="ctr" indent="0" marL="0">
+              <a:buNone/>
+            </a:pPr>
+            <a:r>
+              <a:rPr lang="en-US" sz="1200" b="1" dirty="0">
+                <a:solidFill>
+                  <a:srgbClr val="718096"/>
+                </a:solidFill>
+                <a:latin typeface="Calibri" pitchFamily="34" charset="0"/>
+                <a:ea typeface="Calibri" pitchFamily="34" charset="-122"/>
+                <a:cs typeface="Calibri" pitchFamily="34" charset="-120"/>
+              </a:rPr>
+              <a:t>—</a:t>
+            </a:r>
+            <a:endParaRPr lang="en-US" sz="1200" dirty="0"/>
+          </a:p>
+        </p:txBody>
+      </p:sp>
+      <p:sp>
+        <p:nvSpPr>
+          <p:cNvPr id="16" name="Text 13"/>
+          <p:cNvSpPr/>
+          <p:nvPr/>
+        </p:nvSpPr>
+        <p:spPr>
+          <a:xfrm>
+            <a:off x="2514600" y="5486400"/>
+            <a:ext cx="2377440" cy="347472"/>
+          </a:xfrm>
+          <a:prstGeom prst="rect">
+            <a:avLst/>
+          </a:prstGeom>
+          <a:noFill/>
+          <a:ln/>
+        </p:spPr>
+        <p:txBody>
+          <a:bodyPr wrap="square" rtlCol="0" anchor="ctr"/>
+          <a:lstStyle/>
+          <a:p>
+            <a:pPr algn="ctr" indent="0" marL="0">
+              <a:buNone/>
+            </a:pPr>
+            <a:r>
+              <a:rPr lang="en-US" sz="1200" b="1" dirty="0">
+                <a:solidFill>
+                  <a:srgbClr val="1A7A6E"/>
+                </a:solidFill>
+                <a:latin typeface="Calibri" pitchFamily="34" charset="0"/>
+                <a:ea typeface="Calibri" pitchFamily="34" charset="-122"/>
+                <a:cs typeface="Calibri" pitchFamily="34" charset="-120"/>
+              </a:rPr>
+              <a:t>-75.4%</a:t>
+            </a:r>
+            <a:endParaRPr lang="en-US" sz="1200" dirty="0"/>
+          </a:p>
+        </p:txBody>
+      </p:sp>
+      <p:sp>
+        <p:nvSpPr>
+          <p:cNvPr id="17" name="Text 14"/>
+          <p:cNvSpPr/>
+          <p:nvPr/>
+        </p:nvSpPr>
+        <p:spPr>
+          <a:xfrm>
+            <a:off x="4892040" y="5486400"/>
+            <a:ext cx="2377440" cy="347472"/>
+          </a:xfrm>
+          <a:prstGeom prst="rect">
+            <a:avLst/>
+          </a:prstGeom>
+          <a:noFill/>
+          <a:ln/>
+        </p:spPr>
+        <p:txBody>
+          <a:bodyPr wrap="square" rtlCol="0" anchor="ctr"/>
+          <a:lstStyle/>
+          <a:p>
+            <a:pPr algn="ctr" indent="0" marL="0">
+              <a:buNone/>
+            </a:pPr>
+            <a:r>
+              <a:rPr lang="en-US" sz="1200" b="1" dirty="0">
+                <a:solidFill>
+                  <a:srgbClr val="1A7A6E"/>
+                </a:solidFill>
+                <a:latin typeface="Calibri" pitchFamily="34" charset="0"/>
+                <a:ea typeface="Calibri" pitchFamily="34" charset="-122"/>
+                <a:cs typeface="Calibri" pitchFamily="34" charset="-120"/>
+              </a:rPr>
+              <a:t>-27.3%</a:t>
+            </a:r>
+            <a:endParaRPr lang="en-US" sz="1200" dirty="0"/>
+          </a:p>
+        </p:txBody>
+      </p:sp>
+      <p:sp>
+        <p:nvSpPr>
+          <p:cNvPr id="18" name="Text 15"/>
+          <p:cNvSpPr/>
+          <p:nvPr/>
+        </p:nvSpPr>
+        <p:spPr>
+          <a:xfrm>
+            <a:off x="7269480" y="5486400"/>
+            <a:ext cx="2377440" cy="347472"/>
+          </a:xfrm>
+          <a:prstGeom prst="rect">
+            <a:avLst/>
+          </a:prstGeom>
+          <a:noFill/>
+          <a:ln/>
+        </p:spPr>
+        <p:txBody>
+          <a:bodyPr wrap="square" rtlCol="0" anchor="ctr"/>
+          <a:lstStyle/>
+          <a:p>
+            <a:pPr algn="ctr" indent="0" marL="0">
+              <a:buNone/>
+            </a:pPr>
+            <a:r>
+              <a:rPr lang="en-US" sz="1200" b="1" dirty="0">
+                <a:solidFill>
+                  <a:srgbClr val="718096"/>
+                </a:solidFill>
+                <a:latin typeface="Calibri" pitchFamily="34" charset="0"/>
+                <a:ea typeface="Calibri" pitchFamily="34" charset="-122"/>
+                <a:cs typeface="Calibri" pitchFamily="34" charset="-120"/>
+              </a:rPr>
+              <a:t>—</a:t>
+            </a:r>
+            <a:endParaRPr lang="en-US" sz="1200" dirty="0"/>
+          </a:p>
+        </p:txBody>
+      </p:sp>
+      <p:sp>
+        <p:nvSpPr>
+          <p:cNvPr id="19" name="Text 16"/>
+          <p:cNvSpPr/>
+          <p:nvPr/>
+        </p:nvSpPr>
+        <p:spPr>
+          <a:xfrm>
+            <a:off x="9646920" y="5486400"/>
             <a:ext cx="2377440" cy="347472"/>
           </a:xfrm>
           <a:prstGeom prst="rect">
@@ -5950,13 +6106,102 @@
       </p:sp>
       <p:sp>
         <p:nvSpPr>
-          <p:cNvPr id="16" name="Text 13"/>
-          <p:cNvSpPr/>
-          <p:nvPr/>
-        </p:nvSpPr>
-        <p:spPr>
-          <a:xfrm>
-            <a:off x="2514600" y="5943600"/>
+          <p:cNvPr id="20" name="Shape 17"/>
+          <p:cNvSpPr/>
+          <p:nvPr/>
+        </p:nvSpPr>
+        <p:spPr>
+          <a:xfrm>
+            <a:off x="0" y="5897880"/>
+            <a:ext cx="12161520" cy="292608"/>
+          </a:xfrm>
+          <a:prstGeom prst="rect">
+            <a:avLst/>
+          </a:prstGeom>
+          <a:solidFill>
+            <a:srgbClr val="FFF9D9"/>
+          </a:solidFill>
+          <a:ln w="12700">
+            <a:solidFill>
+              <a:srgbClr val="F0E0B8"/>
+            </a:solidFill>
+            <a:prstDash val="solid"/>
+          </a:ln>
+        </p:spPr>
+      </p:sp>
+      <p:sp>
+        <p:nvSpPr>
+          <p:cNvPr id="21" name="Shape 18"/>
+          <p:cNvSpPr/>
+          <p:nvPr/>
+        </p:nvSpPr>
+        <p:spPr>
+          <a:xfrm>
+            <a:off x="0" y="5897880"/>
+            <a:ext cx="54864" cy="292608"/>
+          </a:xfrm>
+          <a:prstGeom prst="rect">
+            <a:avLst/>
+          </a:prstGeom>
+          <a:solidFill>
+            <a:srgbClr val="5D300F"/>
+          </a:solidFill>
+          <a:ln w="12700">
+            <a:solidFill>
+              <a:srgbClr val="5D300F"/>
+            </a:solidFill>
+            <a:prstDash val="solid"/>
+          </a:ln>
+        </p:spPr>
+      </p:sp>
+      <p:sp>
+        <p:nvSpPr>
+          <p:cNvPr id="22" name="Text 19"/>
+          <p:cNvSpPr/>
+          <p:nvPr/>
+        </p:nvSpPr>
+        <p:spPr>
+          <a:xfrm>
+            <a:off x="109728" y="5897880"/>
+            <a:ext cx="12051792" cy="292608"/>
+          </a:xfrm>
+          <a:prstGeom prst="rect">
+            <a:avLst/>
+          </a:prstGeom>
+          <a:noFill/>
+          <a:ln/>
+        </p:spPr>
+        <p:txBody>
+          <a:bodyPr wrap="square" lIns="0" tIns="0" rIns="0" bIns="0" rtlCol="0" anchor="ctr"/>
+          <a:lstStyle/>
+          <a:p>
+            <a:pPr indent="0" marL="0">
+              <a:buNone/>
+            </a:pPr>
+            <a:r>
+              <a:rPr lang="en-US" sz="1200" b="1" dirty="0">
+                <a:solidFill>
+                  <a:srgbClr val="5D300F"/>
+                </a:solidFill>
+                <a:latin typeface="Century Gothic" pitchFamily="34" charset="0"/>
+                <a:ea typeface="Century Gothic" pitchFamily="34" charset="-122"/>
+                <a:cs typeface="Century Gothic" pitchFamily="34" charset="-120"/>
+              </a:rPr>
+              <a:t>% Change in Disb per Team vs Prior Month</a:t>
+            </a:r>
+            <a:endParaRPr lang="en-US" sz="1200" dirty="0"/>
+          </a:p>
+        </p:txBody>
+      </p:sp>
+      <p:sp>
+        <p:nvSpPr>
+          <p:cNvPr id="23" name="Text 20"/>
+          <p:cNvSpPr/>
+          <p:nvPr/>
+        </p:nvSpPr>
+        <p:spPr>
+          <a:xfrm>
+            <a:off x="137160" y="6199632"/>
             <a:ext cx="2377440" cy="347472"/>
           </a:xfrm>
           <a:prstGeom prst="rect">
@@ -5989,13 +6234,13 @@
       </p:sp>
       <p:sp>
         <p:nvSpPr>
-          <p:cNvPr id="17" name="Text 14"/>
-          <p:cNvSpPr/>
-          <p:nvPr/>
-        </p:nvSpPr>
-        <p:spPr>
-          <a:xfrm>
-            <a:off x="4892040" y="5943600"/>
+          <p:cNvPr id="24" name="Text 21"/>
+          <p:cNvSpPr/>
+          <p:nvPr/>
+        </p:nvSpPr>
+        <p:spPr>
+          <a:xfrm>
+            <a:off x="2514600" y="6199632"/>
             <a:ext cx="2377440" cy="347472"/>
           </a:xfrm>
           <a:prstGeom prst="rect">
@@ -6014,13 +6259,13 @@
             <a:r>
               <a:rPr lang="en-US" sz="1200" b="1" dirty="0">
                 <a:solidFill>
-                  <a:srgbClr val="1A7A6E"/>
+                  <a:srgbClr val="718096"/>
                 </a:solidFill>
                 <a:latin typeface="Calibri" pitchFamily="34" charset="0"/>
                 <a:ea typeface="Calibri" pitchFamily="34" charset="-122"/>
                 <a:cs typeface="Calibri" pitchFamily="34" charset="-120"/>
               </a:rPr>
-              <a:t>-75.4%</a:t>
+              <a:t>—</a:t>
             </a:r>
             <a:endParaRPr lang="en-US" sz="1200" dirty="0"/>
           </a:p>
@@ -6028,13 +6273,13 @@
       </p:sp>
       <p:sp>
         <p:nvSpPr>
-          <p:cNvPr id="18" name="Text 15"/>
-          <p:cNvSpPr/>
-          <p:nvPr/>
-        </p:nvSpPr>
-        <p:spPr>
-          <a:xfrm>
-            <a:off x="7269480" y="5943600"/>
+          <p:cNvPr id="25" name="Text 22"/>
+          <p:cNvSpPr/>
+          <p:nvPr/>
+        </p:nvSpPr>
+        <p:spPr>
+          <a:xfrm>
+            <a:off x="4892040" y="6199632"/>
             <a:ext cx="2377440" cy="347472"/>
           </a:xfrm>
           <a:prstGeom prst="rect">
@@ -6053,13 +6298,13 @@
             <a:r>
               <a:rPr lang="en-US" sz="1200" b="1" dirty="0">
                 <a:solidFill>
-                  <a:srgbClr val="1A7A6E"/>
+                  <a:srgbClr val="718096"/>
                 </a:solidFill>
                 <a:latin typeface="Calibri" pitchFamily="34" charset="0"/>
                 <a:ea typeface="Calibri" pitchFamily="34" charset="-122"/>
                 <a:cs typeface="Calibri" pitchFamily="34" charset="-120"/>
               </a:rPr>
-              <a:t>-27.3%</a:t>
+              <a:t>—</a:t>
             </a:r>
             <a:endParaRPr lang="en-US" sz="1200" dirty="0"/>
           </a:p>
@@ -6067,13 +6312,52 @@
       </p:sp>
       <p:sp>
         <p:nvSpPr>
-          <p:cNvPr id="19" name="Text 16"/>
-          <p:cNvSpPr/>
-          <p:nvPr/>
-        </p:nvSpPr>
-        <p:spPr>
-          <a:xfrm>
-            <a:off x="9646920" y="5943600"/>
+          <p:cNvPr id="26" name="Text 23"/>
+          <p:cNvSpPr/>
+          <p:nvPr/>
+        </p:nvSpPr>
+        <p:spPr>
+          <a:xfrm>
+            <a:off x="7269480" y="6199632"/>
+            <a:ext cx="2377440" cy="347472"/>
+          </a:xfrm>
+          <a:prstGeom prst="rect">
+            <a:avLst/>
+          </a:prstGeom>
+          <a:noFill/>
+          <a:ln/>
+        </p:spPr>
+        <p:txBody>
+          <a:bodyPr wrap="square" rtlCol="0" anchor="ctr"/>
+          <a:lstStyle/>
+          <a:p>
+            <a:pPr algn="ctr" indent="0" marL="0">
+              <a:buNone/>
+            </a:pPr>
+            <a:r>
+              <a:rPr lang="en-US" sz="1200" b="1" dirty="0">
+                <a:solidFill>
+                  <a:srgbClr val="718096"/>
+                </a:solidFill>
+                <a:latin typeface="Calibri" pitchFamily="34" charset="0"/>
+                <a:ea typeface="Calibri" pitchFamily="34" charset="-122"/>
+                <a:cs typeface="Calibri" pitchFamily="34" charset="-120"/>
+              </a:rPr>
+              <a:t>—</a:t>
+            </a:r>
+            <a:endParaRPr lang="en-US" sz="1200" dirty="0"/>
+          </a:p>
+        </p:txBody>
+      </p:sp>
+      <p:sp>
+        <p:nvSpPr>
+          <p:cNvPr id="27" name="Text 24"/>
+          <p:cNvSpPr/>
+          <p:nvPr/>
+        </p:nvSpPr>
+        <p:spPr>
+          <a:xfrm>
+            <a:off x="9646920" y="6199632"/>
             <a:ext cx="2377440" cy="347472"/>
           </a:xfrm>
           <a:prstGeom prst="rect">
@@ -6418,7 +6702,7 @@
         </p:nvGraphicFramePr>
         <p:xfrm>
           <a:off x="137160" y="841248"/>
-          <a:ext cx="11887200" cy="4754880"/>
+          <a:ext cx="11887200" cy="4297680"/>
         </p:xfrm>
         <a:graphic xmlns:a="http://schemas.openxmlformats.org/drawingml/2006/main">
           <a:graphicData uri="http://schemas.openxmlformats.org/drawingml/2006/chart">
@@ -6434,7 +6718,7 @@
         </p:nvSpPr>
         <p:spPr>
           <a:xfrm>
-            <a:off x="0" y="5641848"/>
+            <a:off x="0" y="5184648"/>
             <a:ext cx="12161520" cy="292608"/>
           </a:xfrm>
           <a:prstGeom prst="rect">
@@ -6459,7 +6743,7 @@
         </p:nvSpPr>
         <p:spPr>
           <a:xfrm>
-            <a:off x="0" y="5641848"/>
+            <a:off x="0" y="5184648"/>
             <a:ext cx="54864" cy="292608"/>
           </a:xfrm>
           <a:prstGeom prst="rect">
@@ -6484,7 +6768,7 @@
         </p:nvSpPr>
         <p:spPr>
           <a:xfrm>
-            <a:off x="109728" y="5641848"/>
+            <a:off x="109728" y="5184648"/>
             <a:ext cx="12051792" cy="292608"/>
           </a:xfrm>
           <a:prstGeom prst="rect">
@@ -6509,7 +6793,7 @@
                 <a:ea typeface="Century Gothic" pitchFamily="34" charset="-122"/>
                 <a:cs typeface="Century Gothic" pitchFamily="34" charset="-120"/>
               </a:rPr>
-              <a:t>% Change from Prior Month</a:t>
+              <a:t>% Change in Cost per Team vs Prior Month</a:t>
             </a:r>
             <a:endParaRPr lang="en-US" sz="1200" dirty="0"/>
           </a:p>
@@ -6523,7 +6807,124 @@
         </p:nvSpPr>
         <p:spPr>
           <a:xfrm>
-            <a:off x="137160" y="5943600"/>
+            <a:off x="137160" y="5486400"/>
+            <a:ext cx="2377440" cy="347472"/>
+          </a:xfrm>
+          <a:prstGeom prst="rect">
+            <a:avLst/>
+          </a:prstGeom>
+          <a:noFill/>
+          <a:ln/>
+        </p:spPr>
+        <p:txBody>
+          <a:bodyPr wrap="square" rtlCol="0" anchor="ctr"/>
+          <a:lstStyle/>
+          <a:p>
+            <a:pPr algn="ctr" indent="0" marL="0">
+              <a:buNone/>
+            </a:pPr>
+            <a:r>
+              <a:rPr lang="en-US" sz="1200" b="1" dirty="0">
+                <a:solidFill>
+                  <a:srgbClr val="1A7A6E"/>
+                </a:solidFill>
+                <a:latin typeface="Calibri" pitchFamily="34" charset="0"/>
+                <a:ea typeface="Calibri" pitchFamily="34" charset="-122"/>
+                <a:cs typeface="Calibri" pitchFamily="34" charset="-120"/>
+              </a:rPr>
+              <a:t>-66.1%</a:t>
+            </a:r>
+            <a:endParaRPr lang="en-US" sz="1200" dirty="0"/>
+          </a:p>
+        </p:txBody>
+      </p:sp>
+      <p:sp>
+        <p:nvSpPr>
+          <p:cNvPr id="16" name="Text 13"/>
+          <p:cNvSpPr/>
+          <p:nvPr/>
+        </p:nvSpPr>
+        <p:spPr>
+          <a:xfrm>
+            <a:off x="2514600" y="5486400"/>
+            <a:ext cx="2377440" cy="347472"/>
+          </a:xfrm>
+          <a:prstGeom prst="rect">
+            <a:avLst/>
+          </a:prstGeom>
+          <a:noFill/>
+          <a:ln/>
+        </p:spPr>
+        <p:txBody>
+          <a:bodyPr wrap="square" rtlCol="0" anchor="ctr"/>
+          <a:lstStyle/>
+          <a:p>
+            <a:pPr algn="ctr" indent="0" marL="0">
+              <a:buNone/>
+            </a:pPr>
+            <a:r>
+              <a:rPr lang="en-US" sz="1200" b="1" dirty="0">
+                <a:solidFill>
+                  <a:srgbClr val="718096"/>
+                </a:solidFill>
+                <a:latin typeface="Calibri" pitchFamily="34" charset="0"/>
+                <a:ea typeface="Calibri" pitchFamily="34" charset="-122"/>
+                <a:cs typeface="Calibri" pitchFamily="34" charset="-120"/>
+              </a:rPr>
+              <a:t>—</a:t>
+            </a:r>
+            <a:endParaRPr lang="en-US" sz="1200" dirty="0"/>
+          </a:p>
+        </p:txBody>
+      </p:sp>
+      <p:sp>
+        <p:nvSpPr>
+          <p:cNvPr id="17" name="Text 14"/>
+          <p:cNvSpPr/>
+          <p:nvPr/>
+        </p:nvSpPr>
+        <p:spPr>
+          <a:xfrm>
+            <a:off x="4892040" y="5486400"/>
+            <a:ext cx="2377440" cy="347472"/>
+          </a:xfrm>
+          <a:prstGeom prst="rect">
+            <a:avLst/>
+          </a:prstGeom>
+          <a:noFill/>
+          <a:ln/>
+        </p:spPr>
+        <p:txBody>
+          <a:bodyPr wrap="square" rtlCol="0" anchor="ctr"/>
+          <a:lstStyle/>
+          <a:p>
+            <a:pPr algn="ctr" indent="0" marL="0">
+              <a:buNone/>
+            </a:pPr>
+            <a:r>
+              <a:rPr lang="en-US" sz="1200" b="1" dirty="0">
+                <a:solidFill>
+                  <a:srgbClr val="C0392B"/>
+                </a:solidFill>
+                <a:latin typeface="Calibri" pitchFamily="34" charset="0"/>
+                <a:ea typeface="Calibri" pitchFamily="34" charset="-122"/>
+                <a:cs typeface="Calibri" pitchFamily="34" charset="-120"/>
+              </a:rPr>
+              <a:t>+21.1%</a:t>
+            </a:r>
+            <a:endParaRPr lang="en-US" sz="1200" dirty="0"/>
+          </a:p>
+        </p:txBody>
+      </p:sp>
+      <p:sp>
+        <p:nvSpPr>
+          <p:cNvPr id="18" name="Text 15"/>
+          <p:cNvSpPr/>
+          <p:nvPr/>
+        </p:nvSpPr>
+        <p:spPr>
+          <a:xfrm>
+            <a:off x="7269480" y="5486400"/>
             <a:ext cx="2377440" cy="347472"/>
           </a:xfrm>
           <a:prstGeom prst="rect">
@@ -6556,13 +6957,13 @@
       </p:sp>
       <p:sp>
         <p:nvSpPr>
-          <p:cNvPr id="16" name="Text 13"/>
-          <p:cNvSpPr/>
-          <p:nvPr/>
-        </p:nvSpPr>
-        <p:spPr>
-          <a:xfrm>
-            <a:off x="2514600" y="5943600"/>
+          <p:cNvPr id="19" name="Text 16"/>
+          <p:cNvSpPr/>
+          <p:nvPr/>
+        </p:nvSpPr>
+        <p:spPr>
+          <a:xfrm>
+            <a:off x="9646920" y="5486400"/>
             <a:ext cx="2377440" cy="347472"/>
           </a:xfrm>
           <a:prstGeom prst="rect">
@@ -6595,13 +6996,102 @@
       </p:sp>
       <p:sp>
         <p:nvSpPr>
-          <p:cNvPr id="17" name="Text 14"/>
-          <p:cNvSpPr/>
-          <p:nvPr/>
-        </p:nvSpPr>
-        <p:spPr>
-          <a:xfrm>
-            <a:off x="4892040" y="5943600"/>
+          <p:cNvPr id="20" name="Shape 17"/>
+          <p:cNvSpPr/>
+          <p:nvPr/>
+        </p:nvSpPr>
+        <p:spPr>
+          <a:xfrm>
+            <a:off x="0" y="5897880"/>
+            <a:ext cx="12161520" cy="292608"/>
+          </a:xfrm>
+          <a:prstGeom prst="rect">
+            <a:avLst/>
+          </a:prstGeom>
+          <a:solidFill>
+            <a:srgbClr val="FFF9D9"/>
+          </a:solidFill>
+          <a:ln w="12700">
+            <a:solidFill>
+              <a:srgbClr val="F0E0B8"/>
+            </a:solidFill>
+            <a:prstDash val="solid"/>
+          </a:ln>
+        </p:spPr>
+      </p:sp>
+      <p:sp>
+        <p:nvSpPr>
+          <p:cNvPr id="21" name="Shape 18"/>
+          <p:cNvSpPr/>
+          <p:nvPr/>
+        </p:nvSpPr>
+        <p:spPr>
+          <a:xfrm>
+            <a:off x="0" y="5897880"/>
+            <a:ext cx="54864" cy="292608"/>
+          </a:xfrm>
+          <a:prstGeom prst="rect">
+            <a:avLst/>
+          </a:prstGeom>
+          <a:solidFill>
+            <a:srgbClr val="5D300F"/>
+          </a:solidFill>
+          <a:ln w="12700">
+            <a:solidFill>
+              <a:srgbClr val="5D300F"/>
+            </a:solidFill>
+            <a:prstDash val="solid"/>
+          </a:ln>
+        </p:spPr>
+      </p:sp>
+      <p:sp>
+        <p:nvSpPr>
+          <p:cNvPr id="22" name="Text 19"/>
+          <p:cNvSpPr/>
+          <p:nvPr/>
+        </p:nvSpPr>
+        <p:spPr>
+          <a:xfrm>
+            <a:off x="109728" y="5897880"/>
+            <a:ext cx="12051792" cy="292608"/>
+          </a:xfrm>
+          <a:prstGeom prst="rect">
+            <a:avLst/>
+          </a:prstGeom>
+          <a:noFill/>
+          <a:ln/>
+        </p:spPr>
+        <p:txBody>
+          <a:bodyPr wrap="square" lIns="0" tIns="0" rIns="0" bIns="0" rtlCol="0" anchor="ctr"/>
+          <a:lstStyle/>
+          <a:p>
+            <a:pPr indent="0" marL="0">
+              <a:buNone/>
+            </a:pPr>
+            <a:r>
+              <a:rPr lang="en-US" sz="1200" b="1" dirty="0">
+                <a:solidFill>
+                  <a:srgbClr val="5D300F"/>
+                </a:solidFill>
+                <a:latin typeface="Century Gothic" pitchFamily="34" charset="0"/>
+                <a:ea typeface="Century Gothic" pitchFamily="34" charset="-122"/>
+                <a:cs typeface="Century Gothic" pitchFamily="34" charset="-120"/>
+              </a:rPr>
+              <a:t>% Change in Disb per Team vs Prior Month</a:t>
+            </a:r>
+            <a:endParaRPr lang="en-US" sz="1200" dirty="0"/>
+          </a:p>
+        </p:txBody>
+      </p:sp>
+      <p:sp>
+        <p:nvSpPr>
+          <p:cNvPr id="23" name="Text 20"/>
+          <p:cNvSpPr/>
+          <p:nvPr/>
+        </p:nvSpPr>
+        <p:spPr>
+          <a:xfrm>
+            <a:off x="137160" y="6199632"/>
             <a:ext cx="2377440" cy="347472"/>
           </a:xfrm>
           <a:prstGeom prst="rect">
@@ -6620,13 +7110,13 @@
             <a:r>
               <a:rPr lang="en-US" sz="1200" b="1" dirty="0">
                 <a:solidFill>
-                  <a:srgbClr val="C0392B"/>
+                  <a:srgbClr val="718096"/>
                 </a:solidFill>
                 <a:latin typeface="Calibri" pitchFamily="34" charset="0"/>
                 <a:ea typeface="Calibri" pitchFamily="34" charset="-122"/>
                 <a:cs typeface="Calibri" pitchFamily="34" charset="-120"/>
               </a:rPr>
-              <a:t>+21.1%</a:t>
+              <a:t>—</a:t>
             </a:r>
             <a:endParaRPr lang="en-US" sz="1200" dirty="0"/>
           </a:p>
@@ -6634,13 +7124,13 @@
       </p:sp>
       <p:sp>
         <p:nvSpPr>
-          <p:cNvPr id="18" name="Text 15"/>
-          <p:cNvSpPr/>
-          <p:nvPr/>
-        </p:nvSpPr>
-        <p:spPr>
-          <a:xfrm>
-            <a:off x="7269480" y="5943600"/>
+          <p:cNvPr id="24" name="Text 21"/>
+          <p:cNvSpPr/>
+          <p:nvPr/>
+        </p:nvSpPr>
+        <p:spPr>
+          <a:xfrm>
+            <a:off x="2514600" y="6199632"/>
             <a:ext cx="2377440" cy="347472"/>
           </a:xfrm>
           <a:prstGeom prst="rect">
@@ -6659,13 +7149,13 @@
             <a:r>
               <a:rPr lang="en-US" sz="1200" b="1" dirty="0">
                 <a:solidFill>
-                  <a:srgbClr val="1A7A6E"/>
+                  <a:srgbClr val="718096"/>
                 </a:solidFill>
                 <a:latin typeface="Calibri" pitchFamily="34" charset="0"/>
                 <a:ea typeface="Calibri" pitchFamily="34" charset="-122"/>
                 <a:cs typeface="Calibri" pitchFamily="34" charset="-120"/>
               </a:rPr>
-              <a:t>-66.1%</a:t>
+              <a:t>—</a:t>
             </a:r>
             <a:endParaRPr lang="en-US" sz="1200" dirty="0"/>
           </a:p>
@@ -6673,13 +7163,91 @@
       </p:sp>
       <p:sp>
         <p:nvSpPr>
-          <p:cNvPr id="19" name="Text 16"/>
-          <p:cNvSpPr/>
-          <p:nvPr/>
-        </p:nvSpPr>
-        <p:spPr>
-          <a:xfrm>
-            <a:off x="9646920" y="5943600"/>
+          <p:cNvPr id="25" name="Text 22"/>
+          <p:cNvSpPr/>
+          <p:nvPr/>
+        </p:nvSpPr>
+        <p:spPr>
+          <a:xfrm>
+            <a:off x="4892040" y="6199632"/>
+            <a:ext cx="2377440" cy="347472"/>
+          </a:xfrm>
+          <a:prstGeom prst="rect">
+            <a:avLst/>
+          </a:prstGeom>
+          <a:noFill/>
+          <a:ln/>
+        </p:spPr>
+        <p:txBody>
+          <a:bodyPr wrap="square" rtlCol="0" anchor="ctr"/>
+          <a:lstStyle/>
+          <a:p>
+            <a:pPr algn="ctr" indent="0" marL="0">
+              <a:buNone/>
+            </a:pPr>
+            <a:r>
+              <a:rPr lang="en-US" sz="1200" b="1" dirty="0">
+                <a:solidFill>
+                  <a:srgbClr val="718096"/>
+                </a:solidFill>
+                <a:latin typeface="Calibri" pitchFamily="34" charset="0"/>
+                <a:ea typeface="Calibri" pitchFamily="34" charset="-122"/>
+                <a:cs typeface="Calibri" pitchFamily="34" charset="-120"/>
+              </a:rPr>
+              <a:t>—</a:t>
+            </a:r>
+            <a:endParaRPr lang="en-US" sz="1200" dirty="0"/>
+          </a:p>
+        </p:txBody>
+      </p:sp>
+      <p:sp>
+        <p:nvSpPr>
+          <p:cNvPr id="26" name="Text 23"/>
+          <p:cNvSpPr/>
+          <p:nvPr/>
+        </p:nvSpPr>
+        <p:spPr>
+          <a:xfrm>
+            <a:off x="7269480" y="6199632"/>
+            <a:ext cx="2377440" cy="347472"/>
+          </a:xfrm>
+          <a:prstGeom prst="rect">
+            <a:avLst/>
+          </a:prstGeom>
+          <a:noFill/>
+          <a:ln/>
+        </p:spPr>
+        <p:txBody>
+          <a:bodyPr wrap="square" rtlCol="0" anchor="ctr"/>
+          <a:lstStyle/>
+          <a:p>
+            <a:pPr algn="ctr" indent="0" marL="0">
+              <a:buNone/>
+            </a:pPr>
+            <a:r>
+              <a:rPr lang="en-US" sz="1200" b="1" dirty="0">
+                <a:solidFill>
+                  <a:srgbClr val="718096"/>
+                </a:solidFill>
+                <a:latin typeface="Calibri" pitchFamily="34" charset="0"/>
+                <a:ea typeface="Calibri" pitchFamily="34" charset="-122"/>
+                <a:cs typeface="Calibri" pitchFamily="34" charset="-120"/>
+              </a:rPr>
+              <a:t>—</a:t>
+            </a:r>
+            <a:endParaRPr lang="en-US" sz="1200" dirty="0"/>
+          </a:p>
+        </p:txBody>
+      </p:sp>
+      <p:sp>
+        <p:nvSpPr>
+          <p:cNvPr id="27" name="Text 24"/>
+          <p:cNvSpPr/>
+          <p:nvPr/>
+        </p:nvSpPr>
+        <p:spPr>
+          <a:xfrm>
+            <a:off x="9646920" y="6199632"/>
             <a:ext cx="2377440" cy="347472"/>
           </a:xfrm>
           <a:prstGeom prst="rect">
@@ -10386,6 +10954,109 @@
                 <a:ea typeface="Calibri" pitchFamily="34" charset="-122"/>
                 <a:cs typeface="Calibri" pitchFamily="34" charset="-120"/>
               </a:rPr>
+              <a:t>Sierra Leone</a:t>
+            </a:r>
+            <a:endParaRPr lang="en-US" sz="1200" dirty="0"/>
+          </a:p>
+        </p:txBody>
+      </p:sp>
+      <p:sp>
+        <p:nvSpPr>
+          <p:cNvPr id="43" name="Text 40"/>
+          <p:cNvSpPr/>
+          <p:nvPr/>
+        </p:nvSpPr>
+        <p:spPr>
+          <a:xfrm>
+            <a:off x="10661904" y="4389120"/>
+            <a:ext cx="1234440" cy="310896"/>
+          </a:xfrm>
+          <a:prstGeom prst="rect">
+            <a:avLst/>
+          </a:prstGeom>
+          <a:noFill/>
+          <a:ln/>
+        </p:spPr>
+        <p:txBody>
+          <a:bodyPr wrap="square" rtlCol="0" anchor="ctr"/>
+          <a:lstStyle/>
+          <a:p>
+            <a:pPr algn="ctr" indent="0" marL="0">
+              <a:buNone/>
+            </a:pPr>
+            <a:r>
+              <a:rPr lang="en-US" sz="1200" b="1" dirty="0">
+                <a:solidFill>
+                  <a:srgbClr val="5D300F"/>
+                </a:solidFill>
+                <a:latin typeface="Century Gothic" pitchFamily="34" charset="0"/>
+                <a:ea typeface="Century Gothic" pitchFamily="34" charset="-122"/>
+                <a:cs typeface="Century Gothic" pitchFamily="34" charset="-120"/>
+              </a:rPr>
+              <a:t>33</a:t>
+            </a:r>
+            <a:endParaRPr lang="en-US" sz="1200" dirty="0"/>
+          </a:p>
+        </p:txBody>
+      </p:sp>
+      <p:sp>
+        <p:nvSpPr>
+          <p:cNvPr id="44" name="Shape 41"/>
+          <p:cNvSpPr/>
+          <p:nvPr/>
+        </p:nvSpPr>
+        <p:spPr>
+          <a:xfrm>
+            <a:off x="7955280" y="4791456"/>
+            <a:ext cx="1234440" cy="566928"/>
+          </a:xfrm>
+          <a:prstGeom prst="rect">
+            <a:avLst/>
+          </a:prstGeom>
+          <a:solidFill>
+            <a:srgbClr val="FFF9D9"/>
+          </a:solidFill>
+          <a:ln w="12700">
+            <a:solidFill>
+              <a:srgbClr val="D6CFC4"/>
+            </a:solidFill>
+            <a:prstDash val="solid"/>
+          </a:ln>
+        </p:spPr>
+      </p:sp>
+      <p:sp>
+        <p:nvSpPr>
+          <p:cNvPr id="45" name="Text 42"/>
+          <p:cNvSpPr/>
+          <p:nvPr/>
+        </p:nvSpPr>
+        <p:spPr>
+          <a:xfrm>
+            <a:off x="7955280" y="4791456"/>
+            <a:ext cx="1234440" cy="256032"/>
+          </a:xfrm>
+          <a:prstGeom prst="rect">
+            <a:avLst/>
+          </a:prstGeom>
+          <a:noFill/>
+          <a:ln/>
+        </p:spPr>
+        <p:txBody>
+          <a:bodyPr wrap="square" rtlCol="0" anchor="b"/>
+          <a:lstStyle/>
+          <a:p>
+            <a:pPr algn="ctr" indent="0" marL="0">
+              <a:buNone/>
+            </a:pPr>
+            <a:r>
+              <a:rPr lang="en-US" sz="1200" dirty="0">
+                <a:solidFill>
+                  <a:srgbClr val="718096"/>
+                </a:solidFill>
+                <a:latin typeface="Calibri" pitchFamily="34" charset="0"/>
+                <a:ea typeface="Calibri" pitchFamily="34" charset="-122"/>
+                <a:cs typeface="Calibri" pitchFamily="34" charset="-120"/>
+              </a:rPr>
               <a:t>Uganda</a:t>
             </a:r>
             <a:endParaRPr lang="en-US" sz="1200" dirty="0"/>
@@ -10394,13 +11065,13 @@
       </p:sp>
       <p:sp>
         <p:nvSpPr>
-          <p:cNvPr id="43" name="Text 40"/>
-          <p:cNvSpPr/>
-          <p:nvPr/>
-        </p:nvSpPr>
-        <p:spPr>
-          <a:xfrm>
-            <a:off x="10661904" y="4389120"/>
+          <p:cNvPr id="46" name="Text 43"/>
+          <p:cNvSpPr/>
+          <p:nvPr/>
+        </p:nvSpPr>
+        <p:spPr>
+          <a:xfrm>
+            <a:off x="7955280" y="5047488"/>
             <a:ext cx="1234440" cy="310896"/>
           </a:xfrm>
           <a:prstGeom prst="rect">
@@ -10426,109 +11097,6 @@
                 <a:cs typeface="Century Gothic" pitchFamily="34" charset="-120"/>
               </a:rPr>
               <a:t>39</a:t>
-            </a:r>
-            <a:endParaRPr lang="en-US" sz="1200" dirty="0"/>
-          </a:p>
-        </p:txBody>
-      </p:sp>
-      <p:sp>
-        <p:nvSpPr>
-          <p:cNvPr id="44" name="Shape 41"/>
-          <p:cNvSpPr/>
-          <p:nvPr/>
-        </p:nvSpPr>
-        <p:spPr>
-          <a:xfrm>
-            <a:off x="7955280" y="4791456"/>
-            <a:ext cx="1234440" cy="566928"/>
-          </a:xfrm>
-          <a:prstGeom prst="rect">
-            <a:avLst/>
-          </a:prstGeom>
-          <a:solidFill>
-            <a:srgbClr val="FFF9D9"/>
-          </a:solidFill>
-          <a:ln w="12700">
-            <a:solidFill>
-              <a:srgbClr val="D6CFC4"/>
-            </a:solidFill>
-            <a:prstDash val="solid"/>
-          </a:ln>
-        </p:spPr>
-      </p:sp>
-      <p:sp>
-        <p:nvSpPr>
-          <p:cNvPr id="45" name="Text 42"/>
-          <p:cNvSpPr/>
-          <p:nvPr/>
-        </p:nvSpPr>
-        <p:spPr>
-          <a:xfrm>
-            <a:off x="7955280" y="4791456"/>
-            <a:ext cx="1234440" cy="256032"/>
-          </a:xfrm>
-          <a:prstGeom prst="rect">
-            <a:avLst/>
-          </a:prstGeom>
-          <a:noFill/>
-          <a:ln/>
-        </p:spPr>
-        <p:txBody>
-          <a:bodyPr wrap="square" rtlCol="0" anchor="b"/>
-          <a:lstStyle/>
-          <a:p>
-            <a:pPr algn="ctr" indent="0" marL="0">
-              <a:buNone/>
-            </a:pPr>
-            <a:r>
-              <a:rPr lang="en-US" sz="1200" dirty="0">
-                <a:solidFill>
-                  <a:srgbClr val="718096"/>
-                </a:solidFill>
-                <a:latin typeface="Calibri" pitchFamily="34" charset="0"/>
-                <a:ea typeface="Calibri" pitchFamily="34" charset="-122"/>
-                <a:cs typeface="Calibri" pitchFamily="34" charset="-120"/>
-              </a:rPr>
-              <a:t>Sierra Leone</a:t>
-            </a:r>
-            <a:endParaRPr lang="en-US" sz="1200" dirty="0"/>
-          </a:p>
-        </p:txBody>
-      </p:sp>
-      <p:sp>
-        <p:nvSpPr>
-          <p:cNvPr id="46" name="Text 43"/>
-          <p:cNvSpPr/>
-          <p:nvPr/>
-        </p:nvSpPr>
-        <p:spPr>
-          <a:xfrm>
-            <a:off x="7955280" y="5047488"/>
-            <a:ext cx="1234440" cy="310896"/>
-          </a:xfrm>
-          <a:prstGeom prst="rect">
-            <a:avLst/>
-          </a:prstGeom>
-          <a:noFill/>
-          <a:ln/>
-        </p:spPr>
-        <p:txBody>
-          <a:bodyPr wrap="square" rtlCol="0" anchor="ctr"/>
-          <a:lstStyle/>
-          <a:p>
-            <a:pPr algn="ctr" indent="0" marL="0">
-              <a:buNone/>
-            </a:pPr>
-            <a:r>
-              <a:rPr lang="en-US" sz="1200" b="1" dirty="0">
-                <a:solidFill>
-                  <a:srgbClr val="5D300F"/>
-                </a:solidFill>
-                <a:latin typeface="Century Gothic" pitchFamily="34" charset="0"/>
-                <a:ea typeface="Century Gothic" pitchFamily="34" charset="-122"/>
-                <a:cs typeface="Century Gothic" pitchFamily="34" charset="-120"/>
-              </a:rPr>
-              <a:t>33</a:t>
             </a:r>
             <a:endParaRPr lang="en-US" sz="1200" dirty="0"/>
           </a:p>
@@ -13424,7 +13992,7 @@
                           <a:ea typeface="Century Gothic" pitchFamily="34" charset="-122"/>
                           <a:cs typeface="Century Gothic" pitchFamily="34" charset="-120"/>
                         </a:rPr>
-                        <a:t>Tanzania</a:t>
+                        <a:t>Sierra Leone</a:t>
                       </a:r>
                       <a:endParaRPr lang="en-US" sz="1200" dirty="0">
                         <a:latin typeface="Century Gothic" charset="0"/>
@@ -13560,7 +14128,7 @@
                           <a:ea typeface="Calibri" pitchFamily="34" charset="-122"/>
                           <a:cs typeface="Calibri" pitchFamily="34" charset="-120"/>
                         </a:rPr>
-                        <a:t>4.5%</a:t>
+                        <a:t>2.7%</a:t>
                       </a:r>
                       <a:endParaRPr lang="en-US" sz="1200" dirty="0">
                         <a:latin typeface="Calibri" charset="0"/>
@@ -13698,7 +14266,7 @@
                           <a:ea typeface="Century Gothic" pitchFamily="34" charset="-122"/>
                           <a:cs typeface="Century Gothic" pitchFamily="34" charset="-120"/>
                         </a:rPr>
-                        <a:t>Kenya</a:t>
+                        <a:t>Tanzania</a:t>
                       </a:r>
                       <a:endParaRPr lang="en-US" sz="1200" dirty="0">
                         <a:latin typeface="Century Gothic" charset="0"/>
@@ -13834,7 +14402,7 @@
                           <a:ea typeface="Calibri" pitchFamily="34" charset="-122"/>
                           <a:cs typeface="Calibri" pitchFamily="34" charset="-120"/>
                         </a:rPr>
-                        <a:t>5.1%</a:t>
+                        <a:t>4.5%</a:t>
                       </a:r>
                       <a:endParaRPr lang="en-US" sz="1200" dirty="0">
                         <a:latin typeface="Calibri" charset="0"/>
@@ -13972,7 +14540,7 @@
                           <a:ea typeface="Century Gothic" pitchFamily="34" charset="-122"/>
                           <a:cs typeface="Century Gothic" pitchFamily="34" charset="-120"/>
                         </a:rPr>
-                        <a:t>Uganda</a:t>
+                        <a:t>Kenya</a:t>
                       </a:r>
                       <a:endParaRPr lang="en-US" sz="1200" dirty="0">
                         <a:latin typeface="Century Gothic" charset="0"/>
@@ -14108,7 +14676,7 @@
                           <a:ea typeface="Calibri" pitchFamily="34" charset="-122"/>
                           <a:cs typeface="Calibri" pitchFamily="34" charset="-120"/>
                         </a:rPr>
-                        <a:t>11.1%</a:t>
+                        <a:t>5.1%</a:t>
                       </a:r>
                       <a:endParaRPr lang="en-US" sz="1200" dirty="0">
                         <a:latin typeface="Calibri" charset="0"/>
@@ -14246,7 +14814,7 @@
                           <a:ea typeface="Century Gothic" pitchFamily="34" charset="-122"/>
                           <a:cs typeface="Century Gothic" pitchFamily="34" charset="-120"/>
                         </a:rPr>
-                        <a:t>Sierra Leone</a:t>
+                        <a:t>Uganda</a:t>
                       </a:r>
                       <a:endParaRPr lang="en-US" sz="1200" dirty="0">
                         <a:latin typeface="Century Gothic" charset="0"/>
@@ -14382,7 +14950,7 @@
                           <a:ea typeface="Calibri" pitchFamily="34" charset="-122"/>
                           <a:cs typeface="Calibri" pitchFamily="34" charset="-120"/>
                         </a:rPr>
-                        <a:t>2.7%</a:t>
+                        <a:t>11.1%</a:t>
                       </a:r>
                       <a:endParaRPr lang="en-US" sz="1200" dirty="0">
                         <a:latin typeface="Calibri" charset="0"/>
@@ -15680,7 +16248,7 @@
                           <a:ea typeface="Century Gothic" pitchFamily="34" charset="-122"/>
                           <a:cs typeface="Century Gothic" pitchFamily="34" charset="-120"/>
                         </a:rPr>
-                        <a:t>Tanzania</a:t>
+                        <a:t>Sierra Leone</a:t>
                       </a:r>
                       <a:endParaRPr lang="en-US" sz="1200" dirty="0">
                         <a:latin typeface="Century Gothic" charset="0"/>
@@ -15816,7 +16384,7 @@
                           <a:ea typeface="Calibri" pitchFamily="34" charset="-122"/>
                           <a:cs typeface="Calibri" pitchFamily="34" charset="-120"/>
                         </a:rPr>
-                        <a:t>8.2%</a:t>
+                        <a:t>2.0%</a:t>
                       </a:r>
                       <a:endParaRPr lang="en-US" sz="1200" dirty="0">
                         <a:latin typeface="Calibri" charset="0"/>
@@ -16228,7 +16796,7 @@
                           <a:ea typeface="Century Gothic" pitchFamily="34" charset="-122"/>
                           <a:cs typeface="Century Gothic" pitchFamily="34" charset="-120"/>
                         </a:rPr>
-                        <a:t>Uganda</a:t>
+                        <a:t>Tanzania</a:t>
                       </a:r>
                       <a:endParaRPr lang="en-US" sz="1200" dirty="0">
                         <a:latin typeface="Century Gothic" charset="0"/>
@@ -16364,7 +16932,7 @@
                           <a:ea typeface="Calibri" pitchFamily="34" charset="-122"/>
                           <a:cs typeface="Calibri" pitchFamily="34" charset="-120"/>
                         </a:rPr>
-                        <a:t>17.4%</a:t>
+                        <a:t>8.2%</a:t>
                       </a:r>
                       <a:endParaRPr lang="en-US" sz="1200" dirty="0">
                         <a:latin typeface="Calibri" charset="0"/>
@@ -16502,7 +17070,7 @@
                           <a:ea typeface="Century Gothic" pitchFamily="34" charset="-122"/>
                           <a:cs typeface="Century Gothic" pitchFamily="34" charset="-120"/>
                         </a:rPr>
-                        <a:t>Sierra Leone</a:t>
+                        <a:t>Nigeria</a:t>
                       </a:r>
                       <a:endParaRPr lang="en-US" sz="1200" dirty="0">
                         <a:latin typeface="Century Gothic" charset="0"/>
@@ -16638,7 +17206,7 @@
                           <a:ea typeface="Calibri" pitchFamily="34" charset="-122"/>
                           <a:cs typeface="Calibri" pitchFamily="34" charset="-120"/>
                         </a:rPr>
-                        <a:t>2.0%</a:t>
+                        <a:t>17.0%</a:t>
                       </a:r>
                       <a:endParaRPr lang="en-US" sz="1200" dirty="0">
                         <a:latin typeface="Calibri" charset="0"/>
@@ -16776,7 +17344,7 @@
                           <a:ea typeface="Century Gothic" pitchFamily="34" charset="-122"/>
                           <a:cs typeface="Century Gothic" pitchFamily="34" charset="-120"/>
                         </a:rPr>
-                        <a:t>Nigeria</a:t>
+                        <a:t>Uganda</a:t>
                       </a:r>
                       <a:endParaRPr lang="en-US" sz="1200" dirty="0">
                         <a:latin typeface="Century Gothic" charset="0"/>
@@ -16912,7 +17480,7 @@
                           <a:ea typeface="Calibri" pitchFamily="34" charset="-122"/>
                           <a:cs typeface="Calibri" pitchFamily="34" charset="-120"/>
                         </a:rPr>
-                        <a:t>17.0%</a:t>
+                        <a:t>17.4%</a:t>
                       </a:r>
                       <a:endParaRPr lang="en-US" sz="1200" dirty="0">
                         <a:latin typeface="Calibri" charset="0"/>
@@ -19099,6 +19667,484 @@
                           <a:ea typeface="Century Gothic" pitchFamily="34" charset="-122"/>
                           <a:cs typeface="Century Gothic" pitchFamily="34" charset="-120"/>
                         </a:rPr>
+                        <a:t>Sierra Leone</a:t>
+                      </a:r>
+                      <a:endParaRPr lang="en-US" sz="1200" dirty="0">
+                        <a:latin typeface="Century Gothic" charset="0"/>
+                        <a:ea typeface="Century Gothic" charset="0"/>
+                        <a:cs typeface="Century Gothic" charset="0"/>
+                      </a:endParaRPr>
+                    </a:p>
+                  </a:txBody>
+                  <a:tcPr marL="91440" marR="91440" marT="45720" marB="45720" anchor="ctr">
+                    <a:lnL w="6350" cap="flat" cmpd="sng" algn="ctr">
+                      <a:solidFill>
+                        <a:srgbClr val="D6CFC4"/>
+                      </a:solidFill>
+                      <a:prstDash val="solid"/>
+                      <a:round/>
+                      <a:headEnd type="none" w="med" len="med"/>
+                      <a:tailEnd type="none" w="med" len="med"/>
+                    </a:lnL>
+                    <a:lnR w="6350" cap="flat" cmpd="sng" algn="ctr">
+                      <a:solidFill>
+                        <a:srgbClr val="D6CFC4"/>
+                      </a:solidFill>
+                      <a:prstDash val="solid"/>
+                      <a:round/>
+                      <a:headEnd type="none" w="med" len="med"/>
+                      <a:tailEnd type="none" w="med" len="med"/>
+                    </a:lnR>
+                    <a:lnT w="6350" cap="flat" cmpd="sng" algn="ctr">
+                      <a:solidFill>
+                        <a:srgbClr val="D6CFC4"/>
+                      </a:solidFill>
+                      <a:prstDash val="solid"/>
+                      <a:round/>
+                      <a:headEnd type="none" w="med" len="med"/>
+                      <a:tailEnd type="none" w="med" len="med"/>
+                    </a:lnT>
+                    <a:lnB w="6350" cap="flat" cmpd="sng" algn="ctr">
+                      <a:solidFill>
+                        <a:srgbClr val="D6CFC4"/>
+                      </a:solidFill>
+                      <a:prstDash val="solid"/>
+                      <a:round/>
+                      <a:headEnd type="none" w="med" len="med"/>
+                      <a:tailEnd type="none" w="med" len="med"/>
+                    </a:lnB>
+                    <a:solidFill>
+                      <a:srgbClr val="FFFFFF"/>
+                    </a:solidFill>
+                  </a:tcPr>
+                </a:tc>
+                <a:tc>
+                  <a:txBody>
+                    <a:bodyPr/>
+                    <a:lstStyle/>
+                    <a:p>
+                      <a:pPr algn="ctr" indent="0" marL="0">
+                        <a:buNone/>
+                      </a:pPr>
+                      <a:r>
+                        <a:rPr lang="en-US" sz="1200" dirty="0">
+                          <a:solidFill>
+                            <a:srgbClr val="2D2A26"/>
+                          </a:solidFill>
+                          <a:latin typeface="Calibri" pitchFamily="34" charset="0"/>
+                          <a:ea typeface="Calibri" pitchFamily="34" charset="-122"/>
+                          <a:cs typeface="Calibri" pitchFamily="34" charset="-120"/>
+                        </a:rPr>
+                        <a:t>$183,186</a:t>
+                      </a:r>
+                      <a:endParaRPr lang="en-US" sz="1200" dirty="0">
+                        <a:latin typeface="Calibri" charset="0"/>
+                        <a:ea typeface="Calibri" charset="0"/>
+                        <a:cs typeface="Calibri" charset="0"/>
+                      </a:endParaRPr>
+                    </a:p>
+                  </a:txBody>
+                  <a:tcPr marL="91440" marR="91440" marT="45720" marB="45720" anchor="ctr">
+                    <a:lnL w="6350" cap="flat" cmpd="sng" algn="ctr">
+                      <a:solidFill>
+                        <a:srgbClr val="D6CFC4"/>
+                      </a:solidFill>
+                      <a:prstDash val="solid"/>
+                      <a:round/>
+                      <a:headEnd type="none" w="med" len="med"/>
+                      <a:tailEnd type="none" w="med" len="med"/>
+                    </a:lnL>
+                    <a:lnR w="6350" cap="flat" cmpd="sng" algn="ctr">
+                      <a:solidFill>
+                        <a:srgbClr val="D6CFC4"/>
+                      </a:solidFill>
+                      <a:prstDash val="solid"/>
+                      <a:round/>
+                      <a:headEnd type="none" w="med" len="med"/>
+                      <a:tailEnd type="none" w="med" len="med"/>
+                    </a:lnR>
+                    <a:lnT w="6350" cap="flat" cmpd="sng" algn="ctr">
+                      <a:solidFill>
+                        <a:srgbClr val="D6CFC4"/>
+                      </a:solidFill>
+                      <a:prstDash val="solid"/>
+                      <a:round/>
+                      <a:headEnd type="none" w="med" len="med"/>
+                      <a:tailEnd type="none" w="med" len="med"/>
+                    </a:lnT>
+                    <a:lnB w="6350" cap="flat" cmpd="sng" algn="ctr">
+                      <a:solidFill>
+                        <a:srgbClr val="D6CFC4"/>
+                      </a:solidFill>
+                      <a:prstDash val="solid"/>
+                      <a:round/>
+                      <a:headEnd type="none" w="med" len="med"/>
+                      <a:tailEnd type="none" w="med" len="med"/>
+                    </a:lnB>
+                    <a:solidFill>
+                      <a:srgbClr val="FFFFFF"/>
+                    </a:solidFill>
+                  </a:tcPr>
+                </a:tc>
+                <a:tc>
+                  <a:txBody>
+                    <a:bodyPr/>
+                    <a:lstStyle/>
+                    <a:p>
+                      <a:pPr algn="ctr" indent="0" marL="0">
+                        <a:buNone/>
+                      </a:pPr>
+                      <a:r>
+                        <a:rPr lang="en-US" sz="1200" dirty="0">
+                          <a:solidFill>
+                            <a:srgbClr val="2D2A26"/>
+                          </a:solidFill>
+                          <a:latin typeface="Calibri" pitchFamily="34" charset="0"/>
+                          <a:ea typeface="Calibri" pitchFamily="34" charset="-122"/>
+                          <a:cs typeface="Calibri" pitchFamily="34" charset="-120"/>
+                        </a:rPr>
+                        <a:t>$-7,306</a:t>
+                      </a:r>
+                      <a:endParaRPr lang="en-US" sz="1200" dirty="0">
+                        <a:latin typeface="Calibri" charset="0"/>
+                        <a:ea typeface="Calibri" charset="0"/>
+                        <a:cs typeface="Calibri" charset="0"/>
+                      </a:endParaRPr>
+                    </a:p>
+                  </a:txBody>
+                  <a:tcPr marL="91440" marR="91440" marT="45720" marB="45720" anchor="ctr">
+                    <a:lnL w="6350" cap="flat" cmpd="sng" algn="ctr">
+                      <a:solidFill>
+                        <a:srgbClr val="D6CFC4"/>
+                      </a:solidFill>
+                      <a:prstDash val="solid"/>
+                      <a:round/>
+                      <a:headEnd type="none" w="med" len="med"/>
+                      <a:tailEnd type="none" w="med" len="med"/>
+                    </a:lnL>
+                    <a:lnR w="6350" cap="flat" cmpd="sng" algn="ctr">
+                      <a:solidFill>
+                        <a:srgbClr val="D6CFC4"/>
+                      </a:solidFill>
+                      <a:prstDash val="solid"/>
+                      <a:round/>
+                      <a:headEnd type="none" w="med" len="med"/>
+                      <a:tailEnd type="none" w="med" len="med"/>
+                    </a:lnR>
+                    <a:lnT w="6350" cap="flat" cmpd="sng" algn="ctr">
+                      <a:solidFill>
+                        <a:srgbClr val="D6CFC4"/>
+                      </a:solidFill>
+                      <a:prstDash val="solid"/>
+                      <a:round/>
+                      <a:headEnd type="none" w="med" len="med"/>
+                      <a:tailEnd type="none" w="med" len="med"/>
+                    </a:lnT>
+                    <a:lnB w="6350" cap="flat" cmpd="sng" algn="ctr">
+                      <a:solidFill>
+                        <a:srgbClr val="D6CFC4"/>
+                      </a:solidFill>
+                      <a:prstDash val="solid"/>
+                      <a:round/>
+                      <a:headEnd type="none" w="med" len="med"/>
+                      <a:tailEnd type="none" w="med" len="med"/>
+                    </a:lnB>
+                    <a:solidFill>
+                      <a:srgbClr val="FFFFFF"/>
+                    </a:solidFill>
+                  </a:tcPr>
+                </a:tc>
+                <a:tc>
+                  <a:txBody>
+                    <a:bodyPr/>
+                    <a:lstStyle/>
+                    <a:p>
+                      <a:pPr algn="ctr" indent="0" marL="0">
+                        <a:buNone/>
+                      </a:pPr>
+                      <a:r>
+                        <a:rPr lang="en-US" sz="1200" dirty="0">
+                          <a:solidFill>
+                            <a:srgbClr val="2D2A26"/>
+                          </a:solidFill>
+                          <a:latin typeface="Calibri" pitchFamily="34" charset="0"/>
+                          <a:ea typeface="Calibri" pitchFamily="34" charset="-122"/>
+                          <a:cs typeface="Calibri" pitchFamily="34" charset="-120"/>
+                        </a:rPr>
+                        <a:t>$-120,605</a:t>
+                      </a:r>
+                      <a:endParaRPr lang="en-US" sz="1200" dirty="0">
+                        <a:latin typeface="Calibri" charset="0"/>
+                        <a:ea typeface="Calibri" charset="0"/>
+                        <a:cs typeface="Calibri" charset="0"/>
+                      </a:endParaRPr>
+                    </a:p>
+                  </a:txBody>
+                  <a:tcPr marL="91440" marR="91440" marT="45720" marB="45720" anchor="ctr">
+                    <a:lnL w="6350" cap="flat" cmpd="sng" algn="ctr">
+                      <a:solidFill>
+                        <a:srgbClr val="D6CFC4"/>
+                      </a:solidFill>
+                      <a:prstDash val="solid"/>
+                      <a:round/>
+                      <a:headEnd type="none" w="med" len="med"/>
+                      <a:tailEnd type="none" w="med" len="med"/>
+                    </a:lnL>
+                    <a:lnR w="6350" cap="flat" cmpd="sng" algn="ctr">
+                      <a:solidFill>
+                        <a:srgbClr val="D6CFC4"/>
+                      </a:solidFill>
+                      <a:prstDash val="solid"/>
+                      <a:round/>
+                      <a:headEnd type="none" w="med" len="med"/>
+                      <a:tailEnd type="none" w="med" len="med"/>
+                    </a:lnR>
+                    <a:lnT w="6350" cap="flat" cmpd="sng" algn="ctr">
+                      <a:solidFill>
+                        <a:srgbClr val="D6CFC4"/>
+                      </a:solidFill>
+                      <a:prstDash val="solid"/>
+                      <a:round/>
+                      <a:headEnd type="none" w="med" len="med"/>
+                      <a:tailEnd type="none" w="med" len="med"/>
+                    </a:lnT>
+                    <a:lnB w="6350" cap="flat" cmpd="sng" algn="ctr">
+                      <a:solidFill>
+                        <a:srgbClr val="D6CFC4"/>
+                      </a:solidFill>
+                      <a:prstDash val="solid"/>
+                      <a:round/>
+                      <a:headEnd type="none" w="med" len="med"/>
+                      <a:tailEnd type="none" w="med" len="med"/>
+                    </a:lnB>
+                    <a:solidFill>
+                      <a:srgbClr val="FFFFFF"/>
+                    </a:solidFill>
+                  </a:tcPr>
+                </a:tc>
+                <a:tc>
+                  <a:txBody>
+                    <a:bodyPr/>
+                    <a:lstStyle/>
+                    <a:p>
+                      <a:pPr algn="ctr" indent="0" marL="0">
+                        <a:buNone/>
+                      </a:pPr>
+                      <a:r>
+                        <a:rPr lang="en-US" sz="1200" dirty="0">
+                          <a:solidFill>
+                            <a:srgbClr val="2D2A26"/>
+                          </a:solidFill>
+                          <a:latin typeface="Calibri" pitchFamily="34" charset="0"/>
+                          <a:ea typeface="Calibri" pitchFamily="34" charset="-122"/>
+                          <a:cs typeface="Calibri" pitchFamily="34" charset="-120"/>
+                        </a:rPr>
+                        <a:t>$55,275</a:t>
+                      </a:r>
+                      <a:endParaRPr lang="en-US" sz="1200" dirty="0">
+                        <a:latin typeface="Calibri" charset="0"/>
+                        <a:ea typeface="Calibri" charset="0"/>
+                        <a:cs typeface="Calibri" charset="0"/>
+                      </a:endParaRPr>
+                    </a:p>
+                  </a:txBody>
+                  <a:tcPr marL="91440" marR="91440" marT="45720" marB="45720" anchor="ctr">
+                    <a:lnL w="6350" cap="flat" cmpd="sng" algn="ctr">
+                      <a:solidFill>
+                        <a:srgbClr val="D6CFC4"/>
+                      </a:solidFill>
+                      <a:prstDash val="solid"/>
+                      <a:round/>
+                      <a:headEnd type="none" w="med" len="med"/>
+                      <a:tailEnd type="none" w="med" len="med"/>
+                    </a:lnL>
+                    <a:lnR w="6350" cap="flat" cmpd="sng" algn="ctr">
+                      <a:solidFill>
+                        <a:srgbClr val="D6CFC4"/>
+                      </a:solidFill>
+                      <a:prstDash val="solid"/>
+                      <a:round/>
+                      <a:headEnd type="none" w="med" len="med"/>
+                      <a:tailEnd type="none" w="med" len="med"/>
+                    </a:lnR>
+                    <a:lnT w="6350" cap="flat" cmpd="sng" algn="ctr">
+                      <a:solidFill>
+                        <a:srgbClr val="D6CFC4"/>
+                      </a:solidFill>
+                      <a:prstDash val="solid"/>
+                      <a:round/>
+                      <a:headEnd type="none" w="med" len="med"/>
+                      <a:tailEnd type="none" w="med" len="med"/>
+                    </a:lnT>
+                    <a:lnB w="6350" cap="flat" cmpd="sng" algn="ctr">
+                      <a:solidFill>
+                        <a:srgbClr val="D6CFC4"/>
+                      </a:solidFill>
+                      <a:prstDash val="solid"/>
+                      <a:round/>
+                      <a:headEnd type="none" w="med" len="med"/>
+                      <a:tailEnd type="none" w="med" len="med"/>
+                    </a:lnB>
+                    <a:solidFill>
+                      <a:srgbClr val="FFFFFF"/>
+                    </a:solidFill>
+                  </a:tcPr>
+                </a:tc>
+                <a:tc>
+                  <a:txBody>
+                    <a:bodyPr/>
+                    <a:lstStyle/>
+                    <a:p>
+                      <a:pPr algn="ctr" indent="0" marL="0">
+                        <a:buNone/>
+                      </a:pPr>
+                      <a:r>
+                        <a:rPr lang="en-US" sz="1200" dirty="0">
+                          <a:solidFill>
+                            <a:srgbClr val="2D2A26"/>
+                          </a:solidFill>
+                          <a:latin typeface="Calibri" pitchFamily="34" charset="0"/>
+                          <a:ea typeface="Calibri" pitchFamily="34" charset="-122"/>
+                          <a:cs typeface="Calibri" pitchFamily="34" charset="-120"/>
+                        </a:rPr>
+                        <a:t>30.2%</a:t>
+                      </a:r>
+                      <a:endParaRPr lang="en-US" sz="1200" dirty="0">
+                        <a:latin typeface="Calibri" charset="0"/>
+                        <a:ea typeface="Calibri" charset="0"/>
+                        <a:cs typeface="Calibri" charset="0"/>
+                      </a:endParaRPr>
+                    </a:p>
+                  </a:txBody>
+                  <a:tcPr marL="91440" marR="91440" marT="45720" marB="45720" anchor="ctr">
+                    <a:lnL w="6350" cap="flat" cmpd="sng" algn="ctr">
+                      <a:solidFill>
+                        <a:srgbClr val="D6CFC4"/>
+                      </a:solidFill>
+                      <a:prstDash val="solid"/>
+                      <a:round/>
+                      <a:headEnd type="none" w="med" len="med"/>
+                      <a:tailEnd type="none" w="med" len="med"/>
+                    </a:lnL>
+                    <a:lnR w="6350" cap="flat" cmpd="sng" algn="ctr">
+                      <a:solidFill>
+                        <a:srgbClr val="D6CFC4"/>
+                      </a:solidFill>
+                      <a:prstDash val="solid"/>
+                      <a:round/>
+                      <a:headEnd type="none" w="med" len="med"/>
+                      <a:tailEnd type="none" w="med" len="med"/>
+                    </a:lnR>
+                    <a:lnT w="6350" cap="flat" cmpd="sng" algn="ctr">
+                      <a:solidFill>
+                        <a:srgbClr val="D6CFC4"/>
+                      </a:solidFill>
+                      <a:prstDash val="solid"/>
+                      <a:round/>
+                      <a:headEnd type="none" w="med" len="med"/>
+                      <a:tailEnd type="none" w="med" len="med"/>
+                    </a:lnT>
+                    <a:lnB w="6350" cap="flat" cmpd="sng" algn="ctr">
+                      <a:solidFill>
+                        <a:srgbClr val="D6CFC4"/>
+                      </a:solidFill>
+                      <a:prstDash val="solid"/>
+                      <a:round/>
+                      <a:headEnd type="none" w="med" len="med"/>
+                      <a:tailEnd type="none" w="med" len="med"/>
+                    </a:lnB>
+                    <a:solidFill>
+                      <a:srgbClr val="FFFFFF"/>
+                    </a:solidFill>
+                  </a:tcPr>
+                </a:tc>
+                <a:tc>
+                  <a:txBody>
+                    <a:bodyPr/>
+                    <a:lstStyle/>
+                    <a:p>
+                      <a:pPr algn="ctr" indent="0" marL="0">
+                        <a:buNone/>
+                      </a:pPr>
+                      <a:r>
+                        <a:rPr lang="en-US" sz="1200" dirty="0">
+                          <a:solidFill>
+                            <a:srgbClr val="C0392B"/>
+                          </a:solidFill>
+                          <a:latin typeface="Calibri" pitchFamily="34" charset="0"/>
+                          <a:ea typeface="Calibri" pitchFamily="34" charset="-122"/>
+                          <a:cs typeface="Calibri" pitchFamily="34" charset="-120"/>
+                        </a:rPr>
+                        <a:t>$-59,801</a:t>
+                      </a:r>
+                      <a:endParaRPr lang="en-US" sz="1200" dirty="0">
+                        <a:latin typeface="Calibri" charset="0"/>
+                        <a:ea typeface="Calibri" charset="0"/>
+                        <a:cs typeface="Calibri" charset="0"/>
+                      </a:endParaRPr>
+                    </a:p>
+                  </a:txBody>
+                  <a:tcPr marL="91440" marR="91440" marT="45720" marB="45720" anchor="ctr">
+                    <a:lnL w="6350" cap="flat" cmpd="sng" algn="ctr">
+                      <a:solidFill>
+                        <a:srgbClr val="D6CFC4"/>
+                      </a:solidFill>
+                      <a:prstDash val="solid"/>
+                      <a:round/>
+                      <a:headEnd type="none" w="med" len="med"/>
+                      <a:tailEnd type="none" w="med" len="med"/>
+                    </a:lnL>
+                    <a:lnR w="6350" cap="flat" cmpd="sng" algn="ctr">
+                      <a:solidFill>
+                        <a:srgbClr val="D6CFC4"/>
+                      </a:solidFill>
+                      <a:prstDash val="solid"/>
+                      <a:round/>
+                      <a:headEnd type="none" w="med" len="med"/>
+                      <a:tailEnd type="none" w="med" len="med"/>
+                    </a:lnR>
+                    <a:lnT w="6350" cap="flat" cmpd="sng" algn="ctr">
+                      <a:solidFill>
+                        <a:srgbClr val="D6CFC4"/>
+                      </a:solidFill>
+                      <a:prstDash val="solid"/>
+                      <a:round/>
+                      <a:headEnd type="none" w="med" len="med"/>
+                      <a:tailEnd type="none" w="med" len="med"/>
+                    </a:lnT>
+                    <a:lnB w="6350" cap="flat" cmpd="sng" algn="ctr">
+                      <a:solidFill>
+                        <a:srgbClr val="D6CFC4"/>
+                      </a:solidFill>
+                      <a:prstDash val="solid"/>
+                      <a:round/>
+                      <a:headEnd type="none" w="med" len="med"/>
+                      <a:tailEnd type="none" w="med" len="med"/>
+                    </a:lnB>
+                    <a:solidFill>
+                      <a:srgbClr val="FFFFFF"/>
+                    </a:solidFill>
+                  </a:tcPr>
+                </a:tc>
+              </a:tr>
+              <a:tr h="457200">
+                <a:tc>
+                  <a:txBody>
+                    <a:bodyPr/>
+                    <a:lstStyle/>
+                    <a:p>
+                      <a:pPr algn="l" indent="0" marL="0">
+                        <a:buNone/>
+                      </a:pPr>
+                      <a:r>
+                        <a:rPr lang="en-US" sz="1200" b="1" dirty="0">
+                          <a:solidFill>
+                            <a:srgbClr val="2D2A26"/>
+                          </a:solidFill>
+                          <a:latin typeface="Century Gothic" pitchFamily="34" charset="0"/>
+                          <a:ea typeface="Century Gothic" pitchFamily="34" charset="-122"/>
+                          <a:cs typeface="Century Gothic" pitchFamily="34" charset="-120"/>
+                        </a:rPr>
                         <a:t>Uganda</a:t>
                       </a:r>
                       <a:endParaRPr lang="en-US" sz="1200" dirty="0">
@@ -19146,7 +20192,7 @@
                       <a:tailEnd type="none" w="med" len="med"/>
                     </a:lnB>
                     <a:solidFill>
-                      <a:srgbClr val="FFFFFF"/>
+                      <a:srgbClr val="FAF7F2"/>
                     </a:solidFill>
                   </a:tcPr>
                 </a:tc>
@@ -19214,7 +20260,7 @@
                       <a:tailEnd type="none" w="med" len="med"/>
                     </a:lnB>
                     <a:solidFill>
-                      <a:srgbClr val="FFFFFF"/>
+                      <a:srgbClr val="FAF7F2"/>
                     </a:solidFill>
                   </a:tcPr>
                 </a:tc>
@@ -19282,7 +20328,7 @@
                       <a:tailEnd type="none" w="med" len="med"/>
                     </a:lnB>
                     <a:solidFill>
-                      <a:srgbClr val="FFFFFF"/>
+                      <a:srgbClr val="FAF7F2"/>
                     </a:solidFill>
                   </a:tcPr>
                 </a:tc>
@@ -19350,7 +20396,7 @@
                       <a:tailEnd type="none" w="med" len="med"/>
                     </a:lnB>
                     <a:solidFill>
-                      <a:srgbClr val="FFFFFF"/>
+                      <a:srgbClr val="FAF7F2"/>
                     </a:solidFill>
                   </a:tcPr>
                 </a:tc>
@@ -19418,7 +20464,7 @@
                       <a:tailEnd type="none" w="med" len="med"/>
                     </a:lnB>
                     <a:solidFill>
-                      <a:srgbClr val="FFFFFF"/>
+                      <a:srgbClr val="FAF7F2"/>
                     </a:solidFill>
                   </a:tcPr>
                 </a:tc>
@@ -19486,7 +20532,7 @@
                       <a:tailEnd type="none" w="med" len="med"/>
                     </a:lnB>
                     <a:solidFill>
-                      <a:srgbClr val="FFFFFF"/>
+                      <a:srgbClr val="FAF7F2"/>
                     </a:solidFill>
                   </a:tcPr>
                 </a:tc>
@@ -19508,484 +20554,6 @@
                           <a:cs typeface="Calibri" pitchFamily="34" charset="-120"/>
                         </a:rPr>
                         <a:t>$-113,329</a:t>
-                      </a:r>
-                      <a:endParaRPr lang="en-US" sz="1200" dirty="0">
-                        <a:latin typeface="Calibri" charset="0"/>
-                        <a:ea typeface="Calibri" charset="0"/>
-                        <a:cs typeface="Calibri" charset="0"/>
-                      </a:endParaRPr>
-                    </a:p>
-                  </a:txBody>
-                  <a:tcPr marL="91440" marR="91440" marT="45720" marB="45720" anchor="ctr">
-                    <a:lnL w="6350" cap="flat" cmpd="sng" algn="ctr">
-                      <a:solidFill>
-                        <a:srgbClr val="D6CFC4"/>
-                      </a:solidFill>
-                      <a:prstDash val="solid"/>
-                      <a:round/>
-                      <a:headEnd type="none" w="med" len="med"/>
-                      <a:tailEnd type="none" w="med" len="med"/>
-                    </a:lnL>
-                    <a:lnR w="6350" cap="flat" cmpd="sng" algn="ctr">
-                      <a:solidFill>
-                        <a:srgbClr val="D6CFC4"/>
-                      </a:solidFill>
-                      <a:prstDash val="solid"/>
-                      <a:round/>
-                      <a:headEnd type="none" w="med" len="med"/>
-                      <a:tailEnd type="none" w="med" len="med"/>
-                    </a:lnR>
-                    <a:lnT w="6350" cap="flat" cmpd="sng" algn="ctr">
-                      <a:solidFill>
-                        <a:srgbClr val="D6CFC4"/>
-                      </a:solidFill>
-                      <a:prstDash val="solid"/>
-                      <a:round/>
-                      <a:headEnd type="none" w="med" len="med"/>
-                      <a:tailEnd type="none" w="med" len="med"/>
-                    </a:lnT>
-                    <a:lnB w="6350" cap="flat" cmpd="sng" algn="ctr">
-                      <a:solidFill>
-                        <a:srgbClr val="D6CFC4"/>
-                      </a:solidFill>
-                      <a:prstDash val="solid"/>
-                      <a:round/>
-                      <a:headEnd type="none" w="med" len="med"/>
-                      <a:tailEnd type="none" w="med" len="med"/>
-                    </a:lnB>
-                    <a:solidFill>
-                      <a:srgbClr val="FFFFFF"/>
-                    </a:solidFill>
-                  </a:tcPr>
-                </a:tc>
-              </a:tr>
-              <a:tr h="457200">
-                <a:tc>
-                  <a:txBody>
-                    <a:bodyPr/>
-                    <a:lstStyle/>
-                    <a:p>
-                      <a:pPr algn="l" indent="0" marL="0">
-                        <a:buNone/>
-                      </a:pPr>
-                      <a:r>
-                        <a:rPr lang="en-US" sz="1200" b="1" dirty="0">
-                          <a:solidFill>
-                            <a:srgbClr val="2D2A26"/>
-                          </a:solidFill>
-                          <a:latin typeface="Century Gothic" pitchFamily="34" charset="0"/>
-                          <a:ea typeface="Century Gothic" pitchFamily="34" charset="-122"/>
-                          <a:cs typeface="Century Gothic" pitchFamily="34" charset="-120"/>
-                        </a:rPr>
-                        <a:t>Sierra Leone</a:t>
-                      </a:r>
-                      <a:endParaRPr lang="en-US" sz="1200" dirty="0">
-                        <a:latin typeface="Century Gothic" charset="0"/>
-                        <a:ea typeface="Century Gothic" charset="0"/>
-                        <a:cs typeface="Century Gothic" charset="0"/>
-                      </a:endParaRPr>
-                    </a:p>
-                  </a:txBody>
-                  <a:tcPr marL="91440" marR="91440" marT="45720" marB="45720" anchor="ctr">
-                    <a:lnL w="6350" cap="flat" cmpd="sng" algn="ctr">
-                      <a:solidFill>
-                        <a:srgbClr val="D6CFC4"/>
-                      </a:solidFill>
-                      <a:prstDash val="solid"/>
-                      <a:round/>
-                      <a:headEnd type="none" w="med" len="med"/>
-                      <a:tailEnd type="none" w="med" len="med"/>
-                    </a:lnL>
-                    <a:lnR w="6350" cap="flat" cmpd="sng" algn="ctr">
-                      <a:solidFill>
-                        <a:srgbClr val="D6CFC4"/>
-                      </a:solidFill>
-                      <a:prstDash val="solid"/>
-                      <a:round/>
-                      <a:headEnd type="none" w="med" len="med"/>
-                      <a:tailEnd type="none" w="med" len="med"/>
-                    </a:lnR>
-                    <a:lnT w="6350" cap="flat" cmpd="sng" algn="ctr">
-                      <a:solidFill>
-                        <a:srgbClr val="D6CFC4"/>
-                      </a:solidFill>
-                      <a:prstDash val="solid"/>
-                      <a:round/>
-                      <a:headEnd type="none" w="med" len="med"/>
-                      <a:tailEnd type="none" w="med" len="med"/>
-                    </a:lnT>
-                    <a:lnB w="6350" cap="flat" cmpd="sng" algn="ctr">
-                      <a:solidFill>
-                        <a:srgbClr val="D6CFC4"/>
-                      </a:solidFill>
-                      <a:prstDash val="solid"/>
-                      <a:round/>
-                      <a:headEnd type="none" w="med" len="med"/>
-                      <a:tailEnd type="none" w="med" len="med"/>
-                    </a:lnB>
-                    <a:solidFill>
-                      <a:srgbClr val="FAF7F2"/>
-                    </a:solidFill>
-                  </a:tcPr>
-                </a:tc>
-                <a:tc>
-                  <a:txBody>
-                    <a:bodyPr/>
-                    <a:lstStyle/>
-                    <a:p>
-                      <a:pPr algn="ctr" indent="0" marL="0">
-                        <a:buNone/>
-                      </a:pPr>
-                      <a:r>
-                        <a:rPr lang="en-US" sz="1200" dirty="0">
-                          <a:solidFill>
-                            <a:srgbClr val="2D2A26"/>
-                          </a:solidFill>
-                          <a:latin typeface="Calibri" pitchFamily="34" charset="0"/>
-                          <a:ea typeface="Calibri" pitchFamily="34" charset="-122"/>
-                          <a:cs typeface="Calibri" pitchFamily="34" charset="-120"/>
-                        </a:rPr>
-                        <a:t>$183,186</a:t>
-                      </a:r>
-                      <a:endParaRPr lang="en-US" sz="1200" dirty="0">
-                        <a:latin typeface="Calibri" charset="0"/>
-                        <a:ea typeface="Calibri" charset="0"/>
-                        <a:cs typeface="Calibri" charset="0"/>
-                      </a:endParaRPr>
-                    </a:p>
-                  </a:txBody>
-                  <a:tcPr marL="91440" marR="91440" marT="45720" marB="45720" anchor="ctr">
-                    <a:lnL w="6350" cap="flat" cmpd="sng" algn="ctr">
-                      <a:solidFill>
-                        <a:srgbClr val="D6CFC4"/>
-                      </a:solidFill>
-                      <a:prstDash val="solid"/>
-                      <a:round/>
-                      <a:headEnd type="none" w="med" len="med"/>
-                      <a:tailEnd type="none" w="med" len="med"/>
-                    </a:lnL>
-                    <a:lnR w="6350" cap="flat" cmpd="sng" algn="ctr">
-                      <a:solidFill>
-                        <a:srgbClr val="D6CFC4"/>
-                      </a:solidFill>
-                      <a:prstDash val="solid"/>
-                      <a:round/>
-                      <a:headEnd type="none" w="med" len="med"/>
-                      <a:tailEnd type="none" w="med" len="med"/>
-                    </a:lnR>
-                    <a:lnT w="6350" cap="flat" cmpd="sng" algn="ctr">
-                      <a:solidFill>
-                        <a:srgbClr val="D6CFC4"/>
-                      </a:solidFill>
-                      <a:prstDash val="solid"/>
-                      <a:round/>
-                      <a:headEnd type="none" w="med" len="med"/>
-                      <a:tailEnd type="none" w="med" len="med"/>
-                    </a:lnT>
-                    <a:lnB w="6350" cap="flat" cmpd="sng" algn="ctr">
-                      <a:solidFill>
-                        <a:srgbClr val="D6CFC4"/>
-                      </a:solidFill>
-                      <a:prstDash val="solid"/>
-                      <a:round/>
-                      <a:headEnd type="none" w="med" len="med"/>
-                      <a:tailEnd type="none" w="med" len="med"/>
-                    </a:lnB>
-                    <a:solidFill>
-                      <a:srgbClr val="FAF7F2"/>
-                    </a:solidFill>
-                  </a:tcPr>
-                </a:tc>
-                <a:tc>
-                  <a:txBody>
-                    <a:bodyPr/>
-                    <a:lstStyle/>
-                    <a:p>
-                      <a:pPr algn="ctr" indent="0" marL="0">
-                        <a:buNone/>
-                      </a:pPr>
-                      <a:r>
-                        <a:rPr lang="en-US" sz="1200" dirty="0">
-                          <a:solidFill>
-                            <a:srgbClr val="2D2A26"/>
-                          </a:solidFill>
-                          <a:latin typeface="Calibri" pitchFamily="34" charset="0"/>
-                          <a:ea typeface="Calibri" pitchFamily="34" charset="-122"/>
-                          <a:cs typeface="Calibri" pitchFamily="34" charset="-120"/>
-                        </a:rPr>
-                        <a:t>$-7,306</a:t>
-                      </a:r>
-                      <a:endParaRPr lang="en-US" sz="1200" dirty="0">
-                        <a:latin typeface="Calibri" charset="0"/>
-                        <a:ea typeface="Calibri" charset="0"/>
-                        <a:cs typeface="Calibri" charset="0"/>
-                      </a:endParaRPr>
-                    </a:p>
-                  </a:txBody>
-                  <a:tcPr marL="91440" marR="91440" marT="45720" marB="45720" anchor="ctr">
-                    <a:lnL w="6350" cap="flat" cmpd="sng" algn="ctr">
-                      <a:solidFill>
-                        <a:srgbClr val="D6CFC4"/>
-                      </a:solidFill>
-                      <a:prstDash val="solid"/>
-                      <a:round/>
-                      <a:headEnd type="none" w="med" len="med"/>
-                      <a:tailEnd type="none" w="med" len="med"/>
-                    </a:lnL>
-                    <a:lnR w="6350" cap="flat" cmpd="sng" algn="ctr">
-                      <a:solidFill>
-                        <a:srgbClr val="D6CFC4"/>
-                      </a:solidFill>
-                      <a:prstDash val="solid"/>
-                      <a:round/>
-                      <a:headEnd type="none" w="med" len="med"/>
-                      <a:tailEnd type="none" w="med" len="med"/>
-                    </a:lnR>
-                    <a:lnT w="6350" cap="flat" cmpd="sng" algn="ctr">
-                      <a:solidFill>
-                        <a:srgbClr val="D6CFC4"/>
-                      </a:solidFill>
-                      <a:prstDash val="solid"/>
-                      <a:round/>
-                      <a:headEnd type="none" w="med" len="med"/>
-                      <a:tailEnd type="none" w="med" len="med"/>
-                    </a:lnT>
-                    <a:lnB w="6350" cap="flat" cmpd="sng" algn="ctr">
-                      <a:solidFill>
-                        <a:srgbClr val="D6CFC4"/>
-                      </a:solidFill>
-                      <a:prstDash val="solid"/>
-                      <a:round/>
-                      <a:headEnd type="none" w="med" len="med"/>
-                      <a:tailEnd type="none" w="med" len="med"/>
-                    </a:lnB>
-                    <a:solidFill>
-                      <a:srgbClr val="FAF7F2"/>
-                    </a:solidFill>
-                  </a:tcPr>
-                </a:tc>
-                <a:tc>
-                  <a:txBody>
-                    <a:bodyPr/>
-                    <a:lstStyle/>
-                    <a:p>
-                      <a:pPr algn="ctr" indent="0" marL="0">
-                        <a:buNone/>
-                      </a:pPr>
-                      <a:r>
-                        <a:rPr lang="en-US" sz="1200" dirty="0">
-                          <a:solidFill>
-                            <a:srgbClr val="2D2A26"/>
-                          </a:solidFill>
-                          <a:latin typeface="Calibri" pitchFamily="34" charset="0"/>
-                          <a:ea typeface="Calibri" pitchFamily="34" charset="-122"/>
-                          <a:cs typeface="Calibri" pitchFamily="34" charset="-120"/>
-                        </a:rPr>
-                        <a:t>$-120,605</a:t>
-                      </a:r>
-                      <a:endParaRPr lang="en-US" sz="1200" dirty="0">
-                        <a:latin typeface="Calibri" charset="0"/>
-                        <a:ea typeface="Calibri" charset="0"/>
-                        <a:cs typeface="Calibri" charset="0"/>
-                      </a:endParaRPr>
-                    </a:p>
-                  </a:txBody>
-                  <a:tcPr marL="91440" marR="91440" marT="45720" marB="45720" anchor="ctr">
-                    <a:lnL w="6350" cap="flat" cmpd="sng" algn="ctr">
-                      <a:solidFill>
-                        <a:srgbClr val="D6CFC4"/>
-                      </a:solidFill>
-                      <a:prstDash val="solid"/>
-                      <a:round/>
-                      <a:headEnd type="none" w="med" len="med"/>
-                      <a:tailEnd type="none" w="med" len="med"/>
-                    </a:lnL>
-                    <a:lnR w="6350" cap="flat" cmpd="sng" algn="ctr">
-                      <a:solidFill>
-                        <a:srgbClr val="D6CFC4"/>
-                      </a:solidFill>
-                      <a:prstDash val="solid"/>
-                      <a:round/>
-                      <a:headEnd type="none" w="med" len="med"/>
-                      <a:tailEnd type="none" w="med" len="med"/>
-                    </a:lnR>
-                    <a:lnT w="6350" cap="flat" cmpd="sng" algn="ctr">
-                      <a:solidFill>
-                        <a:srgbClr val="D6CFC4"/>
-                      </a:solidFill>
-                      <a:prstDash val="solid"/>
-                      <a:round/>
-                      <a:headEnd type="none" w="med" len="med"/>
-                      <a:tailEnd type="none" w="med" len="med"/>
-                    </a:lnT>
-                    <a:lnB w="6350" cap="flat" cmpd="sng" algn="ctr">
-                      <a:solidFill>
-                        <a:srgbClr val="D6CFC4"/>
-                      </a:solidFill>
-                      <a:prstDash val="solid"/>
-                      <a:round/>
-                      <a:headEnd type="none" w="med" len="med"/>
-                      <a:tailEnd type="none" w="med" len="med"/>
-                    </a:lnB>
-                    <a:solidFill>
-                      <a:srgbClr val="FAF7F2"/>
-                    </a:solidFill>
-                  </a:tcPr>
-                </a:tc>
-                <a:tc>
-                  <a:txBody>
-                    <a:bodyPr/>
-                    <a:lstStyle/>
-                    <a:p>
-                      <a:pPr algn="ctr" indent="0" marL="0">
-                        <a:buNone/>
-                      </a:pPr>
-                      <a:r>
-                        <a:rPr lang="en-US" sz="1200" dirty="0">
-                          <a:solidFill>
-                            <a:srgbClr val="2D2A26"/>
-                          </a:solidFill>
-                          <a:latin typeface="Calibri" pitchFamily="34" charset="0"/>
-                          <a:ea typeface="Calibri" pitchFamily="34" charset="-122"/>
-                          <a:cs typeface="Calibri" pitchFamily="34" charset="-120"/>
-                        </a:rPr>
-                        <a:t>$55,275</a:t>
-                      </a:r>
-                      <a:endParaRPr lang="en-US" sz="1200" dirty="0">
-                        <a:latin typeface="Calibri" charset="0"/>
-                        <a:ea typeface="Calibri" charset="0"/>
-                        <a:cs typeface="Calibri" charset="0"/>
-                      </a:endParaRPr>
-                    </a:p>
-                  </a:txBody>
-                  <a:tcPr marL="91440" marR="91440" marT="45720" marB="45720" anchor="ctr">
-                    <a:lnL w="6350" cap="flat" cmpd="sng" algn="ctr">
-                      <a:solidFill>
-                        <a:srgbClr val="D6CFC4"/>
-                      </a:solidFill>
-                      <a:prstDash val="solid"/>
-                      <a:round/>
-                      <a:headEnd type="none" w="med" len="med"/>
-                      <a:tailEnd type="none" w="med" len="med"/>
-                    </a:lnL>
-                    <a:lnR w="6350" cap="flat" cmpd="sng" algn="ctr">
-                      <a:solidFill>
-                        <a:srgbClr val="D6CFC4"/>
-                      </a:solidFill>
-                      <a:prstDash val="solid"/>
-                      <a:round/>
-                      <a:headEnd type="none" w="med" len="med"/>
-                      <a:tailEnd type="none" w="med" len="med"/>
-                    </a:lnR>
-                    <a:lnT w="6350" cap="flat" cmpd="sng" algn="ctr">
-                      <a:solidFill>
-                        <a:srgbClr val="D6CFC4"/>
-                      </a:solidFill>
-                      <a:prstDash val="solid"/>
-                      <a:round/>
-                      <a:headEnd type="none" w="med" len="med"/>
-                      <a:tailEnd type="none" w="med" len="med"/>
-                    </a:lnT>
-                    <a:lnB w="6350" cap="flat" cmpd="sng" algn="ctr">
-                      <a:solidFill>
-                        <a:srgbClr val="D6CFC4"/>
-                      </a:solidFill>
-                      <a:prstDash val="solid"/>
-                      <a:round/>
-                      <a:headEnd type="none" w="med" len="med"/>
-                      <a:tailEnd type="none" w="med" len="med"/>
-                    </a:lnB>
-                    <a:solidFill>
-                      <a:srgbClr val="FAF7F2"/>
-                    </a:solidFill>
-                  </a:tcPr>
-                </a:tc>
-                <a:tc>
-                  <a:txBody>
-                    <a:bodyPr/>
-                    <a:lstStyle/>
-                    <a:p>
-                      <a:pPr algn="ctr" indent="0" marL="0">
-                        <a:buNone/>
-                      </a:pPr>
-                      <a:r>
-                        <a:rPr lang="en-US" sz="1200" dirty="0">
-                          <a:solidFill>
-                            <a:srgbClr val="2D2A26"/>
-                          </a:solidFill>
-                          <a:latin typeface="Calibri" pitchFamily="34" charset="0"/>
-                          <a:ea typeface="Calibri" pitchFamily="34" charset="-122"/>
-                          <a:cs typeface="Calibri" pitchFamily="34" charset="-120"/>
-                        </a:rPr>
-                        <a:t>30.2%</a:t>
-                      </a:r>
-                      <a:endParaRPr lang="en-US" sz="1200" dirty="0">
-                        <a:latin typeface="Calibri" charset="0"/>
-                        <a:ea typeface="Calibri" charset="0"/>
-                        <a:cs typeface="Calibri" charset="0"/>
-                      </a:endParaRPr>
-                    </a:p>
-                  </a:txBody>
-                  <a:tcPr marL="91440" marR="91440" marT="45720" marB="45720" anchor="ctr">
-                    <a:lnL w="6350" cap="flat" cmpd="sng" algn="ctr">
-                      <a:solidFill>
-                        <a:srgbClr val="D6CFC4"/>
-                      </a:solidFill>
-                      <a:prstDash val="solid"/>
-                      <a:round/>
-                      <a:headEnd type="none" w="med" len="med"/>
-                      <a:tailEnd type="none" w="med" len="med"/>
-                    </a:lnL>
-                    <a:lnR w="6350" cap="flat" cmpd="sng" algn="ctr">
-                      <a:solidFill>
-                        <a:srgbClr val="D6CFC4"/>
-                      </a:solidFill>
-                      <a:prstDash val="solid"/>
-                      <a:round/>
-                      <a:headEnd type="none" w="med" len="med"/>
-                      <a:tailEnd type="none" w="med" len="med"/>
-                    </a:lnR>
-                    <a:lnT w="6350" cap="flat" cmpd="sng" algn="ctr">
-                      <a:solidFill>
-                        <a:srgbClr val="D6CFC4"/>
-                      </a:solidFill>
-                      <a:prstDash val="solid"/>
-                      <a:round/>
-                      <a:headEnd type="none" w="med" len="med"/>
-                      <a:tailEnd type="none" w="med" len="med"/>
-                    </a:lnT>
-                    <a:lnB w="6350" cap="flat" cmpd="sng" algn="ctr">
-                      <a:solidFill>
-                        <a:srgbClr val="D6CFC4"/>
-                      </a:solidFill>
-                      <a:prstDash val="solid"/>
-                      <a:round/>
-                      <a:headEnd type="none" w="med" len="med"/>
-                      <a:tailEnd type="none" w="med" len="med"/>
-                    </a:lnB>
-                    <a:solidFill>
-                      <a:srgbClr val="FAF7F2"/>
-                    </a:solidFill>
-                  </a:tcPr>
-                </a:tc>
-                <a:tc>
-                  <a:txBody>
-                    <a:bodyPr/>
-                    <a:lstStyle/>
-                    <a:p>
-                      <a:pPr algn="ctr" indent="0" marL="0">
-                        <a:buNone/>
-                      </a:pPr>
-                      <a:r>
-                        <a:rPr lang="en-US" sz="1200" dirty="0">
-                          <a:solidFill>
-                            <a:srgbClr val="C0392B"/>
-                          </a:solidFill>
-                          <a:latin typeface="Calibri" pitchFamily="34" charset="0"/>
-                          <a:ea typeface="Calibri" pitchFamily="34" charset="-122"/>
-                          <a:cs typeface="Calibri" pitchFamily="34" charset="-120"/>
-                        </a:rPr>
-                        <a:t>$-59,801</a:t>
                       </a:r>
                       <a:endParaRPr lang="en-US" sz="1200" dirty="0">
                         <a:latin typeface="Calibri" charset="0"/>

</xml_diff>

<commit_message>
Auto-build: 2026-03-14 16:16 UTC
</commit_message>
<xml_diff>
--- a/reports/2026-01.pptx
+++ b/reports/2026-01.pptx
@@ -118,7 +118,7 @@
 </p:presentation>
 </file>
 
-<file path=ppt/charts/chart1.xml><?xml version="1.0" encoding="utf-8"?>
+<file path=ppt/charts/chart10.xml><?xml version="1.0" encoding="utf-8"?>
 <c:chartSpace xmlns:c="http://schemas.openxmlformats.org/drawingml/2006/chart" xmlns:a="http://schemas.openxmlformats.org/drawingml/2006/main" xmlns:r="http://schemas.openxmlformats.org/officeDocument/2006/relationships">
   <c:date1904 val="0"/>
   <c:roundedCorners val="0"/>
@@ -418,7 +418,7 @@
 </c:chartSpace>
 </file>
 
-<file path=ppt/charts/chart2.xml><?xml version="1.0" encoding="utf-8"?>
+<file path=ppt/charts/chart11.xml><?xml version="1.0" encoding="utf-8"?>
 <c:chartSpace xmlns:c="http://schemas.openxmlformats.org/drawingml/2006/chart" xmlns:a="http://schemas.openxmlformats.org/drawingml/2006/main" xmlns:r="http://schemas.openxmlformats.org/officeDocument/2006/relationships">
   <c:date1904 val="0"/>
   <c:roundedCorners val="0"/>
@@ -718,7 +718,7 @@
 </c:chartSpace>
 </file>
 
-<file path=ppt/charts/chart3.xml><?xml version="1.0" encoding="utf-8"?>
+<file path=ppt/charts/chart12.xml><?xml version="1.0" encoding="utf-8"?>
 <c:chartSpace xmlns:c="http://schemas.openxmlformats.org/drawingml/2006/chart" xmlns:a="http://schemas.openxmlformats.org/drawingml/2006/main" xmlns:r="http://schemas.openxmlformats.org/officeDocument/2006/relationships">
   <c:date1904 val="0"/>
   <c:roundedCorners val="0"/>
@@ -862,19 +862,19 @@
                 <c:formatCode>General</c:formatCode>
                 <c:ptCount val="5"/>
                 <c:pt idx="0">
-                  <c:v>2069728.877</c:v>
+                  <c:v>2901600.368</c:v>
                 </c:pt>
                 <c:pt idx="1">
-                  <c:v>1080878.933</c:v>
+                  <c:v>2078321.191</c:v>
                 </c:pt>
                 <c:pt idx="2">
-                  <c:v>493834.2037</c:v>
+                  <c:v>624808.0046</c:v>
                 </c:pt>
                 <c:pt idx="3">
-                  <c:v>210518.4175</c:v>
+                  <c:v>351200.5457</c:v>
                 </c:pt>
                 <c:pt idx="4">
-                  <c:v>83007.24638</c:v>
+                  <c:v>152463.7681</c:v>
                 </c:pt>
               </c:numCache>
             </c:numRef>
@@ -1018,7 +1018,7 @@
 </c:chartSpace>
 </file>
 
-<file path=ppt/charts/chart4.xml><?xml version="1.0" encoding="utf-8"?>
+<file path=ppt/charts/chart13.xml><?xml version="1.0" encoding="utf-8"?>
 <c:chartSpace xmlns:c="http://schemas.openxmlformats.org/drawingml/2006/chart" xmlns:a="http://schemas.openxmlformats.org/drawingml/2006/main" xmlns:r="http://schemas.openxmlformats.org/officeDocument/2006/relationships">
   <c:date1904 val="0"/>
   <c:roundedCorners val="0"/>
@@ -1162,19 +1162,19 @@
                 <c:formatCode>General</c:formatCode>
                 <c:ptCount val="5"/>
                 <c:pt idx="0">
-                  <c:v>209.932942</c:v>
+                  <c:v>209.501832</c:v>
                 </c:pt>
                 <c:pt idx="1">
-                  <c:v>218.315276</c:v>
+                  <c:v>209.761929</c:v>
                 </c:pt>
                 <c:pt idx="2">
-                  <c:v>423.165556</c:v>
+                  <c:v>415.984024</c:v>
                 </c:pt>
                 <c:pt idx="3">
-                  <c:v>233.132245</c:v>
+                  <c:v>225.417552</c:v>
                 </c:pt>
                 <c:pt idx="4">
-                  <c:v>226.795755</c:v>
+                  <c:v>213.534689</c:v>
                 </c:pt>
               </c:numCache>
             </c:numRef>
@@ -1318,7 +1318,7 @@
 </c:chartSpace>
 </file>
 
-<file path=ppt/charts/chart5.xml><?xml version="1.0" encoding="utf-8"?>
+<file path=ppt/charts/chart14.xml><?xml version="1.0" encoding="utf-8"?>
 <c:chartSpace xmlns:c="http://schemas.openxmlformats.org/drawingml/2006/chart" xmlns:a="http://schemas.openxmlformats.org/drawingml/2006/main" xmlns:r="http://schemas.openxmlformats.org/officeDocument/2006/relationships">
   <c:date1904 val="0"/>
   <c:roundedCorners val="0"/>
@@ -1462,19 +1462,19 @@
                 <c:formatCode>General</c:formatCode>
                 <c:ptCount val="5"/>
                 <c:pt idx="0">
-                  <c:v>219</c:v>
+                  <c:v>247</c:v>
                 </c:pt>
                 <c:pt idx="1">
-                  <c:v>134</c:v>
+                  <c:v>230</c:v>
                 </c:pt>
                 <c:pt idx="2">
-                  <c:v>39</c:v>
+                  <c:v>33</c:v>
                 </c:pt>
                 <c:pt idx="3">
-                  <c:v>41</c:v>
+                  <c:v>68</c:v>
                 </c:pt>
                 <c:pt idx="4">
-                  <c:v>23</c:v>
+                  <c:v>36</c:v>
                 </c:pt>
               </c:numCache>
             </c:numRef>
@@ -1618,7 +1618,7 @@
 </c:chartSpace>
 </file>
 
-<file path=ppt/charts/chart6.xml><?xml version="1.0" encoding="utf-8"?>
+<file path=ppt/charts/chart15.xml><?xml version="1.0" encoding="utf-8"?>
 <c:chartSpace xmlns:c="http://schemas.openxmlformats.org/drawingml/2006/chart" xmlns:a="http://schemas.openxmlformats.org/drawingml/2006/main" xmlns:r="http://schemas.openxmlformats.org/officeDocument/2006/relationships">
   <c:date1904 val="0"/>
   <c:roundedCorners val="0"/>
@@ -1918,7 +1918,7 @@
 </c:chartSpace>
 </file>
 
-<file path=ppt/charts/chart7.xml><?xml version="1.0" encoding="utf-8"?>
+<file path=ppt/charts/chart16.xml><?xml version="1.0" encoding="utf-8"?>
 <c:chartSpace xmlns:c="http://schemas.openxmlformats.org/drawingml/2006/chart" xmlns:a="http://schemas.openxmlformats.org/drawingml/2006/main" xmlns:r="http://schemas.openxmlformats.org/officeDocument/2006/relationships">
   <c:date1904 val="0"/>
   <c:roundedCorners val="0"/>
@@ -2218,7 +2218,7 @@
 </c:chartSpace>
 </file>
 
-<file path=ppt/charts/chart8.xml><?xml version="1.0" encoding="utf-8"?>
+<file path=ppt/charts/chart17.xml><?xml version="1.0" encoding="utf-8"?>
 <c:chartSpace xmlns:c="http://schemas.openxmlformats.org/drawingml/2006/chart" xmlns:a="http://schemas.openxmlformats.org/drawingml/2006/main" xmlns:r="http://schemas.openxmlformats.org/officeDocument/2006/relationships">
   <c:date1904 val="0"/>
   <c:roundedCorners val="0"/>
@@ -2518,7 +2518,7 @@
 </c:chartSpace>
 </file>
 
-<file path=ppt/charts/chart9.xml><?xml version="1.0" encoding="utf-8"?>
+<file path=ppt/charts/chart18.xml><?xml version="1.0" encoding="utf-8"?>
 <c:chartSpace xmlns:c="http://schemas.openxmlformats.org/drawingml/2006/chart" xmlns:a="http://schemas.openxmlformats.org/drawingml/2006/main" xmlns:r="http://schemas.openxmlformats.org/officeDocument/2006/relationships">
   <c:date1904 val="0"/>
   <c:roundedCorners val="0"/>
@@ -10286,7 +10286,7 @@
                 <a:ea typeface="Century Gothic" pitchFamily="34" charset="-122"/>
                 <a:cs typeface="Century Gothic" pitchFamily="34" charset="-120"/>
               </a:rPr>
-              <a:t>$3,937,968</a:t>
+              <a:t>$6,108,394</a:t>
             </a:r>
             <a:endParaRPr lang="en-US" sz="2600" dirty="0"/>
           </a:p>
@@ -10421,7 +10421,7 @@
                 <a:ea typeface="Century Gothic" pitchFamily="34" charset="-122"/>
                 <a:cs typeface="Century Gothic" pitchFamily="34" charset="-120"/>
               </a:rPr>
-              <a:t>50</a:t>
+              <a:t>79</a:t>
             </a:r>
             <a:endParaRPr lang="en-US" sz="2600" dirty="0"/>
           </a:p>
@@ -11327,7 +11327,7 @@
                 <a:ea typeface="Calibri" pitchFamily="34" charset="-122"/>
                 <a:cs typeface="Calibri" pitchFamily="34" charset="-120"/>
               </a:rPr>
-              <a:t>Total disbursed: $3,937,968.</a:t>
+              <a:t>Total disbursed: $6,108,394.</a:t>
             </a:r>
             <a:endParaRPr lang="en-US" sz="1200" dirty="0"/>
           </a:p>
@@ -11344,7 +11344,7 @@
                 <a:ea typeface="Calibri" pitchFamily="34" charset="-122"/>
                 <a:cs typeface="Calibri" pitchFamily="34" charset="-120"/>
               </a:rPr>
-              <a:t>Tanzania had the highest disbursements ($2,069,729).</a:t>
+              <a:t>Tanzania had the highest disbursements ($2,901,600).</a:t>
             </a:r>
             <a:endParaRPr lang="en-US" sz="1200" dirty="0"/>
           </a:p>

</xml_diff>

<commit_message>
Auto-build: 2026-03-17 05:31 UTC
</commit_message>
<xml_diff>
--- a/reports/2026-01.pptx
+++ b/reports/2026-01.pptx
@@ -12413,7 +12413,7 @@
         <p:spPr>
           <a:xfrm>
             <a:off x="7955280" y="685800"/>
-            <a:ext cx="4069080" cy="914400"/>
+            <a:ext cx="4069080" cy="1005840"/>
           </a:xfrm>
           <a:prstGeom prst="rect">
             <a:avLst/>
@@ -12470,7 +12470,7 @@
         <p:spPr>
           <a:xfrm>
             <a:off x="7955280" y="777240"/>
-            <a:ext cx="4069080" cy="502920"/>
+            <a:ext cx="4069080" cy="553212"/>
           </a:xfrm>
           <a:prstGeom prst="rect">
             <a:avLst/>
@@ -12508,8 +12508,8 @@
         </p:nvSpPr>
         <p:spPr>
           <a:xfrm>
-            <a:off x="8001000" y="1234440"/>
-            <a:ext cx="3977640" cy="365760"/>
+            <a:off x="8001000" y="1289304"/>
+            <a:ext cx="3977640" cy="402336"/>
           </a:xfrm>
           <a:prstGeom prst="rect">
             <a:avLst/>
@@ -12547,8 +12547,8 @@
         </p:nvSpPr>
         <p:spPr>
           <a:xfrm>
-            <a:off x="7955280" y="1691640"/>
-            <a:ext cx="4069080" cy="914400"/>
+            <a:off x="7955280" y="1783080"/>
+            <a:ext cx="4069080" cy="1005840"/>
           </a:xfrm>
           <a:prstGeom prst="rect">
             <a:avLst/>
@@ -12579,7 +12579,7 @@
         </p:nvSpPr>
         <p:spPr>
           <a:xfrm>
-            <a:off x="7955280" y="1691640"/>
+            <a:off x="7955280" y="1783080"/>
             <a:ext cx="4069080" cy="45720"/>
           </a:xfrm>
           <a:prstGeom prst="rect">
@@ -12604,8 +12604,8 @@
         </p:nvSpPr>
         <p:spPr>
           <a:xfrm>
-            <a:off x="7955280" y="1783080"/>
-            <a:ext cx="4069080" cy="502920"/>
+            <a:off x="7955280" y="1874520"/>
+            <a:ext cx="4069080" cy="553212"/>
           </a:xfrm>
           <a:prstGeom prst="rect">
             <a:avLst/>
@@ -12643,8 +12643,8 @@
         </p:nvSpPr>
         <p:spPr>
           <a:xfrm>
-            <a:off x="8001000" y="2240280"/>
-            <a:ext cx="3977640" cy="365760"/>
+            <a:off x="8001000" y="2386584"/>
+            <a:ext cx="3977640" cy="402336"/>
           </a:xfrm>
           <a:prstGeom prst="rect">
             <a:avLst/>
@@ -12682,8 +12682,8 @@
         </p:nvSpPr>
         <p:spPr>
           <a:xfrm>
-            <a:off x="7955280" y="2697480"/>
-            <a:ext cx="4069080" cy="914400"/>
+            <a:off x="7955280" y="2880360"/>
+            <a:ext cx="4069080" cy="1005840"/>
           </a:xfrm>
           <a:prstGeom prst="rect">
             <a:avLst/>
@@ -12714,7 +12714,7 @@
         </p:nvSpPr>
         <p:spPr>
           <a:xfrm>
-            <a:off x="7955280" y="2697480"/>
+            <a:off x="7955280" y="2880360"/>
             <a:ext cx="4069080" cy="45720"/>
           </a:xfrm>
           <a:prstGeom prst="rect">
@@ -12739,8 +12739,8 @@
         </p:nvSpPr>
         <p:spPr>
           <a:xfrm>
-            <a:off x="7955280" y="2788920"/>
-            <a:ext cx="4069080" cy="502920"/>
+            <a:off x="7955280" y="2971800"/>
+            <a:ext cx="4069080" cy="553212"/>
           </a:xfrm>
           <a:prstGeom prst="rect">
             <a:avLst/>
@@ -12778,8 +12778,8 @@
         </p:nvSpPr>
         <p:spPr>
           <a:xfrm>
-            <a:off x="8001000" y="3246120"/>
-            <a:ext cx="3977640" cy="365760"/>
+            <a:off x="8001000" y="3483864"/>
+            <a:ext cx="3977640" cy="402336"/>
           </a:xfrm>
           <a:prstGeom prst="rect">
             <a:avLst/>
@@ -12817,14 +12817,14 @@
         </p:nvSpPr>
         <p:spPr>
           <a:xfrm>
-            <a:off x="7955280" y="3703320"/>
-            <a:ext cx="4069080" cy="914400"/>
+            <a:off x="7955280" y="3977640"/>
+            <a:ext cx="4069080" cy="2578608"/>
           </a:xfrm>
           <a:prstGeom prst="rect">
             <a:avLst/>
           </a:prstGeom>
           <a:solidFill>
-            <a:srgbClr val="FFFFFF"/>
+            <a:srgbClr val="FAF7F2"/>
           </a:solidFill>
           <a:ln w="12700">
             <a:solidFill>
@@ -12832,13 +12832,6 @@
             </a:solidFill>
             <a:prstDash val="solid"/>
           </a:ln>
-          <a:effectLst>
-            <a:outerShdw sx="100000" sy="100000" kx="0" ky="0" algn="bl" rotWithShape="0" blurRad="50800" dist="25400" dir="8100000">
-              <a:srgbClr val="000000">
-                <a:alpha val="8000"/>
-              </a:srgbClr>
-            </a:outerShdw>
-          </a:effectLst>
         </p:spPr>
       </p:sp>
       <p:sp>
@@ -12849,8 +12842,8 @@
         </p:nvSpPr>
         <p:spPr>
           <a:xfrm>
-            <a:off x="7955280" y="3703320"/>
-            <a:ext cx="4069080" cy="45720"/>
+            <a:off x="7955280" y="3977640"/>
+            <a:ext cx="54864" cy="2578608"/>
           </a:xfrm>
           <a:prstGeom prst="rect">
             <a:avLst/>
@@ -12874,135 +12867,7 @@
         </p:nvSpPr>
         <p:spPr>
           <a:xfrm>
-            <a:off x="7955280" y="3794760"/>
-            <a:ext cx="4069080" cy="502920"/>
-          </a:xfrm>
-          <a:prstGeom prst="rect">
-            <a:avLst/>
-          </a:prstGeom>
-          <a:noFill/>
-          <a:ln/>
-        </p:spPr>
-        <p:txBody>
-          <a:bodyPr wrap="square" rtlCol="0" anchor="ctr"/>
-          <a:lstStyle/>
-          <a:p>
-            <a:pPr algn="ctr" indent="0" marL="0">
-              <a:buNone/>
-            </a:pPr>
-            <a:r>
-              <a:rPr lang="en-US" sz="2600" b="1" dirty="0">
-                <a:solidFill>
-                  <a:srgbClr val="5D300F"/>
-                </a:solidFill>
-                <a:latin typeface="Century Gothic" pitchFamily="34" charset="0"/>
-                <a:ea typeface="Century Gothic" pitchFamily="34" charset="-122"/>
-                <a:cs typeface="Century Gothic" pitchFamily="34" charset="-120"/>
-              </a:rPr>
-              <a:t>—</a:t>
-            </a:r>
-            <a:endParaRPr lang="en-US" sz="2600" dirty="0"/>
-          </a:p>
-        </p:txBody>
-      </p:sp>
-      <p:sp>
-        <p:nvSpPr>
-          <p:cNvPr id="35" name="Text 32"/>
-          <p:cNvSpPr/>
-          <p:nvPr/>
-        </p:nvSpPr>
-        <p:spPr>
-          <a:xfrm>
-            <a:off x="8001000" y="4251960"/>
-            <a:ext cx="3977640" cy="365760"/>
-          </a:xfrm>
-          <a:prstGeom prst="rect">
-            <a:avLst/>
-          </a:prstGeom>
-          <a:noFill/>
-          <a:ln/>
-        </p:spPr>
-        <p:txBody>
-          <a:bodyPr wrap="square" rtlCol="0" anchor="ctr"/>
-          <a:lstStyle/>
-          <a:p>
-            <a:pPr algn="ctr" indent="0" marL="0">
-              <a:buNone/>
-            </a:pPr>
-            <a:r>
-              <a:rPr lang="en-US" sz="1200" dirty="0">
-                <a:solidFill>
-                  <a:srgbClr val="718096"/>
-                </a:solidFill>
-                <a:latin typeface="Calibri" pitchFamily="34" charset="0"/>
-                <a:ea typeface="Calibri" pitchFamily="34" charset="-122"/>
-                <a:cs typeface="Calibri" pitchFamily="34" charset="-120"/>
-              </a:rPr>
-              <a:t>Avg Turnaround Time</a:t>
-            </a:r>
-            <a:endParaRPr lang="en-US" sz="1200" dirty="0"/>
-          </a:p>
-        </p:txBody>
-      </p:sp>
-      <p:sp>
-        <p:nvSpPr>
-          <p:cNvPr id="36" name="Shape 33"/>
-          <p:cNvSpPr/>
-          <p:nvPr/>
-        </p:nvSpPr>
-        <p:spPr>
-          <a:xfrm>
-            <a:off x="7955280" y="4709160"/>
-            <a:ext cx="4069080" cy="1847088"/>
-          </a:xfrm>
-          <a:prstGeom prst="rect">
-            <a:avLst/>
-          </a:prstGeom>
-          <a:solidFill>
-            <a:srgbClr val="FAF7F2"/>
-          </a:solidFill>
-          <a:ln w="12700">
-            <a:solidFill>
-              <a:srgbClr val="D6CFC4"/>
-            </a:solidFill>
-            <a:prstDash val="solid"/>
-          </a:ln>
-        </p:spPr>
-      </p:sp>
-      <p:sp>
-        <p:nvSpPr>
-          <p:cNvPr id="37" name="Shape 34"/>
-          <p:cNvSpPr/>
-          <p:nvPr/>
-        </p:nvSpPr>
-        <p:spPr>
-          <a:xfrm>
-            <a:off x="7955280" y="4709160"/>
-            <a:ext cx="54864" cy="1847088"/>
-          </a:xfrm>
-          <a:prstGeom prst="rect">
-            <a:avLst/>
-          </a:prstGeom>
-          <a:solidFill>
-            <a:srgbClr val="5D300F"/>
-          </a:solidFill>
-          <a:ln w="12700">
-            <a:solidFill>
-              <a:srgbClr val="5D300F"/>
-            </a:solidFill>
-            <a:prstDash val="solid"/>
-          </a:ln>
-        </p:spPr>
-      </p:sp>
-      <p:sp>
-        <p:nvSpPr>
-          <p:cNvPr id="38" name="Text 35"/>
-          <p:cNvSpPr/>
-          <p:nvPr/>
-        </p:nvSpPr>
-        <p:spPr>
-          <a:xfrm>
-            <a:off x="8065008" y="4764024"/>
+            <a:off x="8065008" y="4032504"/>
             <a:ext cx="3886200" cy="228600"/>
           </a:xfrm>
           <a:prstGeom prst="rect">
@@ -13035,14 +12900,14 @@
       </p:sp>
       <p:sp>
         <p:nvSpPr>
-          <p:cNvPr id="39" name="Text 36"/>
-          <p:cNvSpPr/>
-          <p:nvPr/>
-        </p:nvSpPr>
-        <p:spPr>
-          <a:xfrm>
-            <a:off x="8065008" y="5029200"/>
-            <a:ext cx="3886200" cy="1435608"/>
+          <p:cNvPr id="35" name="Text 32"/>
+          <p:cNvSpPr/>
+          <p:nvPr/>
+        </p:nvSpPr>
+        <p:spPr>
+          <a:xfrm>
+            <a:off x="8065008" y="4297680"/>
+            <a:ext cx="3886200" cy="2167128"/>
           </a:xfrm>
           <a:prstGeom prst="rect">
             <a:avLst/>
@@ -15076,7 +14941,7 @@
                 <a:ea typeface="Century Gothic" pitchFamily="34" charset="-122"/>
                 <a:cs typeface="Century Gothic" pitchFamily="34" charset="-120"/>
               </a:rPr>
-              <a:t>79</a:t>
+              <a:t>—</a:t>
             </a:r>
             <a:endParaRPr lang="en-US" sz="2600" dirty="0"/>
           </a:p>
@@ -15115,7 +14980,7 @@
                 <a:ea typeface="Calibri" pitchFamily="34" charset="-122"/>
                 <a:cs typeface="Calibri" pitchFamily="34" charset="-120"/>
               </a:rPr>
-              <a:t>Group Disb per Team</a:t>
+              <a:t>Change vs Prior Month</a:t>
             </a:r>
             <a:endParaRPr lang="en-US" sz="1200" dirty="0"/>
           </a:p>
@@ -15211,7 +15076,7 @@
                 <a:ea typeface="Century Gothic" pitchFamily="34" charset="-122"/>
                 <a:cs typeface="Century Gothic" pitchFamily="34" charset="-120"/>
               </a:rPr>
-              <a:t>—</a:t>
+              <a:t>79</a:t>
             </a:r>
             <a:endParaRPr lang="en-US" sz="2600" dirty="0"/>
           </a:p>
@@ -15250,7 +15115,7 @@
                 <a:ea typeface="Calibri" pitchFamily="34" charset="-122"/>
                 <a:cs typeface="Calibri" pitchFamily="34" charset="-120"/>
               </a:rPr>
-              <a:t>Change vs Prior Month</a:t>
+              <a:t>Group Disb per Team</a:t>
             </a:r>
             <a:endParaRPr lang="en-US" sz="1200" dirty="0"/>
           </a:p>

</xml_diff>

<commit_message>
Auto-build: 2026-03-17 16:11 UTC
</commit_message>
<xml_diff>
--- a/reports/2026-01.pptx
+++ b/reports/2026-01.pptx
@@ -1747,10 +1747,10 @@
                     <c:v>Uganda</c:v>
                   </c:pt>
                   <c:pt idx="3">
-                    <c:v>Sierra Leone</c:v>
+                    <c:v>Nigeria</c:v>
                   </c:pt>
                   <c:pt idx="4">
-                    <c:v>Nigeria</c:v>
+                    <c:v>Sierra Leone</c:v>
                   </c:pt>
                 </c:lvl>
               </c:multiLvlStrCache>
@@ -1763,19 +1763,19 @@
                 <c:formatCode>General</c:formatCode>
                 <c:ptCount val="5"/>
                 <c:pt idx="0">
-                  <c:v>0</c:v>
+                  <c:v>2</c:v>
                 </c:pt>
                 <c:pt idx="1">
-                  <c:v>0</c:v>
+                  <c:v>3</c:v>
                 </c:pt>
                 <c:pt idx="2">
-                  <c:v>0</c:v>
+                  <c:v>3</c:v>
                 </c:pt>
                 <c:pt idx="3">
-                  <c:v>0</c:v>
+                  <c:v>3</c:v>
                 </c:pt>
                 <c:pt idx="4">
-                  <c:v>0</c:v>
+                  <c:v>6</c:v>
                 </c:pt>
               </c:numCache>
             </c:numRef>
@@ -17561,7 +17561,7 @@
                 <a:ea typeface="Century Gothic" pitchFamily="34" charset="-122"/>
                 <a:cs typeface="Century Gothic" pitchFamily="34" charset="-120"/>
               </a:rPr>
-              <a:t>—</a:t>
+              <a:t>3 days</a:t>
             </a:r>
             <a:endParaRPr lang="en-US" sz="2600" dirty="0"/>
           </a:p>

</xml_diff>

<commit_message>
Auto-build: 2026-03-17 18:13 UTC
</commit_message>
<xml_diff>
--- a/reports/2026-01.pptx
+++ b/reports/2026-01.pptx
@@ -15129,7 +15129,7 @@
         </p:nvSpPr>
         <p:spPr>
           <a:xfrm>
-            <a:off x="7955280" y="3794760"/>
+            <a:off x="7955280" y="3703320"/>
             <a:ext cx="4069080" cy="292608"/>
           </a:xfrm>
           <a:prstGeom prst="rect">
@@ -15154,7 +15154,7 @@
         </p:nvSpPr>
         <p:spPr>
           <a:xfrm>
-            <a:off x="7955280" y="3794760"/>
+            <a:off x="7955280" y="3703320"/>
             <a:ext cx="54864" cy="292608"/>
           </a:xfrm>
           <a:prstGeom prst="rect">
@@ -15179,7 +15179,7 @@
         </p:nvSpPr>
         <p:spPr>
           <a:xfrm>
-            <a:off x="8065008" y="3794760"/>
+            <a:off x="8065008" y="3703320"/>
             <a:ext cx="3959352" cy="292608"/>
           </a:xfrm>
           <a:prstGeom prst="rect">
@@ -15218,8 +15218,8 @@
         </p:nvSpPr>
         <p:spPr>
           <a:xfrm>
-            <a:off x="7955280" y="4133088"/>
-            <a:ext cx="1234440" cy="566928"/>
+            <a:off x="7955280" y="4023360"/>
+            <a:ext cx="1234440" cy="530352"/>
           </a:xfrm>
           <a:prstGeom prst="rect">
             <a:avLst/>
@@ -15243,8 +15243,8 @@
         </p:nvSpPr>
         <p:spPr>
           <a:xfrm>
-            <a:off x="7955280" y="4133088"/>
-            <a:ext cx="1234440" cy="256032"/>
+            <a:off x="7955280" y="4023360"/>
+            <a:ext cx="1234440" cy="237744"/>
           </a:xfrm>
           <a:prstGeom prst="rect">
             <a:avLst/>
@@ -15260,7 +15260,7 @@
               <a:buNone/>
             </a:pPr>
             <a:r>
-              <a:rPr lang="en-US" sz="1200" dirty="0">
+              <a:rPr lang="en-US" sz="1100" dirty="0">
                 <a:solidFill>
                   <a:srgbClr val="718096"/>
                 </a:solidFill>
@@ -15270,7 +15270,7 @@
               </a:rPr>
               <a:t>Tanzania</a:t>
             </a:r>
-            <a:endParaRPr lang="en-US" sz="1200" dirty="0"/>
+            <a:endParaRPr lang="en-US" sz="1100" dirty="0"/>
           </a:p>
         </p:txBody>
       </p:sp>
@@ -15282,8 +15282,8 @@
         </p:nvSpPr>
         <p:spPr>
           <a:xfrm>
-            <a:off x="7955280" y="4389120"/>
-            <a:ext cx="1234440" cy="310896"/>
+            <a:off x="7955280" y="4261104"/>
+            <a:ext cx="1234440" cy="292608"/>
           </a:xfrm>
           <a:prstGeom prst="rect">
             <a:avLst/>
@@ -15299,7 +15299,7 @@
               <a:buNone/>
             </a:pPr>
             <a:r>
-              <a:rPr lang="en-US" sz="1200" b="1" dirty="0">
+              <a:rPr lang="en-US" sz="1100" b="1" dirty="0">
                 <a:solidFill>
                   <a:srgbClr val="5D300F"/>
                 </a:solidFill>
@@ -15309,7 +15309,7 @@
               </a:rPr>
               <a:t>139</a:t>
             </a:r>
-            <a:endParaRPr lang="en-US" sz="1200" dirty="0"/>
+            <a:endParaRPr lang="en-US" sz="1100" dirty="0"/>
           </a:p>
         </p:txBody>
       </p:sp>
@@ -15321,8 +15321,8 @@
         </p:nvSpPr>
         <p:spPr>
           <a:xfrm>
-            <a:off x="9308592" y="4133088"/>
-            <a:ext cx="1234440" cy="566928"/>
+            <a:off x="9308592" y="4023360"/>
+            <a:ext cx="1234440" cy="530352"/>
           </a:xfrm>
           <a:prstGeom prst="rect">
             <a:avLst/>
@@ -15346,8 +15346,8 @@
         </p:nvSpPr>
         <p:spPr>
           <a:xfrm>
-            <a:off x="9308592" y="4133088"/>
-            <a:ext cx="1234440" cy="256032"/>
+            <a:off x="9308592" y="4023360"/>
+            <a:ext cx="1234440" cy="237744"/>
           </a:xfrm>
           <a:prstGeom prst="rect">
             <a:avLst/>
@@ -15363,7 +15363,7 @@
               <a:buNone/>
             </a:pPr>
             <a:r>
-              <a:rPr lang="en-US" sz="1200" dirty="0">
+              <a:rPr lang="en-US" sz="1100" dirty="0">
                 <a:solidFill>
                   <a:srgbClr val="718096"/>
                 </a:solidFill>
@@ -15373,7 +15373,7 @@
               </a:rPr>
               <a:t>Kenya</a:t>
             </a:r>
-            <a:endParaRPr lang="en-US" sz="1200" dirty="0"/>
+            <a:endParaRPr lang="en-US" sz="1100" dirty="0"/>
           </a:p>
         </p:txBody>
       </p:sp>
@@ -15385,8 +15385,8 @@
         </p:nvSpPr>
         <p:spPr>
           <a:xfrm>
-            <a:off x="9308592" y="4389120"/>
-            <a:ext cx="1234440" cy="310896"/>
+            <a:off x="9308592" y="4261104"/>
+            <a:ext cx="1234440" cy="292608"/>
           </a:xfrm>
           <a:prstGeom prst="rect">
             <a:avLst/>
@@ -15402,7 +15402,7 @@
               <a:buNone/>
             </a:pPr>
             <a:r>
-              <a:rPr lang="en-US" sz="1200" b="1" dirty="0">
+              <a:rPr lang="en-US" sz="1100" b="1" dirty="0">
                 <a:solidFill>
                   <a:srgbClr val="5D300F"/>
                 </a:solidFill>
@@ -15412,7 +15412,7 @@
               </a:rPr>
               <a:t>100</a:t>
             </a:r>
-            <a:endParaRPr lang="en-US" sz="1200" dirty="0"/>
+            <a:endParaRPr lang="en-US" sz="1100" dirty="0"/>
           </a:p>
         </p:txBody>
       </p:sp>
@@ -15424,8 +15424,8 @@
         </p:nvSpPr>
         <p:spPr>
           <a:xfrm>
-            <a:off x="10661904" y="4133088"/>
-            <a:ext cx="1234440" cy="566928"/>
+            <a:off x="10661904" y="4023360"/>
+            <a:ext cx="1234440" cy="530352"/>
           </a:xfrm>
           <a:prstGeom prst="rect">
             <a:avLst/>
@@ -15449,8 +15449,8 @@
         </p:nvSpPr>
         <p:spPr>
           <a:xfrm>
-            <a:off x="10661904" y="4133088"/>
-            <a:ext cx="1234440" cy="256032"/>
+            <a:off x="10661904" y="4023360"/>
+            <a:ext cx="1234440" cy="237744"/>
           </a:xfrm>
           <a:prstGeom prst="rect">
             <a:avLst/>
@@ -15466,7 +15466,7 @@
               <a:buNone/>
             </a:pPr>
             <a:r>
-              <a:rPr lang="en-US" sz="1200" dirty="0">
+              <a:rPr lang="en-US" sz="1100" dirty="0">
                 <a:solidFill>
                   <a:srgbClr val="718096"/>
                 </a:solidFill>
@@ -15476,7 +15476,7 @@
               </a:rPr>
               <a:t>Sierra Leone</a:t>
             </a:r>
-            <a:endParaRPr lang="en-US" sz="1200" dirty="0"/>
+            <a:endParaRPr lang="en-US" sz="1100" dirty="0"/>
           </a:p>
         </p:txBody>
       </p:sp>
@@ -15488,8 +15488,8 @@
         </p:nvSpPr>
         <p:spPr>
           <a:xfrm>
-            <a:off x="10661904" y="4389120"/>
-            <a:ext cx="1234440" cy="310896"/>
+            <a:off x="10661904" y="4261104"/>
+            <a:ext cx="1234440" cy="292608"/>
           </a:xfrm>
           <a:prstGeom prst="rect">
             <a:avLst/>
@@ -15505,7 +15505,7 @@
               <a:buNone/>
             </a:pPr>
             <a:r>
-              <a:rPr lang="en-US" sz="1200" b="1" dirty="0">
+              <a:rPr lang="en-US" sz="1100" b="1" dirty="0">
                 <a:solidFill>
                   <a:srgbClr val="5D300F"/>
                 </a:solidFill>
@@ -15515,7 +15515,7 @@
               </a:rPr>
               <a:t>33</a:t>
             </a:r>
-            <a:endParaRPr lang="en-US" sz="1200" dirty="0"/>
+            <a:endParaRPr lang="en-US" sz="1100" dirty="0"/>
           </a:p>
         </p:txBody>
       </p:sp>
@@ -15527,8 +15527,8 @@
         </p:nvSpPr>
         <p:spPr>
           <a:xfrm>
-            <a:off x="7955280" y="4791456"/>
-            <a:ext cx="1234440" cy="566928"/>
+            <a:off x="7955280" y="4617720"/>
+            <a:ext cx="1234440" cy="530352"/>
           </a:xfrm>
           <a:prstGeom prst="rect">
             <a:avLst/>
@@ -15552,8 +15552,8 @@
         </p:nvSpPr>
         <p:spPr>
           <a:xfrm>
-            <a:off x="7955280" y="4791456"/>
-            <a:ext cx="1234440" cy="256032"/>
+            <a:off x="7955280" y="4617720"/>
+            <a:ext cx="1234440" cy="237744"/>
           </a:xfrm>
           <a:prstGeom prst="rect">
             <a:avLst/>
@@ -15569,7 +15569,7 @@
               <a:buNone/>
             </a:pPr>
             <a:r>
-              <a:rPr lang="en-US" sz="1200" dirty="0">
+              <a:rPr lang="en-US" sz="1100" dirty="0">
                 <a:solidFill>
                   <a:srgbClr val="718096"/>
                 </a:solidFill>
@@ -15579,7 +15579,7 @@
               </a:rPr>
               <a:t>Uganda</a:t>
             </a:r>
-            <a:endParaRPr lang="en-US" sz="1200" dirty="0"/>
+            <a:endParaRPr lang="en-US" sz="1100" dirty="0"/>
           </a:p>
         </p:txBody>
       </p:sp>
@@ -15591,8 +15591,8 @@
         </p:nvSpPr>
         <p:spPr>
           <a:xfrm>
-            <a:off x="7955280" y="5047488"/>
-            <a:ext cx="1234440" cy="310896"/>
+            <a:off x="7955280" y="4855464"/>
+            <a:ext cx="1234440" cy="292608"/>
           </a:xfrm>
           <a:prstGeom prst="rect">
             <a:avLst/>
@@ -15608,7 +15608,7 @@
               <a:buNone/>
             </a:pPr>
             <a:r>
-              <a:rPr lang="en-US" sz="1200" b="1" dirty="0">
+              <a:rPr lang="en-US" sz="1100" b="1" dirty="0">
                 <a:solidFill>
                   <a:srgbClr val="5D300F"/>
                 </a:solidFill>
@@ -15618,7 +15618,7 @@
               </a:rPr>
               <a:t>39</a:t>
             </a:r>
-            <a:endParaRPr lang="en-US" sz="1200" dirty="0"/>
+            <a:endParaRPr lang="en-US" sz="1100" dirty="0"/>
           </a:p>
         </p:txBody>
       </p:sp>
@@ -15630,8 +15630,8 @@
         </p:nvSpPr>
         <p:spPr>
           <a:xfrm>
-            <a:off x="9308592" y="4791456"/>
-            <a:ext cx="1234440" cy="566928"/>
+            <a:off x="9308592" y="4617720"/>
+            <a:ext cx="1234440" cy="530352"/>
           </a:xfrm>
           <a:prstGeom prst="rect">
             <a:avLst/>
@@ -15655,8 +15655,8 @@
         </p:nvSpPr>
         <p:spPr>
           <a:xfrm>
-            <a:off x="9308592" y="4791456"/>
-            <a:ext cx="1234440" cy="256032"/>
+            <a:off x="9308592" y="4617720"/>
+            <a:ext cx="1234440" cy="237744"/>
           </a:xfrm>
           <a:prstGeom prst="rect">
             <a:avLst/>
@@ -15672,7 +15672,7 @@
               <a:buNone/>
             </a:pPr>
             <a:r>
-              <a:rPr lang="en-US" sz="1200" dirty="0">
+              <a:rPr lang="en-US" sz="1100" dirty="0">
                 <a:solidFill>
                   <a:srgbClr val="718096"/>
                 </a:solidFill>
@@ -15682,7 +15682,7 @@
               </a:rPr>
               <a:t>Nigeria</a:t>
             </a:r>
-            <a:endParaRPr lang="en-US" sz="1200" dirty="0"/>
+            <a:endParaRPr lang="en-US" sz="1100" dirty="0"/>
           </a:p>
         </p:txBody>
       </p:sp>
@@ -15694,8 +15694,8 @@
         </p:nvSpPr>
         <p:spPr>
           <a:xfrm>
-            <a:off x="9308592" y="5047488"/>
-            <a:ext cx="1234440" cy="310896"/>
+            <a:off x="9308592" y="4855464"/>
+            <a:ext cx="1234440" cy="292608"/>
           </a:xfrm>
           <a:prstGeom prst="rect">
             <a:avLst/>
@@ -15711,7 +15711,7 @@
               <a:buNone/>
             </a:pPr>
             <a:r>
-              <a:rPr lang="en-US" sz="1200" b="1" dirty="0">
+              <a:rPr lang="en-US" sz="1100" b="1" dirty="0">
                 <a:solidFill>
                   <a:srgbClr val="5D300F"/>
                 </a:solidFill>
@@ -15721,7 +15721,7 @@
               </a:rPr>
               <a:t>36</a:t>
             </a:r>
-            <a:endParaRPr lang="en-US" sz="1200" dirty="0"/>
+            <a:endParaRPr lang="en-US" sz="1100" dirty="0"/>
           </a:p>
         </p:txBody>
       </p:sp>
@@ -15733,8 +15733,8 @@
         </p:nvSpPr>
         <p:spPr>
           <a:xfrm>
-            <a:off x="7955280" y="5577840"/>
-            <a:ext cx="4069080" cy="978408"/>
+            <a:off x="7955280" y="5321808"/>
+            <a:ext cx="4069080" cy="960120"/>
           </a:xfrm>
           <a:prstGeom prst="rect">
             <a:avLst/>
@@ -15758,8 +15758,8 @@
         </p:nvSpPr>
         <p:spPr>
           <a:xfrm>
-            <a:off x="7955280" y="5577840"/>
-            <a:ext cx="54864" cy="978408"/>
+            <a:off x="7955280" y="5321808"/>
+            <a:ext cx="54864" cy="960120"/>
           </a:xfrm>
           <a:prstGeom prst="rect">
             <a:avLst/>
@@ -15783,7 +15783,7 @@
         </p:nvSpPr>
         <p:spPr>
           <a:xfrm>
-            <a:off x="8065008" y="5632704"/>
+            <a:off x="8065008" y="5376672"/>
             <a:ext cx="3886200" cy="228600"/>
           </a:xfrm>
           <a:prstGeom prst="rect">
@@ -15822,8 +15822,8 @@
         </p:nvSpPr>
         <p:spPr>
           <a:xfrm>
-            <a:off x="8065008" y="5897880"/>
-            <a:ext cx="3886200" cy="566928"/>
+            <a:off x="8065008" y="5641848"/>
+            <a:ext cx="3886200" cy="548640"/>
           </a:xfrm>
           <a:prstGeom prst="rect">
             <a:avLst/>
@@ -17690,7 +17690,7 @@
             <a:r>
               <a:rPr lang="en-US" sz="2600" b="1" dirty="0">
                 <a:solidFill>
-                  <a:srgbClr val="5D300F"/>
+                  <a:srgbClr val="718096"/>
                 </a:solidFill>
                 <a:latin typeface="Century Gothic" pitchFamily="34" charset="0"/>
                 <a:ea typeface="Century Gothic" pitchFamily="34" charset="-122"/>
@@ -17735,7 +17735,7 @@
                 <a:ea typeface="Calibri" pitchFamily="34" charset="-122"/>
                 <a:cs typeface="Calibri" pitchFamily="34" charset="-120"/>
               </a:rPr>
-              <a:t>Change vs Prior Month</a:t>
+              <a:t>Trend vs Prior Month</a:t>
             </a:r>
             <a:endParaRPr lang="en-US" sz="1200" dirty="0"/>
           </a:p>
@@ -17863,7 +17863,24 @@
                 <a:ea typeface="Calibri" pitchFamily="34" charset="-122"/>
                 <a:cs typeface="Calibri" pitchFamily="34" charset="-120"/>
               </a:rPr>
-              <a:t>—</a:t>
+              <a:t>Group median turnaround: N/A.</a:t>
+            </a:r>
+            <a:endParaRPr lang="en-US" sz="1200" dirty="0"/>
+          </a:p>
+          <a:p>
+            <a:pPr indent="0" marL="0">
+              <a:buNone/>
+            </a:pPr>
+            <a:r>
+              <a:rPr lang="en-US" sz="1200" dirty="0">
+                <a:solidFill>
+                  <a:srgbClr val="2D2A26"/>
+                </a:solidFill>
+                <a:latin typeface="Calibri" pitchFamily="34" charset="0"/>
+                <a:ea typeface="Calibri" pitchFamily="34" charset="-122"/>
+                <a:cs typeface="Calibri" pitchFamily="34" charset="-120"/>
+              </a:rPr>
+              <a:t>Fastest: Tanzania (2 days). Slowest: Sierra Leone (6 days).</a:t>
             </a:r>
             <a:endParaRPr lang="en-US" sz="1200" dirty="0"/>
           </a:p>

</xml_diff>

<commit_message>
Auto-build: 2026-03-17 19:21 UTC
</commit_message>
<xml_diff>
--- a/reports/2026-01.pptx
+++ b/reports/2026-01.pptx
@@ -17165,7 +17165,7 @@
                 <a:ea typeface="Century Gothic" pitchFamily="34" charset="-122"/>
                 <a:cs typeface="Century Gothic" pitchFamily="34" charset="-120"/>
               </a:rPr>
-              <a:t>Median Days from Application to Disbursement – January 2026</a:t>
+              <a:t>Avg Days from Application to Disbursement – January 2026</a:t>
             </a:r>
             <a:endParaRPr lang="en-US" sz="1200" dirty="0"/>
           </a:p>
@@ -17600,7 +17600,7 @@
                 <a:ea typeface="Calibri" pitchFamily="34" charset="-122"/>
                 <a:cs typeface="Calibri" pitchFamily="34" charset="-120"/>
               </a:rPr>
-              <a:t>Group Median Turnaround</a:t>
+              <a:t>Group Avg Turnaround Time</a:t>
             </a:r>
             <a:endParaRPr lang="en-US" sz="1200" dirty="0"/>
           </a:p>
@@ -17863,7 +17863,7 @@
                 <a:ea typeface="Calibri" pitchFamily="34" charset="-122"/>
                 <a:cs typeface="Calibri" pitchFamily="34" charset="-120"/>
               </a:rPr>
-              <a:t>Group median turnaround: N/A.</a:t>
+              <a:t>Group avg turnaround: 3 days.</a:t>
             </a:r>
             <a:endParaRPr lang="en-US" sz="1200" dirty="0"/>
           </a:p>

</xml_diff>

<commit_message>
Auto-build: 2026-05-05 23:57 UTC
</commit_message>
<xml_diff>
--- a/reports/2026-01.pptx
+++ b/reports/2026-01.pptx
@@ -119,7 +119,7 @@
 </p:presentation>
 </file>
 
-<file path=ppt/charts/chart11.xml><?xml version="1.0" encoding="utf-8"?>
+<file path=ppt/charts/chart21.xml><?xml version="1.0" encoding="utf-8"?>
 <c:chartSpace xmlns:c="http://schemas.openxmlformats.org/drawingml/2006/chart" xmlns:a="http://schemas.openxmlformats.org/drawingml/2006/main" xmlns:r="http://schemas.openxmlformats.org/officeDocument/2006/relationships">
   <c:date1904 val="0"/>
   <c:roundedCorners val="0"/>
@@ -419,7 +419,7 @@
 </c:chartSpace>
 </file>
 
-<file path=ppt/charts/chart12.xml><?xml version="1.0" encoding="utf-8"?>
+<file path=ppt/charts/chart22.xml><?xml version="1.0" encoding="utf-8"?>
 <c:chartSpace xmlns:c="http://schemas.openxmlformats.org/drawingml/2006/chart" xmlns:a="http://schemas.openxmlformats.org/drawingml/2006/main" xmlns:r="http://schemas.openxmlformats.org/officeDocument/2006/relationships">
   <c:date1904 val="0"/>
   <c:roundedCorners val="0"/>
@@ -719,7 +719,7 @@
 </c:chartSpace>
 </file>
 
-<file path=ppt/charts/chart13.xml><?xml version="1.0" encoding="utf-8"?>
+<file path=ppt/charts/chart23.xml><?xml version="1.0" encoding="utf-8"?>
 <c:chartSpace xmlns:c="http://schemas.openxmlformats.org/drawingml/2006/chart" xmlns:a="http://schemas.openxmlformats.org/drawingml/2006/main" xmlns:r="http://schemas.openxmlformats.org/officeDocument/2006/relationships">
   <c:date1904 val="0"/>
   <c:roundedCorners val="0"/>
@@ -1019,7 +1019,7 @@
 </c:chartSpace>
 </file>
 
-<file path=ppt/charts/chart14.xml><?xml version="1.0" encoding="utf-8"?>
+<file path=ppt/charts/chart24.xml><?xml version="1.0" encoding="utf-8"?>
 <c:chartSpace xmlns:c="http://schemas.openxmlformats.org/drawingml/2006/chart" xmlns:a="http://schemas.openxmlformats.org/drawingml/2006/main" xmlns:r="http://schemas.openxmlformats.org/officeDocument/2006/relationships">
   <c:date1904 val="0"/>
   <c:roundedCorners val="0"/>
@@ -1319,7 +1319,7 @@
 </c:chartSpace>
 </file>
 
-<file path=ppt/charts/chart15.xml><?xml version="1.0" encoding="utf-8"?>
+<file path=ppt/charts/chart25.xml><?xml version="1.0" encoding="utf-8"?>
 <c:chartSpace xmlns:c="http://schemas.openxmlformats.org/drawingml/2006/chart" xmlns:a="http://schemas.openxmlformats.org/drawingml/2006/main" xmlns:r="http://schemas.openxmlformats.org/officeDocument/2006/relationships">
   <c:date1904 val="0"/>
   <c:roundedCorners val="0"/>
@@ -1619,7 +1619,7 @@
 </c:chartSpace>
 </file>
 
-<file path=ppt/charts/chart16.xml><?xml version="1.0" encoding="utf-8"?>
+<file path=ppt/charts/chart26.xml><?xml version="1.0" encoding="utf-8"?>
 <c:chartSpace xmlns:c="http://schemas.openxmlformats.org/drawingml/2006/chart" xmlns:a="http://schemas.openxmlformats.org/drawingml/2006/main" xmlns:r="http://schemas.openxmlformats.org/officeDocument/2006/relationships">
   <c:date1904 val="0"/>
   <c:roundedCorners val="0"/>
@@ -1919,7 +1919,7 @@
 </c:chartSpace>
 </file>
 
-<file path=ppt/charts/chart17.xml><?xml version="1.0" encoding="utf-8"?>
+<file path=ppt/charts/chart27.xml><?xml version="1.0" encoding="utf-8"?>
 <c:chartSpace xmlns:c="http://schemas.openxmlformats.org/drawingml/2006/chart" xmlns:a="http://schemas.openxmlformats.org/drawingml/2006/main" xmlns:r="http://schemas.openxmlformats.org/officeDocument/2006/relationships">
   <c:date1904 val="0"/>
   <c:roundedCorners val="0"/>
@@ -2219,7 +2219,7 @@
 </c:chartSpace>
 </file>
 
-<file path=ppt/charts/chart18.xml><?xml version="1.0" encoding="utf-8"?>
+<file path=ppt/charts/chart28.xml><?xml version="1.0" encoding="utf-8"?>
 <c:chartSpace xmlns:c="http://schemas.openxmlformats.org/drawingml/2006/chart" xmlns:a="http://schemas.openxmlformats.org/drawingml/2006/main" xmlns:r="http://schemas.openxmlformats.org/officeDocument/2006/relationships">
   <c:date1904 val="0"/>
   <c:roundedCorners val="0"/>
@@ -2519,7 +2519,7 @@
 </c:chartSpace>
 </file>
 
-<file path=ppt/charts/chart19.xml><?xml version="1.0" encoding="utf-8"?>
+<file path=ppt/charts/chart29.xml><?xml version="1.0" encoding="utf-8"?>
 <c:chartSpace xmlns:c="http://schemas.openxmlformats.org/drawingml/2006/chart" xmlns:a="http://schemas.openxmlformats.org/drawingml/2006/main" xmlns:r="http://schemas.openxmlformats.org/officeDocument/2006/relationships">
   <c:date1904 val="0"/>
   <c:roundedCorners val="0"/>
@@ -2819,7 +2819,7 @@
 </c:chartSpace>
 </file>
 
-<file path=ppt/charts/chart20.xml><?xml version="1.0" encoding="utf-8"?>
+<file path=ppt/charts/chart30.xml><?xml version="1.0" encoding="utf-8"?>
 <c:chartSpace xmlns:c="http://schemas.openxmlformats.org/drawingml/2006/chart" xmlns:a="http://schemas.openxmlformats.org/drawingml/2006/main" xmlns:r="http://schemas.openxmlformats.org/officeDocument/2006/relationships">
   <c:date1904 val="0"/>
   <c:roundedCorners val="0"/>
@@ -5236,7 +5236,7 @@
                 <a:ea typeface="Calibri" pitchFamily="34" charset="-122"/>
                 <a:cs typeface="Calibri" pitchFamily="34" charset="-120"/>
               </a:rPr>
-              <a:t>Prepared: March 17, 2026</a:t>
+              <a:t>Prepared: May 5, 2026</a:t>
             </a:r>
             <a:endParaRPr lang="en-US" sz="1200" dirty="0"/>
           </a:p>

</xml_diff>

<commit_message>
Auto-build: 2026-06-06 00:49 UTC
</commit_message>
<xml_diff>
--- a/reports/2026-01.pptx
+++ b/reports/2026-01.pptx
@@ -119,7 +119,7 @@
 </p:presentation>
 </file>
 
-<file path=ppt/charts/chart21.xml><?xml version="1.0" encoding="utf-8"?>
+<file path=ppt/charts/chart41.xml><?xml version="1.0" encoding="utf-8"?>
 <c:chartSpace xmlns:c="http://schemas.openxmlformats.org/drawingml/2006/chart" xmlns:a="http://schemas.openxmlformats.org/drawingml/2006/main" xmlns:r="http://schemas.openxmlformats.org/officeDocument/2006/relationships">
   <c:date1904 val="0"/>
   <c:roundedCorners val="0"/>
@@ -419,7 +419,7 @@
 </c:chartSpace>
 </file>
 
-<file path=ppt/charts/chart22.xml><?xml version="1.0" encoding="utf-8"?>
+<file path=ppt/charts/chart42.xml><?xml version="1.0" encoding="utf-8"?>
 <c:chartSpace xmlns:c="http://schemas.openxmlformats.org/drawingml/2006/chart" xmlns:a="http://schemas.openxmlformats.org/drawingml/2006/main" xmlns:r="http://schemas.openxmlformats.org/officeDocument/2006/relationships">
   <c:date1904 val="0"/>
   <c:roundedCorners val="0"/>
@@ -719,7 +719,7 @@
 </c:chartSpace>
 </file>
 
-<file path=ppt/charts/chart23.xml><?xml version="1.0" encoding="utf-8"?>
+<file path=ppt/charts/chart43.xml><?xml version="1.0" encoding="utf-8"?>
 <c:chartSpace xmlns:c="http://schemas.openxmlformats.org/drawingml/2006/chart" xmlns:a="http://schemas.openxmlformats.org/drawingml/2006/main" xmlns:r="http://schemas.openxmlformats.org/officeDocument/2006/relationships">
   <c:date1904 val="0"/>
   <c:roundedCorners val="0"/>
@@ -1019,7 +1019,7 @@
 </c:chartSpace>
 </file>
 
-<file path=ppt/charts/chart24.xml><?xml version="1.0" encoding="utf-8"?>
+<file path=ppt/charts/chart44.xml><?xml version="1.0" encoding="utf-8"?>
 <c:chartSpace xmlns:c="http://schemas.openxmlformats.org/drawingml/2006/chart" xmlns:a="http://schemas.openxmlformats.org/drawingml/2006/main" xmlns:r="http://schemas.openxmlformats.org/officeDocument/2006/relationships">
   <c:date1904 val="0"/>
   <c:roundedCorners val="0"/>
@@ -1319,7 +1319,7 @@
 </c:chartSpace>
 </file>
 
-<file path=ppt/charts/chart25.xml><?xml version="1.0" encoding="utf-8"?>
+<file path=ppt/charts/chart45.xml><?xml version="1.0" encoding="utf-8"?>
 <c:chartSpace xmlns:c="http://schemas.openxmlformats.org/drawingml/2006/chart" xmlns:a="http://schemas.openxmlformats.org/drawingml/2006/main" xmlns:r="http://schemas.openxmlformats.org/officeDocument/2006/relationships">
   <c:date1904 val="0"/>
   <c:roundedCorners val="0"/>
@@ -1619,7 +1619,7 @@
 </c:chartSpace>
 </file>
 
-<file path=ppt/charts/chart26.xml><?xml version="1.0" encoding="utf-8"?>
+<file path=ppt/charts/chart46.xml><?xml version="1.0" encoding="utf-8"?>
 <c:chartSpace xmlns:c="http://schemas.openxmlformats.org/drawingml/2006/chart" xmlns:a="http://schemas.openxmlformats.org/drawingml/2006/main" xmlns:r="http://schemas.openxmlformats.org/officeDocument/2006/relationships">
   <c:date1904 val="0"/>
   <c:roundedCorners val="0"/>
@@ -1919,7 +1919,7 @@
 </c:chartSpace>
 </file>
 
-<file path=ppt/charts/chart27.xml><?xml version="1.0" encoding="utf-8"?>
+<file path=ppt/charts/chart47.xml><?xml version="1.0" encoding="utf-8"?>
 <c:chartSpace xmlns:c="http://schemas.openxmlformats.org/drawingml/2006/chart" xmlns:a="http://schemas.openxmlformats.org/drawingml/2006/main" xmlns:r="http://schemas.openxmlformats.org/officeDocument/2006/relationships">
   <c:date1904 val="0"/>
   <c:roundedCorners val="0"/>
@@ -2219,7 +2219,7 @@
 </c:chartSpace>
 </file>
 
-<file path=ppt/charts/chart28.xml><?xml version="1.0" encoding="utf-8"?>
+<file path=ppt/charts/chart48.xml><?xml version="1.0" encoding="utf-8"?>
 <c:chartSpace xmlns:c="http://schemas.openxmlformats.org/drawingml/2006/chart" xmlns:a="http://schemas.openxmlformats.org/drawingml/2006/main" xmlns:r="http://schemas.openxmlformats.org/officeDocument/2006/relationships">
   <c:date1904 val="0"/>
   <c:roundedCorners val="0"/>
@@ -2519,7 +2519,7 @@
 </c:chartSpace>
 </file>
 
-<file path=ppt/charts/chart29.xml><?xml version="1.0" encoding="utf-8"?>
+<file path=ppt/charts/chart49.xml><?xml version="1.0" encoding="utf-8"?>
 <c:chartSpace xmlns:c="http://schemas.openxmlformats.org/drawingml/2006/chart" xmlns:a="http://schemas.openxmlformats.org/drawingml/2006/main" xmlns:r="http://schemas.openxmlformats.org/officeDocument/2006/relationships">
   <c:date1904 val="0"/>
   <c:roundedCorners val="0"/>
@@ -2819,7 +2819,7 @@
 </c:chartSpace>
 </file>
 
-<file path=ppt/charts/chart30.xml><?xml version="1.0" encoding="utf-8"?>
+<file path=ppt/charts/chart50.xml><?xml version="1.0" encoding="utf-8"?>
 <c:chartSpace xmlns:c="http://schemas.openxmlformats.org/drawingml/2006/chart" xmlns:a="http://schemas.openxmlformats.org/drawingml/2006/main" xmlns:r="http://schemas.openxmlformats.org/officeDocument/2006/relationships">
   <c:date1904 val="0"/>
   <c:roundedCorners val="0"/>
@@ -5236,7 +5236,7 @@
                 <a:ea typeface="Calibri" pitchFamily="34" charset="-122"/>
                 <a:cs typeface="Calibri" pitchFamily="34" charset="-120"/>
               </a:rPr>
-              <a:t>Prepared: May 5, 2026</a:t>
+              <a:t>Prepared: June 6, 2026</a:t>
             </a:r>
             <a:endParaRPr lang="en-US" sz="1200" dirty="0"/>
           </a:p>

</xml_diff>

<commit_message>
Auto-build: 2026-08-06 00:04 UTC
</commit_message>
<xml_diff>
--- a/reports/2026-01.pptx
+++ b/reports/2026-01.pptx
@@ -119,7 +119,7 @@
 </p:presentation>
 </file>
 
-<file path=ppt/charts/chart41.xml><?xml version="1.0" encoding="utf-8"?>
+<file path=ppt/charts/chart51.xml><?xml version="1.0" encoding="utf-8"?>
 <c:chartSpace xmlns:c="http://schemas.openxmlformats.org/drawingml/2006/chart" xmlns:a="http://schemas.openxmlformats.org/drawingml/2006/main" xmlns:r="http://schemas.openxmlformats.org/officeDocument/2006/relationships">
   <c:date1904 val="0"/>
   <c:roundedCorners val="0"/>
@@ -419,7 +419,7 @@
 </c:chartSpace>
 </file>
 
-<file path=ppt/charts/chart42.xml><?xml version="1.0" encoding="utf-8"?>
+<file path=ppt/charts/chart52.xml><?xml version="1.0" encoding="utf-8"?>
 <c:chartSpace xmlns:c="http://schemas.openxmlformats.org/drawingml/2006/chart" xmlns:a="http://schemas.openxmlformats.org/drawingml/2006/main" xmlns:r="http://schemas.openxmlformats.org/officeDocument/2006/relationships">
   <c:date1904 val="0"/>
   <c:roundedCorners val="0"/>
@@ -719,7 +719,7 @@
 </c:chartSpace>
 </file>
 
-<file path=ppt/charts/chart43.xml><?xml version="1.0" encoding="utf-8"?>
+<file path=ppt/charts/chart53.xml><?xml version="1.0" encoding="utf-8"?>
 <c:chartSpace xmlns:c="http://schemas.openxmlformats.org/drawingml/2006/chart" xmlns:a="http://schemas.openxmlformats.org/drawingml/2006/main" xmlns:r="http://schemas.openxmlformats.org/officeDocument/2006/relationships">
   <c:date1904 val="0"/>
   <c:roundedCorners val="0"/>
@@ -1019,7 +1019,7 @@
 </c:chartSpace>
 </file>
 
-<file path=ppt/charts/chart44.xml><?xml version="1.0" encoding="utf-8"?>
+<file path=ppt/charts/chart54.xml><?xml version="1.0" encoding="utf-8"?>
 <c:chartSpace xmlns:c="http://schemas.openxmlformats.org/drawingml/2006/chart" xmlns:a="http://schemas.openxmlformats.org/drawingml/2006/main" xmlns:r="http://schemas.openxmlformats.org/officeDocument/2006/relationships">
   <c:date1904 val="0"/>
   <c:roundedCorners val="0"/>
@@ -1319,7 +1319,7 @@
 </c:chartSpace>
 </file>
 
-<file path=ppt/charts/chart45.xml><?xml version="1.0" encoding="utf-8"?>
+<file path=ppt/charts/chart55.xml><?xml version="1.0" encoding="utf-8"?>
 <c:chartSpace xmlns:c="http://schemas.openxmlformats.org/drawingml/2006/chart" xmlns:a="http://schemas.openxmlformats.org/drawingml/2006/main" xmlns:r="http://schemas.openxmlformats.org/officeDocument/2006/relationships">
   <c:date1904 val="0"/>
   <c:roundedCorners val="0"/>
@@ -1619,7 +1619,7 @@
 </c:chartSpace>
 </file>
 
-<file path=ppt/charts/chart46.xml><?xml version="1.0" encoding="utf-8"?>
+<file path=ppt/charts/chart56.xml><?xml version="1.0" encoding="utf-8"?>
 <c:chartSpace xmlns:c="http://schemas.openxmlformats.org/drawingml/2006/chart" xmlns:a="http://schemas.openxmlformats.org/drawingml/2006/main" xmlns:r="http://schemas.openxmlformats.org/officeDocument/2006/relationships">
   <c:date1904 val="0"/>
   <c:roundedCorners val="0"/>
@@ -1919,7 +1919,7 @@
 </c:chartSpace>
 </file>
 
-<file path=ppt/charts/chart47.xml><?xml version="1.0" encoding="utf-8"?>
+<file path=ppt/charts/chart57.xml><?xml version="1.0" encoding="utf-8"?>
 <c:chartSpace xmlns:c="http://schemas.openxmlformats.org/drawingml/2006/chart" xmlns:a="http://schemas.openxmlformats.org/drawingml/2006/main" xmlns:r="http://schemas.openxmlformats.org/officeDocument/2006/relationships">
   <c:date1904 val="0"/>
   <c:roundedCorners val="0"/>
@@ -2219,7 +2219,7 @@
 </c:chartSpace>
 </file>
 
-<file path=ppt/charts/chart48.xml><?xml version="1.0" encoding="utf-8"?>
+<file path=ppt/charts/chart58.xml><?xml version="1.0" encoding="utf-8"?>
 <c:chartSpace xmlns:c="http://schemas.openxmlformats.org/drawingml/2006/chart" xmlns:a="http://schemas.openxmlformats.org/drawingml/2006/main" xmlns:r="http://schemas.openxmlformats.org/officeDocument/2006/relationships">
   <c:date1904 val="0"/>
   <c:roundedCorners val="0"/>
@@ -2519,7 +2519,7 @@
 </c:chartSpace>
 </file>
 
-<file path=ppt/charts/chart49.xml><?xml version="1.0" encoding="utf-8"?>
+<file path=ppt/charts/chart59.xml><?xml version="1.0" encoding="utf-8"?>
 <c:chartSpace xmlns:c="http://schemas.openxmlformats.org/drawingml/2006/chart" xmlns:a="http://schemas.openxmlformats.org/drawingml/2006/main" xmlns:r="http://schemas.openxmlformats.org/officeDocument/2006/relationships">
   <c:date1904 val="0"/>
   <c:roundedCorners val="0"/>
@@ -2819,7 +2819,7 @@
 </c:chartSpace>
 </file>
 
-<file path=ppt/charts/chart50.xml><?xml version="1.0" encoding="utf-8"?>
+<file path=ppt/charts/chart60.xml><?xml version="1.0" encoding="utf-8"?>
 <c:chartSpace xmlns:c="http://schemas.openxmlformats.org/drawingml/2006/chart" xmlns:a="http://schemas.openxmlformats.org/drawingml/2006/main" xmlns:r="http://schemas.openxmlformats.org/officeDocument/2006/relationships">
   <c:date1904 val="0"/>
   <c:roundedCorners val="0"/>
@@ -5236,7 +5236,7 @@
                 <a:ea typeface="Calibri" pitchFamily="34" charset="-122"/>
                 <a:cs typeface="Calibri" pitchFamily="34" charset="-120"/>
               </a:rPr>
-              <a:t>Prepared: July 6, 2026</a:t>
+              <a:t>Prepared: August 6, 2026</a:t>
             </a:r>
             <a:endParaRPr lang="en-US" sz="1200" dirty="0"/>
           </a:p>

</xml_diff>

<commit_message>
Auto-build: 2026-09-06 00:47 UTC
</commit_message>
<xml_diff>
--- a/reports/2026-01.pptx
+++ b/reports/2026-01.pptx
@@ -119,7 +119,7 @@
 </p:presentation>
 </file>
 
-<file path=ppt/charts/chart51.xml><?xml version="1.0" encoding="utf-8"?>
+<file path=ppt/charts/chart61.xml><?xml version="1.0" encoding="utf-8"?>
 <c:chartSpace xmlns:c="http://schemas.openxmlformats.org/drawingml/2006/chart" xmlns:a="http://schemas.openxmlformats.org/drawingml/2006/main" xmlns:r="http://schemas.openxmlformats.org/officeDocument/2006/relationships">
   <c:date1904 val="0"/>
   <c:roundedCorners val="0"/>
@@ -419,7 +419,7 @@
 </c:chartSpace>
 </file>
 
-<file path=ppt/charts/chart52.xml><?xml version="1.0" encoding="utf-8"?>
+<file path=ppt/charts/chart62.xml><?xml version="1.0" encoding="utf-8"?>
 <c:chartSpace xmlns:c="http://schemas.openxmlformats.org/drawingml/2006/chart" xmlns:a="http://schemas.openxmlformats.org/drawingml/2006/main" xmlns:r="http://schemas.openxmlformats.org/officeDocument/2006/relationships">
   <c:date1904 val="0"/>
   <c:roundedCorners val="0"/>
@@ -719,7 +719,7 @@
 </c:chartSpace>
 </file>
 
-<file path=ppt/charts/chart53.xml><?xml version="1.0" encoding="utf-8"?>
+<file path=ppt/charts/chart63.xml><?xml version="1.0" encoding="utf-8"?>
 <c:chartSpace xmlns:c="http://schemas.openxmlformats.org/drawingml/2006/chart" xmlns:a="http://schemas.openxmlformats.org/drawingml/2006/main" xmlns:r="http://schemas.openxmlformats.org/officeDocument/2006/relationships">
   <c:date1904 val="0"/>
   <c:roundedCorners val="0"/>
@@ -1019,7 +1019,7 @@
 </c:chartSpace>
 </file>
 
-<file path=ppt/charts/chart54.xml><?xml version="1.0" encoding="utf-8"?>
+<file path=ppt/charts/chart64.xml><?xml version="1.0" encoding="utf-8"?>
 <c:chartSpace xmlns:c="http://schemas.openxmlformats.org/drawingml/2006/chart" xmlns:a="http://schemas.openxmlformats.org/drawingml/2006/main" xmlns:r="http://schemas.openxmlformats.org/officeDocument/2006/relationships">
   <c:date1904 val="0"/>
   <c:roundedCorners val="0"/>
@@ -1319,7 +1319,7 @@
 </c:chartSpace>
 </file>
 
-<file path=ppt/charts/chart55.xml><?xml version="1.0" encoding="utf-8"?>
+<file path=ppt/charts/chart65.xml><?xml version="1.0" encoding="utf-8"?>
 <c:chartSpace xmlns:c="http://schemas.openxmlformats.org/drawingml/2006/chart" xmlns:a="http://schemas.openxmlformats.org/drawingml/2006/main" xmlns:r="http://schemas.openxmlformats.org/officeDocument/2006/relationships">
   <c:date1904 val="0"/>
   <c:roundedCorners val="0"/>
@@ -1619,7 +1619,7 @@
 </c:chartSpace>
 </file>
 
-<file path=ppt/charts/chart56.xml><?xml version="1.0" encoding="utf-8"?>
+<file path=ppt/charts/chart66.xml><?xml version="1.0" encoding="utf-8"?>
 <c:chartSpace xmlns:c="http://schemas.openxmlformats.org/drawingml/2006/chart" xmlns:a="http://schemas.openxmlformats.org/drawingml/2006/main" xmlns:r="http://schemas.openxmlformats.org/officeDocument/2006/relationships">
   <c:date1904 val="0"/>
   <c:roundedCorners val="0"/>
@@ -1919,7 +1919,7 @@
 </c:chartSpace>
 </file>
 
-<file path=ppt/charts/chart57.xml><?xml version="1.0" encoding="utf-8"?>
+<file path=ppt/charts/chart67.xml><?xml version="1.0" encoding="utf-8"?>
 <c:chartSpace xmlns:c="http://schemas.openxmlformats.org/drawingml/2006/chart" xmlns:a="http://schemas.openxmlformats.org/drawingml/2006/main" xmlns:r="http://schemas.openxmlformats.org/officeDocument/2006/relationships">
   <c:date1904 val="0"/>
   <c:roundedCorners val="0"/>
@@ -2219,7 +2219,7 @@
 </c:chartSpace>
 </file>
 
-<file path=ppt/charts/chart58.xml><?xml version="1.0" encoding="utf-8"?>
+<file path=ppt/charts/chart68.xml><?xml version="1.0" encoding="utf-8"?>
 <c:chartSpace xmlns:c="http://schemas.openxmlformats.org/drawingml/2006/chart" xmlns:a="http://schemas.openxmlformats.org/drawingml/2006/main" xmlns:r="http://schemas.openxmlformats.org/officeDocument/2006/relationships">
   <c:date1904 val="0"/>
   <c:roundedCorners val="0"/>
@@ -2519,7 +2519,7 @@
 </c:chartSpace>
 </file>
 
-<file path=ppt/charts/chart59.xml><?xml version="1.0" encoding="utf-8"?>
+<file path=ppt/charts/chart69.xml><?xml version="1.0" encoding="utf-8"?>
 <c:chartSpace xmlns:c="http://schemas.openxmlformats.org/drawingml/2006/chart" xmlns:a="http://schemas.openxmlformats.org/drawingml/2006/main" xmlns:r="http://schemas.openxmlformats.org/officeDocument/2006/relationships">
   <c:date1904 val="0"/>
   <c:roundedCorners val="0"/>
@@ -2819,7 +2819,7 @@
 </c:chartSpace>
 </file>
 
-<file path=ppt/charts/chart60.xml><?xml version="1.0" encoding="utf-8"?>
+<file path=ppt/charts/chart70.xml><?xml version="1.0" encoding="utf-8"?>
 <c:chartSpace xmlns:c="http://schemas.openxmlformats.org/drawingml/2006/chart" xmlns:a="http://schemas.openxmlformats.org/drawingml/2006/main" xmlns:r="http://schemas.openxmlformats.org/officeDocument/2006/relationships">
   <c:date1904 val="0"/>
   <c:roundedCorners val="0"/>
@@ -5236,7 +5236,7 @@
                 <a:ea typeface="Calibri" pitchFamily="34" charset="-122"/>
                 <a:cs typeface="Calibri" pitchFamily="34" charset="-120"/>
               </a:rPr>
-              <a:t>Prepared: August 6, 2026</a:t>
+              <a:t>Prepared: September 6, 2026</a:t>
             </a:r>
             <a:endParaRPr lang="en-US" sz="1200" dirty="0"/>
           </a:p>

</xml_diff>